<commit_message>
Update campaign deck age analysis
</commit_message>
<xml_diff>
--- a/outputs/shapermint-reshaping-rules-brand-campaign.pptx
+++ b/outputs/shapermint-reshaping-rules-brand-campaign.pptx
@@ -2,16 +2,16 @@
 <file path=ppt/presentation.xml><?xml version="1.0" encoding="utf-8"?>
 <p:presentation xmlns:p="http://schemas.openxmlformats.org/presentationml/2006/main">
   <p:sldMasterIdLst>
-    <p:sldMasterId xmlns:r="http://schemas.openxmlformats.org/officeDocument/2006/relationships" id="2147483648" r:id="Rd0b74e579cf44562"/>
+    <p:sldMasterId xmlns:r="http://schemas.openxmlformats.org/officeDocument/2006/relationships" id="2147483648" r:id="Rdb5d1f94713a4cc1"/>
   </p:sldMasterIdLst>
   <p:notesMasterIdLst>
-    <p:notesMasterId xmlns:r="http://schemas.openxmlformats.org/officeDocument/2006/relationships" r:id="R27ca04411f704b11"/>
+    <p:notesMasterId xmlns:r="http://schemas.openxmlformats.org/officeDocument/2006/relationships" r:id="R3875ac926fd7449a"/>
   </p:notesMasterIdLst>
   <p:sldIdLst>
-    <p:sldId xmlns:r="http://schemas.openxmlformats.org/officeDocument/2006/relationships" id="256" r:id="R13523f08d4724cc9"/>
-    <p:sldId xmlns:r="http://schemas.openxmlformats.org/officeDocument/2006/relationships" id="257" r:id="R369a92c508d64222"/>
-    <p:sldId xmlns:r="http://schemas.openxmlformats.org/officeDocument/2006/relationships" id="258" r:id="Reddf7301c4b845fd"/>
-    <p:sldId xmlns:r="http://schemas.openxmlformats.org/officeDocument/2006/relationships" id="259" r:id="R86340a1b123f4d20"/>
+    <p:sldId xmlns:r="http://schemas.openxmlformats.org/officeDocument/2006/relationships" id="256" r:id="Rfdafedefa1b74c1f"/>
+    <p:sldId xmlns:r="http://schemas.openxmlformats.org/officeDocument/2006/relationships" id="257" r:id="R4793aac775294aa7"/>
+    <p:sldId xmlns:r="http://schemas.openxmlformats.org/officeDocument/2006/relationships" id="258" r:id="R582a86bd0aba45c2"/>
+    <p:sldId xmlns:r="http://schemas.openxmlformats.org/officeDocument/2006/relationships" id="259" r:id="R0408c7d8ec5549b2"/>
   </p:sldIdLst>
   <p:sldSz cx="12192000" cy="6858000"/>
   <p:notesSz cx="6858000" cy="9144000"/>
@@ -802,7 +802,7 @@
   </p:cSld>
   <p:clrMap bg1="lt1" tx1="dk1" bg2="lt2" tx2="dk2" accent1="accent1" accent2="accent2" accent3="accent3" accent4="accent4" accent5="accent5" accent6="accent6" hlink="hlink" folHlink="folHlink"/>
   <p:sldLayoutIdLst>
-    <p:sldLayoutId xmlns:r="http://schemas.openxmlformats.org/officeDocument/2006/relationships" id="2147483649" r:id="R892122280db746c7"/>
+    <p:sldLayoutId xmlns:r="http://schemas.openxmlformats.org/officeDocument/2006/relationships" id="2147483649" r:id="R3b9e5a2f52884dfc"/>
   </p:sldLayoutIdLst>
   <p:txStyles>
     <p:titleStyle>
@@ -1590,7 +1590,7 @@
           <p:cNvPr id="30" name="">
             <a:extLst xmlns:a="http://schemas.openxmlformats.org/drawingml/2006/main">
               <a:ext uri="{FF2B5EF4-FFF2-40B4-BE49-F238E27FC236}">
-                <a16:creationId xmlns:a16="http://schemas.microsoft.com/office/drawing/2014/main" id="{901A6463-D4C1-40EA-AB81-AB9BB01B6756}"/>
+                <a16:creationId xmlns:a16="http://schemas.microsoft.com/office/drawing/2014/main" id="{0E7495F2-4A4F-40C6-8C06-FBABEEB6C8BE}"/>
               </a:ext>
             </a:extLst>
           </p:cNvPr>
@@ -1640,7 +1640,7 @@
           <p:cNvPr id="2" name="">
             <a:extLst xmlns:a="http://schemas.openxmlformats.org/drawingml/2006/main">
               <a:ext uri="{FF2B5EF4-FFF2-40B4-BE49-F238E27FC236}">
-                <a16:creationId xmlns:a16="http://schemas.microsoft.com/office/drawing/2014/main" id="{0D66BE03-E137-4994-B5E9-109FA2512D5E}"/>
+                <a16:creationId xmlns:a16="http://schemas.microsoft.com/office/drawing/2014/main" id="{192CC1D8-2EF7-4DBD-8725-88E5592549C2}"/>
               </a:ext>
             </a:extLst>
           </p:cNvPr>
@@ -1690,7 +1690,7 @@
           <p:cNvPr id="3" name="">
             <a:extLst xmlns:a="http://schemas.openxmlformats.org/drawingml/2006/main">
               <a:ext uri="{FF2B5EF4-FFF2-40B4-BE49-F238E27FC236}">
-                <a16:creationId xmlns:a16="http://schemas.microsoft.com/office/drawing/2014/main" id="{884F1C81-F8BA-44BC-A7FD-8F7BA5A92C46}"/>
+                <a16:creationId xmlns:a16="http://schemas.microsoft.com/office/drawing/2014/main" id="{FC478316-6137-4EDE-AAC0-F0A0B5B559F9}"/>
               </a:ext>
             </a:extLst>
           </p:cNvPr>
@@ -1740,7 +1740,7 @@
           <p:cNvPr id="4" name="">
             <a:extLst xmlns:a="http://schemas.openxmlformats.org/drawingml/2006/main">
               <a:ext uri="{FF2B5EF4-FFF2-40B4-BE49-F238E27FC236}">
-                <a16:creationId xmlns:a16="http://schemas.microsoft.com/office/drawing/2014/main" id="{9538AC6B-9795-4C9B-8941-C2E706CEDA9D}"/>
+                <a16:creationId xmlns:a16="http://schemas.microsoft.com/office/drawing/2014/main" id="{CCE80641-064C-4E70-98C8-F77E588A0934}"/>
               </a:ext>
             </a:extLst>
           </p:cNvPr>
@@ -1775,7 +1775,7 @@
           <p:cNvPr id="5" name="">
             <a:extLst xmlns:a="http://schemas.openxmlformats.org/drawingml/2006/main">
               <a:ext uri="{FF2B5EF4-FFF2-40B4-BE49-F238E27FC236}">
-                <a16:creationId xmlns:a16="http://schemas.microsoft.com/office/drawing/2014/main" id="{F4D95892-E263-43AA-82FE-21ADCA1FAE6C}"/>
+                <a16:creationId xmlns:a16="http://schemas.microsoft.com/office/drawing/2014/main" id="{E6D796FC-438C-4495-B618-4D392CB5C884}"/>
               </a:ext>
             </a:extLst>
           </p:cNvPr>
@@ -1825,7 +1825,7 @@
           <p:cNvPr id="6" name="">
             <a:extLst xmlns:a="http://schemas.openxmlformats.org/drawingml/2006/main">
               <a:ext uri="{FF2B5EF4-FFF2-40B4-BE49-F238E27FC236}">
-                <a16:creationId xmlns:a16="http://schemas.microsoft.com/office/drawing/2014/main" id="{A8F3F1BB-9ED9-4732-BBF3-8D00201DA7CF}"/>
+                <a16:creationId xmlns:a16="http://schemas.microsoft.com/office/drawing/2014/main" id="{D8FF5531-2285-4802-A523-714517C1F487}"/>
               </a:ext>
             </a:extLst>
           </p:cNvPr>
@@ -1858,7 +1858,7 @@
           <p:cNvPr id="7" name="">
             <a:extLst xmlns:a="http://schemas.openxmlformats.org/drawingml/2006/main">
               <a:ext uri="{FF2B5EF4-FFF2-40B4-BE49-F238E27FC236}">
-                <a16:creationId xmlns:a16="http://schemas.microsoft.com/office/drawing/2014/main" id="{5228B861-7148-4264-80E3-1D71B722198F}"/>
+                <a16:creationId xmlns:a16="http://schemas.microsoft.com/office/drawing/2014/main" id="{8D26920A-51AD-4E28-A122-E887C94D8BE6}"/>
               </a:ext>
             </a:extLst>
           </p:cNvPr>
@@ -1908,7 +1908,7 @@
           <p:cNvPr id="8" name="">
             <a:extLst xmlns:a="http://schemas.openxmlformats.org/drawingml/2006/main">
               <a:ext uri="{FF2B5EF4-FFF2-40B4-BE49-F238E27FC236}">
-                <a16:creationId xmlns:a16="http://schemas.microsoft.com/office/drawing/2014/main" id="{0064C247-0E51-42C2-8E5E-DEBFB0F9B399}"/>
+                <a16:creationId xmlns:a16="http://schemas.microsoft.com/office/drawing/2014/main" id="{3C425BB6-EA82-4379-8804-30C0975A2D7A}"/>
               </a:ext>
             </a:extLst>
           </p:cNvPr>
@@ -1958,7 +1958,7 @@
           <p:cNvPr id="9" name="">
             <a:extLst xmlns:a="http://schemas.openxmlformats.org/drawingml/2006/main">
               <a:ext uri="{FF2B5EF4-FFF2-40B4-BE49-F238E27FC236}">
-                <a16:creationId xmlns:a16="http://schemas.microsoft.com/office/drawing/2014/main" id="{03CFDF99-38C1-4F3C-A7CA-F0C4F4AA7670}"/>
+                <a16:creationId xmlns:a16="http://schemas.microsoft.com/office/drawing/2014/main" id="{D148CAFA-C242-4165-9CCD-E5270C810ABE}"/>
               </a:ext>
             </a:extLst>
           </p:cNvPr>
@@ -1993,7 +1993,7 @@
           <p:cNvPr id="10" name="">
             <a:extLst xmlns:a="http://schemas.openxmlformats.org/drawingml/2006/main">
               <a:ext uri="{FF2B5EF4-FFF2-40B4-BE49-F238E27FC236}">
-                <a16:creationId xmlns:a16="http://schemas.microsoft.com/office/drawing/2014/main" id="{67BDB02E-E893-4E36-ABE4-DDD7267B185E}"/>
+                <a16:creationId xmlns:a16="http://schemas.microsoft.com/office/drawing/2014/main" id="{740D2B3D-B008-43AD-AC9F-3C525445485B}"/>
               </a:ext>
             </a:extLst>
           </p:cNvPr>
@@ -2043,7 +2043,7 @@
           <p:cNvPr id="11" name="">
             <a:extLst xmlns:a="http://schemas.openxmlformats.org/drawingml/2006/main">
               <a:ext uri="{FF2B5EF4-FFF2-40B4-BE49-F238E27FC236}">
-                <a16:creationId xmlns:a16="http://schemas.microsoft.com/office/drawing/2014/main" id="{763F43E4-11A4-45F7-A4F4-47FE77596000}"/>
+                <a16:creationId xmlns:a16="http://schemas.microsoft.com/office/drawing/2014/main" id="{36A0C4EF-7430-4426-B9C7-7B748ECCBD45}"/>
               </a:ext>
             </a:extLst>
           </p:cNvPr>
@@ -2076,7 +2076,7 @@
           <p:cNvPr id="12" name="">
             <a:extLst xmlns:a="http://schemas.openxmlformats.org/drawingml/2006/main">
               <a:ext uri="{FF2B5EF4-FFF2-40B4-BE49-F238E27FC236}">
-                <a16:creationId xmlns:a16="http://schemas.microsoft.com/office/drawing/2014/main" id="{4D1CC007-6428-4D2D-9A18-440741D16479}"/>
+                <a16:creationId xmlns:a16="http://schemas.microsoft.com/office/drawing/2014/main" id="{170418DF-DC01-48FB-A8F5-93C39D584028}"/>
               </a:ext>
             </a:extLst>
           </p:cNvPr>
@@ -2126,7 +2126,7 @@
           <p:cNvPr id="13" name="">
             <a:extLst xmlns:a="http://schemas.openxmlformats.org/drawingml/2006/main">
               <a:ext uri="{FF2B5EF4-FFF2-40B4-BE49-F238E27FC236}">
-                <a16:creationId xmlns:a16="http://schemas.microsoft.com/office/drawing/2014/main" id="{265DE7BD-F62F-43E0-9F8B-6F95BBCEDF10}"/>
+                <a16:creationId xmlns:a16="http://schemas.microsoft.com/office/drawing/2014/main" id="{AC63D000-72A1-4465-847A-DB11B7E999C5}"/>
               </a:ext>
             </a:extLst>
           </p:cNvPr>
@@ -2176,7 +2176,7 @@
           <p:cNvPr id="14" name="">
             <a:extLst xmlns:a="http://schemas.openxmlformats.org/drawingml/2006/main">
               <a:ext uri="{FF2B5EF4-FFF2-40B4-BE49-F238E27FC236}">
-                <a16:creationId xmlns:a16="http://schemas.microsoft.com/office/drawing/2014/main" id="{BF23B35F-C445-4E51-8760-C98D6083806E}"/>
+                <a16:creationId xmlns:a16="http://schemas.microsoft.com/office/drawing/2014/main" id="{732A3F9F-4686-49A7-B7A4-7429EFBE6B13}"/>
               </a:ext>
             </a:extLst>
           </p:cNvPr>
@@ -2211,7 +2211,7 @@
           <p:cNvPr id="15" name="">
             <a:extLst xmlns:a="http://schemas.openxmlformats.org/drawingml/2006/main">
               <a:ext uri="{FF2B5EF4-FFF2-40B4-BE49-F238E27FC236}">
-                <a16:creationId xmlns:a16="http://schemas.microsoft.com/office/drawing/2014/main" id="{3A7CF4BF-3924-48DC-BBDE-F40B25704AF7}"/>
+                <a16:creationId xmlns:a16="http://schemas.microsoft.com/office/drawing/2014/main" id="{30C5E021-8E2B-462B-866F-E7C8F8DA620C}"/>
               </a:ext>
             </a:extLst>
           </p:cNvPr>
@@ -2261,7 +2261,7 @@
           <p:cNvPr id="16" name="">
             <a:extLst xmlns:a="http://schemas.openxmlformats.org/drawingml/2006/main">
               <a:ext uri="{FF2B5EF4-FFF2-40B4-BE49-F238E27FC236}">
-                <a16:creationId xmlns:a16="http://schemas.microsoft.com/office/drawing/2014/main" id="{2E4B9F8C-DC68-44AC-A302-CA1A8759623D}"/>
+                <a16:creationId xmlns:a16="http://schemas.microsoft.com/office/drawing/2014/main" id="{A57AAC5B-93D2-4174-B87C-659EEC3FF850}"/>
               </a:ext>
             </a:extLst>
           </p:cNvPr>
@@ -2294,7 +2294,7 @@
           <p:cNvPr id="17" name="">
             <a:extLst xmlns:a="http://schemas.openxmlformats.org/drawingml/2006/main">
               <a:ext uri="{FF2B5EF4-FFF2-40B4-BE49-F238E27FC236}">
-                <a16:creationId xmlns:a16="http://schemas.microsoft.com/office/drawing/2014/main" id="{3C2A3458-7BA0-4128-ACF8-6285CA92DA11}"/>
+                <a16:creationId xmlns:a16="http://schemas.microsoft.com/office/drawing/2014/main" id="{FFA55D49-978D-453D-8913-018CF9E4A23B}"/>
               </a:ext>
             </a:extLst>
           </p:cNvPr>
@@ -2344,7 +2344,7 @@
           <p:cNvPr id="18" name="">
             <a:extLst xmlns:a="http://schemas.openxmlformats.org/drawingml/2006/main">
               <a:ext uri="{FF2B5EF4-FFF2-40B4-BE49-F238E27FC236}">
-                <a16:creationId xmlns:a16="http://schemas.microsoft.com/office/drawing/2014/main" id="{4077BFF9-CEA2-4B08-A6D6-C9320295B332}"/>
+                <a16:creationId xmlns:a16="http://schemas.microsoft.com/office/drawing/2014/main" id="{C14287CA-1C45-427D-B15D-8C358423CDC4}"/>
               </a:ext>
             </a:extLst>
           </p:cNvPr>
@@ -2394,7 +2394,7 @@
           <p:cNvPr id="19" name="">
             <a:extLst xmlns:a="http://schemas.openxmlformats.org/drawingml/2006/main">
               <a:ext uri="{FF2B5EF4-FFF2-40B4-BE49-F238E27FC236}">
-                <a16:creationId xmlns:a16="http://schemas.microsoft.com/office/drawing/2014/main" id="{B4EA9E16-2B23-4B54-ACF4-4638E6518EEC}"/>
+                <a16:creationId xmlns:a16="http://schemas.microsoft.com/office/drawing/2014/main" id="{EA96BBBF-CCA0-4C8B-8E25-B815426E4A57}"/>
               </a:ext>
             </a:extLst>
           </p:cNvPr>
@@ -2429,7 +2429,7 @@
           <p:cNvPr id="20" name="">
             <a:extLst xmlns:a="http://schemas.openxmlformats.org/drawingml/2006/main">
               <a:ext uri="{FF2B5EF4-FFF2-40B4-BE49-F238E27FC236}">
-                <a16:creationId xmlns:a16="http://schemas.microsoft.com/office/drawing/2014/main" id="{35F41CEB-5C30-4B41-81E1-F06F96146D1A}"/>
+                <a16:creationId xmlns:a16="http://schemas.microsoft.com/office/drawing/2014/main" id="{EAFDAC69-16FD-4A7F-ADA8-AF72A5AC0FD6}"/>
               </a:ext>
             </a:extLst>
           </p:cNvPr>
@@ -2479,7 +2479,7 @@
           <p:cNvPr id="21" name="">
             <a:extLst xmlns:a="http://schemas.openxmlformats.org/drawingml/2006/main">
               <a:ext uri="{FF2B5EF4-FFF2-40B4-BE49-F238E27FC236}">
-                <a16:creationId xmlns:a16="http://schemas.microsoft.com/office/drawing/2014/main" id="{41BA7F55-7991-4E0C-9B81-53B378214163}"/>
+                <a16:creationId xmlns:a16="http://schemas.microsoft.com/office/drawing/2014/main" id="{9751C88F-4369-4BDA-AE1C-BE414B4DF83F}"/>
               </a:ext>
             </a:extLst>
           </p:cNvPr>
@@ -2512,7 +2512,7 @@
           <p:cNvPr id="22" name="">
             <a:extLst xmlns:a="http://schemas.openxmlformats.org/drawingml/2006/main">
               <a:ext uri="{FF2B5EF4-FFF2-40B4-BE49-F238E27FC236}">
-                <a16:creationId xmlns:a16="http://schemas.microsoft.com/office/drawing/2014/main" id="{F8EEA9BD-3048-469C-B648-594D68213B39}"/>
+                <a16:creationId xmlns:a16="http://schemas.microsoft.com/office/drawing/2014/main" id="{351A8CC1-D762-46F8-A1E0-2E4E13CA802C}"/>
               </a:ext>
             </a:extLst>
           </p:cNvPr>
@@ -2562,7 +2562,7 @@
           <p:cNvPr id="23" name="">
             <a:extLst xmlns:a="http://schemas.openxmlformats.org/drawingml/2006/main">
               <a:ext uri="{FF2B5EF4-FFF2-40B4-BE49-F238E27FC236}">
-                <a16:creationId xmlns:a16="http://schemas.microsoft.com/office/drawing/2014/main" id="{8906ADCA-F36E-431D-A7FE-0ACCA7ECF713}"/>
+                <a16:creationId xmlns:a16="http://schemas.microsoft.com/office/drawing/2014/main" id="{9306DA2F-384F-4997-A3AC-B1E03F653788}"/>
               </a:ext>
             </a:extLst>
           </p:cNvPr>
@@ -2619,7 +2619,7 @@
         </p:xfrm>
         <a:graphic xmlns:a="http://schemas.openxmlformats.org/drawingml/2006/main">
           <a:graphicData uri="http://schemas.openxmlformats.org/drawingml/2006/chart">
-            <c:chart xmlns:r="http://schemas.openxmlformats.org/officeDocument/2006/relationships" xmlns:c="http://schemas.openxmlformats.org/drawingml/2006/chart" r:id="R2f117054f9d448e9"/>
+            <c:chart xmlns:r="http://schemas.openxmlformats.org/officeDocument/2006/relationships" xmlns:c="http://schemas.openxmlformats.org/drawingml/2006/chart" r:id="R67188a916fd7413c"/>
           </a:graphicData>
         </a:graphic>
       </p:graphicFrame>
@@ -2628,7 +2628,7 @@
           <p:cNvPr id="25" name="">
             <a:extLst xmlns:a="http://schemas.openxmlformats.org/drawingml/2006/main">
               <a:ext uri="{FF2B5EF4-FFF2-40B4-BE49-F238E27FC236}">
-                <a16:creationId xmlns:a16="http://schemas.microsoft.com/office/drawing/2014/main" id="{96F71565-1059-418A-8EE2-18E6DB683728}"/>
+                <a16:creationId xmlns:a16="http://schemas.microsoft.com/office/drawing/2014/main" id="{CD6F30BA-1FE4-416D-9C4E-1F284E6EB555}"/>
               </a:ext>
             </a:extLst>
           </p:cNvPr>
@@ -2663,7 +2663,7 @@
           <p:cNvPr id="26" name="">
             <a:extLst xmlns:a="http://schemas.openxmlformats.org/drawingml/2006/main">
               <a:ext uri="{FF2B5EF4-FFF2-40B4-BE49-F238E27FC236}">
-                <a16:creationId xmlns:a16="http://schemas.microsoft.com/office/drawing/2014/main" id="{AF41A3C7-537E-44DE-A505-7DB9F06EF80F}"/>
+                <a16:creationId xmlns:a16="http://schemas.microsoft.com/office/drawing/2014/main" id="{F7234AD1-41D4-4DB5-A6F9-32C80655034E}"/>
               </a:ext>
             </a:extLst>
           </p:cNvPr>
@@ -2713,7 +2713,7 @@
           <p:cNvPr id="27" name="">
             <a:extLst xmlns:a="http://schemas.openxmlformats.org/drawingml/2006/main">
               <a:ext uri="{FF2B5EF4-FFF2-40B4-BE49-F238E27FC236}">
-                <a16:creationId xmlns:a16="http://schemas.microsoft.com/office/drawing/2014/main" id="{D4D285D0-CE60-485C-A27C-D415C8845DE2}"/>
+                <a16:creationId xmlns:a16="http://schemas.microsoft.com/office/drawing/2014/main" id="{B045696A-68C1-4876-8DD5-8EFF6F09E00A}"/>
               </a:ext>
             </a:extLst>
           </p:cNvPr>
@@ -2763,7 +2763,7 @@
           <p:cNvPr id="28" name="">
             <a:extLst xmlns:a="http://schemas.openxmlformats.org/drawingml/2006/main">
               <a:ext uri="{FF2B5EF4-FFF2-40B4-BE49-F238E27FC236}">
-                <a16:creationId xmlns:a16="http://schemas.microsoft.com/office/drawing/2014/main" id="{3E7359E5-77D0-461F-B2A1-7707A1F13CB5}"/>
+                <a16:creationId xmlns:a16="http://schemas.microsoft.com/office/drawing/2014/main" id="{DB580EDC-264D-4077-B5D6-90613E4929D0}"/>
               </a:ext>
             </a:extLst>
           </p:cNvPr>
@@ -2813,7 +2813,7 @@
           <p:cNvPr id="29" name="">
             <a:extLst xmlns:a="http://schemas.openxmlformats.org/drawingml/2006/main">
               <a:ext uri="{FF2B5EF4-FFF2-40B4-BE49-F238E27FC236}">
-                <a16:creationId xmlns:a16="http://schemas.microsoft.com/office/drawing/2014/main" id="{303AE4A4-C534-4342-825A-7310952F142F}"/>
+                <a16:creationId xmlns:a16="http://schemas.microsoft.com/office/drawing/2014/main" id="{8F300A93-B979-43F6-8D94-3D498D7E7B53}"/>
               </a:ext>
             </a:extLst>
           </p:cNvPr>
@@ -2861,7 +2861,7 @@
     </p:spTree>
     <p:extLst>
       <p:ext uri="{BB962C8B-B14F-4D97-AF65-F5344CB8AC3E}">
-        <p14:creationId xmlns:p14="http://schemas.microsoft.com/office/powerpoint/2010/main" val="922915338"/>
+        <p14:creationId xmlns:p14="http://schemas.microsoft.com/office/powerpoint/2010/main" val="965668429"/>
       </p:ext>
     </p:extLst>
   </p:cSld>
@@ -2892,7 +2892,7 @@
           <p:cNvPr id="74" name="">
             <a:extLst xmlns:a="http://schemas.openxmlformats.org/drawingml/2006/main">
               <a:ext uri="{FF2B5EF4-FFF2-40B4-BE49-F238E27FC236}">
-                <a16:creationId xmlns:a16="http://schemas.microsoft.com/office/drawing/2014/main" id="{B066B6DA-6D63-4624-81E3-AA5E3CD3E9DE}"/>
+                <a16:creationId xmlns:a16="http://schemas.microsoft.com/office/drawing/2014/main" id="{38BD5971-238B-4C35-BFFF-20BC5BFCEB8E}"/>
               </a:ext>
             </a:extLst>
           </p:cNvPr>
@@ -2942,7 +2942,7 @@
           <p:cNvPr id="2" name="">
             <a:extLst xmlns:a="http://schemas.openxmlformats.org/drawingml/2006/main">
               <a:ext uri="{FF2B5EF4-FFF2-40B4-BE49-F238E27FC236}">
-                <a16:creationId xmlns:a16="http://schemas.microsoft.com/office/drawing/2014/main" id="{B8103AEA-90EE-4675-98EB-E292AA3822C2}"/>
+                <a16:creationId xmlns:a16="http://schemas.microsoft.com/office/drawing/2014/main" id="{68350CB9-1A5B-4C52-B647-914A7A629657}"/>
               </a:ext>
             </a:extLst>
           </p:cNvPr>
@@ -2992,7 +2992,7 @@
           <p:cNvPr id="3" name="">
             <a:extLst xmlns:a="http://schemas.openxmlformats.org/drawingml/2006/main">
               <a:ext uri="{FF2B5EF4-FFF2-40B4-BE49-F238E27FC236}">
-                <a16:creationId xmlns:a16="http://schemas.microsoft.com/office/drawing/2014/main" id="{E314A300-3A05-4237-B1A2-72CC8F25C752}"/>
+                <a16:creationId xmlns:a16="http://schemas.microsoft.com/office/drawing/2014/main" id="{23D98890-795F-4055-A125-B45A74E1708C}"/>
               </a:ext>
             </a:extLst>
           </p:cNvPr>
@@ -3042,7 +3042,7 @@
           <p:cNvPr id="4" name="">
             <a:extLst xmlns:a="http://schemas.openxmlformats.org/drawingml/2006/main">
               <a:ext uri="{FF2B5EF4-FFF2-40B4-BE49-F238E27FC236}">
-                <a16:creationId xmlns:a16="http://schemas.microsoft.com/office/drawing/2014/main" id="{C56D5953-4747-4C6F-A37A-4DD05ABA1728}"/>
+                <a16:creationId xmlns:a16="http://schemas.microsoft.com/office/drawing/2014/main" id="{9811D643-94D6-4D0A-A4B4-CE95EF728013}"/>
               </a:ext>
             </a:extLst>
           </p:cNvPr>
@@ -3092,7 +3092,7 @@
           <p:cNvPr id="5" name="">
             <a:extLst xmlns:a="http://schemas.openxmlformats.org/drawingml/2006/main">
               <a:ext uri="{FF2B5EF4-FFF2-40B4-BE49-F238E27FC236}">
-                <a16:creationId xmlns:a16="http://schemas.microsoft.com/office/drawing/2014/main" id="{25E1F4DE-1DC1-488D-86C2-67D602BA90C8}"/>
+                <a16:creationId xmlns:a16="http://schemas.microsoft.com/office/drawing/2014/main" id="{7F325447-1BC5-47E6-A198-1699E426AA5C}"/>
               </a:ext>
             </a:extLst>
           </p:cNvPr>
@@ -3142,7 +3142,7 @@
           <p:cNvPr id="6" name="">
             <a:extLst xmlns:a="http://schemas.openxmlformats.org/drawingml/2006/main">
               <a:ext uri="{FF2B5EF4-FFF2-40B4-BE49-F238E27FC236}">
-                <a16:creationId xmlns:a16="http://schemas.microsoft.com/office/drawing/2014/main" id="{4D204D3D-A757-4868-96AF-9BBB13708ED2}"/>
+                <a16:creationId xmlns:a16="http://schemas.microsoft.com/office/drawing/2014/main" id="{B1ED085B-90E4-48A2-BCB3-74AFF0D4BC10}"/>
               </a:ext>
             </a:extLst>
           </p:cNvPr>
@@ -3177,7 +3177,7 @@
           <p:cNvPr id="7" name="">
             <a:extLst xmlns:a="http://schemas.openxmlformats.org/drawingml/2006/main">
               <a:ext uri="{FF2B5EF4-FFF2-40B4-BE49-F238E27FC236}">
-                <a16:creationId xmlns:a16="http://schemas.microsoft.com/office/drawing/2014/main" id="{1FE9EB5B-BDDA-4140-8112-D97B72DB1BBE}"/>
+                <a16:creationId xmlns:a16="http://schemas.microsoft.com/office/drawing/2014/main" id="{75FC5562-C8B9-46FB-BC4A-60FCF623A1D9}"/>
               </a:ext>
             </a:extLst>
           </p:cNvPr>
@@ -3212,7 +3212,7 @@
           <p:cNvPr id="8" name="">
             <a:extLst xmlns:a="http://schemas.openxmlformats.org/drawingml/2006/main">
               <a:ext uri="{FF2B5EF4-FFF2-40B4-BE49-F238E27FC236}">
-                <a16:creationId xmlns:a16="http://schemas.microsoft.com/office/drawing/2014/main" id="{FF3C8ED0-BDBD-4870-8CC7-C2E6958EB097}"/>
+                <a16:creationId xmlns:a16="http://schemas.microsoft.com/office/drawing/2014/main" id="{1CCDE4B7-8CA2-446E-A5E0-121EAAAB904A}"/>
               </a:ext>
             </a:extLst>
           </p:cNvPr>
@@ -3262,7 +3262,7 @@
           <p:cNvPr id="9" name="">
             <a:extLst xmlns:a="http://schemas.openxmlformats.org/drawingml/2006/main">
               <a:ext uri="{FF2B5EF4-FFF2-40B4-BE49-F238E27FC236}">
-                <a16:creationId xmlns:a16="http://schemas.microsoft.com/office/drawing/2014/main" id="{ADF50042-C684-4DC3-A1D4-A5F729A3A453}"/>
+                <a16:creationId xmlns:a16="http://schemas.microsoft.com/office/drawing/2014/main" id="{32175541-B26F-4D1C-B929-BE5CB9C2ABB5}"/>
               </a:ext>
             </a:extLst>
           </p:cNvPr>
@@ -3312,7 +3312,7 @@
           <p:cNvPr id="10" name="">
             <a:extLst xmlns:a="http://schemas.openxmlformats.org/drawingml/2006/main">
               <a:ext uri="{FF2B5EF4-FFF2-40B4-BE49-F238E27FC236}">
-                <a16:creationId xmlns:a16="http://schemas.microsoft.com/office/drawing/2014/main" id="{2C4F43DD-2888-4189-B115-13231FAEB792}"/>
+                <a16:creationId xmlns:a16="http://schemas.microsoft.com/office/drawing/2014/main" id="{EC735563-2AA8-4D0D-B18F-92ACFEB65C5A}"/>
               </a:ext>
             </a:extLst>
           </p:cNvPr>
@@ -3347,7 +3347,7 @@
           <p:cNvPr id="11" name="">
             <a:extLst xmlns:a="http://schemas.openxmlformats.org/drawingml/2006/main">
               <a:ext uri="{FF2B5EF4-FFF2-40B4-BE49-F238E27FC236}">
-                <a16:creationId xmlns:a16="http://schemas.microsoft.com/office/drawing/2014/main" id="{D2582C3B-9DA1-4EA9-B0A1-88AAF0A3D666}"/>
+                <a16:creationId xmlns:a16="http://schemas.microsoft.com/office/drawing/2014/main" id="{5F5617BB-DDBC-43DA-A7B7-60591E88E828}"/>
               </a:ext>
             </a:extLst>
           </p:cNvPr>
@@ -3382,7 +3382,7 @@
           <p:cNvPr id="12" name="">
             <a:extLst xmlns:a="http://schemas.openxmlformats.org/drawingml/2006/main">
               <a:ext uri="{FF2B5EF4-FFF2-40B4-BE49-F238E27FC236}">
-                <a16:creationId xmlns:a16="http://schemas.microsoft.com/office/drawing/2014/main" id="{8C0FE69E-FAD1-416C-9F09-6928C1FADF07}"/>
+                <a16:creationId xmlns:a16="http://schemas.microsoft.com/office/drawing/2014/main" id="{8ECD512E-3292-4244-8124-F3769ECF1559}"/>
               </a:ext>
             </a:extLst>
           </p:cNvPr>
@@ -3432,7 +3432,7 @@
           <p:cNvPr id="13" name="">
             <a:extLst xmlns:a="http://schemas.openxmlformats.org/drawingml/2006/main">
               <a:ext uri="{FF2B5EF4-FFF2-40B4-BE49-F238E27FC236}">
-                <a16:creationId xmlns:a16="http://schemas.microsoft.com/office/drawing/2014/main" id="{9942DFB2-BF17-43A4-BEE8-CDAB46D2FC8B}"/>
+                <a16:creationId xmlns:a16="http://schemas.microsoft.com/office/drawing/2014/main" id="{577AC13B-4E51-44A2-8ECD-C9E6A625855F}"/>
               </a:ext>
             </a:extLst>
           </p:cNvPr>
@@ -3482,7 +3482,7 @@
           <p:cNvPr id="14" name="">
             <a:extLst xmlns:a="http://schemas.openxmlformats.org/drawingml/2006/main">
               <a:ext uri="{FF2B5EF4-FFF2-40B4-BE49-F238E27FC236}">
-                <a16:creationId xmlns:a16="http://schemas.microsoft.com/office/drawing/2014/main" id="{F8EA9FAF-0C2F-4451-811F-59776DFE38C7}"/>
+                <a16:creationId xmlns:a16="http://schemas.microsoft.com/office/drawing/2014/main" id="{1277BA4E-B344-4192-837F-02D37A46E926}"/>
               </a:ext>
             </a:extLst>
           </p:cNvPr>
@@ -3517,7 +3517,7 @@
           <p:cNvPr id="15" name="">
             <a:extLst xmlns:a="http://schemas.openxmlformats.org/drawingml/2006/main">
               <a:ext uri="{FF2B5EF4-FFF2-40B4-BE49-F238E27FC236}">
-                <a16:creationId xmlns:a16="http://schemas.microsoft.com/office/drawing/2014/main" id="{9FB09C84-E181-44E0-96E4-AFEF3220DB1E}"/>
+                <a16:creationId xmlns:a16="http://schemas.microsoft.com/office/drawing/2014/main" id="{763BC95F-1CF4-41E1-9BD6-29A67E3503D7}"/>
               </a:ext>
             </a:extLst>
           </p:cNvPr>
@@ -3552,7 +3552,7 @@
           <p:cNvPr id="16" name="">
             <a:extLst xmlns:a="http://schemas.openxmlformats.org/drawingml/2006/main">
               <a:ext uri="{FF2B5EF4-FFF2-40B4-BE49-F238E27FC236}">
-                <a16:creationId xmlns:a16="http://schemas.microsoft.com/office/drawing/2014/main" id="{38DBED12-3979-4E08-8612-7A0CE09EB9E1}"/>
+                <a16:creationId xmlns:a16="http://schemas.microsoft.com/office/drawing/2014/main" id="{DC61153F-9F53-453D-80DE-1B0951BC501B}"/>
               </a:ext>
             </a:extLst>
           </p:cNvPr>
@@ -3602,7 +3602,7 @@
           <p:cNvPr id="17" name="">
             <a:extLst xmlns:a="http://schemas.openxmlformats.org/drawingml/2006/main">
               <a:ext uri="{FF2B5EF4-FFF2-40B4-BE49-F238E27FC236}">
-                <a16:creationId xmlns:a16="http://schemas.microsoft.com/office/drawing/2014/main" id="{47E164F7-444A-4BBA-B3F1-9F0CBDA0EACA}"/>
+                <a16:creationId xmlns:a16="http://schemas.microsoft.com/office/drawing/2014/main" id="{02635738-75D7-4FEF-BBED-61150FBC8102}"/>
               </a:ext>
             </a:extLst>
           </p:cNvPr>
@@ -3652,7 +3652,7 @@
           <p:cNvPr id="18" name="">
             <a:extLst xmlns:a="http://schemas.openxmlformats.org/drawingml/2006/main">
               <a:ext uri="{FF2B5EF4-FFF2-40B4-BE49-F238E27FC236}">
-                <a16:creationId xmlns:a16="http://schemas.microsoft.com/office/drawing/2014/main" id="{47FBCA55-2C91-4586-9BFB-506ACB1BBED4}"/>
+                <a16:creationId xmlns:a16="http://schemas.microsoft.com/office/drawing/2014/main" id="{77C03318-8601-4D73-87EF-FD0BC12702AE}"/>
               </a:ext>
             </a:extLst>
           </p:cNvPr>
@@ -3687,7 +3687,7 @@
           <p:cNvPr id="19" name="">
             <a:extLst xmlns:a="http://schemas.openxmlformats.org/drawingml/2006/main">
               <a:ext uri="{FF2B5EF4-FFF2-40B4-BE49-F238E27FC236}">
-                <a16:creationId xmlns:a16="http://schemas.microsoft.com/office/drawing/2014/main" id="{F38FC6B0-2985-4075-B832-9C468967F473}"/>
+                <a16:creationId xmlns:a16="http://schemas.microsoft.com/office/drawing/2014/main" id="{C8AE81A2-2C2E-4FD3-96F6-8FDB3EE60BE8}"/>
               </a:ext>
             </a:extLst>
           </p:cNvPr>
@@ -3722,7 +3722,7 @@
           <p:cNvPr id="20" name="">
             <a:extLst xmlns:a="http://schemas.openxmlformats.org/drawingml/2006/main">
               <a:ext uri="{FF2B5EF4-FFF2-40B4-BE49-F238E27FC236}">
-                <a16:creationId xmlns:a16="http://schemas.microsoft.com/office/drawing/2014/main" id="{B16A0F08-72E5-44FE-AC1D-B6C2BCCA0950}"/>
+                <a16:creationId xmlns:a16="http://schemas.microsoft.com/office/drawing/2014/main" id="{27B44497-6D08-4DAD-86D1-A9650CA41F50}"/>
               </a:ext>
             </a:extLst>
           </p:cNvPr>
@@ -3772,7 +3772,7 @@
           <p:cNvPr id="21" name="">
             <a:extLst xmlns:a="http://schemas.openxmlformats.org/drawingml/2006/main">
               <a:ext uri="{FF2B5EF4-FFF2-40B4-BE49-F238E27FC236}">
-                <a16:creationId xmlns:a16="http://schemas.microsoft.com/office/drawing/2014/main" id="{60785522-7F1B-46CE-9A94-326A43195FE6}"/>
+                <a16:creationId xmlns:a16="http://schemas.microsoft.com/office/drawing/2014/main" id="{D61473F9-7183-4437-A196-B96A260B80BB}"/>
               </a:ext>
             </a:extLst>
           </p:cNvPr>
@@ -3822,7 +3822,7 @@
           <p:cNvPr id="22" name="">
             <a:extLst xmlns:a="http://schemas.openxmlformats.org/drawingml/2006/main">
               <a:ext uri="{FF2B5EF4-FFF2-40B4-BE49-F238E27FC236}">
-                <a16:creationId xmlns:a16="http://schemas.microsoft.com/office/drawing/2014/main" id="{59B8F50E-51E6-476D-B253-90B2052A66F9}"/>
+                <a16:creationId xmlns:a16="http://schemas.microsoft.com/office/drawing/2014/main" id="{4D6FDA87-33D7-4112-9487-4E3DCB6DA428}"/>
               </a:ext>
             </a:extLst>
           </p:cNvPr>
@@ -3857,7 +3857,7 @@
           <p:cNvPr id="23" name="">
             <a:extLst xmlns:a="http://schemas.openxmlformats.org/drawingml/2006/main">
               <a:ext uri="{FF2B5EF4-FFF2-40B4-BE49-F238E27FC236}">
-                <a16:creationId xmlns:a16="http://schemas.microsoft.com/office/drawing/2014/main" id="{E476632D-2E9C-4DE9-B465-F8663F7E4E0D}"/>
+                <a16:creationId xmlns:a16="http://schemas.microsoft.com/office/drawing/2014/main" id="{A8C9C601-9A39-4810-B3F7-ED4ACC4CC91B}"/>
               </a:ext>
             </a:extLst>
           </p:cNvPr>
@@ -3892,7 +3892,7 @@
           <p:cNvPr id="24" name="">
             <a:extLst xmlns:a="http://schemas.openxmlformats.org/drawingml/2006/main">
               <a:ext uri="{FF2B5EF4-FFF2-40B4-BE49-F238E27FC236}">
-                <a16:creationId xmlns:a16="http://schemas.microsoft.com/office/drawing/2014/main" id="{11145A52-24AD-4EEA-93F2-680E5A8DD7B1}"/>
+                <a16:creationId xmlns:a16="http://schemas.microsoft.com/office/drawing/2014/main" id="{94CB58E0-240C-4B82-ADB9-C7FF863BF59E}"/>
               </a:ext>
             </a:extLst>
           </p:cNvPr>
@@ -3942,7 +3942,7 @@
           <p:cNvPr id="25" name="">
             <a:extLst xmlns:a="http://schemas.openxmlformats.org/drawingml/2006/main">
               <a:ext uri="{FF2B5EF4-FFF2-40B4-BE49-F238E27FC236}">
-                <a16:creationId xmlns:a16="http://schemas.microsoft.com/office/drawing/2014/main" id="{9D1BF97F-1802-4C22-995B-1598D8D5705F}"/>
+                <a16:creationId xmlns:a16="http://schemas.microsoft.com/office/drawing/2014/main" id="{35BDFBE8-2BDA-44A0-AB31-6B48A9BA9FFB}"/>
               </a:ext>
             </a:extLst>
           </p:cNvPr>
@@ -3992,7 +3992,7 @@
           <p:cNvPr id="26" name="">
             <a:extLst xmlns:a="http://schemas.openxmlformats.org/drawingml/2006/main">
               <a:ext uri="{FF2B5EF4-FFF2-40B4-BE49-F238E27FC236}">
-                <a16:creationId xmlns:a16="http://schemas.microsoft.com/office/drawing/2014/main" id="{0E290566-9AC8-4BF0-90EF-2495F8035BA2}"/>
+                <a16:creationId xmlns:a16="http://schemas.microsoft.com/office/drawing/2014/main" id="{3BC7F365-2B5C-42D5-92DE-2B6A75B54B55}"/>
               </a:ext>
             </a:extLst>
           </p:cNvPr>
@@ -4042,7 +4042,7 @@
           <p:cNvPr id="27" name="">
             <a:extLst xmlns:a="http://schemas.openxmlformats.org/drawingml/2006/main">
               <a:ext uri="{FF2B5EF4-FFF2-40B4-BE49-F238E27FC236}">
-                <a16:creationId xmlns:a16="http://schemas.microsoft.com/office/drawing/2014/main" id="{21F9D99C-493D-46EE-BE8F-24DFA8494B47}"/>
+                <a16:creationId xmlns:a16="http://schemas.microsoft.com/office/drawing/2014/main" id="{A496FAF6-06F2-4D9A-AE35-8D7A2E8E46C6}"/>
               </a:ext>
             </a:extLst>
           </p:cNvPr>
@@ -4077,7 +4077,7 @@
           <p:cNvPr id="28" name="">
             <a:extLst xmlns:a="http://schemas.openxmlformats.org/drawingml/2006/main">
               <a:ext uri="{FF2B5EF4-FFF2-40B4-BE49-F238E27FC236}">
-                <a16:creationId xmlns:a16="http://schemas.microsoft.com/office/drawing/2014/main" id="{AFD67AB9-7A0C-4115-AEAC-99F5853BD191}"/>
+                <a16:creationId xmlns:a16="http://schemas.microsoft.com/office/drawing/2014/main" id="{E5C80A1C-9CB7-4443-95DA-84F7746EC3D1}"/>
               </a:ext>
             </a:extLst>
           </p:cNvPr>
@@ -4112,7 +4112,7 @@
           <p:cNvPr id="29" name="">
             <a:extLst xmlns:a="http://schemas.openxmlformats.org/drawingml/2006/main">
               <a:ext uri="{FF2B5EF4-FFF2-40B4-BE49-F238E27FC236}">
-                <a16:creationId xmlns:a16="http://schemas.microsoft.com/office/drawing/2014/main" id="{4EF460A0-F57B-4899-86CF-D8D16EC80BED}"/>
+                <a16:creationId xmlns:a16="http://schemas.microsoft.com/office/drawing/2014/main" id="{5CB185AC-D850-45E1-B213-F8DE0B00D0E0}"/>
               </a:ext>
             </a:extLst>
           </p:cNvPr>
@@ -4162,7 +4162,7 @@
           <p:cNvPr id="30" name="">
             <a:extLst xmlns:a="http://schemas.openxmlformats.org/drawingml/2006/main">
               <a:ext uri="{FF2B5EF4-FFF2-40B4-BE49-F238E27FC236}">
-                <a16:creationId xmlns:a16="http://schemas.microsoft.com/office/drawing/2014/main" id="{8619474B-C0EC-4A77-8C7A-9B80D741E3AD}"/>
+                <a16:creationId xmlns:a16="http://schemas.microsoft.com/office/drawing/2014/main" id="{90737C3E-9886-4269-B7D0-A7636D3EEC58}"/>
               </a:ext>
             </a:extLst>
           </p:cNvPr>
@@ -4212,7 +4212,7 @@
           <p:cNvPr id="31" name="">
             <a:extLst xmlns:a="http://schemas.openxmlformats.org/drawingml/2006/main">
               <a:ext uri="{FF2B5EF4-FFF2-40B4-BE49-F238E27FC236}">
-                <a16:creationId xmlns:a16="http://schemas.microsoft.com/office/drawing/2014/main" id="{DD7FBE8A-14EC-43AC-9CCB-B2CFEE321138}"/>
+                <a16:creationId xmlns:a16="http://schemas.microsoft.com/office/drawing/2014/main" id="{24790044-1E73-457E-A874-AF5C46EDAA02}"/>
               </a:ext>
             </a:extLst>
           </p:cNvPr>
@@ -4247,7 +4247,7 @@
           <p:cNvPr id="32" name="">
             <a:extLst xmlns:a="http://schemas.openxmlformats.org/drawingml/2006/main">
               <a:ext uri="{FF2B5EF4-FFF2-40B4-BE49-F238E27FC236}">
-                <a16:creationId xmlns:a16="http://schemas.microsoft.com/office/drawing/2014/main" id="{D4D7772A-F6FE-409F-8FCD-CFF539670C85}"/>
+                <a16:creationId xmlns:a16="http://schemas.microsoft.com/office/drawing/2014/main" id="{8AB12321-8C9F-4217-B3DD-544766B2FACC}"/>
               </a:ext>
             </a:extLst>
           </p:cNvPr>
@@ -4282,7 +4282,7 @@
           <p:cNvPr id="33" name="">
             <a:extLst xmlns:a="http://schemas.openxmlformats.org/drawingml/2006/main">
               <a:ext uri="{FF2B5EF4-FFF2-40B4-BE49-F238E27FC236}">
-                <a16:creationId xmlns:a16="http://schemas.microsoft.com/office/drawing/2014/main" id="{BE4A52F0-9788-4FDA-B846-4BD2FFF88CEA}"/>
+                <a16:creationId xmlns:a16="http://schemas.microsoft.com/office/drawing/2014/main" id="{0DC2A442-BFF9-444F-90DB-6B2DEF444AFD}"/>
               </a:ext>
             </a:extLst>
           </p:cNvPr>
@@ -4332,7 +4332,7 @@
           <p:cNvPr id="34" name="">
             <a:extLst xmlns:a="http://schemas.openxmlformats.org/drawingml/2006/main">
               <a:ext uri="{FF2B5EF4-FFF2-40B4-BE49-F238E27FC236}">
-                <a16:creationId xmlns:a16="http://schemas.microsoft.com/office/drawing/2014/main" id="{E0FDE17C-9FBD-44D0-9600-C752506E50F4}"/>
+                <a16:creationId xmlns:a16="http://schemas.microsoft.com/office/drawing/2014/main" id="{660BA5C9-CEB8-41B3-9095-49AEAB67B6CD}"/>
               </a:ext>
             </a:extLst>
           </p:cNvPr>
@@ -4382,7 +4382,7 @@
           <p:cNvPr id="35" name="">
             <a:extLst xmlns:a="http://schemas.openxmlformats.org/drawingml/2006/main">
               <a:ext uri="{FF2B5EF4-FFF2-40B4-BE49-F238E27FC236}">
-                <a16:creationId xmlns:a16="http://schemas.microsoft.com/office/drawing/2014/main" id="{13123A46-38E0-4606-9B9E-DA06ED028DA4}"/>
+                <a16:creationId xmlns:a16="http://schemas.microsoft.com/office/drawing/2014/main" id="{09179440-125F-4768-BD42-A66BD27CEF8E}"/>
               </a:ext>
             </a:extLst>
           </p:cNvPr>
@@ -4417,7 +4417,7 @@
           <p:cNvPr id="36" name="">
             <a:extLst xmlns:a="http://schemas.openxmlformats.org/drawingml/2006/main">
               <a:ext uri="{FF2B5EF4-FFF2-40B4-BE49-F238E27FC236}">
-                <a16:creationId xmlns:a16="http://schemas.microsoft.com/office/drawing/2014/main" id="{16D38C7F-8DBD-4BAC-AA12-981BD802B696}"/>
+                <a16:creationId xmlns:a16="http://schemas.microsoft.com/office/drawing/2014/main" id="{974D0581-6E69-416C-86A5-7C6481E5993E}"/>
               </a:ext>
             </a:extLst>
           </p:cNvPr>
@@ -4452,7 +4452,7 @@
           <p:cNvPr id="37" name="">
             <a:extLst xmlns:a="http://schemas.openxmlformats.org/drawingml/2006/main">
               <a:ext uri="{FF2B5EF4-FFF2-40B4-BE49-F238E27FC236}">
-                <a16:creationId xmlns:a16="http://schemas.microsoft.com/office/drawing/2014/main" id="{1FF06058-F19F-4EFC-BFC5-86F17DE972EF}"/>
+                <a16:creationId xmlns:a16="http://schemas.microsoft.com/office/drawing/2014/main" id="{8807C312-0E6E-45F5-A6AA-2F271B6AC691}"/>
               </a:ext>
             </a:extLst>
           </p:cNvPr>
@@ -4502,7 +4502,7 @@
           <p:cNvPr id="38" name="">
             <a:extLst xmlns:a="http://schemas.openxmlformats.org/drawingml/2006/main">
               <a:ext uri="{FF2B5EF4-FFF2-40B4-BE49-F238E27FC236}">
-                <a16:creationId xmlns:a16="http://schemas.microsoft.com/office/drawing/2014/main" id="{9B8C663E-2996-43F9-A496-EB861978C95C}"/>
+                <a16:creationId xmlns:a16="http://schemas.microsoft.com/office/drawing/2014/main" id="{47D4CF19-154E-45F8-BD97-A1F89E8FFE66}"/>
               </a:ext>
             </a:extLst>
           </p:cNvPr>
@@ -4552,7 +4552,7 @@
           <p:cNvPr id="39" name="">
             <a:extLst xmlns:a="http://schemas.openxmlformats.org/drawingml/2006/main">
               <a:ext uri="{FF2B5EF4-FFF2-40B4-BE49-F238E27FC236}">
-                <a16:creationId xmlns:a16="http://schemas.microsoft.com/office/drawing/2014/main" id="{F8ED67E9-D55A-4B85-953E-E16A294B9841}"/>
+                <a16:creationId xmlns:a16="http://schemas.microsoft.com/office/drawing/2014/main" id="{B51DCEF8-E6AD-4C51-9CD1-16FC4E2C963F}"/>
               </a:ext>
             </a:extLst>
           </p:cNvPr>
@@ -4587,7 +4587,7 @@
           <p:cNvPr id="40" name="">
             <a:extLst xmlns:a="http://schemas.openxmlformats.org/drawingml/2006/main">
               <a:ext uri="{FF2B5EF4-FFF2-40B4-BE49-F238E27FC236}">
-                <a16:creationId xmlns:a16="http://schemas.microsoft.com/office/drawing/2014/main" id="{14E50F1A-7182-48F2-B5EB-1E34BDD2EFDD}"/>
+                <a16:creationId xmlns:a16="http://schemas.microsoft.com/office/drawing/2014/main" id="{738535B1-7274-4818-A1FF-2E9768FBF178}"/>
               </a:ext>
             </a:extLst>
           </p:cNvPr>
@@ -4622,7 +4622,7 @@
           <p:cNvPr id="41" name="">
             <a:extLst xmlns:a="http://schemas.openxmlformats.org/drawingml/2006/main">
               <a:ext uri="{FF2B5EF4-FFF2-40B4-BE49-F238E27FC236}">
-                <a16:creationId xmlns:a16="http://schemas.microsoft.com/office/drawing/2014/main" id="{96356744-B35E-4E55-B705-A692039D8664}"/>
+                <a16:creationId xmlns:a16="http://schemas.microsoft.com/office/drawing/2014/main" id="{B9CB87C1-2C32-4E0A-828B-25573D81FE20}"/>
               </a:ext>
             </a:extLst>
           </p:cNvPr>
@@ -4672,7 +4672,7 @@
           <p:cNvPr id="42" name="">
             <a:extLst xmlns:a="http://schemas.openxmlformats.org/drawingml/2006/main">
               <a:ext uri="{FF2B5EF4-FFF2-40B4-BE49-F238E27FC236}">
-                <a16:creationId xmlns:a16="http://schemas.microsoft.com/office/drawing/2014/main" id="{8A27F0D8-BA41-4147-9947-C80CDF62F85A}"/>
+                <a16:creationId xmlns:a16="http://schemas.microsoft.com/office/drawing/2014/main" id="{ED74ED9D-768E-4C5F-979A-6A0E4DDFA884}"/>
               </a:ext>
             </a:extLst>
           </p:cNvPr>
@@ -4722,7 +4722,7 @@
           <p:cNvPr id="43" name="">
             <a:extLst xmlns:a="http://schemas.openxmlformats.org/drawingml/2006/main">
               <a:ext uri="{FF2B5EF4-FFF2-40B4-BE49-F238E27FC236}">
-                <a16:creationId xmlns:a16="http://schemas.microsoft.com/office/drawing/2014/main" id="{32C500A7-17DB-4183-B5D0-CAF76BCA66BA}"/>
+                <a16:creationId xmlns:a16="http://schemas.microsoft.com/office/drawing/2014/main" id="{4EAC8890-AEF4-44A5-845B-064CA1E14865}"/>
               </a:ext>
             </a:extLst>
           </p:cNvPr>
@@ -4757,7 +4757,7 @@
           <p:cNvPr id="44" name="">
             <a:extLst xmlns:a="http://schemas.openxmlformats.org/drawingml/2006/main">
               <a:ext uri="{FF2B5EF4-FFF2-40B4-BE49-F238E27FC236}">
-                <a16:creationId xmlns:a16="http://schemas.microsoft.com/office/drawing/2014/main" id="{777EDB1F-45FB-44BC-8586-5FBDD6597A6F}"/>
+                <a16:creationId xmlns:a16="http://schemas.microsoft.com/office/drawing/2014/main" id="{9EEF02C8-60D1-4608-A0D3-5D93E05EA24A}"/>
               </a:ext>
             </a:extLst>
           </p:cNvPr>
@@ -4792,7 +4792,7 @@
           <p:cNvPr id="45" name="">
             <a:extLst xmlns:a="http://schemas.openxmlformats.org/drawingml/2006/main">
               <a:ext uri="{FF2B5EF4-FFF2-40B4-BE49-F238E27FC236}">
-                <a16:creationId xmlns:a16="http://schemas.microsoft.com/office/drawing/2014/main" id="{E25E6186-1C67-4E85-A5CC-31F1399546E8}"/>
+                <a16:creationId xmlns:a16="http://schemas.microsoft.com/office/drawing/2014/main" id="{379D8863-E851-4531-921E-E8BBBD3D66F0}"/>
               </a:ext>
             </a:extLst>
           </p:cNvPr>
@@ -4842,7 +4842,7 @@
           <p:cNvPr id="46" name="">
             <a:extLst xmlns:a="http://schemas.openxmlformats.org/drawingml/2006/main">
               <a:ext uri="{FF2B5EF4-FFF2-40B4-BE49-F238E27FC236}">
-                <a16:creationId xmlns:a16="http://schemas.microsoft.com/office/drawing/2014/main" id="{652635F6-126C-4C04-BBC9-293CF20A64C5}"/>
+                <a16:creationId xmlns:a16="http://schemas.microsoft.com/office/drawing/2014/main" id="{AFD06AF6-9FB8-4B3F-BB36-4E6C391C85CB}"/>
               </a:ext>
             </a:extLst>
           </p:cNvPr>
@@ -4892,7 +4892,7 @@
           <p:cNvPr id="47" name="">
             <a:extLst xmlns:a="http://schemas.openxmlformats.org/drawingml/2006/main">
               <a:ext uri="{FF2B5EF4-FFF2-40B4-BE49-F238E27FC236}">
-                <a16:creationId xmlns:a16="http://schemas.microsoft.com/office/drawing/2014/main" id="{8DEF794D-756C-47E8-BA1E-FF07ECE21373}"/>
+                <a16:creationId xmlns:a16="http://schemas.microsoft.com/office/drawing/2014/main" id="{CBD93BB2-EEAA-4B9E-90E2-4C241863979E}"/>
               </a:ext>
             </a:extLst>
           </p:cNvPr>
@@ -4927,7 +4927,7 @@
           <p:cNvPr id="48" name="">
             <a:extLst xmlns:a="http://schemas.openxmlformats.org/drawingml/2006/main">
               <a:ext uri="{FF2B5EF4-FFF2-40B4-BE49-F238E27FC236}">
-                <a16:creationId xmlns:a16="http://schemas.microsoft.com/office/drawing/2014/main" id="{DD2FCD06-D26B-488A-9600-858B72C2B015}"/>
+                <a16:creationId xmlns:a16="http://schemas.microsoft.com/office/drawing/2014/main" id="{25D1129E-CD5E-459A-95A0-70358C918A75}"/>
               </a:ext>
             </a:extLst>
           </p:cNvPr>
@@ -4962,7 +4962,7 @@
           <p:cNvPr id="49" name="">
             <a:extLst xmlns:a="http://schemas.openxmlformats.org/drawingml/2006/main">
               <a:ext uri="{FF2B5EF4-FFF2-40B4-BE49-F238E27FC236}">
-                <a16:creationId xmlns:a16="http://schemas.microsoft.com/office/drawing/2014/main" id="{731BB095-FEB7-4696-A26F-46885270A707}"/>
+                <a16:creationId xmlns:a16="http://schemas.microsoft.com/office/drawing/2014/main" id="{BCAF97C2-B5CF-429D-AB6C-2DA633C4C7A2}"/>
               </a:ext>
             </a:extLst>
           </p:cNvPr>
@@ -5012,7 +5012,7 @@
           <p:cNvPr id="50" name="">
             <a:extLst xmlns:a="http://schemas.openxmlformats.org/drawingml/2006/main">
               <a:ext uri="{FF2B5EF4-FFF2-40B4-BE49-F238E27FC236}">
-                <a16:creationId xmlns:a16="http://schemas.microsoft.com/office/drawing/2014/main" id="{7FF0FF48-1FFF-416D-8650-DE5E96CF0483}"/>
+                <a16:creationId xmlns:a16="http://schemas.microsoft.com/office/drawing/2014/main" id="{B57A5D24-F799-4FA7-A731-DD69E07448A8}"/>
               </a:ext>
             </a:extLst>
           </p:cNvPr>
@@ -5062,7 +5062,7 @@
           <p:cNvPr id="51" name="">
             <a:extLst xmlns:a="http://schemas.openxmlformats.org/drawingml/2006/main">
               <a:ext uri="{FF2B5EF4-FFF2-40B4-BE49-F238E27FC236}">
-                <a16:creationId xmlns:a16="http://schemas.microsoft.com/office/drawing/2014/main" id="{35BA8905-E379-4DBE-BC73-1A40EC313D47}"/>
+                <a16:creationId xmlns:a16="http://schemas.microsoft.com/office/drawing/2014/main" id="{BC5C30C3-045F-4A14-B439-83ABC1FE853B}"/>
               </a:ext>
             </a:extLst>
           </p:cNvPr>
@@ -5112,7 +5112,7 @@
           <p:cNvPr id="52" name="">
             <a:extLst xmlns:a="http://schemas.openxmlformats.org/drawingml/2006/main">
               <a:ext uri="{FF2B5EF4-FFF2-40B4-BE49-F238E27FC236}">
-                <a16:creationId xmlns:a16="http://schemas.microsoft.com/office/drawing/2014/main" id="{C09D68A4-5154-4723-96A5-E21D4546412F}"/>
+                <a16:creationId xmlns:a16="http://schemas.microsoft.com/office/drawing/2014/main" id="{DCF696CF-71F6-408E-8D6A-26D00BEB7609}"/>
               </a:ext>
             </a:extLst>
           </p:cNvPr>
@@ -5147,7 +5147,7 @@
           <p:cNvPr id="53" name="">
             <a:extLst xmlns:a="http://schemas.openxmlformats.org/drawingml/2006/main">
               <a:ext uri="{FF2B5EF4-FFF2-40B4-BE49-F238E27FC236}">
-                <a16:creationId xmlns:a16="http://schemas.microsoft.com/office/drawing/2014/main" id="{F5C93284-1BF5-4988-A0D5-488874FA1C95}"/>
+                <a16:creationId xmlns:a16="http://schemas.microsoft.com/office/drawing/2014/main" id="{B6D5B3AD-58D3-4272-94AF-7CA12E08FAD9}"/>
               </a:ext>
             </a:extLst>
           </p:cNvPr>
@@ -5182,7 +5182,7 @@
           <p:cNvPr id="54" name="">
             <a:extLst xmlns:a="http://schemas.openxmlformats.org/drawingml/2006/main">
               <a:ext uri="{FF2B5EF4-FFF2-40B4-BE49-F238E27FC236}">
-                <a16:creationId xmlns:a16="http://schemas.microsoft.com/office/drawing/2014/main" id="{585FC0D9-1120-4D01-A30F-EFC67AA56F60}"/>
+                <a16:creationId xmlns:a16="http://schemas.microsoft.com/office/drawing/2014/main" id="{9C30CAFA-D589-416B-B8A0-E3D180D4194E}"/>
               </a:ext>
             </a:extLst>
           </p:cNvPr>
@@ -5232,7 +5232,7 @@
           <p:cNvPr id="55" name="">
             <a:extLst xmlns:a="http://schemas.openxmlformats.org/drawingml/2006/main">
               <a:ext uri="{FF2B5EF4-FFF2-40B4-BE49-F238E27FC236}">
-                <a16:creationId xmlns:a16="http://schemas.microsoft.com/office/drawing/2014/main" id="{79792CAD-FCE6-4DA7-885C-4AA20AFEE478}"/>
+                <a16:creationId xmlns:a16="http://schemas.microsoft.com/office/drawing/2014/main" id="{99B42BC4-0975-4A59-988B-169B2BF03F71}"/>
               </a:ext>
             </a:extLst>
           </p:cNvPr>
@@ -5282,7 +5282,7 @@
           <p:cNvPr id="56" name="">
             <a:extLst xmlns:a="http://schemas.openxmlformats.org/drawingml/2006/main">
               <a:ext uri="{FF2B5EF4-FFF2-40B4-BE49-F238E27FC236}">
-                <a16:creationId xmlns:a16="http://schemas.microsoft.com/office/drawing/2014/main" id="{8F686092-F6CE-4F39-AF12-6109D179EA72}"/>
+                <a16:creationId xmlns:a16="http://schemas.microsoft.com/office/drawing/2014/main" id="{0EC9B9ED-3DDB-47CA-90C2-DD3685162177}"/>
               </a:ext>
             </a:extLst>
           </p:cNvPr>
@@ -5317,7 +5317,7 @@
           <p:cNvPr id="57" name="">
             <a:extLst xmlns:a="http://schemas.openxmlformats.org/drawingml/2006/main">
               <a:ext uri="{FF2B5EF4-FFF2-40B4-BE49-F238E27FC236}">
-                <a16:creationId xmlns:a16="http://schemas.microsoft.com/office/drawing/2014/main" id="{01256AD4-A90E-4053-9CFD-6EBA104B88E2}"/>
+                <a16:creationId xmlns:a16="http://schemas.microsoft.com/office/drawing/2014/main" id="{ADB9F2E7-9045-4593-A56E-005F5C6331E2}"/>
               </a:ext>
             </a:extLst>
           </p:cNvPr>
@@ -5352,7 +5352,7 @@
           <p:cNvPr id="58" name="">
             <a:extLst xmlns:a="http://schemas.openxmlformats.org/drawingml/2006/main">
               <a:ext uri="{FF2B5EF4-FFF2-40B4-BE49-F238E27FC236}">
-                <a16:creationId xmlns:a16="http://schemas.microsoft.com/office/drawing/2014/main" id="{ACFCECEE-CAC6-4672-99B2-C294661C5A21}"/>
+                <a16:creationId xmlns:a16="http://schemas.microsoft.com/office/drawing/2014/main" id="{7AD42378-980A-4D77-9A73-E3CAD3A52B33}"/>
               </a:ext>
             </a:extLst>
           </p:cNvPr>
@@ -5402,7 +5402,7 @@
           <p:cNvPr id="59" name="">
             <a:extLst xmlns:a="http://schemas.openxmlformats.org/drawingml/2006/main">
               <a:ext uri="{FF2B5EF4-FFF2-40B4-BE49-F238E27FC236}">
-                <a16:creationId xmlns:a16="http://schemas.microsoft.com/office/drawing/2014/main" id="{48BE6FFC-2B8D-4F2F-926D-1FD10A52CD8D}"/>
+                <a16:creationId xmlns:a16="http://schemas.microsoft.com/office/drawing/2014/main" id="{06042E9A-3F3C-469E-BE16-DB0BBEB610EF}"/>
               </a:ext>
             </a:extLst>
           </p:cNvPr>
@@ -5452,7 +5452,7 @@
           <p:cNvPr id="60" name="">
             <a:extLst xmlns:a="http://schemas.openxmlformats.org/drawingml/2006/main">
               <a:ext uri="{FF2B5EF4-FFF2-40B4-BE49-F238E27FC236}">
-                <a16:creationId xmlns:a16="http://schemas.microsoft.com/office/drawing/2014/main" id="{68AF5BE3-C9FA-45D9-A329-2644A3F9651A}"/>
+                <a16:creationId xmlns:a16="http://schemas.microsoft.com/office/drawing/2014/main" id="{22BD3E92-7822-400E-A32E-18964DD19578}"/>
               </a:ext>
             </a:extLst>
           </p:cNvPr>
@@ -5487,7 +5487,7 @@
           <p:cNvPr id="61" name="">
             <a:extLst xmlns:a="http://schemas.openxmlformats.org/drawingml/2006/main">
               <a:ext uri="{FF2B5EF4-FFF2-40B4-BE49-F238E27FC236}">
-                <a16:creationId xmlns:a16="http://schemas.microsoft.com/office/drawing/2014/main" id="{9E75B672-0C5A-48DF-B397-B24AEFDBFA48}"/>
+                <a16:creationId xmlns:a16="http://schemas.microsoft.com/office/drawing/2014/main" id="{063B059B-B8E1-4E1F-A5E5-9F8BB160E0BC}"/>
               </a:ext>
             </a:extLst>
           </p:cNvPr>
@@ -5522,7 +5522,7 @@
           <p:cNvPr id="62" name="">
             <a:extLst xmlns:a="http://schemas.openxmlformats.org/drawingml/2006/main">
               <a:ext uri="{FF2B5EF4-FFF2-40B4-BE49-F238E27FC236}">
-                <a16:creationId xmlns:a16="http://schemas.microsoft.com/office/drawing/2014/main" id="{ABB5E832-436B-466C-A3FB-1678AB3C700B}"/>
+                <a16:creationId xmlns:a16="http://schemas.microsoft.com/office/drawing/2014/main" id="{F4FFB051-001E-4485-A9AD-10A83D923761}"/>
               </a:ext>
             </a:extLst>
           </p:cNvPr>
@@ -5572,7 +5572,7 @@
           <p:cNvPr id="63" name="">
             <a:extLst xmlns:a="http://schemas.openxmlformats.org/drawingml/2006/main">
               <a:ext uri="{FF2B5EF4-FFF2-40B4-BE49-F238E27FC236}">
-                <a16:creationId xmlns:a16="http://schemas.microsoft.com/office/drawing/2014/main" id="{B192116F-08FF-461E-A2D2-04598581846D}"/>
+                <a16:creationId xmlns:a16="http://schemas.microsoft.com/office/drawing/2014/main" id="{12EB976D-BE85-4C4F-A59C-524822F37060}"/>
               </a:ext>
             </a:extLst>
           </p:cNvPr>
@@ -5622,7 +5622,7 @@
           <p:cNvPr id="64" name="">
             <a:extLst xmlns:a="http://schemas.openxmlformats.org/drawingml/2006/main">
               <a:ext uri="{FF2B5EF4-FFF2-40B4-BE49-F238E27FC236}">
-                <a16:creationId xmlns:a16="http://schemas.microsoft.com/office/drawing/2014/main" id="{29E9D22B-DD50-4DF1-862F-8F97744BFA85}"/>
+                <a16:creationId xmlns:a16="http://schemas.microsoft.com/office/drawing/2014/main" id="{8F709901-2AA8-48BF-8928-E9F5954DF983}"/>
               </a:ext>
             </a:extLst>
           </p:cNvPr>
@@ -5657,7 +5657,7 @@
           <p:cNvPr id="65" name="">
             <a:extLst xmlns:a="http://schemas.openxmlformats.org/drawingml/2006/main">
               <a:ext uri="{FF2B5EF4-FFF2-40B4-BE49-F238E27FC236}">
-                <a16:creationId xmlns:a16="http://schemas.microsoft.com/office/drawing/2014/main" id="{3CAD8FA1-559A-41CF-9202-65D84439A587}"/>
+                <a16:creationId xmlns:a16="http://schemas.microsoft.com/office/drawing/2014/main" id="{E8F8DA83-3D15-422B-88FF-D4B71D1E2207}"/>
               </a:ext>
             </a:extLst>
           </p:cNvPr>
@@ -5692,7 +5692,7 @@
           <p:cNvPr id="66" name="">
             <a:extLst xmlns:a="http://schemas.openxmlformats.org/drawingml/2006/main">
               <a:ext uri="{FF2B5EF4-FFF2-40B4-BE49-F238E27FC236}">
-                <a16:creationId xmlns:a16="http://schemas.microsoft.com/office/drawing/2014/main" id="{7BE7D098-36DB-4B2A-B721-60808A546C44}"/>
+                <a16:creationId xmlns:a16="http://schemas.microsoft.com/office/drawing/2014/main" id="{D3FE523E-96B0-4530-9B5B-63100CEE3AB2}"/>
               </a:ext>
             </a:extLst>
           </p:cNvPr>
@@ -5742,7 +5742,7 @@
           <p:cNvPr id="67" name="">
             <a:extLst xmlns:a="http://schemas.openxmlformats.org/drawingml/2006/main">
               <a:ext uri="{FF2B5EF4-FFF2-40B4-BE49-F238E27FC236}">
-                <a16:creationId xmlns:a16="http://schemas.microsoft.com/office/drawing/2014/main" id="{CB96565C-A6D9-4917-AF54-11C252FBA59B}"/>
+                <a16:creationId xmlns:a16="http://schemas.microsoft.com/office/drawing/2014/main" id="{C65186F7-6FA1-46B0-A438-3612748614E8}"/>
               </a:ext>
             </a:extLst>
           </p:cNvPr>
@@ -5792,7 +5792,7 @@
           <p:cNvPr id="68" name="">
             <a:extLst xmlns:a="http://schemas.openxmlformats.org/drawingml/2006/main">
               <a:ext uri="{FF2B5EF4-FFF2-40B4-BE49-F238E27FC236}">
-                <a16:creationId xmlns:a16="http://schemas.microsoft.com/office/drawing/2014/main" id="{0BC56F77-7186-459B-89E7-68FD2D5ED649}"/>
+                <a16:creationId xmlns:a16="http://schemas.microsoft.com/office/drawing/2014/main" id="{F65B2247-E91E-4653-95A6-C878B431F8E4}"/>
               </a:ext>
             </a:extLst>
           </p:cNvPr>
@@ -5827,7 +5827,7 @@
           <p:cNvPr id="69" name="">
             <a:extLst xmlns:a="http://schemas.openxmlformats.org/drawingml/2006/main">
               <a:ext uri="{FF2B5EF4-FFF2-40B4-BE49-F238E27FC236}">
-                <a16:creationId xmlns:a16="http://schemas.microsoft.com/office/drawing/2014/main" id="{99CB0402-A009-4CA6-8CE8-EEF18935FEFE}"/>
+                <a16:creationId xmlns:a16="http://schemas.microsoft.com/office/drawing/2014/main" id="{044E0195-BDE1-4A98-873A-8C45A4F6A379}"/>
               </a:ext>
             </a:extLst>
           </p:cNvPr>
@@ -5862,7 +5862,7 @@
           <p:cNvPr id="70" name="">
             <a:extLst xmlns:a="http://schemas.openxmlformats.org/drawingml/2006/main">
               <a:ext uri="{FF2B5EF4-FFF2-40B4-BE49-F238E27FC236}">
-                <a16:creationId xmlns:a16="http://schemas.microsoft.com/office/drawing/2014/main" id="{057C6420-726D-4720-8292-850A4DC5A43F}"/>
+                <a16:creationId xmlns:a16="http://schemas.microsoft.com/office/drawing/2014/main" id="{5D4BCA8F-D408-4413-9D73-20BF28252DA9}"/>
               </a:ext>
             </a:extLst>
           </p:cNvPr>
@@ -5912,7 +5912,7 @@
           <p:cNvPr id="71" name="">
             <a:extLst xmlns:a="http://schemas.openxmlformats.org/drawingml/2006/main">
               <a:ext uri="{FF2B5EF4-FFF2-40B4-BE49-F238E27FC236}">
-                <a16:creationId xmlns:a16="http://schemas.microsoft.com/office/drawing/2014/main" id="{2EC49B6C-975B-4AE3-9C0A-698710B11AD4}"/>
+                <a16:creationId xmlns:a16="http://schemas.microsoft.com/office/drawing/2014/main" id="{B9ED6363-8156-4427-851A-5C34CADDBA9C}"/>
               </a:ext>
             </a:extLst>
           </p:cNvPr>
@@ -5962,7 +5962,7 @@
           <p:cNvPr id="72" name="">
             <a:extLst xmlns:a="http://schemas.openxmlformats.org/drawingml/2006/main">
               <a:ext uri="{FF2B5EF4-FFF2-40B4-BE49-F238E27FC236}">
-                <a16:creationId xmlns:a16="http://schemas.microsoft.com/office/drawing/2014/main" id="{62CD50F4-1C7E-4469-AFA5-F3A969372FC7}"/>
+                <a16:creationId xmlns:a16="http://schemas.microsoft.com/office/drawing/2014/main" id="{85234841-690E-4730-BE3D-2DD613236253}"/>
               </a:ext>
             </a:extLst>
           </p:cNvPr>
@@ -6012,7 +6012,7 @@
           <p:cNvPr id="73" name="">
             <a:extLst xmlns:a="http://schemas.openxmlformats.org/drawingml/2006/main">
               <a:ext uri="{FF2B5EF4-FFF2-40B4-BE49-F238E27FC236}">
-                <a16:creationId xmlns:a16="http://schemas.microsoft.com/office/drawing/2014/main" id="{3E3DC42B-9790-4BFB-AEFE-4F090ADBDAED}"/>
+                <a16:creationId xmlns:a16="http://schemas.microsoft.com/office/drawing/2014/main" id="{B0647C4E-7A87-404A-AF5A-E0DDD23F0D6A}"/>
               </a:ext>
             </a:extLst>
           </p:cNvPr>
@@ -6060,7 +6060,7 @@
     </p:spTree>
     <p:extLst>
       <p:ext uri="{BB962C8B-B14F-4D97-AF65-F5344CB8AC3E}">
-        <p14:creationId xmlns:p14="http://schemas.microsoft.com/office/powerpoint/2010/main" val="557428003"/>
+        <p14:creationId xmlns:p14="http://schemas.microsoft.com/office/powerpoint/2010/main" val="1405342135"/>
       </p:ext>
     </p:extLst>
   </p:cSld>
@@ -6088,10 +6088,10 @@
       </p:grpSpPr>
       <p:sp>
         <p:nvSpPr>
-          <p:cNvPr id="37" name="">
-            <a:extLst xmlns:a="http://schemas.openxmlformats.org/drawingml/2006/main">
-              <a:ext uri="{FF2B5EF4-FFF2-40B4-BE49-F238E27FC236}">
-                <a16:creationId xmlns:a16="http://schemas.microsoft.com/office/drawing/2014/main" id="{6CEB4067-55CF-4BFF-AFED-CBDA99AF5AC8}"/>
+          <p:cNvPr id="63" name="">
+            <a:extLst xmlns:a="http://schemas.openxmlformats.org/drawingml/2006/main">
+              <a:ext uri="{FF2B5EF4-FFF2-40B4-BE49-F238E27FC236}">
+                <a16:creationId xmlns:a16="http://schemas.microsoft.com/office/drawing/2014/main" id="{28034EC1-CB92-4EC3-8712-DBE66350396A}"/>
               </a:ext>
             </a:extLst>
           </p:cNvPr>
@@ -6131,7 +6131,7 @@
                   <a:srgbClr val="7C3AED"/>
                 </a:solidFill>
               </a:rPr>
-              <a:t>AGE MIX IS A REAL HYPOTHESIS, BUT NOT YET THE AGE SPLIT WE NEED.</a:t>
+              <a:t>SUPPLIED AGE SPLIT</a:t>
             </a:r>
           </a:p>
         </p:txBody>
@@ -6141,7 +6141,7 @@
           <p:cNvPr id="2" name="">
             <a:extLst xmlns:a="http://schemas.openxmlformats.org/drawingml/2006/main">
               <a:ext uri="{FF2B5EF4-FFF2-40B4-BE49-F238E27FC236}">
-                <a16:creationId xmlns:a16="http://schemas.microsoft.com/office/drawing/2014/main" id="{F726E42B-D03B-4F57-891B-BB0295217F26}"/>
+                <a16:creationId xmlns:a16="http://schemas.microsoft.com/office/drawing/2014/main" id="{A30D3354-3D4D-4B37-9CE9-CAD955E9E35B}"/>
               </a:ext>
             </a:extLst>
           </p:cNvPr>
@@ -6181,7 +6181,7 @@
                   <a:srgbClr val="07111F"/>
                 </a:solidFill>
               </a:rPr>
-              <a:t>Q34 points to a sample-mix effect; Q17-Q19 age splits need raw data.</a:t>
+              <a:t>The promise can travel across ages; the competitor to beat changes.</a:t>
             </a:r>
           </a:p>
         </p:txBody>
@@ -6191,7 +6191,7 @@
           <p:cNvPr id="3" name="">
             <a:extLst xmlns:a="http://schemas.openxmlformats.org/drawingml/2006/main">
               <a:ext uri="{FF2B5EF4-FFF2-40B4-BE49-F238E27FC236}">
-                <a16:creationId xmlns:a16="http://schemas.microsoft.com/office/drawing/2014/main" id="{C796D053-FDD9-4988-AD05-DB9A155D6C75}"/>
+                <a16:creationId xmlns:a16="http://schemas.microsoft.com/office/drawing/2014/main" id="{694160A8-E8DB-422B-B4E2-082EECCCCF73}"/>
               </a:ext>
             </a:extLst>
           </p:cNvPr>
@@ -6231,7 +6231,7 @@
                   <a:srgbClr val="42526B"/>
                 </a:solidFill>
               </a:rPr>
-              <a:t>The Q2 sample is 80% 40+, up from 62% in Q4. That can contribute to broad aided-awareness softness, but it is not a substitute for a Q17-Q19 x age crosstab.</a:t>
+              <a:t>The supplied age-filtered exports are Q4 2025, not Q2 2026 Q17-Q19. They still show a useful directional read: under-40 is a Skims battle, while 40+ is a Spanx/Maidenform battle.</a:t>
             </a:r>
           </a:p>
         </p:txBody>
@@ -6241,29 +6241,131 @@
           <p:cNvPr id="4" name="">
             <a:extLst xmlns:a="http://schemas.openxmlformats.org/drawingml/2006/main">
               <a:ext uri="{FF2B5EF4-FFF2-40B4-BE49-F238E27FC236}">
-                <a16:creationId xmlns:a16="http://schemas.microsoft.com/office/drawing/2014/main" id="{B18CA5E2-70B8-413E-B447-3ED9AC836AA5}"/>
-              </a:ext>
-            </a:extLst>
-          </p:cNvPr>
-          <p:cNvSpPr>
-            <a:spLocks xmlns:a="http://schemas.openxmlformats.org/drawingml/2006/main" noGrp="1"/>
-          </p:cNvSpPr>
-          <p:nvPr/>
-        </p:nvSpPr>
-        <p:spPr>
-          <a:xfrm xmlns:a="http://schemas.openxmlformats.org/drawingml/2006/main">
-            <a:off x="1066800" y="2381250"/>
-            <a:ext cx="876300" cy="1363447"/>
-          </a:xfrm>
-          <a:prstGeom xmlns:a="http://schemas.openxmlformats.org/drawingml/2006/main" prst="rect">
-            <a:avLst/>
+                <a16:creationId xmlns:a16="http://schemas.microsoft.com/office/drawing/2014/main" id="{34580010-5A7B-4C94-BD31-FCA20FF3F034}"/>
+              </a:ext>
+            </a:extLst>
+          </p:cNvPr>
+          <p:cNvSpPr>
+            <a:spLocks xmlns:a="http://schemas.openxmlformats.org/drawingml/2006/main" noGrp="1"/>
+          </p:cNvSpPr>
+          <p:nvPr/>
+        </p:nvSpPr>
+        <p:spPr>
+          <a:xfrm xmlns:a="http://schemas.openxmlformats.org/drawingml/2006/main">
+            <a:off x="590550" y="2038350"/>
+            <a:ext cx="3048000" cy="228600"/>
+          </a:xfrm>
+          <a:prstGeom xmlns:a="http://schemas.openxmlformats.org/drawingml/2006/main" prst="rect">
+            <a:avLst/>
+          </a:prstGeom>
+          <a:noFill xmlns:a="http://schemas.openxmlformats.org/drawingml/2006/main"/>
+          <a:ln xmlns:a="http://schemas.openxmlformats.org/drawingml/2006/main" w="0">
+            <a:noFill/>
+            <a:prstDash val="solid"/>
+          </a:ln>
+        </p:spPr>
+        <p:txBody>
+          <a:bodyPr xmlns:a="http://schemas.openxmlformats.org/drawingml/2006/main"/>
+          <a:lstStyle xmlns:a="http://schemas.openxmlformats.org/drawingml/2006/main"/>
+          <a:p xmlns:a="http://schemas.openxmlformats.org/drawingml/2006/main">
+            <a:pPr>
+              <a:defRPr sz="1200" b="1">
+                <a:solidFill>
+                  <a:srgbClr val="7C3AED"/>
+                </a:solidFill>
+              </a:defRPr>
+            </a:pPr>
+            <a:r>
+              <a:rPr sz="1200" b="1">
+                <a:solidFill>
+                  <a:srgbClr val="7C3AED"/>
+                </a:solidFill>
+              </a:rPr>
+              <a:t>Shapermint read</a:t>
+            </a:r>
+          </a:p>
+        </p:txBody>
+      </p:sp>
+      <p:sp>
+        <p:nvSpPr>
+          <p:cNvPr id="5" name="">
+            <a:extLst xmlns:a="http://schemas.openxmlformats.org/drawingml/2006/main">
+              <a:ext uri="{FF2B5EF4-FFF2-40B4-BE49-F238E27FC236}">
+                <a16:creationId xmlns:a16="http://schemas.microsoft.com/office/drawing/2014/main" id="{6BA0BC39-D20B-4A7D-BA11-8D4B8C27E304}"/>
+              </a:ext>
+            </a:extLst>
+          </p:cNvPr>
+          <p:cNvSpPr>
+            <a:spLocks xmlns:a="http://schemas.openxmlformats.org/drawingml/2006/main" noGrp="1"/>
+          </p:cNvSpPr>
+          <p:nvPr/>
+        </p:nvSpPr>
+        <p:spPr>
+          <a:xfrm xmlns:a="http://schemas.openxmlformats.org/drawingml/2006/main">
+            <a:off x="590550" y="2400300"/>
+            <a:ext cx="1085850" cy="350520"/>
+          </a:xfrm>
+          <a:prstGeom xmlns:a="http://schemas.openxmlformats.org/drawingml/2006/main" prst="rect">
+            <a:avLst/>
+          </a:prstGeom>
+          <a:noFill xmlns:a="http://schemas.openxmlformats.org/drawingml/2006/main"/>
+          <a:ln xmlns:a="http://schemas.openxmlformats.org/drawingml/2006/main" w="0">
+            <a:noFill/>
+            <a:prstDash val="solid"/>
+          </a:ln>
+        </p:spPr>
+        <p:txBody>
+          <a:bodyPr xmlns:a="http://schemas.openxmlformats.org/drawingml/2006/main"/>
+          <a:lstStyle xmlns:a="http://schemas.openxmlformats.org/drawingml/2006/main"/>
+          <a:p xmlns:a="http://schemas.openxmlformats.org/drawingml/2006/main">
+            <a:pPr algn="r">
+              <a:defRPr sz="825">
+                <a:solidFill>
+                  <a:srgbClr val="42526B"/>
+                </a:solidFill>
+              </a:defRPr>
+            </a:pPr>
+            <a:r>
+              <a:rPr sz="825">
+                <a:solidFill>
+                  <a:srgbClr val="42526B"/>
+                </a:solidFill>
+              </a:rPr>
+              <a:t>Aided awareness</a:t>
+            </a:r>
+          </a:p>
+        </p:txBody>
+      </p:sp>
+      <p:sp>
+        <p:nvSpPr>
+          <p:cNvPr id="6" name="">
+            <a:extLst xmlns:a="http://schemas.openxmlformats.org/drawingml/2006/main">
+              <a:ext uri="{FF2B5EF4-FFF2-40B4-BE49-F238E27FC236}">
+                <a16:creationId xmlns:a16="http://schemas.microsoft.com/office/drawing/2014/main" id="{7E86BD51-337E-45AF-9091-BAA7CC54FD07}"/>
+              </a:ext>
+            </a:extLst>
+          </p:cNvPr>
+          <p:cNvSpPr>
+            <a:spLocks xmlns:a="http://schemas.openxmlformats.org/drawingml/2006/main" noGrp="1"/>
+          </p:cNvSpPr>
+          <p:nvPr/>
+        </p:nvSpPr>
+        <p:spPr>
+          <a:xfrm xmlns:a="http://schemas.openxmlformats.org/drawingml/2006/main">
+            <a:off x="1752600" y="2409825"/>
+            <a:ext cx="1628775" cy="293370"/>
+          </a:xfrm>
+          <a:prstGeom xmlns:a="http://schemas.openxmlformats.org/drawingml/2006/main" prst="roundRect">
+            <a:avLst>
+              <a:gd name="adj" fmla="val 6494"/>
+            </a:avLst>
           </a:prstGeom>
           <a:solidFill xmlns:a="http://schemas.openxmlformats.org/drawingml/2006/main">
-            <a:srgbClr val="D8CFC4"/>
+            <a:srgbClr val="F3ECE3"/>
           </a:solidFill>
           <a:ln xmlns:a="http://schemas.openxmlformats.org/drawingml/2006/main" w="0">
             <a:solidFill>
-              <a:srgbClr val="D8CFC4"/>
+              <a:srgbClr val="F3ECE3"/>
             </a:solidFill>
             <a:prstDash val="solid"/>
           </a:ln>
@@ -6271,25 +6373,27 @@
       </p:sp>
       <p:sp>
         <p:nvSpPr>
-          <p:cNvPr id="5" name="">
-            <a:extLst xmlns:a="http://schemas.openxmlformats.org/drawingml/2006/main">
-              <a:ext uri="{FF2B5EF4-FFF2-40B4-BE49-F238E27FC236}">
-                <a16:creationId xmlns:a16="http://schemas.microsoft.com/office/drawing/2014/main" id="{54B468F1-B1FE-42E4-BDFE-4C289BDA28E1}"/>
-              </a:ext>
-            </a:extLst>
-          </p:cNvPr>
-          <p:cNvSpPr>
-            <a:spLocks xmlns:a="http://schemas.openxmlformats.org/drawingml/2006/main" noGrp="1"/>
-          </p:cNvSpPr>
-          <p:nvPr/>
-        </p:nvSpPr>
-        <p:spPr>
-          <a:xfrm xmlns:a="http://schemas.openxmlformats.org/drawingml/2006/main">
-            <a:off x="1066800" y="3744697"/>
-            <a:ext cx="876300" cy="846353"/>
-          </a:xfrm>
-          <a:prstGeom xmlns:a="http://schemas.openxmlformats.org/drawingml/2006/main" prst="rect">
-            <a:avLst/>
+          <p:cNvPr id="7" name="">
+            <a:extLst xmlns:a="http://schemas.openxmlformats.org/drawingml/2006/main">
+              <a:ext uri="{FF2B5EF4-FFF2-40B4-BE49-F238E27FC236}">
+                <a16:creationId xmlns:a16="http://schemas.microsoft.com/office/drawing/2014/main" id="{A6844DEE-9323-4935-A77E-30D391450772}"/>
+              </a:ext>
+            </a:extLst>
+          </p:cNvPr>
+          <p:cNvSpPr>
+            <a:spLocks xmlns:a="http://schemas.openxmlformats.org/drawingml/2006/main" noGrp="1"/>
+          </p:cNvSpPr>
+          <p:nvPr/>
+        </p:nvSpPr>
+        <p:spPr>
+          <a:xfrm xmlns:a="http://schemas.openxmlformats.org/drawingml/2006/main">
+            <a:off x="1752600" y="2409825"/>
+            <a:ext cx="1189006" cy="293370"/>
+          </a:xfrm>
+          <a:prstGeom xmlns:a="http://schemas.openxmlformats.org/drawingml/2006/main" prst="roundRect">
+            <a:avLst>
+              <a:gd name="adj" fmla="val 6494"/>
+            </a:avLst>
           </a:prstGeom>
           <a:solidFill xmlns:a="http://schemas.openxmlformats.org/drawingml/2006/main">
             <a:srgbClr val="7C3AED"/>
@@ -6304,182 +6408,134 @@
       </p:sp>
       <p:sp>
         <p:nvSpPr>
-          <p:cNvPr id="6" name="">
-            <a:extLst xmlns:a="http://schemas.openxmlformats.org/drawingml/2006/main">
-              <a:ext uri="{FF2B5EF4-FFF2-40B4-BE49-F238E27FC236}">
-                <a16:creationId xmlns:a16="http://schemas.microsoft.com/office/drawing/2014/main" id="{F99EC0BE-CAAA-4019-B2E4-6498CE33FF50}"/>
-              </a:ext>
-            </a:extLst>
-          </p:cNvPr>
-          <p:cNvSpPr>
-            <a:spLocks xmlns:a="http://schemas.openxmlformats.org/drawingml/2006/main" noGrp="1"/>
-          </p:cNvSpPr>
-          <p:nvPr/>
-        </p:nvSpPr>
-        <p:spPr>
-          <a:xfrm xmlns:a="http://schemas.openxmlformats.org/drawingml/2006/main">
-            <a:off x="1066800" y="2628900"/>
-            <a:ext cx="876300" cy="190500"/>
-          </a:xfrm>
-          <a:prstGeom xmlns:a="http://schemas.openxmlformats.org/drawingml/2006/main" prst="rect">
-            <a:avLst/>
-          </a:prstGeom>
-          <a:noFill xmlns:a="http://schemas.openxmlformats.org/drawingml/2006/main"/>
-          <a:ln xmlns:a="http://schemas.openxmlformats.org/drawingml/2006/main" w="0">
-            <a:noFill/>
-            <a:prstDash val="solid"/>
-          </a:ln>
-        </p:spPr>
-        <p:txBody>
-          <a:bodyPr xmlns:a="http://schemas.openxmlformats.org/drawingml/2006/main"/>
-          <a:lstStyle xmlns:a="http://schemas.openxmlformats.org/drawingml/2006/main"/>
-          <a:p xmlns:a="http://schemas.openxmlformats.org/drawingml/2006/main">
-            <a:pPr algn="ctr">
-              <a:defRPr sz="1050" b="1">
+          <p:cNvPr id="8" name="">
+            <a:extLst xmlns:a="http://schemas.openxmlformats.org/drawingml/2006/main">
+              <a:ext uri="{FF2B5EF4-FFF2-40B4-BE49-F238E27FC236}">
+                <a16:creationId xmlns:a16="http://schemas.microsoft.com/office/drawing/2014/main" id="{26A7B6BC-ADA3-42D0-8B81-EFF1B297F610}"/>
+              </a:ext>
+            </a:extLst>
+          </p:cNvPr>
+          <p:cNvSpPr>
+            <a:spLocks xmlns:a="http://schemas.openxmlformats.org/drawingml/2006/main" noGrp="1"/>
+          </p:cNvSpPr>
+          <p:nvPr/>
+        </p:nvSpPr>
+        <p:spPr>
+          <a:xfrm xmlns:a="http://schemas.openxmlformats.org/drawingml/2006/main">
+            <a:off x="3017806" y="2419350"/>
+            <a:ext cx="419100" cy="350520"/>
+          </a:xfrm>
+          <a:prstGeom xmlns:a="http://schemas.openxmlformats.org/drawingml/2006/main" prst="rect">
+            <a:avLst/>
+          </a:prstGeom>
+          <a:noFill xmlns:a="http://schemas.openxmlformats.org/drawingml/2006/main"/>
+          <a:ln xmlns:a="http://schemas.openxmlformats.org/drawingml/2006/main" w="0">
+            <a:noFill/>
+            <a:prstDash val="solid"/>
+          </a:ln>
+        </p:spPr>
+        <p:txBody>
+          <a:bodyPr xmlns:a="http://schemas.openxmlformats.org/drawingml/2006/main"/>
+          <a:lstStyle xmlns:a="http://schemas.openxmlformats.org/drawingml/2006/main"/>
+          <a:p xmlns:a="http://schemas.openxmlformats.org/drawingml/2006/main">
+            <a:pPr>
+              <a:defRPr sz="900" b="1">
                 <a:solidFill>
                   <a:srgbClr val="07111F"/>
                 </a:solidFill>
               </a:defRPr>
             </a:pPr>
             <a:r>
-              <a:rPr sz="1050" b="1">
+              <a:rPr sz="900" b="1">
                 <a:solidFill>
                   <a:srgbClr val="07111F"/>
                 </a:solidFill>
               </a:rPr>
-              <a:t>62%</a:t>
-            </a:r>
-          </a:p>
-        </p:txBody>
-      </p:sp>
-      <p:sp>
-        <p:nvSpPr>
-          <p:cNvPr id="7" name="">
-            <a:extLst xmlns:a="http://schemas.openxmlformats.org/drawingml/2006/main">
-              <a:ext uri="{FF2B5EF4-FFF2-40B4-BE49-F238E27FC236}">
-                <a16:creationId xmlns:a16="http://schemas.microsoft.com/office/drawing/2014/main" id="{F7A39908-19E3-405B-9B50-7F7EF32B4942}"/>
-              </a:ext>
-            </a:extLst>
-          </p:cNvPr>
-          <p:cNvSpPr>
-            <a:spLocks xmlns:a="http://schemas.openxmlformats.org/drawingml/2006/main" noGrp="1"/>
-          </p:cNvSpPr>
-          <p:nvPr/>
-        </p:nvSpPr>
-        <p:spPr>
-          <a:xfrm xmlns:a="http://schemas.openxmlformats.org/drawingml/2006/main">
-            <a:off x="1066800" y="4072623"/>
-            <a:ext cx="876300" cy="190500"/>
-          </a:xfrm>
-          <a:prstGeom xmlns:a="http://schemas.openxmlformats.org/drawingml/2006/main" prst="rect">
-            <a:avLst/>
-          </a:prstGeom>
-          <a:noFill xmlns:a="http://schemas.openxmlformats.org/drawingml/2006/main"/>
-          <a:ln xmlns:a="http://schemas.openxmlformats.org/drawingml/2006/main" w="0">
-            <a:noFill/>
-            <a:prstDash val="solid"/>
-          </a:ln>
-        </p:spPr>
-        <p:txBody>
-          <a:bodyPr xmlns:a="http://schemas.openxmlformats.org/drawingml/2006/main"/>
-          <a:lstStyle xmlns:a="http://schemas.openxmlformats.org/drawingml/2006/main"/>
-          <a:p xmlns:a="http://schemas.openxmlformats.org/drawingml/2006/main">
-            <a:pPr algn="ctr">
-              <a:defRPr sz="1050" b="1">
-                <a:solidFill>
-                  <a:srgbClr val="FFFFFF"/>
-                </a:solidFill>
-              </a:defRPr>
-            </a:pPr>
-            <a:r>
-              <a:rPr sz="1050" b="1">
-                <a:solidFill>
-                  <a:srgbClr val="FFFFFF"/>
-                </a:solidFill>
-              </a:rPr>
-              <a:t>38%</a:t>
-            </a:r>
-          </a:p>
-        </p:txBody>
-      </p:sp>
-      <p:sp>
-        <p:nvSpPr>
-          <p:cNvPr id="8" name="">
-            <a:extLst xmlns:a="http://schemas.openxmlformats.org/drawingml/2006/main">
-              <a:ext uri="{FF2B5EF4-FFF2-40B4-BE49-F238E27FC236}">
-                <a16:creationId xmlns:a16="http://schemas.microsoft.com/office/drawing/2014/main" id="{193C22F4-DCA0-48A8-AB68-FDB62A4F5FBF}"/>
-              </a:ext>
-            </a:extLst>
-          </p:cNvPr>
-          <p:cNvSpPr>
-            <a:spLocks xmlns:a="http://schemas.openxmlformats.org/drawingml/2006/main" noGrp="1"/>
-          </p:cNvSpPr>
-          <p:nvPr/>
-        </p:nvSpPr>
-        <p:spPr>
-          <a:xfrm xmlns:a="http://schemas.openxmlformats.org/drawingml/2006/main">
-            <a:off x="990600" y="4762500"/>
-            <a:ext cx="1028700" cy="209550"/>
-          </a:xfrm>
-          <a:prstGeom xmlns:a="http://schemas.openxmlformats.org/drawingml/2006/main" prst="rect">
-            <a:avLst/>
-          </a:prstGeom>
-          <a:noFill xmlns:a="http://schemas.openxmlformats.org/drawingml/2006/main"/>
-          <a:ln xmlns:a="http://schemas.openxmlformats.org/drawingml/2006/main" w="0">
-            <a:noFill/>
-            <a:prstDash val="solid"/>
-          </a:ln>
-        </p:spPr>
-        <p:txBody>
-          <a:bodyPr xmlns:a="http://schemas.openxmlformats.org/drawingml/2006/main"/>
-          <a:lstStyle xmlns:a="http://schemas.openxmlformats.org/drawingml/2006/main"/>
-          <a:p xmlns:a="http://schemas.openxmlformats.org/drawingml/2006/main">
-            <a:pPr algn="ctr">
-              <a:defRPr sz="1050">
+              <a:t>51%</a:t>
+            </a:r>
+          </a:p>
+        </p:txBody>
+      </p:sp>
+      <p:sp>
+        <p:nvSpPr>
+          <p:cNvPr id="9" name="">
+            <a:extLst xmlns:a="http://schemas.openxmlformats.org/drawingml/2006/main">
+              <a:ext uri="{FF2B5EF4-FFF2-40B4-BE49-F238E27FC236}">
+                <a16:creationId xmlns:a16="http://schemas.microsoft.com/office/drawing/2014/main" id="{6CCF073A-2B4B-4963-AA61-DC75B18DE88A}"/>
+              </a:ext>
+            </a:extLst>
+          </p:cNvPr>
+          <p:cNvSpPr>
+            <a:spLocks xmlns:a="http://schemas.openxmlformats.org/drawingml/2006/main" noGrp="1"/>
+          </p:cNvSpPr>
+          <p:nvPr/>
+        </p:nvSpPr>
+        <p:spPr>
+          <a:xfrm xmlns:a="http://schemas.openxmlformats.org/drawingml/2006/main">
+            <a:off x="590550" y="2846070"/>
+            <a:ext cx="1085850" cy="350520"/>
+          </a:xfrm>
+          <a:prstGeom xmlns:a="http://schemas.openxmlformats.org/drawingml/2006/main" prst="rect">
+            <a:avLst/>
+          </a:prstGeom>
+          <a:noFill xmlns:a="http://schemas.openxmlformats.org/drawingml/2006/main"/>
+          <a:ln xmlns:a="http://schemas.openxmlformats.org/drawingml/2006/main" w="0">
+            <a:noFill/>
+            <a:prstDash val="solid"/>
+          </a:ln>
+        </p:spPr>
+        <p:txBody>
+          <a:bodyPr xmlns:a="http://schemas.openxmlformats.org/drawingml/2006/main"/>
+          <a:lstStyle xmlns:a="http://schemas.openxmlformats.org/drawingml/2006/main"/>
+          <a:p xmlns:a="http://schemas.openxmlformats.org/drawingml/2006/main">
+            <a:pPr algn="r">
+              <a:defRPr sz="825">
                 <a:solidFill>
                   <a:srgbClr val="42526B"/>
                 </a:solidFill>
               </a:defRPr>
             </a:pPr>
             <a:r>
-              <a:rPr sz="1050">
+              <a:rPr sz="825">
                 <a:solidFill>
                   <a:srgbClr val="42526B"/>
                 </a:solidFill>
               </a:rPr>
-              <a:t>Q4 '25</a:t>
-            </a:r>
-          </a:p>
-        </p:txBody>
-      </p:sp>
-      <p:sp>
-        <p:nvSpPr>
-          <p:cNvPr id="9" name="">
-            <a:extLst xmlns:a="http://schemas.openxmlformats.org/drawingml/2006/main">
-              <a:ext uri="{FF2B5EF4-FFF2-40B4-BE49-F238E27FC236}">
-                <a16:creationId xmlns:a16="http://schemas.microsoft.com/office/drawing/2014/main" id="{BE1C33F0-7116-4323-B00D-DAA38B3AAFA3}"/>
-              </a:ext>
-            </a:extLst>
-          </p:cNvPr>
-          <p:cNvSpPr>
-            <a:spLocks xmlns:a="http://schemas.openxmlformats.org/drawingml/2006/main" noGrp="1"/>
-          </p:cNvSpPr>
-          <p:nvPr/>
-        </p:nvSpPr>
-        <p:spPr>
-          <a:xfrm xmlns:a="http://schemas.openxmlformats.org/drawingml/2006/main">
-            <a:off x="2505075" y="2381250"/>
-            <a:ext cx="876300" cy="1575587"/>
-          </a:xfrm>
-          <a:prstGeom xmlns:a="http://schemas.openxmlformats.org/drawingml/2006/main" prst="rect">
-            <a:avLst/>
+              <a:t>Serious consideration</a:t>
+            </a:r>
+          </a:p>
+        </p:txBody>
+      </p:sp>
+      <p:sp>
+        <p:nvSpPr>
+          <p:cNvPr id="10" name="">
+            <a:extLst xmlns:a="http://schemas.openxmlformats.org/drawingml/2006/main">
+              <a:ext uri="{FF2B5EF4-FFF2-40B4-BE49-F238E27FC236}">
+                <a16:creationId xmlns:a16="http://schemas.microsoft.com/office/drawing/2014/main" id="{B97BC4D9-BB9D-46D0-8D6C-350BACA124F8}"/>
+              </a:ext>
+            </a:extLst>
+          </p:cNvPr>
+          <p:cNvSpPr>
+            <a:spLocks xmlns:a="http://schemas.openxmlformats.org/drawingml/2006/main" noGrp="1"/>
+          </p:cNvSpPr>
+          <p:nvPr/>
+        </p:nvSpPr>
+        <p:spPr>
+          <a:xfrm xmlns:a="http://schemas.openxmlformats.org/drawingml/2006/main">
+            <a:off x="1752600" y="2855595"/>
+            <a:ext cx="1628775" cy="293370"/>
+          </a:xfrm>
+          <a:prstGeom xmlns:a="http://schemas.openxmlformats.org/drawingml/2006/main" prst="roundRect">
+            <a:avLst>
+              <a:gd name="adj" fmla="val 6494"/>
+            </a:avLst>
           </a:prstGeom>
           <a:solidFill xmlns:a="http://schemas.openxmlformats.org/drawingml/2006/main">
-            <a:srgbClr val="D8CFC4"/>
+            <a:srgbClr val="F3ECE3"/>
           </a:solidFill>
           <a:ln xmlns:a="http://schemas.openxmlformats.org/drawingml/2006/main" w="0">
             <a:solidFill>
-              <a:srgbClr val="D8CFC4"/>
+              <a:srgbClr val="F3ECE3"/>
             </a:solidFill>
             <a:prstDash val="solid"/>
           </a:ln>
@@ -6487,25 +6543,27 @@
       </p:sp>
       <p:sp>
         <p:nvSpPr>
-          <p:cNvPr id="10" name="">
-            <a:extLst xmlns:a="http://schemas.openxmlformats.org/drawingml/2006/main">
-              <a:ext uri="{FF2B5EF4-FFF2-40B4-BE49-F238E27FC236}">
-                <a16:creationId xmlns:a16="http://schemas.microsoft.com/office/drawing/2014/main" id="{3082AB83-AE98-438D-AA30-78D3BFF455E5}"/>
-              </a:ext>
-            </a:extLst>
-          </p:cNvPr>
-          <p:cNvSpPr>
-            <a:spLocks xmlns:a="http://schemas.openxmlformats.org/drawingml/2006/main" noGrp="1"/>
-          </p:cNvSpPr>
-          <p:nvPr/>
-        </p:nvSpPr>
-        <p:spPr>
-          <a:xfrm xmlns:a="http://schemas.openxmlformats.org/drawingml/2006/main">
-            <a:off x="2505075" y="3956837"/>
-            <a:ext cx="876300" cy="634213"/>
-          </a:xfrm>
-          <a:prstGeom xmlns:a="http://schemas.openxmlformats.org/drawingml/2006/main" prst="rect">
-            <a:avLst/>
+          <p:cNvPr id="11" name="">
+            <a:extLst xmlns:a="http://schemas.openxmlformats.org/drawingml/2006/main">
+              <a:ext uri="{FF2B5EF4-FFF2-40B4-BE49-F238E27FC236}">
+                <a16:creationId xmlns:a16="http://schemas.microsoft.com/office/drawing/2014/main" id="{D0DA6E73-C9E7-4498-9EA3-4666FBBD8572}"/>
+              </a:ext>
+            </a:extLst>
+          </p:cNvPr>
+          <p:cNvSpPr>
+            <a:spLocks xmlns:a="http://schemas.openxmlformats.org/drawingml/2006/main" noGrp="1"/>
+          </p:cNvSpPr>
+          <p:nvPr/>
+        </p:nvSpPr>
+        <p:spPr>
+          <a:xfrm xmlns:a="http://schemas.openxmlformats.org/drawingml/2006/main">
+            <a:off x="1752600" y="2855595"/>
+            <a:ext cx="616608" cy="293370"/>
+          </a:xfrm>
+          <a:prstGeom xmlns:a="http://schemas.openxmlformats.org/drawingml/2006/main" prst="roundRect">
+            <a:avLst>
+              <a:gd name="adj" fmla="val 6494"/>
+            </a:avLst>
           </a:prstGeom>
           <a:solidFill xmlns:a="http://schemas.openxmlformats.org/drawingml/2006/main">
             <a:srgbClr val="7C3AED"/>
@@ -6520,100 +6578,50 @@
       </p:sp>
       <p:sp>
         <p:nvSpPr>
-          <p:cNvPr id="11" name="">
-            <a:extLst xmlns:a="http://schemas.openxmlformats.org/drawingml/2006/main">
-              <a:ext uri="{FF2B5EF4-FFF2-40B4-BE49-F238E27FC236}">
-                <a16:creationId xmlns:a16="http://schemas.microsoft.com/office/drawing/2014/main" id="{AB7622CD-E1DC-4AEF-80E4-7CB659EF5103}"/>
-              </a:ext>
-            </a:extLst>
-          </p:cNvPr>
-          <p:cNvSpPr>
-            <a:spLocks xmlns:a="http://schemas.openxmlformats.org/drawingml/2006/main" noGrp="1"/>
-          </p:cNvSpPr>
-          <p:nvPr/>
-        </p:nvSpPr>
-        <p:spPr>
-          <a:xfrm xmlns:a="http://schemas.openxmlformats.org/drawingml/2006/main">
-            <a:off x="2505075" y="2628900"/>
-            <a:ext cx="876300" cy="190500"/>
-          </a:xfrm>
-          <a:prstGeom xmlns:a="http://schemas.openxmlformats.org/drawingml/2006/main" prst="rect">
-            <a:avLst/>
-          </a:prstGeom>
-          <a:noFill xmlns:a="http://schemas.openxmlformats.org/drawingml/2006/main"/>
-          <a:ln xmlns:a="http://schemas.openxmlformats.org/drawingml/2006/main" w="0">
-            <a:noFill/>
-            <a:prstDash val="solid"/>
-          </a:ln>
-        </p:spPr>
-        <p:txBody>
-          <a:bodyPr xmlns:a="http://schemas.openxmlformats.org/drawingml/2006/main"/>
-          <a:lstStyle xmlns:a="http://schemas.openxmlformats.org/drawingml/2006/main"/>
-          <a:p xmlns:a="http://schemas.openxmlformats.org/drawingml/2006/main">
-            <a:pPr algn="ctr">
-              <a:defRPr sz="1050" b="1">
+          <p:cNvPr id="12" name="">
+            <a:extLst xmlns:a="http://schemas.openxmlformats.org/drawingml/2006/main">
+              <a:ext uri="{FF2B5EF4-FFF2-40B4-BE49-F238E27FC236}">
+                <a16:creationId xmlns:a16="http://schemas.microsoft.com/office/drawing/2014/main" id="{C68F347A-F842-498F-8D88-3B3A36319974}"/>
+              </a:ext>
+            </a:extLst>
+          </p:cNvPr>
+          <p:cNvSpPr>
+            <a:spLocks xmlns:a="http://schemas.openxmlformats.org/drawingml/2006/main" noGrp="1"/>
+          </p:cNvSpPr>
+          <p:nvPr/>
+        </p:nvSpPr>
+        <p:spPr>
+          <a:xfrm xmlns:a="http://schemas.openxmlformats.org/drawingml/2006/main">
+            <a:off x="2445408" y="2865120"/>
+            <a:ext cx="419100" cy="350520"/>
+          </a:xfrm>
+          <a:prstGeom xmlns:a="http://schemas.openxmlformats.org/drawingml/2006/main" prst="rect">
+            <a:avLst/>
+          </a:prstGeom>
+          <a:noFill xmlns:a="http://schemas.openxmlformats.org/drawingml/2006/main"/>
+          <a:ln xmlns:a="http://schemas.openxmlformats.org/drawingml/2006/main" w="0">
+            <a:noFill/>
+            <a:prstDash val="solid"/>
+          </a:ln>
+        </p:spPr>
+        <p:txBody>
+          <a:bodyPr xmlns:a="http://schemas.openxmlformats.org/drawingml/2006/main"/>
+          <a:lstStyle xmlns:a="http://schemas.openxmlformats.org/drawingml/2006/main"/>
+          <a:p xmlns:a="http://schemas.openxmlformats.org/drawingml/2006/main">
+            <a:pPr>
+              <a:defRPr sz="900" b="1">
                 <a:solidFill>
                   <a:srgbClr val="07111F"/>
                 </a:solidFill>
               </a:defRPr>
             </a:pPr>
             <a:r>
-              <a:rPr sz="1050" b="1">
+              <a:rPr sz="900" b="1">
                 <a:solidFill>
                   <a:srgbClr val="07111F"/>
                 </a:solidFill>
               </a:rPr>
-              <a:t>71%</a:t>
-            </a:r>
-          </a:p>
-        </p:txBody>
-      </p:sp>
-      <p:sp>
-        <p:nvSpPr>
-          <p:cNvPr id="12" name="">
-            <a:extLst xmlns:a="http://schemas.openxmlformats.org/drawingml/2006/main">
-              <a:ext uri="{FF2B5EF4-FFF2-40B4-BE49-F238E27FC236}">
-                <a16:creationId xmlns:a16="http://schemas.microsoft.com/office/drawing/2014/main" id="{05D3CF59-F936-478D-BCC0-D5D055D40705}"/>
-              </a:ext>
-            </a:extLst>
-          </p:cNvPr>
-          <p:cNvSpPr>
-            <a:spLocks xmlns:a="http://schemas.openxmlformats.org/drawingml/2006/main" noGrp="1"/>
-          </p:cNvSpPr>
-          <p:nvPr/>
-        </p:nvSpPr>
-        <p:spPr>
-          <a:xfrm xmlns:a="http://schemas.openxmlformats.org/drawingml/2006/main">
-            <a:off x="2505075" y="4178694"/>
-            <a:ext cx="876300" cy="190500"/>
-          </a:xfrm>
-          <a:prstGeom xmlns:a="http://schemas.openxmlformats.org/drawingml/2006/main" prst="rect">
-            <a:avLst/>
-          </a:prstGeom>
-          <a:noFill xmlns:a="http://schemas.openxmlformats.org/drawingml/2006/main"/>
-          <a:ln xmlns:a="http://schemas.openxmlformats.org/drawingml/2006/main" w="0">
-            <a:noFill/>
-            <a:prstDash val="solid"/>
-          </a:ln>
-        </p:spPr>
-        <p:txBody>
-          <a:bodyPr xmlns:a="http://schemas.openxmlformats.org/drawingml/2006/main"/>
-          <a:lstStyle xmlns:a="http://schemas.openxmlformats.org/drawingml/2006/main"/>
-          <a:p xmlns:a="http://schemas.openxmlformats.org/drawingml/2006/main">
-            <a:pPr algn="ctr">
-              <a:defRPr sz="1050" b="1">
-                <a:solidFill>
-                  <a:srgbClr val="FFFFFF"/>
-                </a:solidFill>
-              </a:defRPr>
-            </a:pPr>
-            <a:r>
-              <a:rPr sz="1050" b="1">
-                <a:solidFill>
-                  <a:srgbClr val="FFFFFF"/>
-                </a:solidFill>
-              </a:rPr>
-              <a:t>29%</a:t>
+              <a:t>27%</a:t>
             </a:r>
           </a:p>
         </p:txBody>
@@ -6623,47 +6631,47 @@
           <p:cNvPr id="13" name="">
             <a:extLst xmlns:a="http://schemas.openxmlformats.org/drawingml/2006/main">
               <a:ext uri="{FF2B5EF4-FFF2-40B4-BE49-F238E27FC236}">
-                <a16:creationId xmlns:a16="http://schemas.microsoft.com/office/drawing/2014/main" id="{12630004-032E-44B6-A4E2-4B69EC5A9409}"/>
-              </a:ext>
-            </a:extLst>
-          </p:cNvPr>
-          <p:cNvSpPr>
-            <a:spLocks xmlns:a="http://schemas.openxmlformats.org/drawingml/2006/main" noGrp="1"/>
-          </p:cNvSpPr>
-          <p:nvPr/>
-        </p:nvSpPr>
-        <p:spPr>
-          <a:xfrm xmlns:a="http://schemas.openxmlformats.org/drawingml/2006/main">
-            <a:off x="2428875" y="4762500"/>
-            <a:ext cx="1028700" cy="209550"/>
-          </a:xfrm>
-          <a:prstGeom xmlns:a="http://schemas.openxmlformats.org/drawingml/2006/main" prst="rect">
-            <a:avLst/>
-          </a:prstGeom>
-          <a:noFill xmlns:a="http://schemas.openxmlformats.org/drawingml/2006/main"/>
-          <a:ln xmlns:a="http://schemas.openxmlformats.org/drawingml/2006/main" w="0">
-            <a:noFill/>
-            <a:prstDash val="solid"/>
-          </a:ln>
-        </p:spPr>
-        <p:txBody>
-          <a:bodyPr xmlns:a="http://schemas.openxmlformats.org/drawingml/2006/main"/>
-          <a:lstStyle xmlns:a="http://schemas.openxmlformats.org/drawingml/2006/main"/>
-          <a:p xmlns:a="http://schemas.openxmlformats.org/drawingml/2006/main">
-            <a:pPr algn="ctr">
-              <a:defRPr sz="1050">
+                <a16:creationId xmlns:a16="http://schemas.microsoft.com/office/drawing/2014/main" id="{90E35F8E-5A84-4130-85FE-D331402E6153}"/>
+              </a:ext>
+            </a:extLst>
+          </p:cNvPr>
+          <p:cNvSpPr>
+            <a:spLocks xmlns:a="http://schemas.openxmlformats.org/drawingml/2006/main" noGrp="1"/>
+          </p:cNvSpPr>
+          <p:nvPr/>
+        </p:nvSpPr>
+        <p:spPr>
+          <a:xfrm xmlns:a="http://schemas.openxmlformats.org/drawingml/2006/main">
+            <a:off x="590550" y="3291840"/>
+            <a:ext cx="1085850" cy="350520"/>
+          </a:xfrm>
+          <a:prstGeom xmlns:a="http://schemas.openxmlformats.org/drawingml/2006/main" prst="rect">
+            <a:avLst/>
+          </a:prstGeom>
+          <a:noFill xmlns:a="http://schemas.openxmlformats.org/drawingml/2006/main"/>
+          <a:ln xmlns:a="http://schemas.openxmlformats.org/drawingml/2006/main" w="0">
+            <a:noFill/>
+            <a:prstDash val="solid"/>
+          </a:ln>
+        </p:spPr>
+        <p:txBody>
+          <a:bodyPr xmlns:a="http://schemas.openxmlformats.org/drawingml/2006/main"/>
+          <a:lstStyle xmlns:a="http://schemas.openxmlformats.org/drawingml/2006/main"/>
+          <a:p xmlns:a="http://schemas.openxmlformats.org/drawingml/2006/main">
+            <a:pPr algn="r">
+              <a:defRPr sz="825">
                 <a:solidFill>
                   <a:srgbClr val="42526B"/>
                 </a:solidFill>
               </a:defRPr>
             </a:pPr>
             <a:r>
-              <a:rPr sz="1050">
+              <a:rPr sz="825">
                 <a:solidFill>
                   <a:srgbClr val="42526B"/>
                 </a:solidFill>
               </a:rPr>
-              <a:t>Q1 '26</a:t>
+              <a:t>Choose Shapermint</a:t>
             </a:r>
           </a:p>
         </p:txBody>
@@ -6673,29 +6681,31 @@
           <p:cNvPr id="14" name="">
             <a:extLst xmlns:a="http://schemas.openxmlformats.org/drawingml/2006/main">
               <a:ext uri="{FF2B5EF4-FFF2-40B4-BE49-F238E27FC236}">
-                <a16:creationId xmlns:a16="http://schemas.microsoft.com/office/drawing/2014/main" id="{99D287D7-25CC-4EDD-A9CC-DCB3DEAC33DA}"/>
-              </a:ext>
-            </a:extLst>
-          </p:cNvPr>
-          <p:cNvSpPr>
-            <a:spLocks xmlns:a="http://schemas.openxmlformats.org/drawingml/2006/main" noGrp="1"/>
-          </p:cNvSpPr>
-          <p:nvPr/>
-        </p:nvSpPr>
-        <p:spPr>
-          <a:xfrm xmlns:a="http://schemas.openxmlformats.org/drawingml/2006/main">
-            <a:off x="3943350" y="2381250"/>
-            <a:ext cx="876300" cy="1763420"/>
-          </a:xfrm>
-          <a:prstGeom xmlns:a="http://schemas.openxmlformats.org/drawingml/2006/main" prst="rect">
-            <a:avLst/>
+                <a16:creationId xmlns:a16="http://schemas.microsoft.com/office/drawing/2014/main" id="{71379CA6-BD51-4DF8-9A73-E49A3D772F09}"/>
+              </a:ext>
+            </a:extLst>
+          </p:cNvPr>
+          <p:cNvSpPr>
+            <a:spLocks xmlns:a="http://schemas.openxmlformats.org/drawingml/2006/main" noGrp="1"/>
+          </p:cNvSpPr>
+          <p:nvPr/>
+        </p:nvSpPr>
+        <p:spPr>
+          <a:xfrm xmlns:a="http://schemas.openxmlformats.org/drawingml/2006/main">
+            <a:off x="1752600" y="3301365"/>
+            <a:ext cx="1628775" cy="293370"/>
+          </a:xfrm>
+          <a:prstGeom xmlns:a="http://schemas.openxmlformats.org/drawingml/2006/main" prst="roundRect">
+            <a:avLst>
+              <a:gd name="adj" fmla="val 6494"/>
+            </a:avLst>
           </a:prstGeom>
           <a:solidFill xmlns:a="http://schemas.openxmlformats.org/drawingml/2006/main">
-            <a:srgbClr val="D8CFC4"/>
+            <a:srgbClr val="F3ECE3"/>
           </a:solidFill>
           <a:ln xmlns:a="http://schemas.openxmlformats.org/drawingml/2006/main" w="0">
             <a:solidFill>
-              <a:srgbClr val="D8CFC4"/>
+              <a:srgbClr val="F3ECE3"/>
             </a:solidFill>
             <a:prstDash val="solid"/>
           </a:ln>
@@ -6706,22 +6716,24 @@
           <p:cNvPr id="15" name="">
             <a:extLst xmlns:a="http://schemas.openxmlformats.org/drawingml/2006/main">
               <a:ext uri="{FF2B5EF4-FFF2-40B4-BE49-F238E27FC236}">
-                <a16:creationId xmlns:a16="http://schemas.microsoft.com/office/drawing/2014/main" id="{DFF1A2C5-4828-418A-BC98-47021B17EFC0}"/>
-              </a:ext>
-            </a:extLst>
-          </p:cNvPr>
-          <p:cNvSpPr>
-            <a:spLocks xmlns:a="http://schemas.openxmlformats.org/drawingml/2006/main" noGrp="1"/>
-          </p:cNvSpPr>
-          <p:nvPr/>
-        </p:nvSpPr>
-        <p:spPr>
-          <a:xfrm xmlns:a="http://schemas.openxmlformats.org/drawingml/2006/main">
-            <a:off x="3943350" y="4144670"/>
-            <a:ext cx="876300" cy="446380"/>
-          </a:xfrm>
-          <a:prstGeom xmlns:a="http://schemas.openxmlformats.org/drawingml/2006/main" prst="rect">
-            <a:avLst/>
+                <a16:creationId xmlns:a16="http://schemas.microsoft.com/office/drawing/2014/main" id="{43417D1C-89C5-4D09-8AF3-6510A55D8FBB}"/>
+              </a:ext>
+            </a:extLst>
+          </p:cNvPr>
+          <p:cNvSpPr>
+            <a:spLocks xmlns:a="http://schemas.openxmlformats.org/drawingml/2006/main" noGrp="1"/>
+          </p:cNvSpPr>
+          <p:nvPr/>
+        </p:nvSpPr>
+        <p:spPr>
+          <a:xfrm xmlns:a="http://schemas.openxmlformats.org/drawingml/2006/main">
+            <a:off x="1752600" y="3301365"/>
+            <a:ext cx="148917" cy="293370"/>
+          </a:xfrm>
+          <a:prstGeom xmlns:a="http://schemas.openxmlformats.org/drawingml/2006/main" prst="roundRect">
+            <a:avLst>
+              <a:gd name="adj" fmla="val 12792"/>
+            </a:avLst>
           </a:prstGeom>
           <a:solidFill xmlns:a="http://schemas.openxmlformats.org/drawingml/2006/main">
             <a:srgbClr val="7C3AED"/>
@@ -6739,19 +6751,409 @@
           <p:cNvPr id="16" name="">
             <a:extLst xmlns:a="http://schemas.openxmlformats.org/drawingml/2006/main">
               <a:ext uri="{FF2B5EF4-FFF2-40B4-BE49-F238E27FC236}">
-                <a16:creationId xmlns:a16="http://schemas.microsoft.com/office/drawing/2014/main" id="{2BF0F8FE-C966-4691-906C-A6BB10DB1D12}"/>
-              </a:ext>
-            </a:extLst>
-          </p:cNvPr>
-          <p:cNvSpPr>
-            <a:spLocks xmlns:a="http://schemas.openxmlformats.org/drawingml/2006/main" noGrp="1"/>
-          </p:cNvSpPr>
-          <p:nvPr/>
-        </p:nvSpPr>
-        <p:spPr>
-          <a:xfrm xmlns:a="http://schemas.openxmlformats.org/drawingml/2006/main">
-            <a:off x="3943350" y="2628900"/>
-            <a:ext cx="876300" cy="190500"/>
+                <a16:creationId xmlns:a16="http://schemas.microsoft.com/office/drawing/2014/main" id="{BACCAC28-C04E-46B0-AB30-AB5D60A4DD5E}"/>
+              </a:ext>
+            </a:extLst>
+          </p:cNvPr>
+          <p:cNvSpPr>
+            <a:spLocks xmlns:a="http://schemas.openxmlformats.org/drawingml/2006/main" noGrp="1"/>
+          </p:cNvSpPr>
+          <p:nvPr/>
+        </p:nvSpPr>
+        <p:spPr>
+          <a:xfrm xmlns:a="http://schemas.openxmlformats.org/drawingml/2006/main">
+            <a:off x="1977717" y="3310890"/>
+            <a:ext cx="419100" cy="350520"/>
+          </a:xfrm>
+          <a:prstGeom xmlns:a="http://schemas.openxmlformats.org/drawingml/2006/main" prst="rect">
+            <a:avLst/>
+          </a:prstGeom>
+          <a:noFill xmlns:a="http://schemas.openxmlformats.org/drawingml/2006/main"/>
+          <a:ln xmlns:a="http://schemas.openxmlformats.org/drawingml/2006/main" w="0">
+            <a:noFill/>
+            <a:prstDash val="solid"/>
+          </a:ln>
+        </p:spPr>
+        <p:txBody>
+          <a:bodyPr xmlns:a="http://schemas.openxmlformats.org/drawingml/2006/main"/>
+          <a:lstStyle xmlns:a="http://schemas.openxmlformats.org/drawingml/2006/main"/>
+          <a:p xmlns:a="http://schemas.openxmlformats.org/drawingml/2006/main">
+            <a:pPr>
+              <a:defRPr sz="900" b="1">
+                <a:solidFill>
+                  <a:srgbClr val="07111F"/>
+                </a:solidFill>
+              </a:defRPr>
+            </a:pPr>
+            <a:r>
+              <a:rPr sz="900" b="1">
+                <a:solidFill>
+                  <a:srgbClr val="07111F"/>
+                </a:solidFill>
+              </a:rPr>
+              <a:t>6%</a:t>
+            </a:r>
+          </a:p>
+        </p:txBody>
+      </p:sp>
+      <p:sp>
+        <p:nvSpPr>
+          <p:cNvPr id="17" name="">
+            <a:extLst xmlns:a="http://schemas.openxmlformats.org/drawingml/2006/main">
+              <a:ext uri="{FF2B5EF4-FFF2-40B4-BE49-F238E27FC236}">
+                <a16:creationId xmlns:a16="http://schemas.microsoft.com/office/drawing/2014/main" id="{262DBA80-8D51-43AA-B228-5058876A3431}"/>
+              </a:ext>
+            </a:extLst>
+          </p:cNvPr>
+          <p:cNvSpPr>
+            <a:spLocks xmlns:a="http://schemas.openxmlformats.org/drawingml/2006/main" noGrp="1"/>
+          </p:cNvSpPr>
+          <p:nvPr/>
+        </p:nvSpPr>
+        <p:spPr>
+          <a:xfrm xmlns:a="http://schemas.openxmlformats.org/drawingml/2006/main">
+            <a:off x="590550" y="3737610"/>
+            <a:ext cx="1085850" cy="350520"/>
+          </a:xfrm>
+          <a:prstGeom xmlns:a="http://schemas.openxmlformats.org/drawingml/2006/main" prst="rect">
+            <a:avLst/>
+          </a:prstGeom>
+          <a:noFill xmlns:a="http://schemas.openxmlformats.org/drawingml/2006/main"/>
+          <a:ln xmlns:a="http://schemas.openxmlformats.org/drawingml/2006/main" w="0">
+            <a:noFill/>
+            <a:prstDash val="solid"/>
+          </a:ln>
+        </p:spPr>
+        <p:txBody>
+          <a:bodyPr xmlns:a="http://schemas.openxmlformats.org/drawingml/2006/main"/>
+          <a:lstStyle xmlns:a="http://schemas.openxmlformats.org/drawingml/2006/main"/>
+          <a:p xmlns:a="http://schemas.openxmlformats.org/drawingml/2006/main">
+            <a:pPr algn="r">
+              <a:defRPr sz="825">
+                <a:solidFill>
+                  <a:srgbClr val="42526B"/>
+                </a:solidFill>
+              </a:defRPr>
+            </a:pPr>
+            <a:r>
+              <a:rPr sz="825">
+                <a:solidFill>
+                  <a:srgbClr val="42526B"/>
+                </a:solidFill>
+              </a:rPr>
+              <a:t>Good value</a:t>
+            </a:r>
+          </a:p>
+        </p:txBody>
+      </p:sp>
+      <p:sp>
+        <p:nvSpPr>
+          <p:cNvPr id="18" name="">
+            <a:extLst xmlns:a="http://schemas.openxmlformats.org/drawingml/2006/main">
+              <a:ext uri="{FF2B5EF4-FFF2-40B4-BE49-F238E27FC236}">
+                <a16:creationId xmlns:a16="http://schemas.microsoft.com/office/drawing/2014/main" id="{7A7D5137-DB06-42F8-BE9D-58F0F8D3E825}"/>
+              </a:ext>
+            </a:extLst>
+          </p:cNvPr>
+          <p:cNvSpPr>
+            <a:spLocks xmlns:a="http://schemas.openxmlformats.org/drawingml/2006/main" noGrp="1"/>
+          </p:cNvSpPr>
+          <p:nvPr/>
+        </p:nvSpPr>
+        <p:spPr>
+          <a:xfrm xmlns:a="http://schemas.openxmlformats.org/drawingml/2006/main">
+            <a:off x="1752600" y="3747135"/>
+            <a:ext cx="1628775" cy="293370"/>
+          </a:xfrm>
+          <a:prstGeom xmlns:a="http://schemas.openxmlformats.org/drawingml/2006/main" prst="roundRect">
+            <a:avLst>
+              <a:gd name="adj" fmla="val 6494"/>
+            </a:avLst>
+          </a:prstGeom>
+          <a:solidFill xmlns:a="http://schemas.openxmlformats.org/drawingml/2006/main">
+            <a:srgbClr val="F3ECE3"/>
+          </a:solidFill>
+          <a:ln xmlns:a="http://schemas.openxmlformats.org/drawingml/2006/main" w="0">
+            <a:solidFill>
+              <a:srgbClr val="F3ECE3"/>
+            </a:solidFill>
+            <a:prstDash val="solid"/>
+          </a:ln>
+        </p:spPr>
+      </p:sp>
+      <p:sp>
+        <p:nvSpPr>
+          <p:cNvPr id="19" name="">
+            <a:extLst xmlns:a="http://schemas.openxmlformats.org/drawingml/2006/main">
+              <a:ext uri="{FF2B5EF4-FFF2-40B4-BE49-F238E27FC236}">
+                <a16:creationId xmlns:a16="http://schemas.microsoft.com/office/drawing/2014/main" id="{54095672-6624-4D29-B880-F79897B99A01}"/>
+              </a:ext>
+            </a:extLst>
+          </p:cNvPr>
+          <p:cNvSpPr>
+            <a:spLocks xmlns:a="http://schemas.openxmlformats.org/drawingml/2006/main" noGrp="1"/>
+          </p:cNvSpPr>
+          <p:nvPr/>
+        </p:nvSpPr>
+        <p:spPr>
+          <a:xfrm xmlns:a="http://schemas.openxmlformats.org/drawingml/2006/main">
+            <a:off x="1752600" y="3747135"/>
+            <a:ext cx="1426342" cy="293370"/>
+          </a:xfrm>
+          <a:prstGeom xmlns:a="http://schemas.openxmlformats.org/drawingml/2006/main" prst="roundRect">
+            <a:avLst>
+              <a:gd name="adj" fmla="val 6494"/>
+            </a:avLst>
+          </a:prstGeom>
+          <a:solidFill xmlns:a="http://schemas.openxmlformats.org/drawingml/2006/main">
+            <a:srgbClr val="7C3AED"/>
+          </a:solidFill>
+          <a:ln xmlns:a="http://schemas.openxmlformats.org/drawingml/2006/main" w="0">
+            <a:solidFill>
+              <a:srgbClr val="7C3AED"/>
+            </a:solidFill>
+            <a:prstDash val="solid"/>
+          </a:ln>
+        </p:spPr>
+      </p:sp>
+      <p:sp>
+        <p:nvSpPr>
+          <p:cNvPr id="20" name="">
+            <a:extLst xmlns:a="http://schemas.openxmlformats.org/drawingml/2006/main">
+              <a:ext uri="{FF2B5EF4-FFF2-40B4-BE49-F238E27FC236}">
+                <a16:creationId xmlns:a16="http://schemas.microsoft.com/office/drawing/2014/main" id="{8A867128-8C83-414F-AFE4-966CD5AAFD0E}"/>
+              </a:ext>
+            </a:extLst>
+          </p:cNvPr>
+          <p:cNvSpPr>
+            <a:spLocks xmlns:a="http://schemas.openxmlformats.org/drawingml/2006/main" noGrp="1"/>
+          </p:cNvSpPr>
+          <p:nvPr/>
+        </p:nvSpPr>
+        <p:spPr>
+          <a:xfrm xmlns:a="http://schemas.openxmlformats.org/drawingml/2006/main">
+            <a:off x="3255142" y="3756660"/>
+            <a:ext cx="419100" cy="350520"/>
+          </a:xfrm>
+          <a:prstGeom xmlns:a="http://schemas.openxmlformats.org/drawingml/2006/main" prst="rect">
+            <a:avLst/>
+          </a:prstGeom>
+          <a:noFill xmlns:a="http://schemas.openxmlformats.org/drawingml/2006/main"/>
+          <a:ln xmlns:a="http://schemas.openxmlformats.org/drawingml/2006/main" w="0">
+            <a:noFill/>
+            <a:prstDash val="solid"/>
+          </a:ln>
+        </p:spPr>
+        <p:txBody>
+          <a:bodyPr xmlns:a="http://schemas.openxmlformats.org/drawingml/2006/main"/>
+          <a:lstStyle xmlns:a="http://schemas.openxmlformats.org/drawingml/2006/main"/>
+          <a:p xmlns:a="http://schemas.openxmlformats.org/drawingml/2006/main">
+            <a:pPr>
+              <a:defRPr sz="900" b="1">
+                <a:solidFill>
+                  <a:srgbClr val="07111F"/>
+                </a:solidFill>
+              </a:defRPr>
+            </a:pPr>
+            <a:r>
+              <a:rPr sz="900" b="1">
+                <a:solidFill>
+                  <a:srgbClr val="07111F"/>
+                </a:solidFill>
+              </a:rPr>
+              <a:t>61%</a:t>
+            </a:r>
+          </a:p>
+        </p:txBody>
+      </p:sp>
+      <p:sp>
+        <p:nvSpPr>
+          <p:cNvPr id="21" name="">
+            <a:extLst xmlns:a="http://schemas.openxmlformats.org/drawingml/2006/main">
+              <a:ext uri="{FF2B5EF4-FFF2-40B4-BE49-F238E27FC236}">
+                <a16:creationId xmlns:a16="http://schemas.microsoft.com/office/drawing/2014/main" id="{493CCF23-93B1-402B-8B72-2B756738773E}"/>
+              </a:ext>
+            </a:extLst>
+          </p:cNvPr>
+          <p:cNvSpPr>
+            <a:spLocks xmlns:a="http://schemas.openxmlformats.org/drawingml/2006/main" noGrp="1"/>
+          </p:cNvSpPr>
+          <p:nvPr/>
+        </p:nvSpPr>
+        <p:spPr>
+          <a:xfrm xmlns:a="http://schemas.openxmlformats.org/drawingml/2006/main">
+            <a:off x="590550" y="4183380"/>
+            <a:ext cx="1085850" cy="350520"/>
+          </a:xfrm>
+          <a:prstGeom xmlns:a="http://schemas.openxmlformats.org/drawingml/2006/main" prst="rect">
+            <a:avLst/>
+          </a:prstGeom>
+          <a:noFill xmlns:a="http://schemas.openxmlformats.org/drawingml/2006/main"/>
+          <a:ln xmlns:a="http://schemas.openxmlformats.org/drawingml/2006/main" w="0">
+            <a:noFill/>
+            <a:prstDash val="solid"/>
+          </a:ln>
+        </p:spPr>
+        <p:txBody>
+          <a:bodyPr xmlns:a="http://schemas.openxmlformats.org/drawingml/2006/main"/>
+          <a:lstStyle xmlns:a="http://schemas.openxmlformats.org/drawingml/2006/main"/>
+          <a:p xmlns:a="http://schemas.openxmlformats.org/drawingml/2006/main">
+            <a:pPr algn="r">
+              <a:defRPr sz="825">
+                <a:solidFill>
+                  <a:srgbClr val="42526B"/>
+                </a:solidFill>
+              </a:defRPr>
+            </a:pPr>
+            <a:r>
+              <a:rPr sz="825">
+                <a:solidFill>
+                  <a:srgbClr val="42526B"/>
+                </a:solidFill>
+              </a:rPr>
+              <a:t>Pay more</a:t>
+            </a:r>
+          </a:p>
+        </p:txBody>
+      </p:sp>
+      <p:sp>
+        <p:nvSpPr>
+          <p:cNvPr id="22" name="">
+            <a:extLst xmlns:a="http://schemas.openxmlformats.org/drawingml/2006/main">
+              <a:ext uri="{FF2B5EF4-FFF2-40B4-BE49-F238E27FC236}">
+                <a16:creationId xmlns:a16="http://schemas.microsoft.com/office/drawing/2014/main" id="{57181FC2-38CD-4CB7-9D44-A38C6408BCB7}"/>
+              </a:ext>
+            </a:extLst>
+          </p:cNvPr>
+          <p:cNvSpPr>
+            <a:spLocks xmlns:a="http://schemas.openxmlformats.org/drawingml/2006/main" noGrp="1"/>
+          </p:cNvSpPr>
+          <p:nvPr/>
+        </p:nvSpPr>
+        <p:spPr>
+          <a:xfrm xmlns:a="http://schemas.openxmlformats.org/drawingml/2006/main">
+            <a:off x="1752600" y="4192905"/>
+            <a:ext cx="1628775" cy="293370"/>
+          </a:xfrm>
+          <a:prstGeom xmlns:a="http://schemas.openxmlformats.org/drawingml/2006/main" prst="roundRect">
+            <a:avLst>
+              <a:gd name="adj" fmla="val 6494"/>
+            </a:avLst>
+          </a:prstGeom>
+          <a:solidFill xmlns:a="http://schemas.openxmlformats.org/drawingml/2006/main">
+            <a:srgbClr val="F3ECE3"/>
+          </a:solidFill>
+          <a:ln xmlns:a="http://schemas.openxmlformats.org/drawingml/2006/main" w="0">
+            <a:solidFill>
+              <a:srgbClr val="F3ECE3"/>
+            </a:solidFill>
+            <a:prstDash val="solid"/>
+          </a:ln>
+        </p:spPr>
+      </p:sp>
+      <p:sp>
+        <p:nvSpPr>
+          <p:cNvPr id="23" name="">
+            <a:extLst xmlns:a="http://schemas.openxmlformats.org/drawingml/2006/main">
+              <a:ext uri="{FF2B5EF4-FFF2-40B4-BE49-F238E27FC236}">
+                <a16:creationId xmlns:a16="http://schemas.microsoft.com/office/drawing/2014/main" id="{3CCB9EBE-B23A-4E8C-978F-210FCB9BF386}"/>
+              </a:ext>
+            </a:extLst>
+          </p:cNvPr>
+          <p:cNvSpPr>
+            <a:spLocks xmlns:a="http://schemas.openxmlformats.org/drawingml/2006/main" noGrp="1"/>
+          </p:cNvSpPr>
+          <p:nvPr/>
+        </p:nvSpPr>
+        <p:spPr>
+          <a:xfrm xmlns:a="http://schemas.openxmlformats.org/drawingml/2006/main">
+            <a:off x="1752600" y="4192905"/>
+            <a:ext cx="1116874" cy="293370"/>
+          </a:xfrm>
+          <a:prstGeom xmlns:a="http://schemas.openxmlformats.org/drawingml/2006/main" prst="roundRect">
+            <a:avLst>
+              <a:gd name="adj" fmla="val 6494"/>
+            </a:avLst>
+          </a:prstGeom>
+          <a:solidFill xmlns:a="http://schemas.openxmlformats.org/drawingml/2006/main">
+            <a:srgbClr val="7C3AED"/>
+          </a:solidFill>
+          <a:ln xmlns:a="http://schemas.openxmlformats.org/drawingml/2006/main" w="0">
+            <a:solidFill>
+              <a:srgbClr val="7C3AED"/>
+            </a:solidFill>
+            <a:prstDash val="solid"/>
+          </a:ln>
+        </p:spPr>
+      </p:sp>
+      <p:sp>
+        <p:nvSpPr>
+          <p:cNvPr id="24" name="">
+            <a:extLst xmlns:a="http://schemas.openxmlformats.org/drawingml/2006/main">
+              <a:ext uri="{FF2B5EF4-FFF2-40B4-BE49-F238E27FC236}">
+                <a16:creationId xmlns:a16="http://schemas.microsoft.com/office/drawing/2014/main" id="{FCF7D0BF-CE06-4D71-A41A-F8A0E8DA1E69}"/>
+              </a:ext>
+            </a:extLst>
+          </p:cNvPr>
+          <p:cNvSpPr>
+            <a:spLocks xmlns:a="http://schemas.openxmlformats.org/drawingml/2006/main" noGrp="1"/>
+          </p:cNvSpPr>
+          <p:nvPr/>
+        </p:nvSpPr>
+        <p:spPr>
+          <a:xfrm xmlns:a="http://schemas.openxmlformats.org/drawingml/2006/main">
+            <a:off x="2945674" y="4202430"/>
+            <a:ext cx="419100" cy="350520"/>
+          </a:xfrm>
+          <a:prstGeom xmlns:a="http://schemas.openxmlformats.org/drawingml/2006/main" prst="rect">
+            <a:avLst/>
+          </a:prstGeom>
+          <a:noFill xmlns:a="http://schemas.openxmlformats.org/drawingml/2006/main"/>
+          <a:ln xmlns:a="http://schemas.openxmlformats.org/drawingml/2006/main" w="0">
+            <a:noFill/>
+            <a:prstDash val="solid"/>
+          </a:ln>
+        </p:spPr>
+        <p:txBody>
+          <a:bodyPr xmlns:a="http://schemas.openxmlformats.org/drawingml/2006/main"/>
+          <a:lstStyle xmlns:a="http://schemas.openxmlformats.org/drawingml/2006/main"/>
+          <a:p xmlns:a="http://schemas.openxmlformats.org/drawingml/2006/main">
+            <a:pPr>
+              <a:defRPr sz="900" b="1">
+                <a:solidFill>
+                  <a:srgbClr val="07111F"/>
+                </a:solidFill>
+              </a:defRPr>
+            </a:pPr>
+            <a:r>
+              <a:rPr sz="900" b="1">
+                <a:solidFill>
+                  <a:srgbClr val="07111F"/>
+                </a:solidFill>
+              </a:rPr>
+              <a:t>48%</a:t>
+            </a:r>
+          </a:p>
+        </p:txBody>
+      </p:sp>
+      <p:sp>
+        <p:nvSpPr>
+          <p:cNvPr id="25" name="">
+            <a:extLst xmlns:a="http://schemas.openxmlformats.org/drawingml/2006/main">
+              <a:ext uri="{FF2B5EF4-FFF2-40B4-BE49-F238E27FC236}">
+                <a16:creationId xmlns:a16="http://schemas.microsoft.com/office/drawing/2014/main" id="{FE0AFDC0-D940-45E3-8154-36955AEA6E10}"/>
+              </a:ext>
+            </a:extLst>
+          </p:cNvPr>
+          <p:cNvSpPr>
+            <a:spLocks xmlns:a="http://schemas.openxmlformats.org/drawingml/2006/main" noGrp="1"/>
+          </p:cNvSpPr>
+          <p:nvPr/>
+        </p:nvSpPr>
+        <p:spPr>
+          <a:xfrm xmlns:a="http://schemas.openxmlformats.org/drawingml/2006/main">
+            <a:off x="1752600" y="4781550"/>
+            <a:ext cx="1143000" cy="228600"/>
           </a:xfrm>
           <a:prstGeom xmlns:a="http://schemas.openxmlformats.org/drawingml/2006/main" prst="rect">
             <a:avLst/>
@@ -6767,41 +7169,891 @@
           <a:lstStyle xmlns:a="http://schemas.openxmlformats.org/drawingml/2006/main"/>
           <a:p xmlns:a="http://schemas.openxmlformats.org/drawingml/2006/main">
             <a:pPr algn="ctr">
-              <a:defRPr sz="1050" b="1">
+              <a:defRPr sz="1125" b="1">
+                <a:solidFill>
+                  <a:srgbClr val="7C3AED"/>
+                </a:solidFill>
+              </a:defRPr>
+            </a:pPr>
+            <a:r>
+              <a:rPr sz="1125" b="1">
+                <a:solidFill>
+                  <a:srgbClr val="7C3AED"/>
+                </a:solidFill>
+              </a:rPr>
+              <a:t>Under 40</a:t>
+            </a:r>
+          </a:p>
+        </p:txBody>
+      </p:sp>
+      <p:sp>
+        <p:nvSpPr>
+          <p:cNvPr id="26" name="">
+            <a:extLst xmlns:a="http://schemas.openxmlformats.org/drawingml/2006/main">
+              <a:ext uri="{FF2B5EF4-FFF2-40B4-BE49-F238E27FC236}">
+                <a16:creationId xmlns:a16="http://schemas.microsoft.com/office/drawing/2014/main" id="{610C951E-3E37-47AB-84CF-FCE186D87774}"/>
+              </a:ext>
+            </a:extLst>
+          </p:cNvPr>
+          <p:cNvSpPr>
+            <a:spLocks xmlns:a="http://schemas.openxmlformats.org/drawingml/2006/main" noGrp="1"/>
+          </p:cNvSpPr>
+          <p:nvPr/>
+        </p:nvSpPr>
+        <p:spPr>
+          <a:xfrm xmlns:a="http://schemas.openxmlformats.org/drawingml/2006/main">
+            <a:off x="4171950" y="2400300"/>
+            <a:ext cx="1085850" cy="350520"/>
+          </a:xfrm>
+          <a:prstGeom xmlns:a="http://schemas.openxmlformats.org/drawingml/2006/main" prst="rect">
+            <a:avLst/>
+          </a:prstGeom>
+          <a:noFill xmlns:a="http://schemas.openxmlformats.org/drawingml/2006/main"/>
+          <a:ln xmlns:a="http://schemas.openxmlformats.org/drawingml/2006/main" w="0">
+            <a:noFill/>
+            <a:prstDash val="solid"/>
+          </a:ln>
+        </p:spPr>
+        <p:txBody>
+          <a:bodyPr xmlns:a="http://schemas.openxmlformats.org/drawingml/2006/main"/>
+          <a:lstStyle xmlns:a="http://schemas.openxmlformats.org/drawingml/2006/main"/>
+          <a:p xmlns:a="http://schemas.openxmlformats.org/drawingml/2006/main">
+            <a:pPr algn="r">
+              <a:defRPr sz="825">
+                <a:solidFill>
+                  <a:srgbClr val="42526B"/>
+                </a:solidFill>
+              </a:defRPr>
+            </a:pPr>
+            <a:r>
+              <a:rPr sz="825">
+                <a:solidFill>
+                  <a:srgbClr val="42526B"/>
+                </a:solidFill>
+              </a:rPr>
+              <a:t>Aided awareness</a:t>
+            </a:r>
+          </a:p>
+        </p:txBody>
+      </p:sp>
+      <p:sp>
+        <p:nvSpPr>
+          <p:cNvPr id="27" name="">
+            <a:extLst xmlns:a="http://schemas.openxmlformats.org/drawingml/2006/main">
+              <a:ext uri="{FF2B5EF4-FFF2-40B4-BE49-F238E27FC236}">
+                <a16:creationId xmlns:a16="http://schemas.microsoft.com/office/drawing/2014/main" id="{7B100FC3-18C2-4CBA-9B04-B79F0E5FA246}"/>
+              </a:ext>
+            </a:extLst>
+          </p:cNvPr>
+          <p:cNvSpPr>
+            <a:spLocks xmlns:a="http://schemas.openxmlformats.org/drawingml/2006/main" noGrp="1"/>
+          </p:cNvSpPr>
+          <p:nvPr/>
+        </p:nvSpPr>
+        <p:spPr>
+          <a:xfrm xmlns:a="http://schemas.openxmlformats.org/drawingml/2006/main">
+            <a:off x="5334000" y="2409825"/>
+            <a:ext cx="1628775" cy="293370"/>
+          </a:xfrm>
+          <a:prstGeom xmlns:a="http://schemas.openxmlformats.org/drawingml/2006/main" prst="roundRect">
+            <a:avLst>
+              <a:gd name="adj" fmla="val 6494"/>
+            </a:avLst>
+          </a:prstGeom>
+          <a:solidFill xmlns:a="http://schemas.openxmlformats.org/drawingml/2006/main">
+            <a:srgbClr val="F3ECE3"/>
+          </a:solidFill>
+          <a:ln xmlns:a="http://schemas.openxmlformats.org/drawingml/2006/main" w="0">
+            <a:solidFill>
+              <a:srgbClr val="F3ECE3"/>
+            </a:solidFill>
+            <a:prstDash val="solid"/>
+          </a:ln>
+        </p:spPr>
+      </p:sp>
+      <p:sp>
+        <p:nvSpPr>
+          <p:cNvPr id="28" name="">
+            <a:extLst xmlns:a="http://schemas.openxmlformats.org/drawingml/2006/main">
+              <a:ext uri="{FF2B5EF4-FFF2-40B4-BE49-F238E27FC236}">
+                <a16:creationId xmlns:a16="http://schemas.microsoft.com/office/drawing/2014/main" id="{EAD7C8B1-8296-41B4-B127-ADCB4807E027}"/>
+              </a:ext>
+            </a:extLst>
+          </p:cNvPr>
+          <p:cNvSpPr>
+            <a:spLocks xmlns:a="http://schemas.openxmlformats.org/drawingml/2006/main" noGrp="1"/>
+          </p:cNvSpPr>
+          <p:nvPr/>
+        </p:nvSpPr>
+        <p:spPr>
+          <a:xfrm xmlns:a="http://schemas.openxmlformats.org/drawingml/2006/main">
+            <a:off x="5334000" y="2409825"/>
+            <a:ext cx="1093606" cy="293370"/>
+          </a:xfrm>
+          <a:prstGeom xmlns:a="http://schemas.openxmlformats.org/drawingml/2006/main" prst="roundRect">
+            <a:avLst>
+              <a:gd name="adj" fmla="val 6494"/>
+            </a:avLst>
+          </a:prstGeom>
+          <a:solidFill xmlns:a="http://schemas.openxmlformats.org/drawingml/2006/main">
+            <a:srgbClr val="F59E0B"/>
+          </a:solidFill>
+          <a:ln xmlns:a="http://schemas.openxmlformats.org/drawingml/2006/main" w="0">
+            <a:solidFill>
+              <a:srgbClr val="F59E0B"/>
+            </a:solidFill>
+            <a:prstDash val="solid"/>
+          </a:ln>
+        </p:spPr>
+      </p:sp>
+      <p:sp>
+        <p:nvSpPr>
+          <p:cNvPr id="29" name="">
+            <a:extLst xmlns:a="http://schemas.openxmlformats.org/drawingml/2006/main">
+              <a:ext uri="{FF2B5EF4-FFF2-40B4-BE49-F238E27FC236}">
+                <a16:creationId xmlns:a16="http://schemas.microsoft.com/office/drawing/2014/main" id="{E79A4099-319F-4B62-AA9F-D6F728516383}"/>
+              </a:ext>
+            </a:extLst>
+          </p:cNvPr>
+          <p:cNvSpPr>
+            <a:spLocks xmlns:a="http://schemas.openxmlformats.org/drawingml/2006/main" noGrp="1"/>
+          </p:cNvSpPr>
+          <p:nvPr/>
+        </p:nvSpPr>
+        <p:spPr>
+          <a:xfrm xmlns:a="http://schemas.openxmlformats.org/drawingml/2006/main">
+            <a:off x="6503806" y="2419350"/>
+            <a:ext cx="419100" cy="350520"/>
+          </a:xfrm>
+          <a:prstGeom xmlns:a="http://schemas.openxmlformats.org/drawingml/2006/main" prst="rect">
+            <a:avLst/>
+          </a:prstGeom>
+          <a:noFill xmlns:a="http://schemas.openxmlformats.org/drawingml/2006/main"/>
+          <a:ln xmlns:a="http://schemas.openxmlformats.org/drawingml/2006/main" w="0">
+            <a:noFill/>
+            <a:prstDash val="solid"/>
+          </a:ln>
+        </p:spPr>
+        <p:txBody>
+          <a:bodyPr xmlns:a="http://schemas.openxmlformats.org/drawingml/2006/main"/>
+          <a:lstStyle xmlns:a="http://schemas.openxmlformats.org/drawingml/2006/main"/>
+          <a:p xmlns:a="http://schemas.openxmlformats.org/drawingml/2006/main">
+            <a:pPr>
+              <a:defRPr sz="900" b="1">
                 <a:solidFill>
                   <a:srgbClr val="07111F"/>
                 </a:solidFill>
               </a:defRPr>
             </a:pPr>
             <a:r>
-              <a:rPr sz="1050" b="1">
+              <a:rPr sz="900" b="1">
                 <a:solidFill>
                   <a:srgbClr val="07111F"/>
                 </a:solidFill>
               </a:rPr>
-              <a:t>80%</a:t>
-            </a:r>
-          </a:p>
-        </p:txBody>
-      </p:sp>
-      <p:sp>
-        <p:nvSpPr>
-          <p:cNvPr id="17" name="">
-            <a:extLst xmlns:a="http://schemas.openxmlformats.org/drawingml/2006/main">
-              <a:ext uri="{FF2B5EF4-FFF2-40B4-BE49-F238E27FC236}">
-                <a16:creationId xmlns:a16="http://schemas.microsoft.com/office/drawing/2014/main" id="{6F5686E3-5A00-4FFF-9B1F-53975FECBDA7}"/>
-              </a:ext>
-            </a:extLst>
-          </p:cNvPr>
-          <p:cNvSpPr>
-            <a:spLocks xmlns:a="http://schemas.openxmlformats.org/drawingml/2006/main" noGrp="1"/>
-          </p:cNvSpPr>
-          <p:nvPr/>
-        </p:nvSpPr>
-        <p:spPr>
-          <a:xfrm xmlns:a="http://schemas.openxmlformats.org/drawingml/2006/main">
-            <a:off x="3943350" y="4272610"/>
-            <a:ext cx="876300" cy="190500"/>
+              <a:t>47%</a:t>
+            </a:r>
+          </a:p>
+        </p:txBody>
+      </p:sp>
+      <p:sp>
+        <p:nvSpPr>
+          <p:cNvPr id="30" name="">
+            <a:extLst xmlns:a="http://schemas.openxmlformats.org/drawingml/2006/main">
+              <a:ext uri="{FF2B5EF4-FFF2-40B4-BE49-F238E27FC236}">
+                <a16:creationId xmlns:a16="http://schemas.microsoft.com/office/drawing/2014/main" id="{C7786F22-4E33-46C4-B54D-5422801D1F77}"/>
+              </a:ext>
+            </a:extLst>
+          </p:cNvPr>
+          <p:cNvSpPr>
+            <a:spLocks xmlns:a="http://schemas.openxmlformats.org/drawingml/2006/main" noGrp="1"/>
+          </p:cNvSpPr>
+          <p:nvPr/>
+        </p:nvSpPr>
+        <p:spPr>
+          <a:xfrm xmlns:a="http://schemas.openxmlformats.org/drawingml/2006/main">
+            <a:off x="4171950" y="2846070"/>
+            <a:ext cx="1085850" cy="350520"/>
+          </a:xfrm>
+          <a:prstGeom xmlns:a="http://schemas.openxmlformats.org/drawingml/2006/main" prst="rect">
+            <a:avLst/>
+          </a:prstGeom>
+          <a:noFill xmlns:a="http://schemas.openxmlformats.org/drawingml/2006/main"/>
+          <a:ln xmlns:a="http://schemas.openxmlformats.org/drawingml/2006/main" w="0">
+            <a:noFill/>
+            <a:prstDash val="solid"/>
+          </a:ln>
+        </p:spPr>
+        <p:txBody>
+          <a:bodyPr xmlns:a="http://schemas.openxmlformats.org/drawingml/2006/main"/>
+          <a:lstStyle xmlns:a="http://schemas.openxmlformats.org/drawingml/2006/main"/>
+          <a:p xmlns:a="http://schemas.openxmlformats.org/drawingml/2006/main">
+            <a:pPr algn="r">
+              <a:defRPr sz="825">
+                <a:solidFill>
+                  <a:srgbClr val="42526B"/>
+                </a:solidFill>
+              </a:defRPr>
+            </a:pPr>
+            <a:r>
+              <a:rPr sz="825">
+                <a:solidFill>
+                  <a:srgbClr val="42526B"/>
+                </a:solidFill>
+              </a:rPr>
+              <a:t>Serious consideration</a:t>
+            </a:r>
+          </a:p>
+        </p:txBody>
+      </p:sp>
+      <p:sp>
+        <p:nvSpPr>
+          <p:cNvPr id="31" name="">
+            <a:extLst xmlns:a="http://schemas.openxmlformats.org/drawingml/2006/main">
+              <a:ext uri="{FF2B5EF4-FFF2-40B4-BE49-F238E27FC236}">
+                <a16:creationId xmlns:a16="http://schemas.microsoft.com/office/drawing/2014/main" id="{4C0DF0D1-CEDE-432E-B680-7EF5A1EE1A10}"/>
+              </a:ext>
+            </a:extLst>
+          </p:cNvPr>
+          <p:cNvSpPr>
+            <a:spLocks xmlns:a="http://schemas.openxmlformats.org/drawingml/2006/main" noGrp="1"/>
+          </p:cNvSpPr>
+          <p:nvPr/>
+        </p:nvSpPr>
+        <p:spPr>
+          <a:xfrm xmlns:a="http://schemas.openxmlformats.org/drawingml/2006/main">
+            <a:off x="5334000" y="2855595"/>
+            <a:ext cx="1628775" cy="293370"/>
+          </a:xfrm>
+          <a:prstGeom xmlns:a="http://schemas.openxmlformats.org/drawingml/2006/main" prst="roundRect">
+            <a:avLst>
+              <a:gd name="adj" fmla="val 6494"/>
+            </a:avLst>
+          </a:prstGeom>
+          <a:solidFill xmlns:a="http://schemas.openxmlformats.org/drawingml/2006/main">
+            <a:srgbClr val="F3ECE3"/>
+          </a:solidFill>
+          <a:ln xmlns:a="http://schemas.openxmlformats.org/drawingml/2006/main" w="0">
+            <a:solidFill>
+              <a:srgbClr val="F3ECE3"/>
+            </a:solidFill>
+            <a:prstDash val="solid"/>
+          </a:ln>
+        </p:spPr>
+      </p:sp>
+      <p:sp>
+        <p:nvSpPr>
+          <p:cNvPr id="32" name="">
+            <a:extLst xmlns:a="http://schemas.openxmlformats.org/drawingml/2006/main">
+              <a:ext uri="{FF2B5EF4-FFF2-40B4-BE49-F238E27FC236}">
+                <a16:creationId xmlns:a16="http://schemas.microsoft.com/office/drawing/2014/main" id="{876C19A6-A665-4F5A-BFE3-1CFE425EC325}"/>
+              </a:ext>
+            </a:extLst>
+          </p:cNvPr>
+          <p:cNvSpPr>
+            <a:spLocks xmlns:a="http://schemas.openxmlformats.org/drawingml/2006/main" noGrp="1"/>
+          </p:cNvSpPr>
+          <p:nvPr/>
+        </p:nvSpPr>
+        <p:spPr>
+          <a:xfrm xmlns:a="http://schemas.openxmlformats.org/drawingml/2006/main">
+            <a:off x="5334000" y="2855595"/>
+            <a:ext cx="677105" cy="293370"/>
+          </a:xfrm>
+          <a:prstGeom xmlns:a="http://schemas.openxmlformats.org/drawingml/2006/main" prst="roundRect">
+            <a:avLst>
+              <a:gd name="adj" fmla="val 6494"/>
+            </a:avLst>
+          </a:prstGeom>
+          <a:solidFill xmlns:a="http://schemas.openxmlformats.org/drawingml/2006/main">
+            <a:srgbClr val="F59E0B"/>
+          </a:solidFill>
+          <a:ln xmlns:a="http://schemas.openxmlformats.org/drawingml/2006/main" w="0">
+            <a:solidFill>
+              <a:srgbClr val="F59E0B"/>
+            </a:solidFill>
+            <a:prstDash val="solid"/>
+          </a:ln>
+        </p:spPr>
+      </p:sp>
+      <p:sp>
+        <p:nvSpPr>
+          <p:cNvPr id="33" name="">
+            <a:extLst xmlns:a="http://schemas.openxmlformats.org/drawingml/2006/main">
+              <a:ext uri="{FF2B5EF4-FFF2-40B4-BE49-F238E27FC236}">
+                <a16:creationId xmlns:a16="http://schemas.microsoft.com/office/drawing/2014/main" id="{2BD00D9D-01F0-4108-AFF3-0A1511D4BB28}"/>
+              </a:ext>
+            </a:extLst>
+          </p:cNvPr>
+          <p:cNvSpPr>
+            <a:spLocks xmlns:a="http://schemas.openxmlformats.org/drawingml/2006/main" noGrp="1"/>
+          </p:cNvSpPr>
+          <p:nvPr/>
+        </p:nvSpPr>
+        <p:spPr>
+          <a:xfrm xmlns:a="http://schemas.openxmlformats.org/drawingml/2006/main">
+            <a:off x="6087305" y="2865120"/>
+            <a:ext cx="419100" cy="350520"/>
+          </a:xfrm>
+          <a:prstGeom xmlns:a="http://schemas.openxmlformats.org/drawingml/2006/main" prst="rect">
+            <a:avLst/>
+          </a:prstGeom>
+          <a:noFill xmlns:a="http://schemas.openxmlformats.org/drawingml/2006/main"/>
+          <a:ln xmlns:a="http://schemas.openxmlformats.org/drawingml/2006/main" w="0">
+            <a:noFill/>
+            <a:prstDash val="solid"/>
+          </a:ln>
+        </p:spPr>
+        <p:txBody>
+          <a:bodyPr xmlns:a="http://schemas.openxmlformats.org/drawingml/2006/main"/>
+          <a:lstStyle xmlns:a="http://schemas.openxmlformats.org/drawingml/2006/main"/>
+          <a:p xmlns:a="http://schemas.openxmlformats.org/drawingml/2006/main">
+            <a:pPr>
+              <a:defRPr sz="900" b="1">
+                <a:solidFill>
+                  <a:srgbClr val="07111F"/>
+                </a:solidFill>
+              </a:defRPr>
+            </a:pPr>
+            <a:r>
+              <a:rPr sz="900" b="1">
+                <a:solidFill>
+                  <a:srgbClr val="07111F"/>
+                </a:solidFill>
+              </a:rPr>
+              <a:t>29%</a:t>
+            </a:r>
+          </a:p>
+        </p:txBody>
+      </p:sp>
+      <p:sp>
+        <p:nvSpPr>
+          <p:cNvPr id="34" name="">
+            <a:extLst xmlns:a="http://schemas.openxmlformats.org/drawingml/2006/main">
+              <a:ext uri="{FF2B5EF4-FFF2-40B4-BE49-F238E27FC236}">
+                <a16:creationId xmlns:a16="http://schemas.microsoft.com/office/drawing/2014/main" id="{9D70B596-C713-45E7-B470-F0AEC40B9BFF}"/>
+              </a:ext>
+            </a:extLst>
+          </p:cNvPr>
+          <p:cNvSpPr>
+            <a:spLocks xmlns:a="http://schemas.openxmlformats.org/drawingml/2006/main" noGrp="1"/>
+          </p:cNvSpPr>
+          <p:nvPr/>
+        </p:nvSpPr>
+        <p:spPr>
+          <a:xfrm xmlns:a="http://schemas.openxmlformats.org/drawingml/2006/main">
+            <a:off x="4171950" y="3291840"/>
+            <a:ext cx="1085850" cy="350520"/>
+          </a:xfrm>
+          <a:prstGeom xmlns:a="http://schemas.openxmlformats.org/drawingml/2006/main" prst="rect">
+            <a:avLst/>
+          </a:prstGeom>
+          <a:noFill xmlns:a="http://schemas.openxmlformats.org/drawingml/2006/main"/>
+          <a:ln xmlns:a="http://schemas.openxmlformats.org/drawingml/2006/main" w="0">
+            <a:noFill/>
+            <a:prstDash val="solid"/>
+          </a:ln>
+        </p:spPr>
+        <p:txBody>
+          <a:bodyPr xmlns:a="http://schemas.openxmlformats.org/drawingml/2006/main"/>
+          <a:lstStyle xmlns:a="http://schemas.openxmlformats.org/drawingml/2006/main"/>
+          <a:p xmlns:a="http://schemas.openxmlformats.org/drawingml/2006/main">
+            <a:pPr algn="r">
+              <a:defRPr sz="825">
+                <a:solidFill>
+                  <a:srgbClr val="42526B"/>
+                </a:solidFill>
+              </a:defRPr>
+            </a:pPr>
+            <a:r>
+              <a:rPr sz="825">
+                <a:solidFill>
+                  <a:srgbClr val="42526B"/>
+                </a:solidFill>
+              </a:rPr>
+              <a:t>Choose Shapermint</a:t>
+            </a:r>
+          </a:p>
+        </p:txBody>
+      </p:sp>
+      <p:sp>
+        <p:nvSpPr>
+          <p:cNvPr id="35" name="">
+            <a:extLst xmlns:a="http://schemas.openxmlformats.org/drawingml/2006/main">
+              <a:ext uri="{FF2B5EF4-FFF2-40B4-BE49-F238E27FC236}">
+                <a16:creationId xmlns:a16="http://schemas.microsoft.com/office/drawing/2014/main" id="{95DC2BDC-9895-40F1-8701-77966262115C}"/>
+              </a:ext>
+            </a:extLst>
+          </p:cNvPr>
+          <p:cNvSpPr>
+            <a:spLocks xmlns:a="http://schemas.openxmlformats.org/drawingml/2006/main" noGrp="1"/>
+          </p:cNvSpPr>
+          <p:nvPr/>
+        </p:nvSpPr>
+        <p:spPr>
+          <a:xfrm xmlns:a="http://schemas.openxmlformats.org/drawingml/2006/main">
+            <a:off x="5334000" y="3301365"/>
+            <a:ext cx="1628775" cy="293370"/>
+          </a:xfrm>
+          <a:prstGeom xmlns:a="http://schemas.openxmlformats.org/drawingml/2006/main" prst="roundRect">
+            <a:avLst>
+              <a:gd name="adj" fmla="val 6494"/>
+            </a:avLst>
+          </a:prstGeom>
+          <a:solidFill xmlns:a="http://schemas.openxmlformats.org/drawingml/2006/main">
+            <a:srgbClr val="F3ECE3"/>
+          </a:solidFill>
+          <a:ln xmlns:a="http://schemas.openxmlformats.org/drawingml/2006/main" w="0">
+            <a:solidFill>
+              <a:srgbClr val="F3ECE3"/>
+            </a:solidFill>
+            <a:prstDash val="solid"/>
+          </a:ln>
+        </p:spPr>
+      </p:sp>
+      <p:sp>
+        <p:nvSpPr>
+          <p:cNvPr id="36" name="">
+            <a:extLst xmlns:a="http://schemas.openxmlformats.org/drawingml/2006/main">
+              <a:ext uri="{FF2B5EF4-FFF2-40B4-BE49-F238E27FC236}">
+                <a16:creationId xmlns:a16="http://schemas.microsoft.com/office/drawing/2014/main" id="{D60284B0-1FC9-4ACC-B0D6-0BAC2486436A}"/>
+              </a:ext>
+            </a:extLst>
+          </p:cNvPr>
+          <p:cNvSpPr>
+            <a:spLocks xmlns:a="http://schemas.openxmlformats.org/drawingml/2006/main" noGrp="1"/>
+          </p:cNvSpPr>
+          <p:nvPr/>
+        </p:nvSpPr>
+        <p:spPr>
+          <a:xfrm xmlns:a="http://schemas.openxmlformats.org/drawingml/2006/main">
+            <a:off x="5334000" y="3301365"/>
+            <a:ext cx="258277" cy="293370"/>
+          </a:xfrm>
+          <a:prstGeom xmlns:a="http://schemas.openxmlformats.org/drawingml/2006/main" prst="roundRect">
+            <a:avLst>
+              <a:gd name="adj" fmla="val 7376"/>
+            </a:avLst>
+          </a:prstGeom>
+          <a:solidFill xmlns:a="http://schemas.openxmlformats.org/drawingml/2006/main">
+            <a:srgbClr val="F59E0B"/>
+          </a:solidFill>
+          <a:ln xmlns:a="http://schemas.openxmlformats.org/drawingml/2006/main" w="0">
+            <a:solidFill>
+              <a:srgbClr val="F59E0B"/>
+            </a:solidFill>
+            <a:prstDash val="solid"/>
+          </a:ln>
+        </p:spPr>
+      </p:sp>
+      <p:sp>
+        <p:nvSpPr>
+          <p:cNvPr id="37" name="">
+            <a:extLst xmlns:a="http://schemas.openxmlformats.org/drawingml/2006/main">
+              <a:ext uri="{FF2B5EF4-FFF2-40B4-BE49-F238E27FC236}">
+                <a16:creationId xmlns:a16="http://schemas.microsoft.com/office/drawing/2014/main" id="{4E8C7060-3C2F-47F5-A980-37C289A5AC96}"/>
+              </a:ext>
+            </a:extLst>
+          </p:cNvPr>
+          <p:cNvSpPr>
+            <a:spLocks xmlns:a="http://schemas.openxmlformats.org/drawingml/2006/main" noGrp="1"/>
+          </p:cNvSpPr>
+          <p:nvPr/>
+        </p:nvSpPr>
+        <p:spPr>
+          <a:xfrm xmlns:a="http://schemas.openxmlformats.org/drawingml/2006/main">
+            <a:off x="5668477" y="3310890"/>
+            <a:ext cx="419100" cy="350520"/>
+          </a:xfrm>
+          <a:prstGeom xmlns:a="http://schemas.openxmlformats.org/drawingml/2006/main" prst="rect">
+            <a:avLst/>
+          </a:prstGeom>
+          <a:noFill xmlns:a="http://schemas.openxmlformats.org/drawingml/2006/main"/>
+          <a:ln xmlns:a="http://schemas.openxmlformats.org/drawingml/2006/main" w="0">
+            <a:noFill/>
+            <a:prstDash val="solid"/>
+          </a:ln>
+        </p:spPr>
+        <p:txBody>
+          <a:bodyPr xmlns:a="http://schemas.openxmlformats.org/drawingml/2006/main"/>
+          <a:lstStyle xmlns:a="http://schemas.openxmlformats.org/drawingml/2006/main"/>
+          <a:p xmlns:a="http://schemas.openxmlformats.org/drawingml/2006/main">
+            <a:pPr>
+              <a:defRPr sz="900" b="1">
+                <a:solidFill>
+                  <a:srgbClr val="07111F"/>
+                </a:solidFill>
+              </a:defRPr>
+            </a:pPr>
+            <a:r>
+              <a:rPr sz="900" b="1">
+                <a:solidFill>
+                  <a:srgbClr val="07111F"/>
+                </a:solidFill>
+              </a:rPr>
+              <a:t>11%</a:t>
+            </a:r>
+          </a:p>
+        </p:txBody>
+      </p:sp>
+      <p:sp>
+        <p:nvSpPr>
+          <p:cNvPr id="38" name="">
+            <a:extLst xmlns:a="http://schemas.openxmlformats.org/drawingml/2006/main">
+              <a:ext uri="{FF2B5EF4-FFF2-40B4-BE49-F238E27FC236}">
+                <a16:creationId xmlns:a16="http://schemas.microsoft.com/office/drawing/2014/main" id="{F50BE886-03FA-4282-B09A-E318AAD63F45}"/>
+              </a:ext>
+            </a:extLst>
+          </p:cNvPr>
+          <p:cNvSpPr>
+            <a:spLocks xmlns:a="http://schemas.openxmlformats.org/drawingml/2006/main" noGrp="1"/>
+          </p:cNvSpPr>
+          <p:nvPr/>
+        </p:nvSpPr>
+        <p:spPr>
+          <a:xfrm xmlns:a="http://schemas.openxmlformats.org/drawingml/2006/main">
+            <a:off x="4171950" y="3737610"/>
+            <a:ext cx="1085850" cy="350520"/>
+          </a:xfrm>
+          <a:prstGeom xmlns:a="http://schemas.openxmlformats.org/drawingml/2006/main" prst="rect">
+            <a:avLst/>
+          </a:prstGeom>
+          <a:noFill xmlns:a="http://schemas.openxmlformats.org/drawingml/2006/main"/>
+          <a:ln xmlns:a="http://schemas.openxmlformats.org/drawingml/2006/main" w="0">
+            <a:noFill/>
+            <a:prstDash val="solid"/>
+          </a:ln>
+        </p:spPr>
+        <p:txBody>
+          <a:bodyPr xmlns:a="http://schemas.openxmlformats.org/drawingml/2006/main"/>
+          <a:lstStyle xmlns:a="http://schemas.openxmlformats.org/drawingml/2006/main"/>
+          <a:p xmlns:a="http://schemas.openxmlformats.org/drawingml/2006/main">
+            <a:pPr algn="r">
+              <a:defRPr sz="825">
+                <a:solidFill>
+                  <a:srgbClr val="42526B"/>
+                </a:solidFill>
+              </a:defRPr>
+            </a:pPr>
+            <a:r>
+              <a:rPr sz="825">
+                <a:solidFill>
+                  <a:srgbClr val="42526B"/>
+                </a:solidFill>
+              </a:rPr>
+              <a:t>Good value</a:t>
+            </a:r>
+          </a:p>
+        </p:txBody>
+      </p:sp>
+      <p:sp>
+        <p:nvSpPr>
+          <p:cNvPr id="39" name="">
+            <a:extLst xmlns:a="http://schemas.openxmlformats.org/drawingml/2006/main">
+              <a:ext uri="{FF2B5EF4-FFF2-40B4-BE49-F238E27FC236}">
+                <a16:creationId xmlns:a16="http://schemas.microsoft.com/office/drawing/2014/main" id="{14110B0D-033C-406B-8626-36A68AB9AA8E}"/>
+              </a:ext>
+            </a:extLst>
+          </p:cNvPr>
+          <p:cNvSpPr>
+            <a:spLocks xmlns:a="http://schemas.openxmlformats.org/drawingml/2006/main" noGrp="1"/>
+          </p:cNvSpPr>
+          <p:nvPr/>
+        </p:nvSpPr>
+        <p:spPr>
+          <a:xfrm xmlns:a="http://schemas.openxmlformats.org/drawingml/2006/main">
+            <a:off x="5334000" y="3747135"/>
+            <a:ext cx="1628775" cy="293370"/>
+          </a:xfrm>
+          <a:prstGeom xmlns:a="http://schemas.openxmlformats.org/drawingml/2006/main" prst="roundRect">
+            <a:avLst>
+              <a:gd name="adj" fmla="val 6494"/>
+            </a:avLst>
+          </a:prstGeom>
+          <a:solidFill xmlns:a="http://schemas.openxmlformats.org/drawingml/2006/main">
+            <a:srgbClr val="F3ECE3"/>
+          </a:solidFill>
+          <a:ln xmlns:a="http://schemas.openxmlformats.org/drawingml/2006/main" w="0">
+            <a:solidFill>
+              <a:srgbClr val="F3ECE3"/>
+            </a:solidFill>
+            <a:prstDash val="solid"/>
+          </a:ln>
+        </p:spPr>
+      </p:sp>
+      <p:sp>
+        <p:nvSpPr>
+          <p:cNvPr id="40" name="">
+            <a:extLst xmlns:a="http://schemas.openxmlformats.org/drawingml/2006/main">
+              <a:ext uri="{FF2B5EF4-FFF2-40B4-BE49-F238E27FC236}">
+                <a16:creationId xmlns:a16="http://schemas.microsoft.com/office/drawing/2014/main" id="{194D8E3C-CB24-4B03-A30C-FA9DD8BAEC95}"/>
+              </a:ext>
+            </a:extLst>
+          </p:cNvPr>
+          <p:cNvSpPr>
+            <a:spLocks xmlns:a="http://schemas.openxmlformats.org/drawingml/2006/main" noGrp="1"/>
+          </p:cNvSpPr>
+          <p:nvPr/>
+        </p:nvSpPr>
+        <p:spPr>
+          <a:xfrm xmlns:a="http://schemas.openxmlformats.org/drawingml/2006/main">
+            <a:off x="5334000" y="3747135"/>
+            <a:ext cx="1286732" cy="293370"/>
+          </a:xfrm>
+          <a:prstGeom xmlns:a="http://schemas.openxmlformats.org/drawingml/2006/main" prst="roundRect">
+            <a:avLst>
+              <a:gd name="adj" fmla="val 6494"/>
+            </a:avLst>
+          </a:prstGeom>
+          <a:solidFill xmlns:a="http://schemas.openxmlformats.org/drawingml/2006/main">
+            <a:srgbClr val="F59E0B"/>
+          </a:solidFill>
+          <a:ln xmlns:a="http://schemas.openxmlformats.org/drawingml/2006/main" w="0">
+            <a:solidFill>
+              <a:srgbClr val="F59E0B"/>
+            </a:solidFill>
+            <a:prstDash val="solid"/>
+          </a:ln>
+        </p:spPr>
+      </p:sp>
+      <p:sp>
+        <p:nvSpPr>
+          <p:cNvPr id="41" name="">
+            <a:extLst xmlns:a="http://schemas.openxmlformats.org/drawingml/2006/main">
+              <a:ext uri="{FF2B5EF4-FFF2-40B4-BE49-F238E27FC236}">
+                <a16:creationId xmlns:a16="http://schemas.microsoft.com/office/drawing/2014/main" id="{4D03B640-F106-4F68-8884-E296582B3839}"/>
+              </a:ext>
+            </a:extLst>
+          </p:cNvPr>
+          <p:cNvSpPr>
+            <a:spLocks xmlns:a="http://schemas.openxmlformats.org/drawingml/2006/main" noGrp="1"/>
+          </p:cNvSpPr>
+          <p:nvPr/>
+        </p:nvSpPr>
+        <p:spPr>
+          <a:xfrm xmlns:a="http://schemas.openxmlformats.org/drawingml/2006/main">
+            <a:off x="6696932" y="3756660"/>
+            <a:ext cx="419100" cy="350520"/>
+          </a:xfrm>
+          <a:prstGeom xmlns:a="http://schemas.openxmlformats.org/drawingml/2006/main" prst="rect">
+            <a:avLst/>
+          </a:prstGeom>
+          <a:noFill xmlns:a="http://schemas.openxmlformats.org/drawingml/2006/main"/>
+          <a:ln xmlns:a="http://schemas.openxmlformats.org/drawingml/2006/main" w="0">
+            <a:noFill/>
+            <a:prstDash val="solid"/>
+          </a:ln>
+        </p:spPr>
+        <p:txBody>
+          <a:bodyPr xmlns:a="http://schemas.openxmlformats.org/drawingml/2006/main"/>
+          <a:lstStyle xmlns:a="http://schemas.openxmlformats.org/drawingml/2006/main"/>
+          <a:p xmlns:a="http://schemas.openxmlformats.org/drawingml/2006/main">
+            <a:pPr>
+              <a:defRPr sz="900" b="1">
+                <a:solidFill>
+                  <a:srgbClr val="07111F"/>
+                </a:solidFill>
+              </a:defRPr>
+            </a:pPr>
+            <a:r>
+              <a:rPr sz="900" b="1">
+                <a:solidFill>
+                  <a:srgbClr val="07111F"/>
+                </a:solidFill>
+              </a:rPr>
+              <a:t>55%</a:t>
+            </a:r>
+          </a:p>
+        </p:txBody>
+      </p:sp>
+      <p:sp>
+        <p:nvSpPr>
+          <p:cNvPr id="42" name="">
+            <a:extLst xmlns:a="http://schemas.openxmlformats.org/drawingml/2006/main">
+              <a:ext uri="{FF2B5EF4-FFF2-40B4-BE49-F238E27FC236}">
+                <a16:creationId xmlns:a16="http://schemas.microsoft.com/office/drawing/2014/main" id="{BE1E73CC-0165-44A6-8BAE-61FF8A6AF447}"/>
+              </a:ext>
+            </a:extLst>
+          </p:cNvPr>
+          <p:cNvSpPr>
+            <a:spLocks xmlns:a="http://schemas.openxmlformats.org/drawingml/2006/main" noGrp="1"/>
+          </p:cNvSpPr>
+          <p:nvPr/>
+        </p:nvSpPr>
+        <p:spPr>
+          <a:xfrm xmlns:a="http://schemas.openxmlformats.org/drawingml/2006/main">
+            <a:off x="4171950" y="4183380"/>
+            <a:ext cx="1085850" cy="350520"/>
+          </a:xfrm>
+          <a:prstGeom xmlns:a="http://schemas.openxmlformats.org/drawingml/2006/main" prst="rect">
+            <a:avLst/>
+          </a:prstGeom>
+          <a:noFill xmlns:a="http://schemas.openxmlformats.org/drawingml/2006/main"/>
+          <a:ln xmlns:a="http://schemas.openxmlformats.org/drawingml/2006/main" w="0">
+            <a:noFill/>
+            <a:prstDash val="solid"/>
+          </a:ln>
+        </p:spPr>
+        <p:txBody>
+          <a:bodyPr xmlns:a="http://schemas.openxmlformats.org/drawingml/2006/main"/>
+          <a:lstStyle xmlns:a="http://schemas.openxmlformats.org/drawingml/2006/main"/>
+          <a:p xmlns:a="http://schemas.openxmlformats.org/drawingml/2006/main">
+            <a:pPr algn="r">
+              <a:defRPr sz="825">
+                <a:solidFill>
+                  <a:srgbClr val="42526B"/>
+                </a:solidFill>
+              </a:defRPr>
+            </a:pPr>
+            <a:r>
+              <a:rPr sz="825">
+                <a:solidFill>
+                  <a:srgbClr val="42526B"/>
+                </a:solidFill>
+              </a:rPr>
+              <a:t>Pay more</a:t>
+            </a:r>
+          </a:p>
+        </p:txBody>
+      </p:sp>
+      <p:sp>
+        <p:nvSpPr>
+          <p:cNvPr id="43" name="">
+            <a:extLst xmlns:a="http://schemas.openxmlformats.org/drawingml/2006/main">
+              <a:ext uri="{FF2B5EF4-FFF2-40B4-BE49-F238E27FC236}">
+                <a16:creationId xmlns:a16="http://schemas.microsoft.com/office/drawing/2014/main" id="{CCB0B96F-8536-4E2B-8846-B3C6FF81C73E}"/>
+              </a:ext>
+            </a:extLst>
+          </p:cNvPr>
+          <p:cNvSpPr>
+            <a:spLocks xmlns:a="http://schemas.openxmlformats.org/drawingml/2006/main" noGrp="1"/>
+          </p:cNvSpPr>
+          <p:nvPr/>
+        </p:nvSpPr>
+        <p:spPr>
+          <a:xfrm xmlns:a="http://schemas.openxmlformats.org/drawingml/2006/main">
+            <a:off x="5334000" y="4192905"/>
+            <a:ext cx="1628775" cy="293370"/>
+          </a:xfrm>
+          <a:prstGeom xmlns:a="http://schemas.openxmlformats.org/drawingml/2006/main" prst="roundRect">
+            <a:avLst>
+              <a:gd name="adj" fmla="val 6494"/>
+            </a:avLst>
+          </a:prstGeom>
+          <a:solidFill xmlns:a="http://schemas.openxmlformats.org/drawingml/2006/main">
+            <a:srgbClr val="F3ECE3"/>
+          </a:solidFill>
+          <a:ln xmlns:a="http://schemas.openxmlformats.org/drawingml/2006/main" w="0">
+            <a:solidFill>
+              <a:srgbClr val="F3ECE3"/>
+            </a:solidFill>
+            <a:prstDash val="solid"/>
+          </a:ln>
+        </p:spPr>
+      </p:sp>
+      <p:sp>
+        <p:nvSpPr>
+          <p:cNvPr id="44" name="">
+            <a:extLst xmlns:a="http://schemas.openxmlformats.org/drawingml/2006/main">
+              <a:ext uri="{FF2B5EF4-FFF2-40B4-BE49-F238E27FC236}">
+                <a16:creationId xmlns:a16="http://schemas.microsoft.com/office/drawing/2014/main" id="{6E0DD535-CEA9-4BD6-9CB9-310564667BB5}"/>
+              </a:ext>
+            </a:extLst>
+          </p:cNvPr>
+          <p:cNvSpPr>
+            <a:spLocks xmlns:a="http://schemas.openxmlformats.org/drawingml/2006/main" noGrp="1"/>
+          </p:cNvSpPr>
+          <p:nvPr/>
+        </p:nvSpPr>
+        <p:spPr>
+          <a:xfrm xmlns:a="http://schemas.openxmlformats.org/drawingml/2006/main">
+            <a:off x="5334000" y="4192905"/>
+            <a:ext cx="830675" cy="293370"/>
+          </a:xfrm>
+          <a:prstGeom xmlns:a="http://schemas.openxmlformats.org/drawingml/2006/main" prst="roundRect">
+            <a:avLst>
+              <a:gd name="adj" fmla="val 6494"/>
+            </a:avLst>
+          </a:prstGeom>
+          <a:solidFill xmlns:a="http://schemas.openxmlformats.org/drawingml/2006/main">
+            <a:srgbClr val="F59E0B"/>
+          </a:solidFill>
+          <a:ln xmlns:a="http://schemas.openxmlformats.org/drawingml/2006/main" w="0">
+            <a:solidFill>
+              <a:srgbClr val="F59E0B"/>
+            </a:solidFill>
+            <a:prstDash val="solid"/>
+          </a:ln>
+        </p:spPr>
+      </p:sp>
+      <p:sp>
+        <p:nvSpPr>
+          <p:cNvPr id="45" name="">
+            <a:extLst xmlns:a="http://schemas.openxmlformats.org/drawingml/2006/main">
+              <a:ext uri="{FF2B5EF4-FFF2-40B4-BE49-F238E27FC236}">
+                <a16:creationId xmlns:a16="http://schemas.microsoft.com/office/drawing/2014/main" id="{DBBDD839-8D81-4642-A217-16A76CBE2402}"/>
+              </a:ext>
+            </a:extLst>
+          </p:cNvPr>
+          <p:cNvSpPr>
+            <a:spLocks xmlns:a="http://schemas.openxmlformats.org/drawingml/2006/main" noGrp="1"/>
+          </p:cNvSpPr>
+          <p:nvPr/>
+        </p:nvSpPr>
+        <p:spPr>
+          <a:xfrm xmlns:a="http://schemas.openxmlformats.org/drawingml/2006/main">
+            <a:off x="6240875" y="4202430"/>
+            <a:ext cx="419100" cy="350520"/>
+          </a:xfrm>
+          <a:prstGeom xmlns:a="http://schemas.openxmlformats.org/drawingml/2006/main" prst="rect">
+            <a:avLst/>
+          </a:prstGeom>
+          <a:noFill xmlns:a="http://schemas.openxmlformats.org/drawingml/2006/main"/>
+          <a:ln xmlns:a="http://schemas.openxmlformats.org/drawingml/2006/main" w="0">
+            <a:noFill/>
+            <a:prstDash val="solid"/>
+          </a:ln>
+        </p:spPr>
+        <p:txBody>
+          <a:bodyPr xmlns:a="http://schemas.openxmlformats.org/drawingml/2006/main"/>
+          <a:lstStyle xmlns:a="http://schemas.openxmlformats.org/drawingml/2006/main"/>
+          <a:p xmlns:a="http://schemas.openxmlformats.org/drawingml/2006/main">
+            <a:pPr>
+              <a:defRPr sz="900" b="1">
+                <a:solidFill>
+                  <a:srgbClr val="07111F"/>
+                </a:solidFill>
+              </a:defRPr>
+            </a:pPr>
+            <a:r>
+              <a:rPr sz="900" b="1">
+                <a:solidFill>
+                  <a:srgbClr val="07111F"/>
+                </a:solidFill>
+              </a:rPr>
+              <a:t>36%</a:t>
+            </a:r>
+          </a:p>
+        </p:txBody>
+      </p:sp>
+      <p:sp>
+        <p:nvSpPr>
+          <p:cNvPr id="46" name="">
+            <a:extLst xmlns:a="http://schemas.openxmlformats.org/drawingml/2006/main">
+              <a:ext uri="{FF2B5EF4-FFF2-40B4-BE49-F238E27FC236}">
+                <a16:creationId xmlns:a16="http://schemas.microsoft.com/office/drawing/2014/main" id="{7B7A59C9-47AA-4F9E-A637-AEC62DA0236A}"/>
+              </a:ext>
+            </a:extLst>
+          </p:cNvPr>
+          <p:cNvSpPr>
+            <a:spLocks xmlns:a="http://schemas.openxmlformats.org/drawingml/2006/main" noGrp="1"/>
+          </p:cNvSpPr>
+          <p:nvPr/>
+        </p:nvSpPr>
+        <p:spPr>
+          <a:xfrm xmlns:a="http://schemas.openxmlformats.org/drawingml/2006/main">
+            <a:off x="5448300" y="4781550"/>
+            <a:ext cx="819150" cy="228600"/>
           </a:xfrm>
           <a:prstGeom xmlns:a="http://schemas.openxmlformats.org/drawingml/2006/main" prst="rect">
             <a:avLst/>
@@ -6817,116 +8069,16 @@
           <a:lstStyle xmlns:a="http://schemas.openxmlformats.org/drawingml/2006/main"/>
           <a:p xmlns:a="http://schemas.openxmlformats.org/drawingml/2006/main">
             <a:pPr algn="ctr">
-              <a:defRPr sz="1050" b="1">
-                <a:solidFill>
-                  <a:srgbClr val="FFFFFF"/>
-                </a:solidFill>
-              </a:defRPr>
-            </a:pPr>
-            <a:r>
-              <a:rPr sz="1050" b="1">
-                <a:solidFill>
-                  <a:srgbClr val="FFFFFF"/>
-                </a:solidFill>
-              </a:rPr>
-              <a:t>20%</a:t>
-            </a:r>
-          </a:p>
-        </p:txBody>
-      </p:sp>
-      <p:sp>
-        <p:nvSpPr>
-          <p:cNvPr id="18" name="">
-            <a:extLst xmlns:a="http://schemas.openxmlformats.org/drawingml/2006/main">
-              <a:ext uri="{FF2B5EF4-FFF2-40B4-BE49-F238E27FC236}">
-                <a16:creationId xmlns:a16="http://schemas.microsoft.com/office/drawing/2014/main" id="{F2E69CE3-2DE3-43CD-960D-091471B0D1D7}"/>
-              </a:ext>
-            </a:extLst>
-          </p:cNvPr>
-          <p:cNvSpPr>
-            <a:spLocks xmlns:a="http://schemas.openxmlformats.org/drawingml/2006/main" noGrp="1"/>
-          </p:cNvSpPr>
-          <p:nvPr/>
-        </p:nvSpPr>
-        <p:spPr>
-          <a:xfrm xmlns:a="http://schemas.openxmlformats.org/drawingml/2006/main">
-            <a:off x="3867150" y="4762500"/>
-            <a:ext cx="1028700" cy="209550"/>
-          </a:xfrm>
-          <a:prstGeom xmlns:a="http://schemas.openxmlformats.org/drawingml/2006/main" prst="rect">
-            <a:avLst/>
-          </a:prstGeom>
-          <a:noFill xmlns:a="http://schemas.openxmlformats.org/drawingml/2006/main"/>
-          <a:ln xmlns:a="http://schemas.openxmlformats.org/drawingml/2006/main" w="0">
-            <a:noFill/>
-            <a:prstDash val="solid"/>
-          </a:ln>
-        </p:spPr>
-        <p:txBody>
-          <a:bodyPr xmlns:a="http://schemas.openxmlformats.org/drawingml/2006/main"/>
-          <a:lstStyle xmlns:a="http://schemas.openxmlformats.org/drawingml/2006/main"/>
-          <a:p xmlns:a="http://schemas.openxmlformats.org/drawingml/2006/main">
-            <a:pPr algn="ctr">
-              <a:defRPr sz="1050">
-                <a:solidFill>
-                  <a:srgbClr val="42526B"/>
-                </a:solidFill>
-              </a:defRPr>
-            </a:pPr>
-            <a:r>
-              <a:rPr sz="1050">
-                <a:solidFill>
-                  <a:srgbClr val="42526B"/>
-                </a:solidFill>
-              </a:rPr>
-              <a:t>Q2 '26</a:t>
-            </a:r>
-          </a:p>
-        </p:txBody>
-      </p:sp>
-      <p:sp>
-        <p:nvSpPr>
-          <p:cNvPr id="19" name="">
-            <a:extLst xmlns:a="http://schemas.openxmlformats.org/drawingml/2006/main">
-              <a:ext uri="{FF2B5EF4-FFF2-40B4-BE49-F238E27FC236}">
-                <a16:creationId xmlns:a16="http://schemas.microsoft.com/office/drawing/2014/main" id="{1D9D354F-3C5F-4A95-BBDA-7666E84E352A}"/>
-              </a:ext>
-            </a:extLst>
-          </p:cNvPr>
-          <p:cNvSpPr>
-            <a:spLocks xmlns:a="http://schemas.openxmlformats.org/drawingml/2006/main" noGrp="1"/>
-          </p:cNvSpPr>
-          <p:nvPr/>
-        </p:nvSpPr>
-        <p:spPr>
-          <a:xfrm xmlns:a="http://schemas.openxmlformats.org/drawingml/2006/main">
-            <a:off x="4991100" y="2781300"/>
-            <a:ext cx="762000" cy="190500"/>
-          </a:xfrm>
-          <a:prstGeom xmlns:a="http://schemas.openxmlformats.org/drawingml/2006/main" prst="rect">
-            <a:avLst/>
-          </a:prstGeom>
-          <a:noFill xmlns:a="http://schemas.openxmlformats.org/drawingml/2006/main"/>
-          <a:ln xmlns:a="http://schemas.openxmlformats.org/drawingml/2006/main" w="0">
-            <a:noFill/>
-            <a:prstDash val="solid"/>
-          </a:ln>
-        </p:spPr>
-        <p:txBody>
-          <a:bodyPr xmlns:a="http://schemas.openxmlformats.org/drawingml/2006/main"/>
-          <a:lstStyle xmlns:a="http://schemas.openxmlformats.org/drawingml/2006/main"/>
-          <a:p xmlns:a="http://schemas.openxmlformats.org/drawingml/2006/main">
-            <a:pPr>
-              <a:defRPr sz="1050" b="1">
-                <a:solidFill>
-                  <a:srgbClr val="42526B"/>
-                </a:solidFill>
-              </a:defRPr>
-            </a:pPr>
-            <a:r>
-              <a:rPr sz="1050" b="1">
-                <a:solidFill>
-                  <a:srgbClr val="42526B"/>
+              <a:defRPr sz="1125" b="1">
+                <a:solidFill>
+                  <a:srgbClr val="F59E0B"/>
+                </a:solidFill>
+              </a:defRPr>
+            </a:pPr>
+            <a:r>
+              <a:rPr sz="1125" b="1">
+                <a:solidFill>
+                  <a:srgbClr val="F59E0B"/>
                 </a:solidFill>
               </a:rPr>
               <a:t>40+</a:t>
@@ -6936,72 +8088,22 @@
       </p:sp>
       <p:sp>
         <p:nvSpPr>
-          <p:cNvPr id="20" name="">
-            <a:extLst xmlns:a="http://schemas.openxmlformats.org/drawingml/2006/main">
-              <a:ext uri="{FF2B5EF4-FFF2-40B4-BE49-F238E27FC236}">
-                <a16:creationId xmlns:a16="http://schemas.microsoft.com/office/drawing/2014/main" id="{2ED53E7A-5500-4018-B28D-5CE93E9428CF}"/>
-              </a:ext>
-            </a:extLst>
-          </p:cNvPr>
-          <p:cNvSpPr>
-            <a:spLocks xmlns:a="http://schemas.openxmlformats.org/drawingml/2006/main" noGrp="1"/>
-          </p:cNvSpPr>
-          <p:nvPr/>
-        </p:nvSpPr>
-        <p:spPr>
-          <a:xfrm xmlns:a="http://schemas.openxmlformats.org/drawingml/2006/main">
-            <a:off x="4991100" y="4286250"/>
-            <a:ext cx="952500" cy="190500"/>
-          </a:xfrm>
-          <a:prstGeom xmlns:a="http://schemas.openxmlformats.org/drawingml/2006/main" prst="rect">
-            <a:avLst/>
-          </a:prstGeom>
-          <a:noFill xmlns:a="http://schemas.openxmlformats.org/drawingml/2006/main"/>
-          <a:ln xmlns:a="http://schemas.openxmlformats.org/drawingml/2006/main" w="0">
-            <a:noFill/>
-            <a:prstDash val="solid"/>
-          </a:ln>
-        </p:spPr>
-        <p:txBody>
-          <a:bodyPr xmlns:a="http://schemas.openxmlformats.org/drawingml/2006/main"/>
-          <a:lstStyle xmlns:a="http://schemas.openxmlformats.org/drawingml/2006/main"/>
-          <a:p xmlns:a="http://schemas.openxmlformats.org/drawingml/2006/main">
-            <a:pPr>
-              <a:defRPr sz="1050" b="1">
-                <a:solidFill>
-                  <a:srgbClr val="7C3AED"/>
-                </a:solidFill>
-              </a:defRPr>
-            </a:pPr>
-            <a:r>
-              <a:rPr sz="1050" b="1">
-                <a:solidFill>
-                  <a:srgbClr val="7C3AED"/>
-                </a:solidFill>
-              </a:rPr>
-              <a:t>Under 40</a:t>
-            </a:r>
-          </a:p>
-        </p:txBody>
-      </p:sp>
-      <p:sp>
-        <p:nvSpPr>
-          <p:cNvPr id="21" name="">
-            <a:extLst xmlns:a="http://schemas.openxmlformats.org/drawingml/2006/main">
-              <a:ext uri="{FF2B5EF4-FFF2-40B4-BE49-F238E27FC236}">
-                <a16:creationId xmlns:a16="http://schemas.microsoft.com/office/drawing/2014/main" id="{A982BE0D-AB30-4BBC-9069-83B87DADC20D}"/>
-              </a:ext>
-            </a:extLst>
-          </p:cNvPr>
-          <p:cNvSpPr>
-            <a:spLocks xmlns:a="http://schemas.openxmlformats.org/drawingml/2006/main" noGrp="1"/>
-          </p:cNvSpPr>
-          <p:nvPr/>
-        </p:nvSpPr>
-        <p:spPr>
-          <a:xfrm xmlns:a="http://schemas.openxmlformats.org/drawingml/2006/main">
-            <a:off x="6515100" y="2114550"/>
-            <a:ext cx="4667250" cy="666750"/>
+          <p:cNvPr id="47" name="">
+            <a:extLst xmlns:a="http://schemas.openxmlformats.org/drawingml/2006/main">
+              <a:ext uri="{FF2B5EF4-FFF2-40B4-BE49-F238E27FC236}">
+                <a16:creationId xmlns:a16="http://schemas.microsoft.com/office/drawing/2014/main" id="{97CF2917-4A73-48F5-AAD4-995EA5E30FB7}"/>
+              </a:ext>
+            </a:extLst>
+          </p:cNvPr>
+          <p:cNvSpPr>
+            <a:spLocks xmlns:a="http://schemas.openxmlformats.org/drawingml/2006/main" noGrp="1"/>
+          </p:cNvSpPr>
+          <p:nvPr/>
+        </p:nvSpPr>
+        <p:spPr>
+          <a:xfrm xmlns:a="http://schemas.openxmlformats.org/drawingml/2006/main">
+            <a:off x="7829550" y="2114550"/>
+            <a:ext cx="3390900" cy="666750"/>
           </a:xfrm>
           <a:prstGeom xmlns:a="http://schemas.openxmlformats.org/drawingml/2006/main" prst="roundRect">
             <a:avLst>
@@ -7021,22 +8123,22 @@
       </p:sp>
       <p:sp>
         <p:nvSpPr>
-          <p:cNvPr id="22" name="">
-            <a:extLst xmlns:a="http://schemas.openxmlformats.org/drawingml/2006/main">
-              <a:ext uri="{FF2B5EF4-FFF2-40B4-BE49-F238E27FC236}">
-                <a16:creationId xmlns:a16="http://schemas.microsoft.com/office/drawing/2014/main" id="{84C87B20-C433-4E85-8EB3-834F63BD45CA}"/>
-              </a:ext>
-            </a:extLst>
-          </p:cNvPr>
-          <p:cNvSpPr>
-            <a:spLocks xmlns:a="http://schemas.openxmlformats.org/drawingml/2006/main" noGrp="1"/>
-          </p:cNvSpPr>
-          <p:nvPr/>
-        </p:nvSpPr>
-        <p:spPr>
-          <a:xfrm xmlns:a="http://schemas.openxmlformats.org/drawingml/2006/main">
-            <a:off x="6705600" y="2247900"/>
-            <a:ext cx="1428750" cy="209550"/>
+          <p:cNvPr id="48" name="">
+            <a:extLst xmlns:a="http://schemas.openxmlformats.org/drawingml/2006/main">
+              <a:ext uri="{FF2B5EF4-FFF2-40B4-BE49-F238E27FC236}">
+                <a16:creationId xmlns:a16="http://schemas.microsoft.com/office/drawing/2014/main" id="{4954D653-EF0F-4C15-B2C1-9121617C72B5}"/>
+              </a:ext>
+            </a:extLst>
+          </p:cNvPr>
+          <p:cNvSpPr>
+            <a:spLocks xmlns:a="http://schemas.openxmlformats.org/drawingml/2006/main" noGrp="1"/>
+          </p:cNvSpPr>
+          <p:nvPr/>
+        </p:nvSpPr>
+        <p:spPr>
+          <a:xfrm xmlns:a="http://schemas.openxmlformats.org/drawingml/2006/main">
+            <a:off x="8020050" y="2247900"/>
+            <a:ext cx="914400" cy="209550"/>
           </a:xfrm>
           <a:prstGeom xmlns:a="http://schemas.openxmlformats.org/drawingml/2006/main" prst="rect">
             <a:avLst/>
@@ -7064,29 +8166,29 @@
                   <a:srgbClr val="07111F"/>
                 </a:solidFill>
               </a:rPr>
-              <a:t>Sample mix</a:t>
-            </a:r>
-          </a:p>
-        </p:txBody>
-      </p:sp>
-      <p:sp>
-        <p:nvSpPr>
-          <p:cNvPr id="23" name="">
-            <a:extLst xmlns:a="http://schemas.openxmlformats.org/drawingml/2006/main">
-              <a:ext uri="{FF2B5EF4-FFF2-40B4-BE49-F238E27FC236}">
-                <a16:creationId xmlns:a16="http://schemas.microsoft.com/office/drawing/2014/main" id="{36CF1F94-010B-4718-B290-8CBCD6068489}"/>
-              </a:ext>
-            </a:extLst>
-          </p:cNvPr>
-          <p:cNvSpPr>
-            <a:spLocks xmlns:a="http://schemas.openxmlformats.org/drawingml/2006/main" noGrp="1"/>
-          </p:cNvSpPr>
-          <p:nvPr/>
-        </p:nvSpPr>
-        <p:spPr>
-          <a:xfrm xmlns:a="http://schemas.openxmlformats.org/drawingml/2006/main">
-            <a:off x="8191500" y="2228850"/>
-            <a:ext cx="2800350" cy="438150"/>
+              <a:t>Same job</a:t>
+            </a:r>
+          </a:p>
+        </p:txBody>
+      </p:sp>
+      <p:sp>
+        <p:nvSpPr>
+          <p:cNvPr id="49" name="">
+            <a:extLst xmlns:a="http://schemas.openxmlformats.org/drawingml/2006/main">
+              <a:ext uri="{FF2B5EF4-FFF2-40B4-BE49-F238E27FC236}">
+                <a16:creationId xmlns:a16="http://schemas.microsoft.com/office/drawing/2014/main" id="{8C190628-FF39-4DDF-980D-BA6AE292792E}"/>
+              </a:ext>
+            </a:extLst>
+          </p:cNvPr>
+          <p:cNvSpPr>
+            <a:spLocks xmlns:a="http://schemas.openxmlformats.org/drawingml/2006/main" noGrp="1"/>
+          </p:cNvSpPr>
+          <p:nvPr/>
+        </p:nvSpPr>
+        <p:spPr>
+          <a:xfrm xmlns:a="http://schemas.openxmlformats.org/drawingml/2006/main">
+            <a:off x="8953500" y="2228850"/>
+            <a:ext cx="2076450" cy="438150"/>
           </a:xfrm>
           <a:prstGeom xmlns:a="http://schemas.openxmlformats.org/drawingml/2006/main" prst="rect">
             <a:avLst/>
@@ -7102,41 +8204,41 @@
           <a:lstStyle xmlns:a="http://schemas.openxmlformats.org/drawingml/2006/main"/>
           <a:p xmlns:a="http://schemas.openxmlformats.org/drawingml/2006/main">
             <a:pPr>
-              <a:defRPr sz="1050">
+              <a:defRPr sz="1013">
                 <a:solidFill>
                   <a:srgbClr val="42526B"/>
                 </a:solidFill>
               </a:defRPr>
             </a:pPr>
             <a:r>
-              <a:rPr sz="1050">
+              <a:rPr sz="1013">
                 <a:solidFill>
                   <a:srgbClr val="42526B"/>
                 </a:solidFill>
               </a:rPr>
-              <a:t>Under-40 share fell to 20.2% in Q2. That can depress recall for brands with younger/social-led memory.</a:t>
-            </a:r>
-          </a:p>
-        </p:txBody>
-      </p:sp>
-      <p:sp>
-        <p:nvSpPr>
-          <p:cNvPr id="24" name="">
-            <a:extLst xmlns:a="http://schemas.openxmlformats.org/drawingml/2006/main">
-              <a:ext uri="{FF2B5EF4-FFF2-40B4-BE49-F238E27FC236}">
-                <a16:creationId xmlns:a16="http://schemas.microsoft.com/office/drawing/2014/main" id="{FC36BE64-7924-44CC-86EA-E7F3537C6DF4}"/>
-              </a:ext>
-            </a:extLst>
-          </p:cNvPr>
-          <p:cNvSpPr>
-            <a:spLocks xmlns:a="http://schemas.openxmlformats.org/drawingml/2006/main" noGrp="1"/>
-          </p:cNvSpPr>
-          <p:nvPr/>
-        </p:nvSpPr>
-        <p:spPr>
-          <a:xfrm xmlns:a="http://schemas.openxmlformats.org/drawingml/2006/main">
-            <a:off x="6515100" y="2933700"/>
-            <a:ext cx="4667250" cy="666750"/>
+              <a:t>Aided awareness and consideration are close by age. Shapermint's gap is not one audience only.</a:t>
+            </a:r>
+          </a:p>
+        </p:txBody>
+      </p:sp>
+      <p:sp>
+        <p:nvSpPr>
+          <p:cNvPr id="50" name="">
+            <a:extLst xmlns:a="http://schemas.openxmlformats.org/drawingml/2006/main">
+              <a:ext uri="{FF2B5EF4-FFF2-40B4-BE49-F238E27FC236}">
+                <a16:creationId xmlns:a16="http://schemas.microsoft.com/office/drawing/2014/main" id="{C15D5A81-D652-4325-9945-DC3ABBF5F6B5}"/>
+              </a:ext>
+            </a:extLst>
+          </p:cNvPr>
+          <p:cNvSpPr>
+            <a:spLocks xmlns:a="http://schemas.openxmlformats.org/drawingml/2006/main" noGrp="1"/>
+          </p:cNvSpPr>
+          <p:nvPr/>
+        </p:nvSpPr>
+        <p:spPr>
+          <a:xfrm xmlns:a="http://schemas.openxmlformats.org/drawingml/2006/main">
+            <a:off x="7829550" y="2933700"/>
+            <a:ext cx="3390900" cy="666750"/>
           </a:xfrm>
           <a:prstGeom xmlns:a="http://schemas.openxmlformats.org/drawingml/2006/main" prst="roundRect">
             <a:avLst>
@@ -7156,22 +8258,22 @@
       </p:sp>
       <p:sp>
         <p:nvSpPr>
-          <p:cNvPr id="25" name="">
-            <a:extLst xmlns:a="http://schemas.openxmlformats.org/drawingml/2006/main">
-              <a:ext uri="{FF2B5EF4-FFF2-40B4-BE49-F238E27FC236}">
-                <a16:creationId xmlns:a16="http://schemas.microsoft.com/office/drawing/2014/main" id="{233CA9AD-C2B6-46FD-8937-C48C48E711F6}"/>
-              </a:ext>
-            </a:extLst>
-          </p:cNvPr>
-          <p:cNvSpPr>
-            <a:spLocks xmlns:a="http://schemas.openxmlformats.org/drawingml/2006/main" noGrp="1"/>
-          </p:cNvSpPr>
-          <p:nvPr/>
-        </p:nvSpPr>
-        <p:spPr>
-          <a:xfrm xmlns:a="http://schemas.openxmlformats.org/drawingml/2006/main">
-            <a:off x="6705600" y="3067050"/>
-            <a:ext cx="1428750" cy="209550"/>
+          <p:cNvPr id="51" name="">
+            <a:extLst xmlns:a="http://schemas.openxmlformats.org/drawingml/2006/main">
+              <a:ext uri="{FF2B5EF4-FFF2-40B4-BE49-F238E27FC236}">
+                <a16:creationId xmlns:a16="http://schemas.microsoft.com/office/drawing/2014/main" id="{F861B2B4-6485-45E6-9348-11571D0D693F}"/>
+              </a:ext>
+            </a:extLst>
+          </p:cNvPr>
+          <p:cNvSpPr>
+            <a:spLocks xmlns:a="http://schemas.openxmlformats.org/drawingml/2006/main" noGrp="1"/>
+          </p:cNvSpPr>
+          <p:nvPr/>
+        </p:nvSpPr>
+        <p:spPr>
+          <a:xfrm xmlns:a="http://schemas.openxmlformats.org/drawingml/2006/main">
+            <a:off x="8020050" y="3067050"/>
+            <a:ext cx="914400" cy="209550"/>
           </a:xfrm>
           <a:prstGeom xmlns:a="http://schemas.openxmlformats.org/drawingml/2006/main" prst="rect">
             <a:avLst/>
@@ -7199,29 +8301,29 @@
                   <a:srgbClr val="07111F"/>
                 </a:solidFill>
               </a:rPr>
-              <a:t>Broad aided reset</a:t>
-            </a:r>
-          </a:p>
-        </p:txBody>
-      </p:sp>
-      <p:sp>
-        <p:nvSpPr>
-          <p:cNvPr id="26" name="">
-            <a:extLst xmlns:a="http://schemas.openxmlformats.org/drawingml/2006/main">
-              <a:ext uri="{FF2B5EF4-FFF2-40B4-BE49-F238E27FC236}">
-                <a16:creationId xmlns:a16="http://schemas.microsoft.com/office/drawing/2014/main" id="{E81A1796-B2D4-4B4C-954E-D72090844DE9}"/>
-              </a:ext>
-            </a:extLst>
-          </p:cNvPr>
-          <p:cNvSpPr>
-            <a:spLocks xmlns:a="http://schemas.openxmlformats.org/drawingml/2006/main" noGrp="1"/>
-          </p:cNvSpPr>
-          <p:nvPr/>
-        </p:nvSpPr>
-        <p:spPr>
-          <a:xfrm xmlns:a="http://schemas.openxmlformats.org/drawingml/2006/main">
-            <a:off x="8191500" y="3048000"/>
-            <a:ext cx="2800350" cy="438150"/>
+              <a:t>Under 40</a:t>
+            </a:r>
+          </a:p>
+        </p:txBody>
+      </p:sp>
+      <p:sp>
+        <p:nvSpPr>
+          <p:cNvPr id="52" name="">
+            <a:extLst xmlns:a="http://schemas.openxmlformats.org/drawingml/2006/main">
+              <a:ext uri="{FF2B5EF4-FFF2-40B4-BE49-F238E27FC236}">
+                <a16:creationId xmlns:a16="http://schemas.microsoft.com/office/drawing/2014/main" id="{C8253A3D-0A7F-4F3D-8344-FE48FF6C4A06}"/>
+              </a:ext>
+            </a:extLst>
+          </p:cNvPr>
+          <p:cNvSpPr>
+            <a:spLocks xmlns:a="http://schemas.openxmlformats.org/drawingml/2006/main" noGrp="1"/>
+          </p:cNvSpPr>
+          <p:nvPr/>
+        </p:nvSpPr>
+        <p:spPr>
+          <a:xfrm xmlns:a="http://schemas.openxmlformats.org/drawingml/2006/main">
+            <a:off x="8953500" y="3048000"/>
+            <a:ext cx="2076450" cy="438150"/>
           </a:xfrm>
           <a:prstGeom xmlns:a="http://schemas.openxmlformats.org/drawingml/2006/main" prst="rect">
             <a:avLst/>
@@ -7237,41 +8339,41 @@
           <a:lstStyle xmlns:a="http://schemas.openxmlformats.org/drawingml/2006/main"/>
           <a:p xmlns:a="http://schemas.openxmlformats.org/drawingml/2006/main">
             <a:pPr>
-              <a:defRPr sz="1050">
+              <a:defRPr sz="1013">
                 <a:solidFill>
                   <a:srgbClr val="42526B"/>
                 </a:solidFill>
               </a:defRPr>
             </a:pPr>
             <a:r>
-              <a:rPr sz="1050">
+              <a:rPr sz="1013">
                 <a:solidFill>
                   <a:srgbClr val="42526B"/>
                 </a:solidFill>
               </a:rPr>
-              <a:t>Shapermint, Spanx, Skims, Maidenform, and Honeylove all fell on aided awareness, pointing to tracker/sample/context too.</a:t>
-            </a:r>
-          </a:p>
-        </p:txBody>
-      </p:sp>
-      <p:sp>
-        <p:nvSpPr>
-          <p:cNvPr id="27" name="">
-            <a:extLst xmlns:a="http://schemas.openxmlformats.org/drawingml/2006/main">
-              <a:ext uri="{FF2B5EF4-FFF2-40B4-BE49-F238E27FC236}">
-                <a16:creationId xmlns:a16="http://schemas.microsoft.com/office/drawing/2014/main" id="{F940402B-3880-4D14-A7A9-A2771947B95C}"/>
-              </a:ext>
-            </a:extLst>
-          </p:cNvPr>
-          <p:cNvSpPr>
-            <a:spLocks xmlns:a="http://schemas.openxmlformats.org/drawingml/2006/main" noGrp="1"/>
-          </p:cNvSpPr>
-          <p:nvPr/>
-        </p:nvSpPr>
-        <p:spPr>
-          <a:xfrm xmlns:a="http://schemas.openxmlformats.org/drawingml/2006/main">
-            <a:off x="6515100" y="3752850"/>
-            <a:ext cx="4667250" cy="666750"/>
+              <a:t>Skims dominates: 68% consider and 45% choose Skims. Shapermint is 27% / 6%.</a:t>
+            </a:r>
+          </a:p>
+        </p:txBody>
+      </p:sp>
+      <p:sp>
+        <p:nvSpPr>
+          <p:cNvPr id="53" name="">
+            <a:extLst xmlns:a="http://schemas.openxmlformats.org/drawingml/2006/main">
+              <a:ext uri="{FF2B5EF4-FFF2-40B4-BE49-F238E27FC236}">
+                <a16:creationId xmlns:a16="http://schemas.microsoft.com/office/drawing/2014/main" id="{7B98F121-9941-47B8-AF2B-4FD02AA1224F}"/>
+              </a:ext>
+            </a:extLst>
+          </p:cNvPr>
+          <p:cNvSpPr>
+            <a:spLocks xmlns:a="http://schemas.openxmlformats.org/drawingml/2006/main" noGrp="1"/>
+          </p:cNvSpPr>
+          <p:nvPr/>
+        </p:nvSpPr>
+        <p:spPr>
+          <a:xfrm xmlns:a="http://schemas.openxmlformats.org/drawingml/2006/main">
+            <a:off x="7829550" y="3752850"/>
+            <a:ext cx="3390900" cy="666750"/>
           </a:xfrm>
           <a:prstGeom xmlns:a="http://schemas.openxmlformats.org/drawingml/2006/main" prst="roundRect">
             <a:avLst>
@@ -7291,22 +8393,22 @@
       </p:sp>
       <p:sp>
         <p:nvSpPr>
-          <p:cNvPr id="28" name="">
-            <a:extLst xmlns:a="http://schemas.openxmlformats.org/drawingml/2006/main">
-              <a:ext uri="{FF2B5EF4-FFF2-40B4-BE49-F238E27FC236}">
-                <a16:creationId xmlns:a16="http://schemas.microsoft.com/office/drawing/2014/main" id="{C108A22C-BD10-4EA1-85E3-393C7B072A79}"/>
-              </a:ext>
-            </a:extLst>
-          </p:cNvPr>
-          <p:cNvSpPr>
-            <a:spLocks xmlns:a="http://schemas.openxmlformats.org/drawingml/2006/main" noGrp="1"/>
-          </p:cNvSpPr>
-          <p:nvPr/>
-        </p:nvSpPr>
-        <p:spPr>
-          <a:xfrm xmlns:a="http://schemas.openxmlformats.org/drawingml/2006/main">
-            <a:off x="6705600" y="3886200"/>
-            <a:ext cx="1428750" cy="209550"/>
+          <p:cNvPr id="54" name="">
+            <a:extLst xmlns:a="http://schemas.openxmlformats.org/drawingml/2006/main">
+              <a:ext uri="{FF2B5EF4-FFF2-40B4-BE49-F238E27FC236}">
+                <a16:creationId xmlns:a16="http://schemas.microsoft.com/office/drawing/2014/main" id="{A220CD77-246B-49E8-854F-CDC3ECA03333}"/>
+              </a:ext>
+            </a:extLst>
+          </p:cNvPr>
+          <p:cNvSpPr>
+            <a:spLocks xmlns:a="http://schemas.openxmlformats.org/drawingml/2006/main" noGrp="1"/>
+          </p:cNvSpPr>
+          <p:nvPr/>
+        </p:nvSpPr>
+        <p:spPr>
+          <a:xfrm xmlns:a="http://schemas.openxmlformats.org/drawingml/2006/main">
+            <a:off x="8020050" y="3886200"/>
+            <a:ext cx="914400" cy="209550"/>
           </a:xfrm>
           <a:prstGeom xmlns:a="http://schemas.openxmlformats.org/drawingml/2006/main" prst="rect">
             <a:avLst/>
@@ -7334,29 +8436,29 @@
                   <a:srgbClr val="07111F"/>
                 </a:solidFill>
               </a:rPr>
-              <a:t>Timing &amp; attention</a:t>
-            </a:r>
-          </a:p>
-        </p:txBody>
-      </p:sp>
-      <p:sp>
-        <p:nvSpPr>
-          <p:cNvPr id="29" name="">
-            <a:extLst xmlns:a="http://schemas.openxmlformats.org/drawingml/2006/main">
-              <a:ext uri="{FF2B5EF4-FFF2-40B4-BE49-F238E27FC236}">
-                <a16:creationId xmlns:a16="http://schemas.microsoft.com/office/drawing/2014/main" id="{A117A67B-4381-4639-9444-841538BB6DEB}"/>
-              </a:ext>
-            </a:extLst>
-          </p:cNvPr>
-          <p:cNvSpPr>
-            <a:spLocks xmlns:a="http://schemas.openxmlformats.org/drawingml/2006/main" noGrp="1"/>
-          </p:cNvSpPr>
-          <p:nvPr/>
-        </p:nvSpPr>
-        <p:spPr>
-          <a:xfrm xmlns:a="http://schemas.openxmlformats.org/drawingml/2006/main">
-            <a:off x="8191500" y="3867150"/>
-            <a:ext cx="2800350" cy="438150"/>
+              <a:t>40+</a:t>
+            </a:r>
+          </a:p>
+        </p:txBody>
+      </p:sp>
+      <p:sp>
+        <p:nvSpPr>
+          <p:cNvPr id="55" name="">
+            <a:extLst xmlns:a="http://schemas.openxmlformats.org/drawingml/2006/main">
+              <a:ext uri="{FF2B5EF4-FFF2-40B4-BE49-F238E27FC236}">
+                <a16:creationId xmlns:a16="http://schemas.microsoft.com/office/drawing/2014/main" id="{F744EA22-F8DA-4D90-87E0-06D587F7A774}"/>
+              </a:ext>
+            </a:extLst>
+          </p:cNvPr>
+          <p:cNvSpPr>
+            <a:spLocks xmlns:a="http://schemas.openxmlformats.org/drawingml/2006/main" noGrp="1"/>
+          </p:cNvSpPr>
+          <p:nvPr/>
+        </p:nvSpPr>
+        <p:spPr>
+          <a:xfrm xmlns:a="http://schemas.openxmlformats.org/drawingml/2006/main">
+            <a:off x="8953500" y="3867150"/>
+            <a:ext cx="2076450" cy="438150"/>
           </a:xfrm>
           <a:prstGeom xmlns:a="http://schemas.openxmlformats.org/drawingml/2006/main" prst="rect">
             <a:avLst/>
@@ -7372,41 +8474,41 @@
           <a:lstStyle xmlns:a="http://schemas.openxmlformats.org/drawingml/2006/main"/>
           <a:p xmlns:a="http://schemas.openxmlformats.org/drawingml/2006/main">
             <a:pPr>
-              <a:defRPr sz="1050">
+              <a:defRPr sz="1013">
                 <a:solidFill>
                   <a:srgbClr val="42526B"/>
                 </a:solidFill>
               </a:defRPr>
             </a:pPr>
             <a:r>
-              <a:rPr sz="1050">
+              <a:rPr sz="1013">
                 <a:solidFill>
                   <a:srgbClr val="42526B"/>
                 </a:solidFill>
               </a:rPr>
-              <a:t>Later fielding, summer travel, Prime Day/deal mode, and media distraction could soften recognition across brands.</a:t>
-            </a:r>
-          </a:p>
-        </p:txBody>
-      </p:sp>
-      <p:sp>
-        <p:nvSpPr>
-          <p:cNvPr id="30" name="">
-            <a:extLst xmlns:a="http://schemas.openxmlformats.org/drawingml/2006/main">
-              <a:ext uri="{FF2B5EF4-FFF2-40B4-BE49-F238E27FC236}">
-                <a16:creationId xmlns:a16="http://schemas.microsoft.com/office/drawing/2014/main" id="{E03EC5CB-FFB1-4A7F-B7DA-A763B8639623}"/>
-              </a:ext>
-            </a:extLst>
-          </p:cNvPr>
-          <p:cNvSpPr>
-            <a:spLocks xmlns:a="http://schemas.openxmlformats.org/drawingml/2006/main" noGrp="1"/>
-          </p:cNvSpPr>
-          <p:nvPr/>
-        </p:nvSpPr>
-        <p:spPr>
-          <a:xfrm xmlns:a="http://schemas.openxmlformats.org/drawingml/2006/main">
-            <a:off x="6515100" y="4572000"/>
-            <a:ext cx="4667250" cy="666750"/>
+              <a:t>Spanx leads choice at 40%; Maidenform becomes a major consideration brand at 48%.</a:t>
+            </a:r>
+          </a:p>
+        </p:txBody>
+      </p:sp>
+      <p:sp>
+        <p:nvSpPr>
+          <p:cNvPr id="56" name="">
+            <a:extLst xmlns:a="http://schemas.openxmlformats.org/drawingml/2006/main">
+              <a:ext uri="{FF2B5EF4-FFF2-40B4-BE49-F238E27FC236}">
+                <a16:creationId xmlns:a16="http://schemas.microsoft.com/office/drawing/2014/main" id="{84CE48BA-49C2-4431-9A23-A4732A8201B3}"/>
+              </a:ext>
+            </a:extLst>
+          </p:cNvPr>
+          <p:cNvSpPr>
+            <a:spLocks xmlns:a="http://schemas.openxmlformats.org/drawingml/2006/main" noGrp="1"/>
+          </p:cNvSpPr>
+          <p:nvPr/>
+        </p:nvSpPr>
+        <p:spPr>
+          <a:xfrm xmlns:a="http://schemas.openxmlformats.org/drawingml/2006/main">
+            <a:off x="7829550" y="4572000"/>
+            <a:ext cx="3390900" cy="666750"/>
           </a:xfrm>
           <a:prstGeom xmlns:a="http://schemas.openxmlformats.org/drawingml/2006/main" prst="roundRect">
             <a:avLst>
@@ -7426,22 +8528,22 @@
       </p:sp>
       <p:sp>
         <p:nvSpPr>
-          <p:cNvPr id="31" name="">
-            <a:extLst xmlns:a="http://schemas.openxmlformats.org/drawingml/2006/main">
-              <a:ext uri="{FF2B5EF4-FFF2-40B4-BE49-F238E27FC236}">
-                <a16:creationId xmlns:a16="http://schemas.microsoft.com/office/drawing/2014/main" id="{540CC5C2-DDD1-4BE4-945B-4C3AB0F26B62}"/>
-              </a:ext>
-            </a:extLst>
-          </p:cNvPr>
-          <p:cNvSpPr>
-            <a:spLocks xmlns:a="http://schemas.openxmlformats.org/drawingml/2006/main" noGrp="1"/>
-          </p:cNvSpPr>
-          <p:nvPr/>
-        </p:nvSpPr>
-        <p:spPr>
-          <a:xfrm xmlns:a="http://schemas.openxmlformats.org/drawingml/2006/main">
-            <a:off x="6705600" y="4705350"/>
-            <a:ext cx="1428750" cy="209550"/>
+          <p:cNvPr id="57" name="">
+            <a:extLst xmlns:a="http://schemas.openxmlformats.org/drawingml/2006/main">
+              <a:ext uri="{FF2B5EF4-FFF2-40B4-BE49-F238E27FC236}">
+                <a16:creationId xmlns:a16="http://schemas.microsoft.com/office/drawing/2014/main" id="{AEAB496F-04CF-467F-A637-1C3752BF8832}"/>
+              </a:ext>
+            </a:extLst>
+          </p:cNvPr>
+          <p:cNvSpPr>
+            <a:spLocks xmlns:a="http://schemas.openxmlformats.org/drawingml/2006/main" noGrp="1"/>
+          </p:cNvSpPr>
+          <p:nvPr/>
+        </p:nvSpPr>
+        <p:spPr>
+          <a:xfrm xmlns:a="http://schemas.openxmlformats.org/drawingml/2006/main">
+            <a:off x="8020050" y="4705350"/>
+            <a:ext cx="914400" cy="209550"/>
           </a:xfrm>
           <a:prstGeom xmlns:a="http://schemas.openxmlformats.org/drawingml/2006/main" prst="rect">
             <a:avLst/>
@@ -7469,29 +8571,29 @@
                   <a:srgbClr val="07111F"/>
                 </a:solidFill>
               </a:rPr>
-              <a:t>Question framing</a:t>
-            </a:r>
-          </a:p>
-        </p:txBody>
-      </p:sp>
-      <p:sp>
-        <p:nvSpPr>
-          <p:cNvPr id="32" name="">
-            <a:extLst xmlns:a="http://schemas.openxmlformats.org/drawingml/2006/main">
-              <a:ext uri="{FF2B5EF4-FFF2-40B4-BE49-F238E27FC236}">
-                <a16:creationId xmlns:a16="http://schemas.microsoft.com/office/drawing/2014/main" id="{84157451-6ABF-4AD9-83FB-AECA6E6287AE}"/>
-              </a:ext>
-            </a:extLst>
-          </p:cNvPr>
-          <p:cNvSpPr>
-            <a:spLocks xmlns:a="http://schemas.openxmlformats.org/drawingml/2006/main" noGrp="1"/>
-          </p:cNvSpPr>
-          <p:nvPr/>
-        </p:nvSpPr>
-        <p:spPr>
-          <a:xfrm xmlns:a="http://schemas.openxmlformats.org/drawingml/2006/main">
-            <a:off x="8191500" y="4686300"/>
-            <a:ext cx="2800350" cy="438150"/>
+              <a:t>Where to win</a:t>
+            </a:r>
+          </a:p>
+        </p:txBody>
+      </p:sp>
+      <p:sp>
+        <p:nvSpPr>
+          <p:cNvPr id="58" name="">
+            <a:extLst xmlns:a="http://schemas.openxmlformats.org/drawingml/2006/main">
+              <a:ext uri="{FF2B5EF4-FFF2-40B4-BE49-F238E27FC236}">
+                <a16:creationId xmlns:a16="http://schemas.microsoft.com/office/drawing/2014/main" id="{C1DEBBB1-35DE-4B8A-B726-A30317D0368E}"/>
+              </a:ext>
+            </a:extLst>
+          </p:cNvPr>
+          <p:cNvSpPr>
+            <a:spLocks xmlns:a="http://schemas.openxmlformats.org/drawingml/2006/main" noGrp="1"/>
+          </p:cNvSpPr>
+          <p:nvPr/>
+        </p:nvSpPr>
+        <p:spPr>
+          <a:xfrm xmlns:a="http://schemas.openxmlformats.org/drawingml/2006/main">
+            <a:off x="8953500" y="4686300"/>
+            <a:ext cx="2076450" cy="438150"/>
           </a:xfrm>
           <a:prstGeom xmlns:a="http://schemas.openxmlformats.org/drawingml/2006/main" prst="rect">
             <a:avLst/>
@@ -7507,41 +8609,41 @@
           <a:lstStyle xmlns:a="http://schemas.openxmlformats.org/drawingml/2006/main"/>
           <a:p xmlns:a="http://schemas.openxmlformats.org/drawingml/2006/main">
             <a:pPr>
-              <a:defRPr sz="1050">
+              <a:defRPr sz="1013">
                 <a:solidFill>
                   <a:srgbClr val="42526B"/>
                 </a:solidFill>
               </a:defRPr>
             </a:pPr>
             <a:r>
-              <a:rPr sz="1050">
+              <a:rPr sz="1013">
                 <a:solidFill>
                   <a:srgbClr val="42526B"/>
                 </a:solidFill>
               </a:rPr>
-              <a:t>The Q17-Q19 category critique may prime respondents to be less generous about brand familiarity and differentiation.</a:t>
-            </a:r>
-          </a:p>
-        </p:txBody>
-      </p:sp>
-      <p:sp>
-        <p:nvSpPr>
-          <p:cNvPr id="33" name="">
-            <a:extLst xmlns:a="http://schemas.openxmlformats.org/drawingml/2006/main">
-              <a:ext uri="{FF2B5EF4-FFF2-40B4-BE49-F238E27FC236}">
-                <a16:creationId xmlns:a16="http://schemas.microsoft.com/office/drawing/2014/main" id="{EC00366E-E8CA-492D-AB65-40E787039A5F}"/>
-              </a:ext>
-            </a:extLst>
-          </p:cNvPr>
-          <p:cNvSpPr>
-            <a:spLocks xmlns:a="http://schemas.openxmlformats.org/drawingml/2006/main" noGrp="1"/>
-          </p:cNvSpPr>
-          <p:nvPr/>
-        </p:nvSpPr>
-        <p:spPr>
-          <a:xfrm xmlns:a="http://schemas.openxmlformats.org/drawingml/2006/main">
-            <a:off x="7086600" y="5562600"/>
-            <a:ext cx="3238500" cy="304800"/>
+              <a:t>Shapermint earns similar 'real women / no fight' association in both groups, but only 12-14% ownership.</a:t>
+            </a:r>
+          </a:p>
+        </p:txBody>
+      </p:sp>
+      <p:sp>
+        <p:nvSpPr>
+          <p:cNvPr id="59" name="">
+            <a:extLst xmlns:a="http://schemas.openxmlformats.org/drawingml/2006/main">
+              <a:ext uri="{FF2B5EF4-FFF2-40B4-BE49-F238E27FC236}">
+                <a16:creationId xmlns:a16="http://schemas.microsoft.com/office/drawing/2014/main" id="{13D77B7C-F6DF-4196-B1B1-B5BA45379B20}"/>
+              </a:ext>
+            </a:extLst>
+          </p:cNvPr>
+          <p:cNvSpPr>
+            <a:spLocks xmlns:a="http://schemas.openxmlformats.org/drawingml/2006/main" noGrp="1"/>
+          </p:cNvSpPr>
+          <p:nvPr/>
+        </p:nvSpPr>
+        <p:spPr>
+          <a:xfrm xmlns:a="http://schemas.openxmlformats.org/drawingml/2006/main">
+            <a:off x="3829050" y="5562600"/>
+            <a:ext cx="3714750" cy="304800"/>
           </a:xfrm>
           <a:prstGeom xmlns:a="http://schemas.openxmlformats.org/drawingml/2006/main" prst="roundRect">
             <a:avLst>
@@ -7549,11 +8651,11 @@
             </a:avLst>
           </a:prstGeom>
           <a:solidFill xmlns:a="http://schemas.openxmlformats.org/drawingml/2006/main">
-            <a:srgbClr val="EF4444"/>
+            <a:srgbClr val="0C1726"/>
           </a:solidFill>
           <a:ln xmlns:a="http://schemas.openxmlformats.org/drawingml/2006/main" w="0">
             <a:solidFill>
-              <a:srgbClr val="EF4444"/>
+              <a:srgbClr val="0C1726"/>
             </a:solidFill>
             <a:prstDash val="solid"/>
           </a:ln>
@@ -7561,22 +8663,22 @@
       </p:sp>
       <p:sp>
         <p:nvSpPr>
-          <p:cNvPr id="34" name="">
-            <a:extLst xmlns:a="http://schemas.openxmlformats.org/drawingml/2006/main">
-              <a:ext uri="{FF2B5EF4-FFF2-40B4-BE49-F238E27FC236}">
-                <a16:creationId xmlns:a16="http://schemas.microsoft.com/office/drawing/2014/main" id="{2BCC5EAE-6469-4EF2-B53D-490A441AB63A}"/>
-              </a:ext>
-            </a:extLst>
-          </p:cNvPr>
-          <p:cNvSpPr>
-            <a:spLocks xmlns:a="http://schemas.openxmlformats.org/drawingml/2006/main" noGrp="1"/>
-          </p:cNvSpPr>
-          <p:nvPr/>
-        </p:nvSpPr>
-        <p:spPr>
-          <a:xfrm xmlns:a="http://schemas.openxmlformats.org/drawingml/2006/main">
-            <a:off x="7200900" y="5629275"/>
-            <a:ext cx="3009900" cy="171450"/>
+          <p:cNvPr id="60" name="">
+            <a:extLst xmlns:a="http://schemas.openxmlformats.org/drawingml/2006/main">
+              <a:ext uri="{FF2B5EF4-FFF2-40B4-BE49-F238E27FC236}">
+                <a16:creationId xmlns:a16="http://schemas.microsoft.com/office/drawing/2014/main" id="{6909CAAA-B42E-4370-86A2-5C6442815A26}"/>
+              </a:ext>
+            </a:extLst>
+          </p:cNvPr>
+          <p:cNvSpPr>
+            <a:spLocks xmlns:a="http://schemas.openxmlformats.org/drawingml/2006/main" noGrp="1"/>
+          </p:cNvSpPr>
+          <p:nvPr/>
+        </p:nvSpPr>
+        <p:spPr>
+          <a:xfrm xmlns:a="http://schemas.openxmlformats.org/drawingml/2006/main">
+            <a:off x="3943350" y="5629275"/>
+            <a:ext cx="3486150" cy="171450"/>
           </a:xfrm>
           <a:prstGeom xmlns:a="http://schemas.openxmlformats.org/drawingml/2006/main" prst="rect">
             <a:avLst/>
@@ -7604,17 +8706,17 @@
                   <a:srgbClr val="FFFFFF"/>
                 </a:solidFill>
               </a:rPr>
-              <a:t>Need: Q17-Q19 x Q34 raw/crosstab</a:t>
-            </a:r>
-          </a:p>
-        </p:txBody>
-      </p:sp>
-      <p:sp>
-        <p:nvSpPr>
-          <p:cNvPr id="35" name="">
-            <a:extLst xmlns:a="http://schemas.openxmlformats.org/drawingml/2006/main">
-              <a:ext uri="{FF2B5EF4-FFF2-40B4-BE49-F238E27FC236}">
-                <a16:creationId xmlns:a16="http://schemas.microsoft.com/office/drawing/2014/main" id="{9CDF51D6-FFE7-4D2E-964A-6163C9DE6F7A}"/>
+              <a:t>Same promise, age-specific proof</a:t>
+            </a:r>
+          </a:p>
+        </p:txBody>
+      </p:sp>
+      <p:sp>
+        <p:nvSpPr>
+          <p:cNvPr id="61" name="">
+            <a:extLst xmlns:a="http://schemas.openxmlformats.org/drawingml/2006/main">
+              <a:ext uri="{FF2B5EF4-FFF2-40B4-BE49-F238E27FC236}">
+                <a16:creationId xmlns:a16="http://schemas.microsoft.com/office/drawing/2014/main" id="{E89DE263-9B15-43C0-9B15-A95D262578BB}"/>
               </a:ext>
             </a:extLst>
           </p:cNvPr>
@@ -7654,17 +8756,17 @@
                   <a:srgbClr val="6B7280"/>
                 </a:solidFill>
               </a:rPr>
-              <a:t>Source: Q34 age tables from Q4 2025, Q1 2026, and Q2 2026 tracker exports. Q17-Q19 age crosstab not present in supplied XLS.</a:t>
-            </a:r>
-          </a:p>
-        </p:txBody>
-      </p:sp>
-      <p:sp>
-        <p:nvSpPr>
-          <p:cNvPr id="36" name="">
-            <a:extLst xmlns:a="http://schemas.openxmlformats.org/drawingml/2006/main">
-              <a:ext uri="{FF2B5EF4-FFF2-40B4-BE49-F238E27FC236}">
-                <a16:creationId xmlns:a16="http://schemas.microsoft.com/office/drawing/2014/main" id="{8AC6CE09-E16B-46AD-87AE-06A6FCF236BC}"/>
+              <a:t>Source: supplied Q4 2025 age-filtered exports export-10198 (1)/(2), n=607 under 40 and n=977 age 40+. Q2 2026 Q17-Q19 by-age cut still not supplied.</a:t>
+            </a:r>
+          </a:p>
+        </p:txBody>
+      </p:sp>
+      <p:sp>
+        <p:nvSpPr>
+          <p:cNvPr id="62" name="">
+            <a:extLst xmlns:a="http://schemas.openxmlformats.org/drawingml/2006/main">
+              <a:ext uri="{FF2B5EF4-FFF2-40B4-BE49-F238E27FC236}">
+                <a16:creationId xmlns:a16="http://schemas.microsoft.com/office/drawing/2014/main" id="{77B9A63C-53FC-44B3-B5C2-5719B1FBCAA7}"/>
               </a:ext>
             </a:extLst>
           </p:cNvPr>
@@ -7712,7 +8814,7 @@
     </p:spTree>
     <p:extLst>
       <p:ext uri="{BB962C8B-B14F-4D97-AF65-F5344CB8AC3E}">
-        <p14:creationId xmlns:p14="http://schemas.microsoft.com/office/powerpoint/2010/main" val="497381143"/>
+        <p14:creationId xmlns:p14="http://schemas.microsoft.com/office/powerpoint/2010/main" val="1925636144"/>
       </p:ext>
     </p:extLst>
   </p:cSld>
@@ -7743,7 +8845,7 @@
           <p:cNvPr id="28" name="">
             <a:extLst xmlns:a="http://schemas.openxmlformats.org/drawingml/2006/main">
               <a:ext uri="{FF2B5EF4-FFF2-40B4-BE49-F238E27FC236}">
-                <a16:creationId xmlns:a16="http://schemas.microsoft.com/office/drawing/2014/main" id="{9B60F184-98C2-4BDD-A93D-995366C3D640}"/>
+                <a16:creationId xmlns:a16="http://schemas.microsoft.com/office/drawing/2014/main" id="{28DD0DE2-54E0-49C3-BE6E-DA4BC29AA701}"/>
               </a:ext>
             </a:extLst>
           </p:cNvPr>
@@ -7793,7 +8895,7 @@
           <p:cNvPr id="2" name="">
             <a:extLst xmlns:a="http://schemas.openxmlformats.org/drawingml/2006/main">
               <a:ext uri="{FF2B5EF4-FFF2-40B4-BE49-F238E27FC236}">
-                <a16:creationId xmlns:a16="http://schemas.microsoft.com/office/drawing/2014/main" id="{C18C6966-07F2-4A96-8202-41FD2ED65257}"/>
+                <a16:creationId xmlns:a16="http://schemas.microsoft.com/office/drawing/2014/main" id="{3E68FB2F-A44A-4533-9277-AF399D77689F}"/>
               </a:ext>
             </a:extLst>
           </p:cNvPr>
@@ -7843,7 +8945,7 @@
           <p:cNvPr id="3" name="">
             <a:extLst xmlns:a="http://schemas.openxmlformats.org/drawingml/2006/main">
               <a:ext uri="{FF2B5EF4-FFF2-40B4-BE49-F238E27FC236}">
-                <a16:creationId xmlns:a16="http://schemas.microsoft.com/office/drawing/2014/main" id="{622E92E5-5060-4A7B-B57D-337E1E99EB4C}"/>
+                <a16:creationId xmlns:a16="http://schemas.microsoft.com/office/drawing/2014/main" id="{7FA4752F-7966-4B76-A20D-5CB3E86B1C33}"/>
               </a:ext>
             </a:extLst>
           </p:cNvPr>
@@ -7878,7 +8980,7 @@
           <p:cNvPr id="4" name="">
             <a:extLst xmlns:a="http://schemas.openxmlformats.org/drawingml/2006/main">
               <a:ext uri="{FF2B5EF4-FFF2-40B4-BE49-F238E27FC236}">
-                <a16:creationId xmlns:a16="http://schemas.microsoft.com/office/drawing/2014/main" id="{C7CCA61C-F1E4-4729-BCEE-AAAC9191C066}"/>
+                <a16:creationId xmlns:a16="http://schemas.microsoft.com/office/drawing/2014/main" id="{4BAF6E2F-BAF2-4FC4-94A5-2357FB467FCE}"/>
               </a:ext>
             </a:extLst>
           </p:cNvPr>
@@ -7913,7 +9015,7 @@
           <p:cNvPr id="5" name="">
             <a:extLst xmlns:a="http://schemas.openxmlformats.org/drawingml/2006/main">
               <a:ext uri="{FF2B5EF4-FFF2-40B4-BE49-F238E27FC236}">
-                <a16:creationId xmlns:a16="http://schemas.microsoft.com/office/drawing/2014/main" id="{FEC6009F-0D81-4BC9-8A51-E17EFE318883}"/>
+                <a16:creationId xmlns:a16="http://schemas.microsoft.com/office/drawing/2014/main" id="{BA4F2AFD-EB3D-441F-BC46-CCF0E65D423E}"/>
               </a:ext>
             </a:extLst>
           </p:cNvPr>
@@ -7963,7 +9065,7 @@
           <p:cNvPr id="6" name="">
             <a:extLst xmlns:a="http://schemas.openxmlformats.org/drawingml/2006/main">
               <a:ext uri="{FF2B5EF4-FFF2-40B4-BE49-F238E27FC236}">
-                <a16:creationId xmlns:a16="http://schemas.microsoft.com/office/drawing/2014/main" id="{1C32F0FF-B304-40DC-9ECA-55BB281CDD70}"/>
+                <a16:creationId xmlns:a16="http://schemas.microsoft.com/office/drawing/2014/main" id="{43D721B6-C5B0-48FB-A5BB-FFADB78265F6}"/>
               </a:ext>
             </a:extLst>
           </p:cNvPr>
@@ -8013,7 +9115,7 @@
           <p:cNvPr id="7" name="">
             <a:extLst xmlns:a="http://schemas.openxmlformats.org/drawingml/2006/main">
               <a:ext uri="{FF2B5EF4-FFF2-40B4-BE49-F238E27FC236}">
-                <a16:creationId xmlns:a16="http://schemas.microsoft.com/office/drawing/2014/main" id="{D4579E4E-AAAC-422B-8926-EC582A1A918B}"/>
+                <a16:creationId xmlns:a16="http://schemas.microsoft.com/office/drawing/2014/main" id="{DF61B7A3-4A50-425D-AC22-93AAEB663E91}"/>
               </a:ext>
             </a:extLst>
           </p:cNvPr>
@@ -8063,7 +9165,7 @@
           <p:cNvPr id="8" name="">
             <a:extLst xmlns:a="http://schemas.openxmlformats.org/drawingml/2006/main">
               <a:ext uri="{FF2B5EF4-FFF2-40B4-BE49-F238E27FC236}">
-                <a16:creationId xmlns:a16="http://schemas.microsoft.com/office/drawing/2014/main" id="{D2C12E86-8707-41CF-B35E-2A914F9F53E8}"/>
+                <a16:creationId xmlns:a16="http://schemas.microsoft.com/office/drawing/2014/main" id="{2A72C2E4-944E-4781-B5A9-EEECD93B9E71}"/>
               </a:ext>
             </a:extLst>
           </p:cNvPr>
@@ -8098,7 +9200,7 @@
           <p:cNvPr id="9" name="">
             <a:extLst xmlns:a="http://schemas.openxmlformats.org/drawingml/2006/main">
               <a:ext uri="{FF2B5EF4-FFF2-40B4-BE49-F238E27FC236}">
-                <a16:creationId xmlns:a16="http://schemas.microsoft.com/office/drawing/2014/main" id="{FE05A173-8B90-4E98-A56A-14F25A272C17}"/>
+                <a16:creationId xmlns:a16="http://schemas.microsoft.com/office/drawing/2014/main" id="{9C11E897-5378-4740-A432-1C5A02E72057}"/>
               </a:ext>
             </a:extLst>
           </p:cNvPr>
@@ -8133,7 +9235,7 @@
           <p:cNvPr id="10" name="">
             <a:extLst xmlns:a="http://schemas.openxmlformats.org/drawingml/2006/main">
               <a:ext uri="{FF2B5EF4-FFF2-40B4-BE49-F238E27FC236}">
-                <a16:creationId xmlns:a16="http://schemas.microsoft.com/office/drawing/2014/main" id="{63FEBEA8-9139-4913-888A-D8077DEE8EF5}"/>
+                <a16:creationId xmlns:a16="http://schemas.microsoft.com/office/drawing/2014/main" id="{5B0077D8-3DBB-4711-BC8E-C722B072FD1C}"/>
               </a:ext>
             </a:extLst>
           </p:cNvPr>
@@ -8183,7 +9285,7 @@
           <p:cNvPr id="11" name="">
             <a:extLst xmlns:a="http://schemas.openxmlformats.org/drawingml/2006/main">
               <a:ext uri="{FF2B5EF4-FFF2-40B4-BE49-F238E27FC236}">
-                <a16:creationId xmlns:a16="http://schemas.microsoft.com/office/drawing/2014/main" id="{00367663-D2B6-47BB-85A7-F087F2CF129A}"/>
+                <a16:creationId xmlns:a16="http://schemas.microsoft.com/office/drawing/2014/main" id="{B05E5C6E-F2B9-4041-A1BA-B97C78141625}"/>
               </a:ext>
             </a:extLst>
           </p:cNvPr>
@@ -8233,7 +9335,7 @@
           <p:cNvPr id="12" name="">
             <a:extLst xmlns:a="http://schemas.openxmlformats.org/drawingml/2006/main">
               <a:ext uri="{FF2B5EF4-FFF2-40B4-BE49-F238E27FC236}">
-                <a16:creationId xmlns:a16="http://schemas.microsoft.com/office/drawing/2014/main" id="{2D001EE0-D432-4D6A-96C4-0D017AE2B94A}"/>
+                <a16:creationId xmlns:a16="http://schemas.microsoft.com/office/drawing/2014/main" id="{9C8C46E5-0D58-4BFC-A392-81BECBCBECD1}"/>
               </a:ext>
             </a:extLst>
           </p:cNvPr>
@@ -8283,7 +9385,7 @@
           <p:cNvPr id="13" name="">
             <a:extLst xmlns:a="http://schemas.openxmlformats.org/drawingml/2006/main">
               <a:ext uri="{FF2B5EF4-FFF2-40B4-BE49-F238E27FC236}">
-                <a16:creationId xmlns:a16="http://schemas.microsoft.com/office/drawing/2014/main" id="{EDAF4BF7-E82C-4B00-A674-23791B839617}"/>
+                <a16:creationId xmlns:a16="http://schemas.microsoft.com/office/drawing/2014/main" id="{E43C04E6-18AD-4A15-B912-ECA2739EC71C}"/>
               </a:ext>
             </a:extLst>
           </p:cNvPr>
@@ -8318,7 +9420,7 @@
           <p:cNvPr id="14" name="">
             <a:extLst xmlns:a="http://schemas.openxmlformats.org/drawingml/2006/main">
               <a:ext uri="{FF2B5EF4-FFF2-40B4-BE49-F238E27FC236}">
-                <a16:creationId xmlns:a16="http://schemas.microsoft.com/office/drawing/2014/main" id="{D1425AF9-69D7-4BF3-8AD2-ED869AFE1A3D}"/>
+                <a16:creationId xmlns:a16="http://schemas.microsoft.com/office/drawing/2014/main" id="{89A7BF59-9704-4F58-9137-D509AF188409}"/>
               </a:ext>
             </a:extLst>
           </p:cNvPr>
@@ -8353,7 +9455,7 @@
           <p:cNvPr id="15" name="">
             <a:extLst xmlns:a="http://schemas.openxmlformats.org/drawingml/2006/main">
               <a:ext uri="{FF2B5EF4-FFF2-40B4-BE49-F238E27FC236}">
-                <a16:creationId xmlns:a16="http://schemas.microsoft.com/office/drawing/2014/main" id="{423E06A8-E090-4AB1-8238-58C3BE39B5EB}"/>
+                <a16:creationId xmlns:a16="http://schemas.microsoft.com/office/drawing/2014/main" id="{2F830820-AFB0-46D5-9C9D-C6D6548251D8}"/>
               </a:ext>
             </a:extLst>
           </p:cNvPr>
@@ -8403,7 +9505,7 @@
           <p:cNvPr id="16" name="">
             <a:extLst xmlns:a="http://schemas.openxmlformats.org/drawingml/2006/main">
               <a:ext uri="{FF2B5EF4-FFF2-40B4-BE49-F238E27FC236}">
-                <a16:creationId xmlns:a16="http://schemas.microsoft.com/office/drawing/2014/main" id="{98683D19-0D8D-452A-89F9-B645FDFD080C}"/>
+                <a16:creationId xmlns:a16="http://schemas.microsoft.com/office/drawing/2014/main" id="{B60CF05F-1186-4D7D-9242-2E5E124A2D62}"/>
               </a:ext>
             </a:extLst>
           </p:cNvPr>
@@ -8453,7 +9555,7 @@
           <p:cNvPr id="17" name="">
             <a:extLst xmlns:a="http://schemas.openxmlformats.org/drawingml/2006/main">
               <a:ext uri="{FF2B5EF4-FFF2-40B4-BE49-F238E27FC236}">
-                <a16:creationId xmlns:a16="http://schemas.microsoft.com/office/drawing/2014/main" id="{3B904F05-982A-497F-AC3D-11D25681FB9C}"/>
+                <a16:creationId xmlns:a16="http://schemas.microsoft.com/office/drawing/2014/main" id="{1C01AF40-B7E4-4BE1-A105-DC21856DBF8E}"/>
               </a:ext>
             </a:extLst>
           </p:cNvPr>
@@ -8503,7 +9605,7 @@
           <p:cNvPr id="18" name="">
             <a:extLst xmlns:a="http://schemas.openxmlformats.org/drawingml/2006/main">
               <a:ext uri="{FF2B5EF4-FFF2-40B4-BE49-F238E27FC236}">
-                <a16:creationId xmlns:a16="http://schemas.microsoft.com/office/drawing/2014/main" id="{CB989CB1-FF4D-4186-9AEF-859A4A1C5DAF}"/>
+                <a16:creationId xmlns:a16="http://schemas.microsoft.com/office/drawing/2014/main" id="{AE29E19F-00A4-4A8B-8A4C-738FADA7C94D}"/>
               </a:ext>
             </a:extLst>
           </p:cNvPr>
@@ -8538,7 +9640,7 @@
           <p:cNvPr id="19" name="">
             <a:extLst xmlns:a="http://schemas.openxmlformats.org/drawingml/2006/main">
               <a:ext uri="{FF2B5EF4-FFF2-40B4-BE49-F238E27FC236}">
-                <a16:creationId xmlns:a16="http://schemas.microsoft.com/office/drawing/2014/main" id="{06EEBD66-88BD-460E-AAB9-AAE2A8D89145}"/>
+                <a16:creationId xmlns:a16="http://schemas.microsoft.com/office/drawing/2014/main" id="{B1EBC418-5215-4C74-9207-A11073849BAB}"/>
               </a:ext>
             </a:extLst>
           </p:cNvPr>
@@ -8573,7 +9675,7 @@
           <p:cNvPr id="20" name="">
             <a:extLst xmlns:a="http://schemas.openxmlformats.org/drawingml/2006/main">
               <a:ext uri="{FF2B5EF4-FFF2-40B4-BE49-F238E27FC236}">
-                <a16:creationId xmlns:a16="http://schemas.microsoft.com/office/drawing/2014/main" id="{D6066E74-73EA-42F5-AED6-A19DA8F7FB04}"/>
+                <a16:creationId xmlns:a16="http://schemas.microsoft.com/office/drawing/2014/main" id="{A8A3BF07-01CB-45E8-A60B-888794E1E220}"/>
               </a:ext>
             </a:extLst>
           </p:cNvPr>
@@ -8623,7 +9725,7 @@
           <p:cNvPr id="21" name="">
             <a:extLst xmlns:a="http://schemas.openxmlformats.org/drawingml/2006/main">
               <a:ext uri="{FF2B5EF4-FFF2-40B4-BE49-F238E27FC236}">
-                <a16:creationId xmlns:a16="http://schemas.microsoft.com/office/drawing/2014/main" id="{6281D4A5-9C0D-4E1B-BA37-D1A749A81A1D}"/>
+                <a16:creationId xmlns:a16="http://schemas.microsoft.com/office/drawing/2014/main" id="{F7AA2FCD-648D-4868-B838-0CBB3F61BF5C}"/>
               </a:ext>
             </a:extLst>
           </p:cNvPr>
@@ -8673,7 +9775,7 @@
           <p:cNvPr id="22" name="">
             <a:extLst xmlns:a="http://schemas.openxmlformats.org/drawingml/2006/main">
               <a:ext uri="{FF2B5EF4-FFF2-40B4-BE49-F238E27FC236}">
-                <a16:creationId xmlns:a16="http://schemas.microsoft.com/office/drawing/2014/main" id="{DDE4B298-030F-4D4B-984B-EF2499F09C16}"/>
+                <a16:creationId xmlns:a16="http://schemas.microsoft.com/office/drawing/2014/main" id="{84B2EDAE-ABDD-40F9-B2F9-6CBEEC1BDA29}"/>
               </a:ext>
             </a:extLst>
           </p:cNvPr>
@@ -8723,7 +9825,7 @@
           <p:cNvPr id="23" name="">
             <a:extLst xmlns:a="http://schemas.openxmlformats.org/drawingml/2006/main">
               <a:ext uri="{FF2B5EF4-FFF2-40B4-BE49-F238E27FC236}">
-                <a16:creationId xmlns:a16="http://schemas.microsoft.com/office/drawing/2014/main" id="{A6F81CD4-C32E-4943-9E0F-765025CDB569}"/>
+                <a16:creationId xmlns:a16="http://schemas.microsoft.com/office/drawing/2014/main" id="{77F6CADD-8369-4E58-BBEA-280D91A1502D}"/>
               </a:ext>
             </a:extLst>
           </p:cNvPr>
@@ -8758,7 +9860,7 @@
           <p:cNvPr id="24" name="">
             <a:extLst xmlns:a="http://schemas.openxmlformats.org/drawingml/2006/main">
               <a:ext uri="{FF2B5EF4-FFF2-40B4-BE49-F238E27FC236}">
-                <a16:creationId xmlns:a16="http://schemas.microsoft.com/office/drawing/2014/main" id="{8B7C4B00-3A74-4895-8737-485249F998B2}"/>
+                <a16:creationId xmlns:a16="http://schemas.microsoft.com/office/drawing/2014/main" id="{CB86F01F-2B94-4008-8F01-D5AA28E5506F}"/>
               </a:ext>
             </a:extLst>
           </p:cNvPr>
@@ -8808,7 +9910,7 @@
           <p:cNvPr id="25" name="">
             <a:extLst xmlns:a="http://schemas.openxmlformats.org/drawingml/2006/main">
               <a:ext uri="{FF2B5EF4-FFF2-40B4-BE49-F238E27FC236}">
-                <a16:creationId xmlns:a16="http://schemas.microsoft.com/office/drawing/2014/main" id="{FC2B1FBC-EF1C-4A06-8CD8-45DD39E75621}"/>
+                <a16:creationId xmlns:a16="http://schemas.microsoft.com/office/drawing/2014/main" id="{8E9416FC-75B2-49C2-B9B2-8D269814B6CB}"/>
               </a:ext>
             </a:extLst>
           </p:cNvPr>
@@ -8858,7 +9960,7 @@
           <p:cNvPr id="26" name="">
             <a:extLst xmlns:a="http://schemas.openxmlformats.org/drawingml/2006/main">
               <a:ext uri="{FF2B5EF4-FFF2-40B4-BE49-F238E27FC236}">
-                <a16:creationId xmlns:a16="http://schemas.microsoft.com/office/drawing/2014/main" id="{82BBD624-CAA9-4521-9468-C7CB8A375B2B}"/>
+                <a16:creationId xmlns:a16="http://schemas.microsoft.com/office/drawing/2014/main" id="{9EF997F2-A912-47A1-89AB-0E3B2BC4234A}"/>
               </a:ext>
             </a:extLst>
           </p:cNvPr>
@@ -8908,7 +10010,7 @@
           <p:cNvPr id="27" name="">
             <a:extLst xmlns:a="http://schemas.openxmlformats.org/drawingml/2006/main">
               <a:ext uri="{FF2B5EF4-FFF2-40B4-BE49-F238E27FC236}">
-                <a16:creationId xmlns:a16="http://schemas.microsoft.com/office/drawing/2014/main" id="{D6D863D0-3A55-4283-8761-DC844BD90623}"/>
+                <a16:creationId xmlns:a16="http://schemas.microsoft.com/office/drawing/2014/main" id="{879CB73F-483C-4C7F-84C6-7862B2A84480}"/>
               </a:ext>
             </a:extLst>
           </p:cNvPr>
@@ -8956,7 +10058,7 @@
     </p:spTree>
     <p:extLst>
       <p:ext uri="{BB962C8B-B14F-4D97-AF65-F5344CB8AC3E}">
-        <p14:creationId xmlns:p14="http://schemas.microsoft.com/office/powerpoint/2010/main" val="103295093"/>
+        <p14:creationId xmlns:p14="http://schemas.microsoft.com/office/powerpoint/2010/main" val="1503594480"/>
       </p:ext>
     </p:extLst>
   </p:cSld>

</xml_diff>

<commit_message>
Revise campaign deck age analysis and tactics
</commit_message>
<xml_diff>
--- a/outputs/shapermint-reshaping-rules-brand-campaign.pptx
+++ b/outputs/shapermint-reshaping-rules-brand-campaign.pptx
@@ -2,16 +2,16 @@
 <file path=ppt/presentation.xml><?xml version="1.0" encoding="utf-8"?>
 <p:presentation xmlns:p="http://schemas.openxmlformats.org/presentationml/2006/main">
   <p:sldMasterIdLst>
-    <p:sldMasterId xmlns:r="http://schemas.openxmlformats.org/officeDocument/2006/relationships" id="2147483648" r:id="Rb0274d88b943446e"/>
+    <p:sldMasterId xmlns:r="http://schemas.openxmlformats.org/officeDocument/2006/relationships" id="2147483648" r:id="R3b53a1411074482e"/>
   </p:sldMasterIdLst>
   <p:notesMasterIdLst>
-    <p:notesMasterId xmlns:r="http://schemas.openxmlformats.org/officeDocument/2006/relationships" r:id="R10aaf4e0f2784763"/>
+    <p:notesMasterId xmlns:r="http://schemas.openxmlformats.org/officeDocument/2006/relationships" r:id="Rf8f2981b005040d2"/>
   </p:notesMasterIdLst>
   <p:sldIdLst>
-    <p:sldId xmlns:r="http://schemas.openxmlformats.org/officeDocument/2006/relationships" id="256" r:id="Rae2e2cc099a44a8a"/>
-    <p:sldId xmlns:r="http://schemas.openxmlformats.org/officeDocument/2006/relationships" id="257" r:id="R72548cb9f7dd4bf3"/>
-    <p:sldId xmlns:r="http://schemas.openxmlformats.org/officeDocument/2006/relationships" id="258" r:id="R7a38d6f42a63474c"/>
-    <p:sldId xmlns:r="http://schemas.openxmlformats.org/officeDocument/2006/relationships" id="259" r:id="R75299da2c2ca4963"/>
+    <p:sldId xmlns:r="http://schemas.openxmlformats.org/officeDocument/2006/relationships" id="256" r:id="Rb39b025abba54b94"/>
+    <p:sldId xmlns:r="http://schemas.openxmlformats.org/officeDocument/2006/relationships" id="257" r:id="R40135b14c7dd4d2f"/>
+    <p:sldId xmlns:r="http://schemas.openxmlformats.org/officeDocument/2006/relationships" id="258" r:id="R8c1a094924ca4c79"/>
+    <p:sldId xmlns:r="http://schemas.openxmlformats.org/officeDocument/2006/relationships" id="259" r:id="R3226251d92754ea7"/>
   </p:sldIdLst>
   <p:sldSz cx="12192000" cy="6858000"/>
   <p:notesSz cx="6858000" cy="9144000"/>
@@ -802,7 +802,7 @@
   </p:cSld>
   <p:clrMap bg1="lt1" tx1="dk1" bg2="lt2" tx2="dk2" accent1="accent1" accent2="accent2" accent3="accent3" accent4="accent4" accent5="accent5" accent6="accent6" hlink="hlink" folHlink="folHlink"/>
   <p:sldLayoutIdLst>
-    <p:sldLayoutId xmlns:r="http://schemas.openxmlformats.org/officeDocument/2006/relationships" id="2147483649" r:id="R1f9e97fb6f554b7d"/>
+    <p:sldLayoutId xmlns:r="http://schemas.openxmlformats.org/officeDocument/2006/relationships" id="2147483649" r:id="R78b806a31552488b"/>
   </p:sldLayoutIdLst>
   <p:txStyles>
     <p:titleStyle>
@@ -2635,7 +2635,7 @@
         </p:xfrm>
         <a:graphic xmlns:a="http://schemas.openxmlformats.org/drawingml/2006/main">
           <a:graphicData uri="http://schemas.openxmlformats.org/drawingml/2006/chart">
-            <c:chart xmlns:r="http://schemas.openxmlformats.org/officeDocument/2006/relationships" xmlns:c="http://schemas.openxmlformats.org/drawingml/2006/chart" r:id="Rdb5aa68890a14800"/>
+            <c:chart xmlns:r="http://schemas.openxmlformats.org/officeDocument/2006/relationships" xmlns:c="http://schemas.openxmlformats.org/drawingml/2006/chart" r:id="R3b8ff60581ad4205"/>
           </a:graphicData>
         </a:graphic>
       </p:graphicFrame>
@@ -7795,6 +7795,1933 @@
           </a:p>
         </p:txBody>
       </p:sp>
+      <p:sp>
+        <p:nvSpPr>
+          <p:cNvPr id="38" name="revision-background">
+            <a:extLst xmlns:a="http://schemas.openxmlformats.org/drawingml/2006/main">
+              <a:ext uri="{FF2B5EF4-FFF2-40B4-BE49-F238E27FC236}">
+                <a16:creationId xmlns:a16="http://schemas.microsoft.com/office/drawing/2014/main" id="{DB3F9FE8-0A44-4D73-9ECA-A25285166793}"/>
+              </a:ext>
+            </a:extLst>
+          </p:cNvPr>
+          <p:cNvSpPr>
+            <a:spLocks xmlns:a="http://schemas.openxmlformats.org/drawingml/2006/main" noGrp="1"/>
+          </p:cNvSpPr>
+          <p:nvPr/>
+        </p:nvSpPr>
+        <p:spPr>
+          <a:xfrm xmlns:a="http://schemas.openxmlformats.org/drawingml/2006/main">
+            <a:off x="0" y="0"/>
+            <a:ext cx="12192000" cy="6858000"/>
+          </a:xfrm>
+          <a:prstGeom xmlns:a="http://schemas.openxmlformats.org/drawingml/2006/main" prst="rect">
+            <a:avLst/>
+          </a:prstGeom>
+          <a:solidFill xmlns:a="http://schemas.openxmlformats.org/drawingml/2006/main">
+            <a:srgbClr val="F8F4EE"/>
+          </a:solidFill>
+          <a:ln xmlns:a="http://schemas.openxmlformats.org/drawingml/2006/main" w="0">
+            <a:noFill/>
+            <a:prstDash val="solid"/>
+          </a:ln>
+        </p:spPr>
+      </p:sp>
+      <p:sp>
+        <p:nvSpPr>
+          <p:cNvPr id="39" name="">
+            <a:extLst xmlns:a="http://schemas.openxmlformats.org/drawingml/2006/main">
+              <a:ext uri="{FF2B5EF4-FFF2-40B4-BE49-F238E27FC236}">
+                <a16:creationId xmlns:a16="http://schemas.microsoft.com/office/drawing/2014/main" id="{70D91A13-34B6-4145-89DA-6C8FAE9459B9}"/>
+              </a:ext>
+            </a:extLst>
+          </p:cNvPr>
+          <p:cNvSpPr>
+            <a:spLocks xmlns:a="http://schemas.openxmlformats.org/drawingml/2006/main" noGrp="1"/>
+          </p:cNvSpPr>
+          <p:nvPr/>
+        </p:nvSpPr>
+        <p:spPr>
+          <a:xfrm xmlns:a="http://schemas.openxmlformats.org/drawingml/2006/main">
+            <a:off x="609600" y="457200"/>
+            <a:ext cx="3143250" cy="209550"/>
+          </a:xfrm>
+          <a:prstGeom xmlns:a="http://schemas.openxmlformats.org/drawingml/2006/main" prst="rect">
+            <a:avLst/>
+          </a:prstGeom>
+          <a:noFill xmlns:a="http://schemas.openxmlformats.org/drawingml/2006/main"/>
+          <a:ln xmlns:a="http://schemas.openxmlformats.org/drawingml/2006/main" w="0">
+            <a:noFill/>
+            <a:prstDash val="solid"/>
+          </a:ln>
+        </p:spPr>
+        <p:txBody>
+          <a:bodyPr xmlns:a="http://schemas.openxmlformats.org/drawingml/2006/main" lIns="0" tIns="0" rIns="0" bIns="0" anchor="t"/>
+          <a:lstStyle xmlns:a="http://schemas.openxmlformats.org/drawingml/2006/main"/>
+          <a:p xmlns:a="http://schemas.openxmlformats.org/drawingml/2006/main">
+            <a:pPr algn="l">
+              <a:lnSpc>
+                <a:spcPct val="105000"/>
+              </a:lnSpc>
+              <a:buNone/>
+              <a:defRPr sz="900" b="1">
+                <a:solidFill>
+                  <a:srgbClr val="7C3AED"/>
+                </a:solidFill>
+              </a:defRPr>
+            </a:pPr>
+            <a:r>
+              <a:rPr sz="900" b="1">
+                <a:solidFill>
+                  <a:srgbClr val="7C3AED"/>
+                </a:solidFill>
+              </a:rPr>
+              <a:t>Q17-Q19 AGE SPLIT</a:t>
+            </a:r>
+          </a:p>
+        </p:txBody>
+      </p:sp>
+      <p:sp>
+        <p:nvSpPr>
+          <p:cNvPr id="40" name="">
+            <a:extLst xmlns:a="http://schemas.openxmlformats.org/drawingml/2006/main">
+              <a:ext uri="{FF2B5EF4-FFF2-40B4-BE49-F238E27FC236}">
+                <a16:creationId xmlns:a16="http://schemas.microsoft.com/office/drawing/2014/main" id="{433F0FA1-A3AB-4420-89A5-F0349CE7509B}"/>
+              </a:ext>
+            </a:extLst>
+          </p:cNvPr>
+          <p:cNvSpPr>
+            <a:spLocks xmlns:a="http://schemas.openxmlformats.org/drawingml/2006/main" noGrp="1"/>
+          </p:cNvSpPr>
+          <p:nvPr/>
+        </p:nvSpPr>
+        <p:spPr>
+          <a:xfrm xmlns:a="http://schemas.openxmlformats.org/drawingml/2006/main">
+            <a:off x="609600" y="838200"/>
+            <a:ext cx="8477250" cy="495300"/>
+          </a:xfrm>
+          <a:prstGeom xmlns:a="http://schemas.openxmlformats.org/drawingml/2006/main" prst="rect">
+            <a:avLst/>
+          </a:prstGeom>
+          <a:noFill xmlns:a="http://schemas.openxmlformats.org/drawingml/2006/main"/>
+          <a:ln xmlns:a="http://schemas.openxmlformats.org/drawingml/2006/main" w="0">
+            <a:noFill/>
+            <a:prstDash val="solid"/>
+          </a:ln>
+        </p:spPr>
+        <p:txBody>
+          <a:bodyPr xmlns:a="http://schemas.openxmlformats.org/drawingml/2006/main" lIns="0" tIns="0" rIns="0" bIns="0" anchor="t"/>
+          <a:lstStyle xmlns:a="http://schemas.openxmlformats.org/drawingml/2006/main"/>
+          <a:p xmlns:a="http://schemas.openxmlformats.org/drawingml/2006/main">
+            <a:pPr algn="l">
+              <a:lnSpc>
+                <a:spcPct val="100000"/>
+              </a:lnSpc>
+              <a:buNone/>
+              <a:defRPr sz="2925" b="1">
+                <a:solidFill>
+                  <a:srgbClr val="071425"/>
+                </a:solidFill>
+              </a:defRPr>
+            </a:pPr>
+            <a:r>
+              <a:rPr sz="2925" b="1">
+                <a:solidFill>
+                  <a:srgbClr val="071425"/>
+                </a:solidFill>
+              </a:rPr>
+              <a:t>Age changes the doorway, not the core idea.</a:t>
+            </a:r>
+          </a:p>
+        </p:txBody>
+      </p:sp>
+      <p:sp>
+        <p:nvSpPr>
+          <p:cNvPr id="41" name="">
+            <a:extLst xmlns:a="http://schemas.openxmlformats.org/drawingml/2006/main">
+              <a:ext uri="{FF2B5EF4-FFF2-40B4-BE49-F238E27FC236}">
+                <a16:creationId xmlns:a16="http://schemas.microsoft.com/office/drawing/2014/main" id="{E6A5A632-6CAA-4675-9C2F-88BFDDE6253C}"/>
+              </a:ext>
+            </a:extLst>
+          </p:cNvPr>
+          <p:cNvSpPr>
+            <a:spLocks xmlns:a="http://schemas.openxmlformats.org/drawingml/2006/main" noGrp="1"/>
+          </p:cNvSpPr>
+          <p:nvPr/>
+        </p:nvSpPr>
+        <p:spPr>
+          <a:xfrm xmlns:a="http://schemas.openxmlformats.org/drawingml/2006/main">
+            <a:off x="609600" y="1466850"/>
+            <a:ext cx="8286750" cy="457200"/>
+          </a:xfrm>
+          <a:prstGeom xmlns:a="http://schemas.openxmlformats.org/drawingml/2006/main" prst="rect">
+            <a:avLst/>
+          </a:prstGeom>
+          <a:noFill xmlns:a="http://schemas.openxmlformats.org/drawingml/2006/main"/>
+          <a:ln xmlns:a="http://schemas.openxmlformats.org/drawingml/2006/main" w="0">
+            <a:noFill/>
+            <a:prstDash val="solid"/>
+          </a:ln>
+        </p:spPr>
+        <p:txBody>
+          <a:bodyPr xmlns:a="http://schemas.openxmlformats.org/drawingml/2006/main" lIns="0" tIns="0" rIns="0" bIns="0" anchor="t"/>
+          <a:lstStyle xmlns:a="http://schemas.openxmlformats.org/drawingml/2006/main"/>
+          <a:p xmlns:a="http://schemas.openxmlformats.org/drawingml/2006/main">
+            <a:pPr algn="l">
+              <a:lnSpc>
+                <a:spcPct val="112000"/>
+              </a:lnSpc>
+              <a:buNone/>
+              <a:defRPr sz="1313" b="0">
+                <a:solidFill>
+                  <a:srgbClr val="41516B"/>
+                </a:solidFill>
+              </a:defRPr>
+            </a:pPr>
+            <a:r>
+              <a:rPr sz="1313" b="0">
+                <a:solidFill>
+                  <a:srgbClr val="41516B"/>
+                </a:solidFill>
+              </a:rPr>
+              <a:t>Under 40 wants comfort to feel powerful; 40+ wants proof the brand understands her stage of life. Both still leave room for Shapermint to own body adaptation.</a:t>
+            </a:r>
+          </a:p>
+        </p:txBody>
+      </p:sp>
+      <p:sp>
+        <p:nvSpPr>
+          <p:cNvPr id="42" name="">
+            <a:extLst xmlns:a="http://schemas.openxmlformats.org/drawingml/2006/main">
+              <a:ext uri="{FF2B5EF4-FFF2-40B4-BE49-F238E27FC236}">
+                <a16:creationId xmlns:a16="http://schemas.microsoft.com/office/drawing/2014/main" id="{37D3E4B9-41EC-45E3-B3DD-D1DC26E8B4BA}"/>
+              </a:ext>
+            </a:extLst>
+          </p:cNvPr>
+          <p:cNvSpPr>
+            <a:spLocks xmlns:a="http://schemas.openxmlformats.org/drawingml/2006/main" noGrp="1"/>
+          </p:cNvSpPr>
+          <p:nvPr/>
+        </p:nvSpPr>
+        <p:spPr>
+          <a:xfrm xmlns:a="http://schemas.openxmlformats.org/drawingml/2006/main">
+            <a:off x="9210675" y="609600"/>
+            <a:ext cx="1238250" cy="285750"/>
+          </a:xfrm>
+          <a:prstGeom xmlns:a="http://schemas.openxmlformats.org/drawingml/2006/main" prst="roundRect">
+            <a:avLst>
+              <a:gd name="adj" fmla="val 50000"/>
+            </a:avLst>
+          </a:prstGeom>
+          <a:solidFill xmlns:a="http://schemas.openxmlformats.org/drawingml/2006/main">
+            <a:srgbClr val="7C3AED"/>
+          </a:solidFill>
+          <a:ln xmlns:a="http://schemas.openxmlformats.org/drawingml/2006/main" w="0">
+            <a:noFill/>
+            <a:prstDash val="solid"/>
+          </a:ln>
+        </p:spPr>
+      </p:sp>
+      <p:sp>
+        <p:nvSpPr>
+          <p:cNvPr id="43" name="">
+            <a:extLst xmlns:a="http://schemas.openxmlformats.org/drawingml/2006/main">
+              <a:ext uri="{FF2B5EF4-FFF2-40B4-BE49-F238E27FC236}">
+                <a16:creationId xmlns:a16="http://schemas.microsoft.com/office/drawing/2014/main" id="{8FFDB9C1-FB5D-452A-8D19-0411F8AC0E18}"/>
+              </a:ext>
+            </a:extLst>
+          </p:cNvPr>
+          <p:cNvSpPr>
+            <a:spLocks xmlns:a="http://schemas.openxmlformats.org/drawingml/2006/main" noGrp="1"/>
+          </p:cNvSpPr>
+          <p:nvPr/>
+        </p:nvSpPr>
+        <p:spPr>
+          <a:xfrm xmlns:a="http://schemas.openxmlformats.org/drawingml/2006/main">
+            <a:off x="9210675" y="666750"/>
+            <a:ext cx="1238250" cy="190500"/>
+          </a:xfrm>
+          <a:prstGeom xmlns:a="http://schemas.openxmlformats.org/drawingml/2006/main" prst="rect">
+            <a:avLst/>
+          </a:prstGeom>
+          <a:noFill xmlns:a="http://schemas.openxmlformats.org/drawingml/2006/main"/>
+          <a:ln xmlns:a="http://schemas.openxmlformats.org/drawingml/2006/main" w="0">
+            <a:noFill/>
+            <a:prstDash val="solid"/>
+          </a:ln>
+        </p:spPr>
+        <p:txBody>
+          <a:bodyPr xmlns:a="http://schemas.openxmlformats.org/drawingml/2006/main" lIns="0" tIns="0" rIns="0" bIns="0" anchor="t"/>
+          <a:lstStyle xmlns:a="http://schemas.openxmlformats.org/drawingml/2006/main"/>
+          <a:p xmlns:a="http://schemas.openxmlformats.org/drawingml/2006/main">
+            <a:pPr algn="ctr">
+              <a:lnSpc>
+                <a:spcPct val="105000"/>
+              </a:lnSpc>
+              <a:buNone/>
+              <a:defRPr sz="975" b="1">
+                <a:solidFill>
+                  <a:srgbClr val="FFFFFF"/>
+                </a:solidFill>
+              </a:defRPr>
+            </a:pPr>
+            <a:r>
+              <a:rPr sz="975" b="1">
+                <a:solidFill>
+                  <a:srgbClr val="FFFFFF"/>
+                </a:solidFill>
+              </a:rPr>
+              <a:t>Under 40 n=333</a:t>
+            </a:r>
+          </a:p>
+        </p:txBody>
+      </p:sp>
+      <p:sp>
+        <p:nvSpPr>
+          <p:cNvPr id="44" name="">
+            <a:extLst xmlns:a="http://schemas.openxmlformats.org/drawingml/2006/main">
+              <a:ext uri="{FF2B5EF4-FFF2-40B4-BE49-F238E27FC236}">
+                <a16:creationId xmlns:a16="http://schemas.microsoft.com/office/drawing/2014/main" id="{C1077CE8-73F6-4BB3-90CC-E7E08C6C6877}"/>
+              </a:ext>
+            </a:extLst>
+          </p:cNvPr>
+          <p:cNvSpPr>
+            <a:spLocks xmlns:a="http://schemas.openxmlformats.org/drawingml/2006/main" noGrp="1"/>
+          </p:cNvSpPr>
+          <p:nvPr/>
+        </p:nvSpPr>
+        <p:spPr>
+          <a:xfrm xmlns:a="http://schemas.openxmlformats.org/drawingml/2006/main">
+            <a:off x="10572750" y="609600"/>
+            <a:ext cx="1143000" cy="285750"/>
+          </a:xfrm>
+          <a:prstGeom xmlns:a="http://schemas.openxmlformats.org/drawingml/2006/main" prst="roundRect">
+            <a:avLst>
+              <a:gd name="adj" fmla="val 50000"/>
+            </a:avLst>
+          </a:prstGeom>
+          <a:solidFill xmlns:a="http://schemas.openxmlformats.org/drawingml/2006/main">
+            <a:srgbClr val="071425"/>
+          </a:solidFill>
+          <a:ln xmlns:a="http://schemas.openxmlformats.org/drawingml/2006/main" w="0">
+            <a:noFill/>
+            <a:prstDash val="solid"/>
+          </a:ln>
+        </p:spPr>
+      </p:sp>
+      <p:sp>
+        <p:nvSpPr>
+          <p:cNvPr id="45" name="">
+            <a:extLst xmlns:a="http://schemas.openxmlformats.org/drawingml/2006/main">
+              <a:ext uri="{FF2B5EF4-FFF2-40B4-BE49-F238E27FC236}">
+                <a16:creationId xmlns:a16="http://schemas.microsoft.com/office/drawing/2014/main" id="{6E8CE8BE-A29A-4814-B014-EA477050667F}"/>
+              </a:ext>
+            </a:extLst>
+          </p:cNvPr>
+          <p:cNvSpPr>
+            <a:spLocks xmlns:a="http://schemas.openxmlformats.org/drawingml/2006/main" noGrp="1"/>
+          </p:cNvSpPr>
+          <p:nvPr/>
+        </p:nvSpPr>
+        <p:spPr>
+          <a:xfrm xmlns:a="http://schemas.openxmlformats.org/drawingml/2006/main">
+            <a:off x="10572750" y="666750"/>
+            <a:ext cx="1143000" cy="190500"/>
+          </a:xfrm>
+          <a:prstGeom xmlns:a="http://schemas.openxmlformats.org/drawingml/2006/main" prst="rect">
+            <a:avLst/>
+          </a:prstGeom>
+          <a:noFill xmlns:a="http://schemas.openxmlformats.org/drawingml/2006/main"/>
+          <a:ln xmlns:a="http://schemas.openxmlformats.org/drawingml/2006/main" w="0">
+            <a:noFill/>
+            <a:prstDash val="solid"/>
+          </a:ln>
+        </p:spPr>
+        <p:txBody>
+          <a:bodyPr xmlns:a="http://schemas.openxmlformats.org/drawingml/2006/main" lIns="0" tIns="0" rIns="0" bIns="0" anchor="t"/>
+          <a:lstStyle xmlns:a="http://schemas.openxmlformats.org/drawingml/2006/main"/>
+          <a:p xmlns:a="http://schemas.openxmlformats.org/drawingml/2006/main">
+            <a:pPr algn="ctr">
+              <a:lnSpc>
+                <a:spcPct val="105000"/>
+              </a:lnSpc>
+              <a:buNone/>
+              <a:defRPr sz="975" b="1">
+                <a:solidFill>
+                  <a:srgbClr val="FFFFFF"/>
+                </a:solidFill>
+              </a:defRPr>
+            </a:pPr>
+            <a:r>
+              <a:rPr sz="975" b="1">
+                <a:solidFill>
+                  <a:srgbClr val="FFFFFF"/>
+                </a:solidFill>
+              </a:rPr>
+              <a:t>40+ n=1,314</a:t>
+            </a:r>
+          </a:p>
+        </p:txBody>
+      </p:sp>
+      <p:sp>
+        <p:nvSpPr>
+          <p:cNvPr id="46" name="">
+            <a:extLst xmlns:a="http://schemas.openxmlformats.org/drawingml/2006/main">
+              <a:ext uri="{FF2B5EF4-FFF2-40B4-BE49-F238E27FC236}">
+                <a16:creationId xmlns:a16="http://schemas.microsoft.com/office/drawing/2014/main" id="{E2863CA1-06E6-4570-8115-8E51E33614E2}"/>
+              </a:ext>
+            </a:extLst>
+          </p:cNvPr>
+          <p:cNvSpPr>
+            <a:spLocks xmlns:a="http://schemas.openxmlformats.org/drawingml/2006/main" noGrp="1"/>
+          </p:cNvSpPr>
+          <p:nvPr/>
+        </p:nvSpPr>
+        <p:spPr>
+          <a:xfrm xmlns:a="http://schemas.openxmlformats.org/drawingml/2006/main">
+            <a:off x="609600" y="2171700"/>
+            <a:ext cx="5238750" cy="3429000"/>
+          </a:xfrm>
+          <a:prstGeom xmlns:a="http://schemas.openxmlformats.org/drawingml/2006/main" prst="roundRect">
+            <a:avLst>
+              <a:gd name="adj" fmla="val 2222"/>
+            </a:avLst>
+          </a:prstGeom>
+          <a:solidFill xmlns:a="http://schemas.openxmlformats.org/drawingml/2006/main">
+            <a:srgbClr val="FFF9F3"/>
+          </a:solidFill>
+          <a:ln xmlns:a="http://schemas.openxmlformats.org/drawingml/2006/main" w="9525">
+            <a:solidFill>
+              <a:srgbClr val="E5DCD1"/>
+            </a:solidFill>
+            <a:prstDash val="solid"/>
+          </a:ln>
+        </p:spPr>
+      </p:sp>
+      <p:sp>
+        <p:nvSpPr>
+          <p:cNvPr id="47" name="">
+            <a:extLst xmlns:a="http://schemas.openxmlformats.org/drawingml/2006/main">
+              <a:ext uri="{FF2B5EF4-FFF2-40B4-BE49-F238E27FC236}">
+                <a16:creationId xmlns:a16="http://schemas.microsoft.com/office/drawing/2014/main" id="{99D0B788-A556-4405-9F89-B0B488FACDF4}"/>
+              </a:ext>
+            </a:extLst>
+          </p:cNvPr>
+          <p:cNvSpPr>
+            <a:spLocks xmlns:a="http://schemas.openxmlformats.org/drawingml/2006/main" noGrp="1"/>
+          </p:cNvSpPr>
+          <p:nvPr/>
+        </p:nvSpPr>
+        <p:spPr>
+          <a:xfrm xmlns:a="http://schemas.openxmlformats.org/drawingml/2006/main">
+            <a:off x="866775" y="2400300"/>
+            <a:ext cx="3048000" cy="247650"/>
+          </a:xfrm>
+          <a:prstGeom xmlns:a="http://schemas.openxmlformats.org/drawingml/2006/main" prst="rect">
+            <a:avLst/>
+          </a:prstGeom>
+          <a:noFill xmlns:a="http://schemas.openxmlformats.org/drawingml/2006/main"/>
+          <a:ln xmlns:a="http://schemas.openxmlformats.org/drawingml/2006/main" w="0">
+            <a:noFill/>
+            <a:prstDash val="solid"/>
+          </a:ln>
+        </p:spPr>
+        <p:txBody>
+          <a:bodyPr xmlns:a="http://schemas.openxmlformats.org/drawingml/2006/main" lIns="0" tIns="0" rIns="0" bIns="0" anchor="t"/>
+          <a:lstStyle xmlns:a="http://schemas.openxmlformats.org/drawingml/2006/main"/>
+          <a:p xmlns:a="http://schemas.openxmlformats.org/drawingml/2006/main">
+            <a:pPr algn="l">
+              <a:lnSpc>
+                <a:spcPct val="105000"/>
+              </a:lnSpc>
+              <a:buNone/>
+              <a:defRPr sz="1500" b="1">
+                <a:solidFill>
+                  <a:srgbClr val="071425"/>
+                </a:solidFill>
+              </a:defRPr>
+            </a:pPr>
+            <a:r>
+              <a:rPr sz="1500" b="1">
+                <a:solidFill>
+                  <a:srgbClr val="071425"/>
+                </a:solidFill>
+              </a:rPr>
+              <a:t>Q19: campaign hooks by age</a:t>
+            </a:r>
+          </a:p>
+        </p:txBody>
+      </p:sp>
+      <p:sp>
+        <p:nvSpPr>
+          <p:cNvPr id="48" name="">
+            <a:extLst xmlns:a="http://schemas.openxmlformats.org/drawingml/2006/main">
+              <a:ext uri="{FF2B5EF4-FFF2-40B4-BE49-F238E27FC236}">
+                <a16:creationId xmlns:a16="http://schemas.microsoft.com/office/drawing/2014/main" id="{6A4C89B5-6F6C-48AE-BEE6-7A3207281D35}"/>
+              </a:ext>
+            </a:extLst>
+          </p:cNvPr>
+          <p:cNvSpPr>
+            <a:spLocks xmlns:a="http://schemas.openxmlformats.org/drawingml/2006/main" noGrp="1"/>
+          </p:cNvSpPr>
+          <p:nvPr/>
+        </p:nvSpPr>
+        <p:spPr>
+          <a:xfrm xmlns:a="http://schemas.openxmlformats.org/drawingml/2006/main">
+            <a:off x="866775" y="2686050"/>
+            <a:ext cx="2476500" cy="190500"/>
+          </a:xfrm>
+          <a:prstGeom xmlns:a="http://schemas.openxmlformats.org/drawingml/2006/main" prst="rect">
+            <a:avLst/>
+          </a:prstGeom>
+          <a:noFill xmlns:a="http://schemas.openxmlformats.org/drawingml/2006/main"/>
+          <a:ln xmlns:a="http://schemas.openxmlformats.org/drawingml/2006/main" w="0">
+            <a:noFill/>
+            <a:prstDash val="solid"/>
+          </a:ln>
+        </p:spPr>
+        <p:txBody>
+          <a:bodyPr xmlns:a="http://schemas.openxmlformats.org/drawingml/2006/main" lIns="0" tIns="0" rIns="0" bIns="0" anchor="t"/>
+          <a:lstStyle xmlns:a="http://schemas.openxmlformats.org/drawingml/2006/main"/>
+          <a:p xmlns:a="http://schemas.openxmlformats.org/drawingml/2006/main">
+            <a:pPr algn="l">
+              <a:lnSpc>
+                <a:spcPct val="105000"/>
+              </a:lnSpc>
+              <a:buNone/>
+              <a:defRPr sz="938" b="1">
+                <a:solidFill>
+                  <a:srgbClr val="667085"/>
+                </a:solidFill>
+              </a:defRPr>
+            </a:pPr>
+            <a:r>
+              <a:rPr sz="938" b="1">
+                <a:solidFill>
+                  <a:srgbClr val="667085"/>
+                </a:solidFill>
+              </a:rPr>
+              <a:t>Purple = under 40; navy = 40+</a:t>
+            </a:r>
+          </a:p>
+        </p:txBody>
+      </p:sp>
+      <p:sp>
+        <p:nvSpPr>
+          <p:cNvPr id="49" name="">
+            <a:extLst xmlns:a="http://schemas.openxmlformats.org/drawingml/2006/main">
+              <a:ext uri="{FF2B5EF4-FFF2-40B4-BE49-F238E27FC236}">
+                <a16:creationId xmlns:a16="http://schemas.microsoft.com/office/drawing/2014/main" id="{8C48ADBC-AC3C-468A-9B4C-BBB2A33DCDE0}"/>
+              </a:ext>
+            </a:extLst>
+          </p:cNvPr>
+          <p:cNvSpPr>
+            <a:spLocks xmlns:a="http://schemas.openxmlformats.org/drawingml/2006/main" noGrp="1"/>
+          </p:cNvSpPr>
+          <p:nvPr/>
+        </p:nvSpPr>
+        <p:spPr>
+          <a:xfrm xmlns:a="http://schemas.openxmlformats.org/drawingml/2006/main">
+            <a:off x="866775" y="3057525"/>
+            <a:ext cx="1952625" cy="323850"/>
+          </a:xfrm>
+          <a:prstGeom xmlns:a="http://schemas.openxmlformats.org/drawingml/2006/main" prst="rect">
+            <a:avLst/>
+          </a:prstGeom>
+          <a:noFill xmlns:a="http://schemas.openxmlformats.org/drawingml/2006/main"/>
+          <a:ln xmlns:a="http://schemas.openxmlformats.org/drawingml/2006/main" w="0">
+            <a:noFill/>
+            <a:prstDash val="solid"/>
+          </a:ln>
+        </p:spPr>
+        <p:txBody>
+          <a:bodyPr xmlns:a="http://schemas.openxmlformats.org/drawingml/2006/main" lIns="0" tIns="0" rIns="0" bIns="0" anchor="t"/>
+          <a:lstStyle xmlns:a="http://schemas.openxmlformats.org/drawingml/2006/main"/>
+          <a:p xmlns:a="http://schemas.openxmlformats.org/drawingml/2006/main">
+            <a:pPr algn="l">
+              <a:lnSpc>
+                <a:spcPct val="100000"/>
+              </a:lnSpc>
+              <a:buNone/>
+              <a:defRPr sz="1050" b="1">
+                <a:solidFill>
+                  <a:srgbClr val="41516B"/>
+                </a:solidFill>
+              </a:defRPr>
+            </a:pPr>
+            <a:r>
+              <a:rPr sz="1050" b="1">
+                <a:solidFill>
+                  <a:srgbClr val="41516B"/>
+                </a:solidFill>
+              </a:rPr>
+              <a:t>Comfort feels powerful</a:t>
+            </a:r>
+          </a:p>
+        </p:txBody>
+      </p:sp>
+      <p:sp>
+        <p:nvSpPr>
+          <p:cNvPr id="50" name="">
+            <a:extLst xmlns:a="http://schemas.openxmlformats.org/drawingml/2006/main">
+              <a:ext uri="{FF2B5EF4-FFF2-40B4-BE49-F238E27FC236}">
+                <a16:creationId xmlns:a16="http://schemas.microsoft.com/office/drawing/2014/main" id="{75080056-AE21-4BB2-9414-2DD5876FE94B}"/>
+              </a:ext>
+            </a:extLst>
+          </p:cNvPr>
+          <p:cNvSpPr>
+            <a:spLocks xmlns:a="http://schemas.openxmlformats.org/drawingml/2006/main" noGrp="1"/>
+          </p:cNvSpPr>
+          <p:nvPr/>
+        </p:nvSpPr>
+        <p:spPr>
+          <a:xfrm xmlns:a="http://schemas.openxmlformats.org/drawingml/2006/main">
+            <a:off x="2943225" y="3114675"/>
+            <a:ext cx="1762125" cy="171450"/>
+          </a:xfrm>
+          <a:prstGeom xmlns:a="http://schemas.openxmlformats.org/drawingml/2006/main" prst="roundRect">
+            <a:avLst>
+              <a:gd name="adj" fmla="val 50000"/>
+            </a:avLst>
+          </a:prstGeom>
+          <a:solidFill xmlns:a="http://schemas.openxmlformats.org/drawingml/2006/main">
+            <a:srgbClr val="EFE7DD"/>
+          </a:solidFill>
+          <a:ln xmlns:a="http://schemas.openxmlformats.org/drawingml/2006/main" w="0">
+            <a:noFill/>
+            <a:prstDash val="solid"/>
+          </a:ln>
+        </p:spPr>
+      </p:sp>
+      <p:sp>
+        <p:nvSpPr>
+          <p:cNvPr id="51" name="">
+            <a:extLst xmlns:a="http://schemas.openxmlformats.org/drawingml/2006/main">
+              <a:ext uri="{FF2B5EF4-FFF2-40B4-BE49-F238E27FC236}">
+                <a16:creationId xmlns:a16="http://schemas.microsoft.com/office/drawing/2014/main" id="{583B77C1-99FB-4078-B4C5-9EA125372D36}"/>
+              </a:ext>
+            </a:extLst>
+          </p:cNvPr>
+          <p:cNvSpPr>
+            <a:spLocks xmlns:a="http://schemas.openxmlformats.org/drawingml/2006/main" noGrp="1"/>
+          </p:cNvSpPr>
+          <p:nvPr/>
+        </p:nvSpPr>
+        <p:spPr>
+          <a:xfrm xmlns:a="http://schemas.openxmlformats.org/drawingml/2006/main">
+            <a:off x="2943225" y="3114675"/>
+            <a:ext cx="1571228" cy="171450"/>
+          </a:xfrm>
+          <a:prstGeom xmlns:a="http://schemas.openxmlformats.org/drawingml/2006/main" prst="roundRect">
+            <a:avLst>
+              <a:gd name="adj" fmla="val 50000"/>
+            </a:avLst>
+          </a:prstGeom>
+          <a:solidFill xmlns:a="http://schemas.openxmlformats.org/drawingml/2006/main">
+            <a:srgbClr val="7C3AED"/>
+          </a:solidFill>
+          <a:ln xmlns:a="http://schemas.openxmlformats.org/drawingml/2006/main" w="0">
+            <a:noFill/>
+            <a:prstDash val="solid"/>
+          </a:ln>
+        </p:spPr>
+      </p:sp>
+      <p:sp>
+        <p:nvSpPr>
+          <p:cNvPr id="52" name="">
+            <a:extLst xmlns:a="http://schemas.openxmlformats.org/drawingml/2006/main">
+              <a:ext uri="{FF2B5EF4-FFF2-40B4-BE49-F238E27FC236}">
+                <a16:creationId xmlns:a16="http://schemas.microsoft.com/office/drawing/2014/main" id="{7CA5FD9B-0EED-4DDD-91C2-72AF5ACB1713}"/>
+              </a:ext>
+            </a:extLst>
+          </p:cNvPr>
+          <p:cNvSpPr>
+            <a:spLocks xmlns:a="http://schemas.openxmlformats.org/drawingml/2006/main" noGrp="1"/>
+          </p:cNvSpPr>
+          <p:nvPr/>
+        </p:nvSpPr>
+        <p:spPr>
+          <a:xfrm xmlns:a="http://schemas.openxmlformats.org/drawingml/2006/main">
+            <a:off x="4800600" y="3105150"/>
+            <a:ext cx="533400" cy="190500"/>
+          </a:xfrm>
+          <a:prstGeom xmlns:a="http://schemas.openxmlformats.org/drawingml/2006/main" prst="rect">
+            <a:avLst/>
+          </a:prstGeom>
+          <a:noFill xmlns:a="http://schemas.openxmlformats.org/drawingml/2006/main"/>
+          <a:ln xmlns:a="http://schemas.openxmlformats.org/drawingml/2006/main" w="0">
+            <a:noFill/>
+            <a:prstDash val="solid"/>
+          </a:ln>
+        </p:spPr>
+        <p:txBody>
+          <a:bodyPr xmlns:a="http://schemas.openxmlformats.org/drawingml/2006/main" lIns="0" tIns="0" rIns="0" bIns="0" anchor="t"/>
+          <a:lstStyle xmlns:a="http://schemas.openxmlformats.org/drawingml/2006/main"/>
+          <a:p xmlns:a="http://schemas.openxmlformats.org/drawingml/2006/main">
+            <a:pPr algn="l">
+              <a:lnSpc>
+                <a:spcPct val="105000"/>
+              </a:lnSpc>
+              <a:buNone/>
+              <a:defRPr sz="1013" b="1">
+                <a:solidFill>
+                  <a:srgbClr val="7C3AED"/>
+                </a:solidFill>
+              </a:defRPr>
+            </a:pPr>
+            <a:r>
+              <a:rPr sz="1013" b="1">
+                <a:solidFill>
+                  <a:srgbClr val="7C3AED"/>
+                </a:solidFill>
+              </a:rPr>
+              <a:t>53.5%</a:t>
+            </a:r>
+          </a:p>
+        </p:txBody>
+      </p:sp>
+      <p:sp>
+        <p:nvSpPr>
+          <p:cNvPr id="53" name="">
+            <a:extLst xmlns:a="http://schemas.openxmlformats.org/drawingml/2006/main">
+              <a:ext uri="{FF2B5EF4-FFF2-40B4-BE49-F238E27FC236}">
+                <a16:creationId xmlns:a16="http://schemas.microsoft.com/office/drawing/2014/main" id="{71ED456A-7FA0-42B7-935D-4A16664D48EE}"/>
+              </a:ext>
+            </a:extLst>
+          </p:cNvPr>
+          <p:cNvSpPr>
+            <a:spLocks xmlns:a="http://schemas.openxmlformats.org/drawingml/2006/main" noGrp="1"/>
+          </p:cNvSpPr>
+          <p:nvPr/>
+        </p:nvSpPr>
+        <p:spPr>
+          <a:xfrm xmlns:a="http://schemas.openxmlformats.org/drawingml/2006/main">
+            <a:off x="2943225" y="3352800"/>
+            <a:ext cx="1762125" cy="171450"/>
+          </a:xfrm>
+          <a:prstGeom xmlns:a="http://schemas.openxmlformats.org/drawingml/2006/main" prst="roundRect">
+            <a:avLst>
+              <a:gd name="adj" fmla="val 50000"/>
+            </a:avLst>
+          </a:prstGeom>
+          <a:solidFill xmlns:a="http://schemas.openxmlformats.org/drawingml/2006/main">
+            <a:srgbClr val="EFE7DD"/>
+          </a:solidFill>
+          <a:ln xmlns:a="http://schemas.openxmlformats.org/drawingml/2006/main" w="0">
+            <a:noFill/>
+            <a:prstDash val="solid"/>
+          </a:ln>
+        </p:spPr>
+      </p:sp>
+      <p:sp>
+        <p:nvSpPr>
+          <p:cNvPr id="54" name="">
+            <a:extLst xmlns:a="http://schemas.openxmlformats.org/drawingml/2006/main">
+              <a:ext uri="{FF2B5EF4-FFF2-40B4-BE49-F238E27FC236}">
+                <a16:creationId xmlns:a16="http://schemas.microsoft.com/office/drawing/2014/main" id="{419646FB-A066-41CE-80CA-3AF12EF61AA5}"/>
+              </a:ext>
+            </a:extLst>
+          </p:cNvPr>
+          <p:cNvSpPr>
+            <a:spLocks xmlns:a="http://schemas.openxmlformats.org/drawingml/2006/main" noGrp="1"/>
+          </p:cNvSpPr>
+          <p:nvPr/>
+        </p:nvSpPr>
+        <p:spPr>
+          <a:xfrm xmlns:a="http://schemas.openxmlformats.org/drawingml/2006/main">
+            <a:off x="2943225" y="3352800"/>
+            <a:ext cx="1154192" cy="171450"/>
+          </a:xfrm>
+          <a:prstGeom xmlns:a="http://schemas.openxmlformats.org/drawingml/2006/main" prst="roundRect">
+            <a:avLst>
+              <a:gd name="adj" fmla="val 50000"/>
+            </a:avLst>
+          </a:prstGeom>
+          <a:solidFill xmlns:a="http://schemas.openxmlformats.org/drawingml/2006/main">
+            <a:srgbClr val="071425"/>
+          </a:solidFill>
+          <a:ln xmlns:a="http://schemas.openxmlformats.org/drawingml/2006/main" w="0">
+            <a:noFill/>
+            <a:prstDash val="solid"/>
+          </a:ln>
+        </p:spPr>
+      </p:sp>
+      <p:sp>
+        <p:nvSpPr>
+          <p:cNvPr id="55" name="">
+            <a:extLst xmlns:a="http://schemas.openxmlformats.org/drawingml/2006/main">
+              <a:ext uri="{FF2B5EF4-FFF2-40B4-BE49-F238E27FC236}">
+                <a16:creationId xmlns:a16="http://schemas.microsoft.com/office/drawing/2014/main" id="{FC349E96-8871-4467-8AF2-4D07CC276995}"/>
+              </a:ext>
+            </a:extLst>
+          </p:cNvPr>
+          <p:cNvSpPr>
+            <a:spLocks xmlns:a="http://schemas.openxmlformats.org/drawingml/2006/main" noGrp="1"/>
+          </p:cNvSpPr>
+          <p:nvPr/>
+        </p:nvSpPr>
+        <p:spPr>
+          <a:xfrm xmlns:a="http://schemas.openxmlformats.org/drawingml/2006/main">
+            <a:off x="4800600" y="3343275"/>
+            <a:ext cx="533400" cy="190500"/>
+          </a:xfrm>
+          <a:prstGeom xmlns:a="http://schemas.openxmlformats.org/drawingml/2006/main" prst="rect">
+            <a:avLst/>
+          </a:prstGeom>
+          <a:noFill xmlns:a="http://schemas.openxmlformats.org/drawingml/2006/main"/>
+          <a:ln xmlns:a="http://schemas.openxmlformats.org/drawingml/2006/main" w="0">
+            <a:noFill/>
+            <a:prstDash val="solid"/>
+          </a:ln>
+        </p:spPr>
+        <p:txBody>
+          <a:bodyPr xmlns:a="http://schemas.openxmlformats.org/drawingml/2006/main" lIns="0" tIns="0" rIns="0" bIns="0" anchor="t"/>
+          <a:lstStyle xmlns:a="http://schemas.openxmlformats.org/drawingml/2006/main"/>
+          <a:p xmlns:a="http://schemas.openxmlformats.org/drawingml/2006/main">
+            <a:pPr algn="l">
+              <a:lnSpc>
+                <a:spcPct val="105000"/>
+              </a:lnSpc>
+              <a:buNone/>
+              <a:defRPr sz="1013" b="1">
+                <a:solidFill>
+                  <a:srgbClr val="071425"/>
+                </a:solidFill>
+              </a:defRPr>
+            </a:pPr>
+            <a:r>
+              <a:rPr sz="1013" b="1">
+                <a:solidFill>
+                  <a:srgbClr val="071425"/>
+                </a:solidFill>
+              </a:rPr>
+              <a:t>39.3%</a:t>
+            </a:r>
+          </a:p>
+        </p:txBody>
+      </p:sp>
+      <p:sp>
+        <p:nvSpPr>
+          <p:cNvPr id="56" name="">
+            <a:extLst xmlns:a="http://schemas.openxmlformats.org/drawingml/2006/main">
+              <a:ext uri="{FF2B5EF4-FFF2-40B4-BE49-F238E27FC236}">
+                <a16:creationId xmlns:a16="http://schemas.microsoft.com/office/drawing/2014/main" id="{5287FD9E-DF81-45B8-BE45-F078C7776A7E}"/>
+              </a:ext>
+            </a:extLst>
+          </p:cNvPr>
+          <p:cNvSpPr>
+            <a:spLocks xmlns:a="http://schemas.openxmlformats.org/drawingml/2006/main" noGrp="1"/>
+          </p:cNvSpPr>
+          <p:nvPr/>
+        </p:nvSpPr>
+        <p:spPr>
+          <a:xfrm xmlns:a="http://schemas.openxmlformats.org/drawingml/2006/main">
+            <a:off x="866775" y="3886200"/>
+            <a:ext cx="1952625" cy="323850"/>
+          </a:xfrm>
+          <a:prstGeom xmlns:a="http://schemas.openxmlformats.org/drawingml/2006/main" prst="rect">
+            <a:avLst/>
+          </a:prstGeom>
+          <a:noFill xmlns:a="http://schemas.openxmlformats.org/drawingml/2006/main"/>
+          <a:ln xmlns:a="http://schemas.openxmlformats.org/drawingml/2006/main" w="0">
+            <a:noFill/>
+            <a:prstDash val="solid"/>
+          </a:ln>
+        </p:spPr>
+        <p:txBody>
+          <a:bodyPr xmlns:a="http://schemas.openxmlformats.org/drawingml/2006/main" lIns="0" tIns="0" rIns="0" bIns="0" anchor="t"/>
+          <a:lstStyle xmlns:a="http://schemas.openxmlformats.org/drawingml/2006/main"/>
+          <a:p xmlns:a="http://schemas.openxmlformats.org/drawingml/2006/main">
+            <a:pPr algn="l">
+              <a:lnSpc>
+                <a:spcPct val="100000"/>
+              </a:lnSpc>
+              <a:buNone/>
+              <a:defRPr sz="1050" b="1">
+                <a:solidFill>
+                  <a:srgbClr val="41516B"/>
+                </a:solidFill>
+              </a:defRPr>
+            </a:pPr>
+            <a:r>
+              <a:rPr sz="1050" b="1">
+                <a:solidFill>
+                  <a:srgbClr val="41516B"/>
+                </a:solidFill>
+              </a:rPr>
+              <a:t>Adapts to my body</a:t>
+            </a:r>
+          </a:p>
+        </p:txBody>
+      </p:sp>
+      <p:sp>
+        <p:nvSpPr>
+          <p:cNvPr id="57" name="">
+            <a:extLst xmlns:a="http://schemas.openxmlformats.org/drawingml/2006/main">
+              <a:ext uri="{FF2B5EF4-FFF2-40B4-BE49-F238E27FC236}">
+                <a16:creationId xmlns:a16="http://schemas.microsoft.com/office/drawing/2014/main" id="{07E2AB56-0958-4A0C-8548-679BF3627FE3}"/>
+              </a:ext>
+            </a:extLst>
+          </p:cNvPr>
+          <p:cNvSpPr>
+            <a:spLocks xmlns:a="http://schemas.openxmlformats.org/drawingml/2006/main" noGrp="1"/>
+          </p:cNvSpPr>
+          <p:nvPr/>
+        </p:nvSpPr>
+        <p:spPr>
+          <a:xfrm xmlns:a="http://schemas.openxmlformats.org/drawingml/2006/main">
+            <a:off x="2943225" y="3943350"/>
+            <a:ext cx="1762125" cy="171450"/>
+          </a:xfrm>
+          <a:prstGeom xmlns:a="http://schemas.openxmlformats.org/drawingml/2006/main" prst="roundRect">
+            <a:avLst>
+              <a:gd name="adj" fmla="val 50000"/>
+            </a:avLst>
+          </a:prstGeom>
+          <a:solidFill xmlns:a="http://schemas.openxmlformats.org/drawingml/2006/main">
+            <a:srgbClr val="EFE7DD"/>
+          </a:solidFill>
+          <a:ln xmlns:a="http://schemas.openxmlformats.org/drawingml/2006/main" w="0">
+            <a:noFill/>
+            <a:prstDash val="solid"/>
+          </a:ln>
+        </p:spPr>
+      </p:sp>
+      <p:sp>
+        <p:nvSpPr>
+          <p:cNvPr id="58" name="">
+            <a:extLst xmlns:a="http://schemas.openxmlformats.org/drawingml/2006/main">
+              <a:ext uri="{FF2B5EF4-FFF2-40B4-BE49-F238E27FC236}">
+                <a16:creationId xmlns:a16="http://schemas.microsoft.com/office/drawing/2014/main" id="{4689CD13-ACB7-46FD-A493-A92E88ADE568}"/>
+              </a:ext>
+            </a:extLst>
+          </p:cNvPr>
+          <p:cNvSpPr>
+            <a:spLocks xmlns:a="http://schemas.openxmlformats.org/drawingml/2006/main" noGrp="1"/>
+          </p:cNvSpPr>
+          <p:nvPr/>
+        </p:nvSpPr>
+        <p:spPr>
+          <a:xfrm xmlns:a="http://schemas.openxmlformats.org/drawingml/2006/main">
+            <a:off x="2943225" y="3943350"/>
+            <a:ext cx="1286351" cy="171450"/>
+          </a:xfrm>
+          <a:prstGeom xmlns:a="http://schemas.openxmlformats.org/drawingml/2006/main" prst="roundRect">
+            <a:avLst>
+              <a:gd name="adj" fmla="val 50000"/>
+            </a:avLst>
+          </a:prstGeom>
+          <a:solidFill xmlns:a="http://schemas.openxmlformats.org/drawingml/2006/main">
+            <a:srgbClr val="7C3AED"/>
+          </a:solidFill>
+          <a:ln xmlns:a="http://schemas.openxmlformats.org/drawingml/2006/main" w="0">
+            <a:noFill/>
+            <a:prstDash val="solid"/>
+          </a:ln>
+        </p:spPr>
+      </p:sp>
+      <p:sp>
+        <p:nvSpPr>
+          <p:cNvPr id="59" name="">
+            <a:extLst xmlns:a="http://schemas.openxmlformats.org/drawingml/2006/main">
+              <a:ext uri="{FF2B5EF4-FFF2-40B4-BE49-F238E27FC236}">
+                <a16:creationId xmlns:a16="http://schemas.microsoft.com/office/drawing/2014/main" id="{CF4A3441-9EB4-44BC-A48C-9EB1D63035B6}"/>
+              </a:ext>
+            </a:extLst>
+          </p:cNvPr>
+          <p:cNvSpPr>
+            <a:spLocks xmlns:a="http://schemas.openxmlformats.org/drawingml/2006/main" noGrp="1"/>
+          </p:cNvSpPr>
+          <p:nvPr/>
+        </p:nvSpPr>
+        <p:spPr>
+          <a:xfrm xmlns:a="http://schemas.openxmlformats.org/drawingml/2006/main">
+            <a:off x="4800600" y="3933825"/>
+            <a:ext cx="533400" cy="190500"/>
+          </a:xfrm>
+          <a:prstGeom xmlns:a="http://schemas.openxmlformats.org/drawingml/2006/main" prst="rect">
+            <a:avLst/>
+          </a:prstGeom>
+          <a:noFill xmlns:a="http://schemas.openxmlformats.org/drawingml/2006/main"/>
+          <a:ln xmlns:a="http://schemas.openxmlformats.org/drawingml/2006/main" w="0">
+            <a:noFill/>
+            <a:prstDash val="solid"/>
+          </a:ln>
+        </p:spPr>
+        <p:txBody>
+          <a:bodyPr xmlns:a="http://schemas.openxmlformats.org/drawingml/2006/main" lIns="0" tIns="0" rIns="0" bIns="0" anchor="t"/>
+          <a:lstStyle xmlns:a="http://schemas.openxmlformats.org/drawingml/2006/main"/>
+          <a:p xmlns:a="http://schemas.openxmlformats.org/drawingml/2006/main">
+            <a:pPr algn="l">
+              <a:lnSpc>
+                <a:spcPct val="105000"/>
+              </a:lnSpc>
+              <a:buNone/>
+              <a:defRPr sz="1013" b="1">
+                <a:solidFill>
+                  <a:srgbClr val="7C3AED"/>
+                </a:solidFill>
+              </a:defRPr>
+            </a:pPr>
+            <a:r>
+              <a:rPr sz="1013" b="1">
+                <a:solidFill>
+                  <a:srgbClr val="7C3AED"/>
+                </a:solidFill>
+              </a:rPr>
+              <a:t>43.8%</a:t>
+            </a:r>
+          </a:p>
+        </p:txBody>
+      </p:sp>
+      <p:sp>
+        <p:nvSpPr>
+          <p:cNvPr id="60" name="">
+            <a:extLst xmlns:a="http://schemas.openxmlformats.org/drawingml/2006/main">
+              <a:ext uri="{FF2B5EF4-FFF2-40B4-BE49-F238E27FC236}">
+                <a16:creationId xmlns:a16="http://schemas.microsoft.com/office/drawing/2014/main" id="{B7C466AE-226D-44D8-BA15-CF35413005EC}"/>
+              </a:ext>
+            </a:extLst>
+          </p:cNvPr>
+          <p:cNvSpPr>
+            <a:spLocks xmlns:a="http://schemas.openxmlformats.org/drawingml/2006/main" noGrp="1"/>
+          </p:cNvSpPr>
+          <p:nvPr/>
+        </p:nvSpPr>
+        <p:spPr>
+          <a:xfrm xmlns:a="http://schemas.openxmlformats.org/drawingml/2006/main">
+            <a:off x="2943225" y="4181475"/>
+            <a:ext cx="1762125" cy="171450"/>
+          </a:xfrm>
+          <a:prstGeom xmlns:a="http://schemas.openxmlformats.org/drawingml/2006/main" prst="roundRect">
+            <a:avLst>
+              <a:gd name="adj" fmla="val 50000"/>
+            </a:avLst>
+          </a:prstGeom>
+          <a:solidFill xmlns:a="http://schemas.openxmlformats.org/drawingml/2006/main">
+            <a:srgbClr val="EFE7DD"/>
+          </a:solidFill>
+          <a:ln xmlns:a="http://schemas.openxmlformats.org/drawingml/2006/main" w="0">
+            <a:noFill/>
+            <a:prstDash val="solid"/>
+          </a:ln>
+        </p:spPr>
+      </p:sp>
+      <p:sp>
+        <p:nvSpPr>
+          <p:cNvPr id="61" name="">
+            <a:extLst xmlns:a="http://schemas.openxmlformats.org/drawingml/2006/main">
+              <a:ext uri="{FF2B5EF4-FFF2-40B4-BE49-F238E27FC236}">
+                <a16:creationId xmlns:a16="http://schemas.microsoft.com/office/drawing/2014/main" id="{1AB48A5B-5054-4D78-90A3-8F37418A3B2D}"/>
+              </a:ext>
+            </a:extLst>
+          </p:cNvPr>
+          <p:cNvSpPr>
+            <a:spLocks xmlns:a="http://schemas.openxmlformats.org/drawingml/2006/main" noGrp="1"/>
+          </p:cNvSpPr>
+          <p:nvPr/>
+        </p:nvSpPr>
+        <p:spPr>
+          <a:xfrm xmlns:a="http://schemas.openxmlformats.org/drawingml/2006/main">
+            <a:off x="2943225" y="4181475"/>
+            <a:ext cx="1559481" cy="171450"/>
+          </a:xfrm>
+          <a:prstGeom xmlns:a="http://schemas.openxmlformats.org/drawingml/2006/main" prst="roundRect">
+            <a:avLst>
+              <a:gd name="adj" fmla="val 50000"/>
+            </a:avLst>
+          </a:prstGeom>
+          <a:solidFill xmlns:a="http://schemas.openxmlformats.org/drawingml/2006/main">
+            <a:srgbClr val="071425"/>
+          </a:solidFill>
+          <a:ln xmlns:a="http://schemas.openxmlformats.org/drawingml/2006/main" w="0">
+            <a:noFill/>
+            <a:prstDash val="solid"/>
+          </a:ln>
+        </p:spPr>
+      </p:sp>
+      <p:sp>
+        <p:nvSpPr>
+          <p:cNvPr id="62" name="">
+            <a:extLst xmlns:a="http://schemas.openxmlformats.org/drawingml/2006/main">
+              <a:ext uri="{FF2B5EF4-FFF2-40B4-BE49-F238E27FC236}">
+                <a16:creationId xmlns:a16="http://schemas.microsoft.com/office/drawing/2014/main" id="{35040F41-F4C6-4CC5-84A0-CA61D2944142}"/>
+              </a:ext>
+            </a:extLst>
+          </p:cNvPr>
+          <p:cNvSpPr>
+            <a:spLocks xmlns:a="http://schemas.openxmlformats.org/drawingml/2006/main" noGrp="1"/>
+          </p:cNvSpPr>
+          <p:nvPr/>
+        </p:nvSpPr>
+        <p:spPr>
+          <a:xfrm xmlns:a="http://schemas.openxmlformats.org/drawingml/2006/main">
+            <a:off x="4800600" y="4171950"/>
+            <a:ext cx="533400" cy="190500"/>
+          </a:xfrm>
+          <a:prstGeom xmlns:a="http://schemas.openxmlformats.org/drawingml/2006/main" prst="rect">
+            <a:avLst/>
+          </a:prstGeom>
+          <a:noFill xmlns:a="http://schemas.openxmlformats.org/drawingml/2006/main"/>
+          <a:ln xmlns:a="http://schemas.openxmlformats.org/drawingml/2006/main" w="0">
+            <a:noFill/>
+            <a:prstDash val="solid"/>
+          </a:ln>
+        </p:spPr>
+        <p:txBody>
+          <a:bodyPr xmlns:a="http://schemas.openxmlformats.org/drawingml/2006/main" lIns="0" tIns="0" rIns="0" bIns="0" anchor="t"/>
+          <a:lstStyle xmlns:a="http://schemas.openxmlformats.org/drawingml/2006/main"/>
+          <a:p xmlns:a="http://schemas.openxmlformats.org/drawingml/2006/main">
+            <a:pPr algn="l">
+              <a:lnSpc>
+                <a:spcPct val="105000"/>
+              </a:lnSpc>
+              <a:buNone/>
+              <a:defRPr sz="1013" b="1">
+                <a:solidFill>
+                  <a:srgbClr val="071425"/>
+                </a:solidFill>
+              </a:defRPr>
+            </a:pPr>
+            <a:r>
+              <a:rPr sz="1013" b="1">
+                <a:solidFill>
+                  <a:srgbClr val="071425"/>
+                </a:solidFill>
+              </a:rPr>
+              <a:t>53.1%</a:t>
+            </a:r>
+          </a:p>
+        </p:txBody>
+      </p:sp>
+      <p:sp>
+        <p:nvSpPr>
+          <p:cNvPr id="63" name="">
+            <a:extLst xmlns:a="http://schemas.openxmlformats.org/drawingml/2006/main">
+              <a:ext uri="{FF2B5EF4-FFF2-40B4-BE49-F238E27FC236}">
+                <a16:creationId xmlns:a16="http://schemas.microsoft.com/office/drawing/2014/main" id="{25B4EDD8-6C04-4400-B06B-A2677292DDAB}"/>
+              </a:ext>
+            </a:extLst>
+          </p:cNvPr>
+          <p:cNvSpPr>
+            <a:spLocks xmlns:a="http://schemas.openxmlformats.org/drawingml/2006/main" noGrp="1"/>
+          </p:cNvSpPr>
+          <p:nvPr/>
+        </p:nvSpPr>
+        <p:spPr>
+          <a:xfrm xmlns:a="http://schemas.openxmlformats.org/drawingml/2006/main">
+            <a:off x="866775" y="4714875"/>
+            <a:ext cx="1952625" cy="323850"/>
+          </a:xfrm>
+          <a:prstGeom xmlns:a="http://schemas.openxmlformats.org/drawingml/2006/main" prst="rect">
+            <a:avLst/>
+          </a:prstGeom>
+          <a:noFill xmlns:a="http://schemas.openxmlformats.org/drawingml/2006/main"/>
+          <a:ln xmlns:a="http://schemas.openxmlformats.org/drawingml/2006/main" w="0">
+            <a:noFill/>
+            <a:prstDash val="solid"/>
+          </a:ln>
+        </p:spPr>
+        <p:txBody>
+          <a:bodyPr xmlns:a="http://schemas.openxmlformats.org/drawingml/2006/main" lIns="0" tIns="0" rIns="0" bIns="0" anchor="t"/>
+          <a:lstStyle xmlns:a="http://schemas.openxmlformats.org/drawingml/2006/main"/>
+          <a:p xmlns:a="http://schemas.openxmlformats.org/drawingml/2006/main">
+            <a:pPr algn="l">
+              <a:lnSpc>
+                <a:spcPct val="100000"/>
+              </a:lnSpc>
+              <a:buNone/>
+              <a:defRPr sz="1050" b="1">
+                <a:solidFill>
+                  <a:srgbClr val="41516B"/>
+                </a:solidFill>
+              </a:defRPr>
+            </a:pPr>
+            <a:r>
+              <a:rPr sz="1050" b="1">
+                <a:solidFill>
+                  <a:srgbClr val="41516B"/>
+                </a:solidFill>
+              </a:rPr>
+              <a:t>Understands my stage</a:t>
+            </a:r>
+          </a:p>
+        </p:txBody>
+      </p:sp>
+      <p:sp>
+        <p:nvSpPr>
+          <p:cNvPr id="64" name="">
+            <a:extLst xmlns:a="http://schemas.openxmlformats.org/drawingml/2006/main">
+              <a:ext uri="{FF2B5EF4-FFF2-40B4-BE49-F238E27FC236}">
+                <a16:creationId xmlns:a16="http://schemas.microsoft.com/office/drawing/2014/main" id="{35E31964-6BC9-44BB-AA45-DBB3508FBAE9}"/>
+              </a:ext>
+            </a:extLst>
+          </p:cNvPr>
+          <p:cNvSpPr>
+            <a:spLocks xmlns:a="http://schemas.openxmlformats.org/drawingml/2006/main" noGrp="1"/>
+          </p:cNvSpPr>
+          <p:nvPr/>
+        </p:nvSpPr>
+        <p:spPr>
+          <a:xfrm xmlns:a="http://schemas.openxmlformats.org/drawingml/2006/main">
+            <a:off x="2943225" y="4772025"/>
+            <a:ext cx="1762125" cy="171450"/>
+          </a:xfrm>
+          <a:prstGeom xmlns:a="http://schemas.openxmlformats.org/drawingml/2006/main" prst="roundRect">
+            <a:avLst>
+              <a:gd name="adj" fmla="val 50000"/>
+            </a:avLst>
+          </a:prstGeom>
+          <a:solidFill xmlns:a="http://schemas.openxmlformats.org/drawingml/2006/main">
+            <a:srgbClr val="EFE7DD"/>
+          </a:solidFill>
+          <a:ln xmlns:a="http://schemas.openxmlformats.org/drawingml/2006/main" w="0">
+            <a:noFill/>
+            <a:prstDash val="solid"/>
+          </a:ln>
+        </p:spPr>
+      </p:sp>
+      <p:sp>
+        <p:nvSpPr>
+          <p:cNvPr id="65" name="">
+            <a:extLst xmlns:a="http://schemas.openxmlformats.org/drawingml/2006/main">
+              <a:ext uri="{FF2B5EF4-FFF2-40B4-BE49-F238E27FC236}">
+                <a16:creationId xmlns:a16="http://schemas.microsoft.com/office/drawing/2014/main" id="{89664DD3-2A92-4931-8FE5-A3DE9D8E6C30}"/>
+              </a:ext>
+            </a:extLst>
+          </p:cNvPr>
+          <p:cNvSpPr>
+            <a:spLocks xmlns:a="http://schemas.openxmlformats.org/drawingml/2006/main" noGrp="1"/>
+          </p:cNvSpPr>
+          <p:nvPr/>
+        </p:nvSpPr>
+        <p:spPr>
+          <a:xfrm xmlns:a="http://schemas.openxmlformats.org/drawingml/2006/main">
+            <a:off x="2943225" y="4772025"/>
+            <a:ext cx="1057275" cy="171450"/>
+          </a:xfrm>
+          <a:prstGeom xmlns:a="http://schemas.openxmlformats.org/drawingml/2006/main" prst="roundRect">
+            <a:avLst>
+              <a:gd name="adj" fmla="val 50000"/>
+            </a:avLst>
+          </a:prstGeom>
+          <a:solidFill xmlns:a="http://schemas.openxmlformats.org/drawingml/2006/main">
+            <a:srgbClr val="7C3AED"/>
+          </a:solidFill>
+          <a:ln xmlns:a="http://schemas.openxmlformats.org/drawingml/2006/main" w="0">
+            <a:noFill/>
+            <a:prstDash val="solid"/>
+          </a:ln>
+        </p:spPr>
+      </p:sp>
+      <p:sp>
+        <p:nvSpPr>
+          <p:cNvPr id="66" name="">
+            <a:extLst xmlns:a="http://schemas.openxmlformats.org/drawingml/2006/main">
+              <a:ext uri="{FF2B5EF4-FFF2-40B4-BE49-F238E27FC236}">
+                <a16:creationId xmlns:a16="http://schemas.microsoft.com/office/drawing/2014/main" id="{DF15904A-1A83-4404-B25A-3D81A19CC550}"/>
+              </a:ext>
+            </a:extLst>
+          </p:cNvPr>
+          <p:cNvSpPr>
+            <a:spLocks xmlns:a="http://schemas.openxmlformats.org/drawingml/2006/main" noGrp="1"/>
+          </p:cNvSpPr>
+          <p:nvPr/>
+        </p:nvSpPr>
+        <p:spPr>
+          <a:xfrm xmlns:a="http://schemas.openxmlformats.org/drawingml/2006/main">
+            <a:off x="4800600" y="4762500"/>
+            <a:ext cx="533400" cy="190500"/>
+          </a:xfrm>
+          <a:prstGeom xmlns:a="http://schemas.openxmlformats.org/drawingml/2006/main" prst="rect">
+            <a:avLst/>
+          </a:prstGeom>
+          <a:noFill xmlns:a="http://schemas.openxmlformats.org/drawingml/2006/main"/>
+          <a:ln xmlns:a="http://schemas.openxmlformats.org/drawingml/2006/main" w="0">
+            <a:noFill/>
+            <a:prstDash val="solid"/>
+          </a:ln>
+        </p:spPr>
+        <p:txBody>
+          <a:bodyPr xmlns:a="http://schemas.openxmlformats.org/drawingml/2006/main" lIns="0" tIns="0" rIns="0" bIns="0" anchor="t"/>
+          <a:lstStyle xmlns:a="http://schemas.openxmlformats.org/drawingml/2006/main"/>
+          <a:p xmlns:a="http://schemas.openxmlformats.org/drawingml/2006/main">
+            <a:pPr algn="l">
+              <a:lnSpc>
+                <a:spcPct val="105000"/>
+              </a:lnSpc>
+              <a:buNone/>
+              <a:defRPr sz="1013" b="1">
+                <a:solidFill>
+                  <a:srgbClr val="7C3AED"/>
+                </a:solidFill>
+              </a:defRPr>
+            </a:pPr>
+            <a:r>
+              <a:rPr sz="1013" b="1">
+                <a:solidFill>
+                  <a:srgbClr val="7C3AED"/>
+                </a:solidFill>
+              </a:rPr>
+              <a:t>36.0%</a:t>
+            </a:r>
+          </a:p>
+        </p:txBody>
+      </p:sp>
+      <p:sp>
+        <p:nvSpPr>
+          <p:cNvPr id="67" name="">
+            <a:extLst xmlns:a="http://schemas.openxmlformats.org/drawingml/2006/main">
+              <a:ext uri="{FF2B5EF4-FFF2-40B4-BE49-F238E27FC236}">
+                <a16:creationId xmlns:a16="http://schemas.microsoft.com/office/drawing/2014/main" id="{20139A85-95C7-42A0-A3B4-7209DA15C7DB}"/>
+              </a:ext>
+            </a:extLst>
+          </p:cNvPr>
+          <p:cNvSpPr>
+            <a:spLocks xmlns:a="http://schemas.openxmlformats.org/drawingml/2006/main" noGrp="1"/>
+          </p:cNvSpPr>
+          <p:nvPr/>
+        </p:nvSpPr>
+        <p:spPr>
+          <a:xfrm xmlns:a="http://schemas.openxmlformats.org/drawingml/2006/main">
+            <a:off x="2943225" y="5010150"/>
+            <a:ext cx="1762125" cy="171450"/>
+          </a:xfrm>
+          <a:prstGeom xmlns:a="http://schemas.openxmlformats.org/drawingml/2006/main" prst="roundRect">
+            <a:avLst>
+              <a:gd name="adj" fmla="val 50000"/>
+            </a:avLst>
+          </a:prstGeom>
+          <a:solidFill xmlns:a="http://schemas.openxmlformats.org/drawingml/2006/main">
+            <a:srgbClr val="EFE7DD"/>
+          </a:solidFill>
+          <a:ln xmlns:a="http://schemas.openxmlformats.org/drawingml/2006/main" w="0">
+            <a:noFill/>
+            <a:prstDash val="solid"/>
+          </a:ln>
+        </p:spPr>
+      </p:sp>
+      <p:sp>
+        <p:nvSpPr>
+          <p:cNvPr id="68" name="">
+            <a:extLst xmlns:a="http://schemas.openxmlformats.org/drawingml/2006/main">
+              <a:ext uri="{FF2B5EF4-FFF2-40B4-BE49-F238E27FC236}">
+                <a16:creationId xmlns:a16="http://schemas.microsoft.com/office/drawing/2014/main" id="{AD338A54-B72D-4D3F-A369-E902D0B910BE}"/>
+              </a:ext>
+            </a:extLst>
+          </p:cNvPr>
+          <p:cNvSpPr>
+            <a:spLocks xmlns:a="http://schemas.openxmlformats.org/drawingml/2006/main" noGrp="1"/>
+          </p:cNvSpPr>
+          <p:nvPr/>
+        </p:nvSpPr>
+        <p:spPr>
+          <a:xfrm xmlns:a="http://schemas.openxmlformats.org/drawingml/2006/main">
+            <a:off x="2943225" y="5010150"/>
+            <a:ext cx="1603534" cy="171450"/>
+          </a:xfrm>
+          <a:prstGeom xmlns:a="http://schemas.openxmlformats.org/drawingml/2006/main" prst="roundRect">
+            <a:avLst>
+              <a:gd name="adj" fmla="val 50000"/>
+            </a:avLst>
+          </a:prstGeom>
+          <a:solidFill xmlns:a="http://schemas.openxmlformats.org/drawingml/2006/main">
+            <a:srgbClr val="071425"/>
+          </a:solidFill>
+          <a:ln xmlns:a="http://schemas.openxmlformats.org/drawingml/2006/main" w="0">
+            <a:noFill/>
+            <a:prstDash val="solid"/>
+          </a:ln>
+        </p:spPr>
+      </p:sp>
+      <p:sp>
+        <p:nvSpPr>
+          <p:cNvPr id="69" name="">
+            <a:extLst xmlns:a="http://schemas.openxmlformats.org/drawingml/2006/main">
+              <a:ext uri="{FF2B5EF4-FFF2-40B4-BE49-F238E27FC236}">
+                <a16:creationId xmlns:a16="http://schemas.microsoft.com/office/drawing/2014/main" id="{D0B3A568-2493-44CA-9091-07834D8DFB44}"/>
+              </a:ext>
+            </a:extLst>
+          </p:cNvPr>
+          <p:cNvSpPr>
+            <a:spLocks xmlns:a="http://schemas.openxmlformats.org/drawingml/2006/main" noGrp="1"/>
+          </p:cNvSpPr>
+          <p:nvPr/>
+        </p:nvSpPr>
+        <p:spPr>
+          <a:xfrm xmlns:a="http://schemas.openxmlformats.org/drawingml/2006/main">
+            <a:off x="4800600" y="5000625"/>
+            <a:ext cx="533400" cy="190500"/>
+          </a:xfrm>
+          <a:prstGeom xmlns:a="http://schemas.openxmlformats.org/drawingml/2006/main" prst="rect">
+            <a:avLst/>
+          </a:prstGeom>
+          <a:noFill xmlns:a="http://schemas.openxmlformats.org/drawingml/2006/main"/>
+          <a:ln xmlns:a="http://schemas.openxmlformats.org/drawingml/2006/main" w="0">
+            <a:noFill/>
+            <a:prstDash val="solid"/>
+          </a:ln>
+        </p:spPr>
+        <p:txBody>
+          <a:bodyPr xmlns:a="http://schemas.openxmlformats.org/drawingml/2006/main" lIns="0" tIns="0" rIns="0" bIns="0" anchor="t"/>
+          <a:lstStyle xmlns:a="http://schemas.openxmlformats.org/drawingml/2006/main"/>
+          <a:p xmlns:a="http://schemas.openxmlformats.org/drawingml/2006/main">
+            <a:pPr algn="l">
+              <a:lnSpc>
+                <a:spcPct val="105000"/>
+              </a:lnSpc>
+              <a:buNone/>
+              <a:defRPr sz="1013" b="1">
+                <a:solidFill>
+                  <a:srgbClr val="071425"/>
+                </a:solidFill>
+              </a:defRPr>
+            </a:pPr>
+            <a:r>
+              <a:rPr sz="1013" b="1">
+                <a:solidFill>
+                  <a:srgbClr val="071425"/>
+                </a:solidFill>
+              </a:rPr>
+              <a:t>54.6%</a:t>
+            </a:r>
+          </a:p>
+        </p:txBody>
+      </p:sp>
+      <p:sp>
+        <p:nvSpPr>
+          <p:cNvPr id="70" name="">
+            <a:extLst xmlns:a="http://schemas.openxmlformats.org/drawingml/2006/main">
+              <a:ext uri="{FF2B5EF4-FFF2-40B4-BE49-F238E27FC236}">
+                <a16:creationId xmlns:a16="http://schemas.microsoft.com/office/drawing/2014/main" id="{2F57EEDD-978C-40F7-BD3D-1F15E3AA15C7}"/>
+              </a:ext>
+            </a:extLst>
+          </p:cNvPr>
+          <p:cNvSpPr>
+            <a:spLocks xmlns:a="http://schemas.openxmlformats.org/drawingml/2006/main" noGrp="1"/>
+          </p:cNvSpPr>
+          <p:nvPr/>
+        </p:nvSpPr>
+        <p:spPr>
+          <a:xfrm xmlns:a="http://schemas.openxmlformats.org/drawingml/2006/main">
+            <a:off x="6191250" y="2171700"/>
+            <a:ext cx="4953000" cy="1162050"/>
+          </a:xfrm>
+          <a:prstGeom xmlns:a="http://schemas.openxmlformats.org/drawingml/2006/main" prst="roundRect">
+            <a:avLst>
+              <a:gd name="adj" fmla="val 6557"/>
+            </a:avLst>
+          </a:prstGeom>
+          <a:solidFill xmlns:a="http://schemas.openxmlformats.org/drawingml/2006/main">
+            <a:srgbClr val="FFFDF9"/>
+          </a:solidFill>
+          <a:ln xmlns:a="http://schemas.openxmlformats.org/drawingml/2006/main" w="9525">
+            <a:solidFill>
+              <a:srgbClr val="E5DCD1"/>
+            </a:solidFill>
+            <a:prstDash val="solid"/>
+          </a:ln>
+        </p:spPr>
+      </p:sp>
+      <p:sp>
+        <p:nvSpPr>
+          <p:cNvPr id="71" name="">
+            <a:extLst xmlns:a="http://schemas.openxmlformats.org/drawingml/2006/main">
+              <a:ext uri="{FF2B5EF4-FFF2-40B4-BE49-F238E27FC236}">
+                <a16:creationId xmlns:a16="http://schemas.microsoft.com/office/drawing/2014/main" id="{4E49FB49-D70D-44CA-8A1E-816C9C85846E}"/>
+              </a:ext>
+            </a:extLst>
+          </p:cNvPr>
+          <p:cNvSpPr>
+            <a:spLocks xmlns:a="http://schemas.openxmlformats.org/drawingml/2006/main" noGrp="1"/>
+          </p:cNvSpPr>
+          <p:nvPr/>
+        </p:nvSpPr>
+        <p:spPr>
+          <a:xfrm xmlns:a="http://schemas.openxmlformats.org/drawingml/2006/main">
+            <a:off x="6477000" y="2400300"/>
+            <a:ext cx="4000500" cy="228600"/>
+          </a:xfrm>
+          <a:prstGeom xmlns:a="http://schemas.openxmlformats.org/drawingml/2006/main" prst="rect">
+            <a:avLst/>
+          </a:prstGeom>
+          <a:noFill xmlns:a="http://schemas.openxmlformats.org/drawingml/2006/main"/>
+          <a:ln xmlns:a="http://schemas.openxmlformats.org/drawingml/2006/main" w="0">
+            <a:noFill/>
+            <a:prstDash val="solid"/>
+          </a:ln>
+        </p:spPr>
+        <p:txBody>
+          <a:bodyPr xmlns:a="http://schemas.openxmlformats.org/drawingml/2006/main" lIns="0" tIns="0" rIns="0" bIns="0" anchor="t"/>
+          <a:lstStyle xmlns:a="http://schemas.openxmlformats.org/drawingml/2006/main"/>
+          <a:p xmlns:a="http://schemas.openxmlformats.org/drawingml/2006/main">
+            <a:pPr algn="l">
+              <a:lnSpc>
+                <a:spcPct val="105000"/>
+              </a:lnSpc>
+              <a:buNone/>
+              <a:defRPr sz="1425" b="1">
+                <a:solidFill>
+                  <a:srgbClr val="071425"/>
+                </a:solidFill>
+              </a:defRPr>
+            </a:pPr>
+            <a:r>
+              <a:rPr sz="1425" b="1">
+                <a:solidFill>
+                  <a:srgbClr val="071425"/>
+                </a:solidFill>
+              </a:rPr>
+              <a:t>Same category tension, different emphasis</a:t>
+            </a:r>
+          </a:p>
+        </p:txBody>
+      </p:sp>
+      <p:sp>
+        <p:nvSpPr>
+          <p:cNvPr id="72" name="">
+            <a:extLst xmlns:a="http://schemas.openxmlformats.org/drawingml/2006/main">
+              <a:ext uri="{FF2B5EF4-FFF2-40B4-BE49-F238E27FC236}">
+                <a16:creationId xmlns:a16="http://schemas.microsoft.com/office/drawing/2014/main" id="{6F4E1E4B-24EF-461F-A32A-0AB86ED939E0}"/>
+              </a:ext>
+            </a:extLst>
+          </p:cNvPr>
+          <p:cNvSpPr>
+            <a:spLocks xmlns:a="http://schemas.openxmlformats.org/drawingml/2006/main" noGrp="1"/>
+          </p:cNvSpPr>
+          <p:nvPr/>
+        </p:nvSpPr>
+        <p:spPr>
+          <a:xfrm xmlns:a="http://schemas.openxmlformats.org/drawingml/2006/main">
+            <a:off x="6477000" y="2714625"/>
+            <a:ext cx="4333875" cy="457200"/>
+          </a:xfrm>
+          <a:prstGeom xmlns:a="http://schemas.openxmlformats.org/drawingml/2006/main" prst="rect">
+            <a:avLst/>
+          </a:prstGeom>
+          <a:noFill xmlns:a="http://schemas.openxmlformats.org/drawingml/2006/main"/>
+          <a:ln xmlns:a="http://schemas.openxmlformats.org/drawingml/2006/main" w="0">
+            <a:noFill/>
+            <a:prstDash val="solid"/>
+          </a:ln>
+        </p:spPr>
+        <p:txBody>
+          <a:bodyPr xmlns:a="http://schemas.openxmlformats.org/drawingml/2006/main" lIns="0" tIns="0" rIns="0" bIns="0" anchor="t"/>
+          <a:lstStyle xmlns:a="http://schemas.openxmlformats.org/drawingml/2006/main"/>
+          <a:p xmlns:a="http://schemas.openxmlformats.org/drawingml/2006/main">
+            <a:pPr algn="l">
+              <a:lnSpc>
+                <a:spcPct val="108000"/>
+              </a:lnSpc>
+              <a:buNone/>
+              <a:defRPr sz="1065" b="0">
+                <a:solidFill>
+                  <a:srgbClr val="41516B"/>
+                </a:solidFill>
+              </a:defRPr>
+            </a:pPr>
+            <a:r>
+              <a:rPr sz="1065" b="0">
+                <a:solidFill>
+                  <a:srgbClr val="41516B"/>
+                </a:solidFill>
+              </a:rPr>
+              <a:t>“Looking slimmer” is the top category critique for both groups: 34.5% under 40 and 33.3% 40+. Under 40 over-indexes on brands changing bodies (25.2%, +10pp), while 40+ over-indexes on younger/life-stage pain (21.5% / 21.1%).</a:t>
+            </a:r>
+          </a:p>
+        </p:txBody>
+      </p:sp>
+      <p:sp>
+        <p:nvSpPr>
+          <p:cNvPr id="73" name="">
+            <a:extLst xmlns:a="http://schemas.openxmlformats.org/drawingml/2006/main">
+              <a:ext uri="{FF2B5EF4-FFF2-40B4-BE49-F238E27FC236}">
+                <a16:creationId xmlns:a16="http://schemas.microsoft.com/office/drawing/2014/main" id="{35A4B350-377B-439F-9880-455A80C8E28A}"/>
+              </a:ext>
+            </a:extLst>
+          </p:cNvPr>
+          <p:cNvSpPr>
+            <a:spLocks xmlns:a="http://schemas.openxmlformats.org/drawingml/2006/main" noGrp="1"/>
+          </p:cNvSpPr>
+          <p:nvPr/>
+        </p:nvSpPr>
+        <p:spPr>
+          <a:xfrm xmlns:a="http://schemas.openxmlformats.org/drawingml/2006/main">
+            <a:off x="6191250" y="3505200"/>
+            <a:ext cx="4953000" cy="1162050"/>
+          </a:xfrm>
+          <a:prstGeom xmlns:a="http://schemas.openxmlformats.org/drawingml/2006/main" prst="roundRect">
+            <a:avLst>
+              <a:gd name="adj" fmla="val 6557"/>
+            </a:avLst>
+          </a:prstGeom>
+          <a:solidFill xmlns:a="http://schemas.openxmlformats.org/drawingml/2006/main">
+            <a:srgbClr val="FFFDF9"/>
+          </a:solidFill>
+          <a:ln xmlns:a="http://schemas.openxmlformats.org/drawingml/2006/main" w="9525">
+            <a:solidFill>
+              <a:srgbClr val="E5DCD1"/>
+            </a:solidFill>
+            <a:prstDash val="solid"/>
+          </a:ln>
+        </p:spPr>
+      </p:sp>
+      <p:sp>
+        <p:nvSpPr>
+          <p:cNvPr id="74" name="">
+            <a:extLst xmlns:a="http://schemas.openxmlformats.org/drawingml/2006/main">
+              <a:ext uri="{FF2B5EF4-FFF2-40B4-BE49-F238E27FC236}">
+                <a16:creationId xmlns:a16="http://schemas.microsoft.com/office/drawing/2014/main" id="{6E39CB78-984A-4F0C-9E5B-241101B035F1}"/>
+              </a:ext>
+            </a:extLst>
+          </p:cNvPr>
+          <p:cNvSpPr>
+            <a:spLocks xmlns:a="http://schemas.openxmlformats.org/drawingml/2006/main" noGrp="1"/>
+          </p:cNvSpPr>
+          <p:nvPr/>
+        </p:nvSpPr>
+        <p:spPr>
+          <a:xfrm xmlns:a="http://schemas.openxmlformats.org/drawingml/2006/main">
+            <a:off x="6477000" y="3733800"/>
+            <a:ext cx="4000500" cy="228600"/>
+          </a:xfrm>
+          <a:prstGeom xmlns:a="http://schemas.openxmlformats.org/drawingml/2006/main" prst="rect">
+            <a:avLst/>
+          </a:prstGeom>
+          <a:noFill xmlns:a="http://schemas.openxmlformats.org/drawingml/2006/main"/>
+          <a:ln xmlns:a="http://schemas.openxmlformats.org/drawingml/2006/main" w="0">
+            <a:noFill/>
+            <a:prstDash val="solid"/>
+          </a:ln>
+        </p:spPr>
+        <p:txBody>
+          <a:bodyPr xmlns:a="http://schemas.openxmlformats.org/drawingml/2006/main" lIns="0" tIns="0" rIns="0" bIns="0" anchor="t"/>
+          <a:lstStyle xmlns:a="http://schemas.openxmlformats.org/drawingml/2006/main"/>
+          <a:p xmlns:a="http://schemas.openxmlformats.org/drawingml/2006/main">
+            <a:pPr algn="l">
+              <a:lnSpc>
+                <a:spcPct val="105000"/>
+              </a:lnSpc>
+              <a:buNone/>
+              <a:defRPr sz="1425" b="1">
+                <a:solidFill>
+                  <a:srgbClr val="071425"/>
+                </a:solidFill>
+              </a:defRPr>
+            </a:pPr>
+            <a:r>
+              <a:rPr sz="1425" b="1">
+                <a:solidFill>
+                  <a:srgbClr val="071425"/>
+                </a:solidFill>
+              </a:rPr>
+              <a:t>The white space is bigger with 40+</a:t>
+            </a:r>
+          </a:p>
+        </p:txBody>
+      </p:sp>
+      <p:sp>
+        <p:nvSpPr>
+          <p:cNvPr id="75" name="">
+            <a:extLst xmlns:a="http://schemas.openxmlformats.org/drawingml/2006/main">
+              <a:ext uri="{FF2B5EF4-FFF2-40B4-BE49-F238E27FC236}">
+                <a16:creationId xmlns:a16="http://schemas.microsoft.com/office/drawing/2014/main" id="{DB314B07-A4C4-4A58-B89D-E6E72BF7BDEF}"/>
+              </a:ext>
+            </a:extLst>
+          </p:cNvPr>
+          <p:cNvSpPr>
+            <a:spLocks xmlns:a="http://schemas.openxmlformats.org/drawingml/2006/main" noGrp="1"/>
+          </p:cNvSpPr>
+          <p:nvPr/>
+        </p:nvSpPr>
+        <p:spPr>
+          <a:xfrm xmlns:a="http://schemas.openxmlformats.org/drawingml/2006/main">
+            <a:off x="6477000" y="4048125"/>
+            <a:ext cx="4333875" cy="457200"/>
+          </a:xfrm>
+          <a:prstGeom xmlns:a="http://schemas.openxmlformats.org/drawingml/2006/main" prst="rect">
+            <a:avLst/>
+          </a:prstGeom>
+          <a:noFill xmlns:a="http://schemas.openxmlformats.org/drawingml/2006/main"/>
+          <a:ln xmlns:a="http://schemas.openxmlformats.org/drawingml/2006/main" w="0">
+            <a:noFill/>
+            <a:prstDash val="solid"/>
+          </a:ln>
+        </p:spPr>
+        <p:txBody>
+          <a:bodyPr xmlns:a="http://schemas.openxmlformats.org/drawingml/2006/main" lIns="0" tIns="0" rIns="0" bIns="0" anchor="t"/>
+          <a:lstStyle xmlns:a="http://schemas.openxmlformats.org/drawingml/2006/main"/>
+          <a:p xmlns:a="http://schemas.openxmlformats.org/drawingml/2006/main">
+            <a:pPr algn="l">
+              <a:lnSpc>
+                <a:spcPct val="108000"/>
+              </a:lnSpc>
+              <a:buNone/>
+              <a:defRPr sz="1065" b="0">
+                <a:solidFill>
+                  <a:srgbClr val="41516B"/>
+                </a:solidFill>
+              </a:defRPr>
+            </a:pPr>
+            <a:r>
+              <a:rPr sz="1065" b="0">
+                <a:solidFill>
+                  <a:srgbClr val="41516B"/>
+                </a:solidFill>
+              </a:rPr>
+              <a:t>Under 40 gives Skims the most credit for moving beyond old rules (29.1%). Among 40+, “no brand” leads at 39.4%. Shapermint is low in both groups: 7.5% under 40 and 6.8% 40+.</a:t>
+            </a:r>
+          </a:p>
+        </p:txBody>
+      </p:sp>
+      <p:sp>
+        <p:nvSpPr>
+          <p:cNvPr id="76" name="">
+            <a:extLst xmlns:a="http://schemas.openxmlformats.org/drawingml/2006/main">
+              <a:ext uri="{FF2B5EF4-FFF2-40B4-BE49-F238E27FC236}">
+                <a16:creationId xmlns:a16="http://schemas.microsoft.com/office/drawing/2014/main" id="{5EA5AC2C-9E8A-4561-97FD-C19FE8DF8D42}"/>
+              </a:ext>
+            </a:extLst>
+          </p:cNvPr>
+          <p:cNvSpPr>
+            <a:spLocks xmlns:a="http://schemas.openxmlformats.org/drawingml/2006/main" noGrp="1"/>
+          </p:cNvSpPr>
+          <p:nvPr/>
+        </p:nvSpPr>
+        <p:spPr>
+          <a:xfrm xmlns:a="http://schemas.openxmlformats.org/drawingml/2006/main">
+            <a:off x="6191250" y="4848225"/>
+            <a:ext cx="4953000" cy="990600"/>
+          </a:xfrm>
+          <a:prstGeom xmlns:a="http://schemas.openxmlformats.org/drawingml/2006/main" prst="roundRect">
+            <a:avLst>
+              <a:gd name="adj" fmla="val 9615"/>
+            </a:avLst>
+          </a:prstGeom>
+          <a:solidFill xmlns:a="http://schemas.openxmlformats.org/drawingml/2006/main">
+            <a:srgbClr val="071425"/>
+          </a:solidFill>
+          <a:ln xmlns:a="http://schemas.openxmlformats.org/drawingml/2006/main" w="0">
+            <a:noFill/>
+            <a:prstDash val="solid"/>
+          </a:ln>
+        </p:spPr>
+      </p:sp>
+      <p:sp>
+        <p:nvSpPr>
+          <p:cNvPr id="77" name="">
+            <a:extLst xmlns:a="http://schemas.openxmlformats.org/drawingml/2006/main">
+              <a:ext uri="{FF2B5EF4-FFF2-40B4-BE49-F238E27FC236}">
+                <a16:creationId xmlns:a16="http://schemas.microsoft.com/office/drawing/2014/main" id="{856523F3-0BE0-4542-946A-BF6026161ADA}"/>
+              </a:ext>
+            </a:extLst>
+          </p:cNvPr>
+          <p:cNvSpPr>
+            <a:spLocks xmlns:a="http://schemas.openxmlformats.org/drawingml/2006/main" noGrp="1"/>
+          </p:cNvSpPr>
+          <p:nvPr/>
+        </p:nvSpPr>
+        <p:spPr>
+          <a:xfrm xmlns:a="http://schemas.openxmlformats.org/drawingml/2006/main">
+            <a:off x="6477000" y="5076825"/>
+            <a:ext cx="1428750" cy="228600"/>
+          </a:xfrm>
+          <a:prstGeom xmlns:a="http://schemas.openxmlformats.org/drawingml/2006/main" prst="rect">
+            <a:avLst/>
+          </a:prstGeom>
+          <a:noFill xmlns:a="http://schemas.openxmlformats.org/drawingml/2006/main"/>
+          <a:ln xmlns:a="http://schemas.openxmlformats.org/drawingml/2006/main" w="0">
+            <a:noFill/>
+            <a:prstDash val="solid"/>
+          </a:ln>
+        </p:spPr>
+        <p:txBody>
+          <a:bodyPr xmlns:a="http://schemas.openxmlformats.org/drawingml/2006/main" lIns="0" tIns="0" rIns="0" bIns="0" anchor="t"/>
+          <a:lstStyle xmlns:a="http://schemas.openxmlformats.org/drawingml/2006/main"/>
+          <a:p xmlns:a="http://schemas.openxmlformats.org/drawingml/2006/main">
+            <a:pPr algn="l">
+              <a:lnSpc>
+                <a:spcPct val="105000"/>
+              </a:lnSpc>
+              <a:buNone/>
+              <a:defRPr sz="1350" b="1">
+                <a:solidFill>
+                  <a:srgbClr val="FFFFFF"/>
+                </a:solidFill>
+              </a:defRPr>
+            </a:pPr>
+            <a:r>
+              <a:rPr sz="1350" b="1">
+                <a:solidFill>
+                  <a:srgbClr val="FFFFFF"/>
+                </a:solidFill>
+              </a:rPr>
+              <a:t>Campaign read</a:t>
+            </a:r>
+          </a:p>
+        </p:txBody>
+      </p:sp>
+      <p:sp>
+        <p:nvSpPr>
+          <p:cNvPr id="78" name="">
+            <a:extLst xmlns:a="http://schemas.openxmlformats.org/drawingml/2006/main">
+              <a:ext uri="{FF2B5EF4-FFF2-40B4-BE49-F238E27FC236}">
+                <a16:creationId xmlns:a16="http://schemas.microsoft.com/office/drawing/2014/main" id="{15A8A12F-57E7-4B2B-B362-04903CECB0FF}"/>
+              </a:ext>
+            </a:extLst>
+          </p:cNvPr>
+          <p:cNvSpPr>
+            <a:spLocks xmlns:a="http://schemas.openxmlformats.org/drawingml/2006/main" noGrp="1"/>
+          </p:cNvSpPr>
+          <p:nvPr/>
+        </p:nvSpPr>
+        <p:spPr>
+          <a:xfrm xmlns:a="http://schemas.openxmlformats.org/drawingml/2006/main">
+            <a:off x="8096250" y="5038725"/>
+            <a:ext cx="2714625" cy="514350"/>
+          </a:xfrm>
+          <a:prstGeom xmlns:a="http://schemas.openxmlformats.org/drawingml/2006/main" prst="rect">
+            <a:avLst/>
+          </a:prstGeom>
+          <a:noFill xmlns:a="http://schemas.openxmlformats.org/drawingml/2006/main"/>
+          <a:ln xmlns:a="http://schemas.openxmlformats.org/drawingml/2006/main" w="0">
+            <a:noFill/>
+            <a:prstDash val="solid"/>
+          </a:ln>
+        </p:spPr>
+        <p:txBody>
+          <a:bodyPr xmlns:a="http://schemas.openxmlformats.org/drawingml/2006/main" lIns="0" tIns="0" rIns="0" bIns="0" anchor="t"/>
+          <a:lstStyle xmlns:a="http://schemas.openxmlformats.org/drawingml/2006/main"/>
+          <a:p xmlns:a="http://schemas.openxmlformats.org/drawingml/2006/main">
+            <a:pPr algn="l">
+              <a:lnSpc>
+                <a:spcPct val="112000"/>
+              </a:lnSpc>
+              <a:buNone/>
+              <a:defRPr sz="1073" b="0">
+                <a:solidFill>
+                  <a:srgbClr val="E8EDF5"/>
+                </a:solidFill>
+              </a:defRPr>
+            </a:pPr>
+            <a:r>
+              <a:rPr sz="1073" b="0">
+                <a:solidFill>
+                  <a:srgbClr val="E8EDF5"/>
+                </a:solidFill>
+              </a:rPr>
+              <a:t>Make “adapts to my body” the shared memory cue, then flex the proof: comfort-as-power for under 40; life-stage fit and no-compromise reassurance for 40+.</a:t>
+            </a:r>
+          </a:p>
+        </p:txBody>
+      </p:sp>
+      <p:sp>
+        <p:nvSpPr>
+          <p:cNvPr id="79" name="">
+            <a:extLst xmlns:a="http://schemas.openxmlformats.org/drawingml/2006/main">
+              <a:ext uri="{FF2B5EF4-FFF2-40B4-BE49-F238E27FC236}">
+                <a16:creationId xmlns:a16="http://schemas.microsoft.com/office/drawing/2014/main" id="{57A7BD17-FD43-4B92-BB83-B3C75B5BD25C}"/>
+              </a:ext>
+            </a:extLst>
+          </p:cNvPr>
+          <p:cNvSpPr>
+            <a:spLocks xmlns:a="http://schemas.openxmlformats.org/drawingml/2006/main" noGrp="1"/>
+          </p:cNvSpPr>
+          <p:nvPr/>
+        </p:nvSpPr>
+        <p:spPr>
+          <a:xfrm xmlns:a="http://schemas.openxmlformats.org/drawingml/2006/main">
+            <a:off x="609600" y="6496050"/>
+            <a:ext cx="7239000" cy="190500"/>
+          </a:xfrm>
+          <a:prstGeom xmlns:a="http://schemas.openxmlformats.org/drawingml/2006/main" prst="rect">
+            <a:avLst/>
+          </a:prstGeom>
+          <a:noFill xmlns:a="http://schemas.openxmlformats.org/drawingml/2006/main"/>
+          <a:ln xmlns:a="http://schemas.openxmlformats.org/drawingml/2006/main" w="0">
+            <a:noFill/>
+            <a:prstDash val="solid"/>
+          </a:ln>
+        </p:spPr>
+        <p:txBody>
+          <a:bodyPr xmlns:a="http://schemas.openxmlformats.org/drawingml/2006/main" lIns="0" tIns="0" rIns="0" bIns="0" anchor="t"/>
+          <a:lstStyle xmlns:a="http://schemas.openxmlformats.org/drawingml/2006/main"/>
+          <a:p xmlns:a="http://schemas.openxmlformats.org/drawingml/2006/main">
+            <a:pPr algn="l">
+              <a:lnSpc>
+                <a:spcPct val="105000"/>
+              </a:lnSpc>
+              <a:buNone/>
+              <a:defRPr sz="788" b="0">
+                <a:solidFill>
+                  <a:srgbClr val="667085"/>
+                </a:solidFill>
+              </a:defRPr>
+            </a:pPr>
+            <a:r>
+              <a:rPr sz="788" b="0">
+                <a:solidFill>
+                  <a:srgbClr val="667085"/>
+                </a:solidFill>
+              </a:rPr>
+              <a:t>Source: Q2 2026 Brand Tracker corrected age split exports; under 40 n=333, 40+ n=1,314. Q17-Q19 tables.</a:t>
+            </a:r>
+          </a:p>
+        </p:txBody>
+      </p:sp>
+      <p:sp>
+        <p:nvSpPr>
+          <p:cNvPr id="80" name="">
+            <a:extLst xmlns:a="http://schemas.openxmlformats.org/drawingml/2006/main">
+              <a:ext uri="{FF2B5EF4-FFF2-40B4-BE49-F238E27FC236}">
+                <a16:creationId xmlns:a16="http://schemas.microsoft.com/office/drawing/2014/main" id="{F7654144-2E0D-4435-A3AE-010A569A4FD4}"/>
+              </a:ext>
+            </a:extLst>
+          </p:cNvPr>
+          <p:cNvSpPr>
+            <a:spLocks xmlns:a="http://schemas.openxmlformats.org/drawingml/2006/main" noGrp="1"/>
+          </p:cNvSpPr>
+          <p:nvPr/>
+        </p:nvSpPr>
+        <p:spPr>
+          <a:xfrm xmlns:a="http://schemas.openxmlformats.org/drawingml/2006/main">
+            <a:off x="10001250" y="6496050"/>
+            <a:ext cx="1619250" cy="190500"/>
+          </a:xfrm>
+          <a:prstGeom xmlns:a="http://schemas.openxmlformats.org/drawingml/2006/main" prst="rect">
+            <a:avLst/>
+          </a:prstGeom>
+          <a:noFill xmlns:a="http://schemas.openxmlformats.org/drawingml/2006/main"/>
+          <a:ln xmlns:a="http://schemas.openxmlformats.org/drawingml/2006/main" w="0">
+            <a:noFill/>
+            <a:prstDash val="solid"/>
+          </a:ln>
+        </p:spPr>
+        <p:txBody>
+          <a:bodyPr xmlns:a="http://schemas.openxmlformats.org/drawingml/2006/main" lIns="0" tIns="0" rIns="0" bIns="0" anchor="t"/>
+          <a:lstStyle xmlns:a="http://schemas.openxmlformats.org/drawingml/2006/main"/>
+          <a:p xmlns:a="http://schemas.openxmlformats.org/drawingml/2006/main">
+            <a:pPr algn="r">
+              <a:lnSpc>
+                <a:spcPct val="105000"/>
+              </a:lnSpc>
+              <a:buNone/>
+              <a:defRPr sz="788" b="1">
+                <a:solidFill>
+                  <a:srgbClr val="41516B"/>
+                </a:solidFill>
+              </a:defRPr>
+            </a:pPr>
+            <a:r>
+              <a:rPr sz="788" b="1">
+                <a:solidFill>
+                  <a:srgbClr val="41516B"/>
+                </a:solidFill>
+              </a:rPr>
+              <a:t>US Brand Tracker | Shapermint</a:t>
+            </a:r>
+          </a:p>
+        </p:txBody>
+      </p:sp>
     </p:spTree>
     <p:extLst>
       <p:ext uri="{BB962C8B-B14F-4D97-AF65-F5344CB8AC3E}">
@@ -7921,7 +9848,7 @@
                   <a:srgbClr val="07111F"/>
                 </a:solidFill>
               </a:rPr>
-              <a:t>Make Reshaping the Rules scale through proof, repeatable cues, and value people can defend.</a:t>
+              <a:t>Reshaping the Rules should be built as a memory system, not a one-off message.</a:t>
             </a:r>
           </a:p>
         </p:txBody>
@@ -8093,7 +10020,7 @@
                   <a:srgbClr val="07111F"/>
                 </a:solidFill>
               </a:rPr>
-              <a:t>Ownable contrast</a:t>
+              <a:t>Single promise</a:t>
             </a:r>
           </a:p>
         </p:txBody>
@@ -8115,7 +10042,7 @@
         <p:spPr>
           <a:xfrm xmlns:a="http://schemas.openxmlformats.org/drawingml/2006/main">
             <a:off x="1428750" y="2552700"/>
-            <a:ext cx="3619500" cy="514350"/>
+            <a:ext cx="3619500" cy="438150"/>
           </a:xfrm>
           <a:prstGeom xmlns:a="http://schemas.openxmlformats.org/drawingml/2006/main" prst="rect">
             <a:avLst/>
@@ -8139,12 +10066,12 @@
               </a:defRPr>
             </a:pPr>
             <a:r>
-              <a:rPr sz="1050">
+              <a:rPr sz="1200">
                 <a:solidFill>
                   <a:srgbClr val="42526B"/>
                 </a:solidFill>
               </a:rPr>
-              <a:t>Position against squeeze and spectacle: Shapermint adapts to real bodies, outfits, and life stages.</a:t>
+              <a:t>Shapermint adapts to my body and life stage.</a:t>
             </a:r>
           </a:p>
         </p:txBody>
@@ -8316,7 +10243,7 @@
                   <a:srgbClr val="07111F"/>
                 </a:solidFill>
               </a:rPr>
-              <a:t>Amazon + retail proof</a:t>
+              <a:t>Proof system</a:t>
             </a:r>
           </a:p>
         </p:txBody>
@@ -8338,7 +10265,7 @@
         <p:spPr>
           <a:xfrm xmlns:a="http://schemas.openxmlformats.org/drawingml/2006/main">
             <a:off x="6762750" y="2552700"/>
-            <a:ext cx="3619500" cy="514350"/>
+            <a:ext cx="3619500" cy="438150"/>
           </a:xfrm>
           <a:prstGeom xmlns:a="http://schemas.openxmlformats.org/drawingml/2006/main" prst="rect">
             <a:avLst/>
@@ -8362,12 +10289,12 @@
               </a:defRPr>
             </a:pPr>
             <a:r>
-              <a:rPr sz="1050">
+              <a:rPr sz="1200">
                 <a:solidFill>
                   <a:srgbClr val="42526B"/>
                 </a:solidFill>
               </a:rPr>
-              <a:t>Turn PDPs and displays into proof: fit videos, compression scale, review badges, movement demos.</a:t>
+              <a:t>Medium compression, everyday comfort, fit flexibility, and real-life movement.</a:t>
             </a:r>
           </a:p>
         </p:txBody>
@@ -8539,7 +10466,7 @@
                   <a:srgbClr val="07111F"/>
                 </a:solidFill>
               </a:rPr>
-              <a:t>Distinctive memory cue</a:t>
+              <a:t>Brand cues</a:t>
             </a:r>
           </a:p>
         </p:txBody>
@@ -8561,7 +10488,7 @@
         <p:spPr>
           <a:xfrm xmlns:a="http://schemas.openxmlformats.org/drawingml/2006/main">
             <a:off x="1428750" y="3905250"/>
-            <a:ext cx="3619500" cy="514350"/>
+            <a:ext cx="3619500" cy="438150"/>
           </a:xfrm>
           <a:prstGeom xmlns:a="http://schemas.openxmlformats.org/drawingml/2006/main" prst="rect">
             <a:avLst/>
@@ -8585,12 +10512,12 @@
               </a:defRPr>
             </a:pPr>
             <a:r>
-              <a:rPr sz="1050">
+              <a:rPr sz="1200">
                 <a:solidFill>
                   <a:srgbClr val="42526B"/>
                 </a:solidFill>
               </a:rPr>
-              <a:t>Repeat one phrase, one visual cue, and one product proof across paid social, search, email, PDP, and packaging.</a:t>
+              <a:t>Repeat one phrase, one visual grammar, and one product proof everywhere.</a:t>
             </a:r>
           </a:p>
         </p:txBody>
@@ -8762,7 +10689,7 @@
                   <a:srgbClr val="07111F"/>
                 </a:solidFill>
               </a:rPr>
-              <a:t>Value without discounting</a:t>
+              <a:t>Media reinforcement</a:t>
             </a:r>
           </a:p>
         </p:txBody>
@@ -8784,7 +10711,7 @@
         <p:spPr>
           <a:xfrm xmlns:a="http://schemas.openxmlformats.org/drawingml/2006/main">
             <a:off x="6762750" y="3905250"/>
-            <a:ext cx="3619500" cy="514350"/>
+            <a:ext cx="3619500" cy="438150"/>
           </a:xfrm>
           <a:prstGeom xmlns:a="http://schemas.openxmlformats.org/drawingml/2006/main" prst="rect">
             <a:avLst/>
@@ -8808,12 +10735,12 @@
               </a:defRPr>
             </a:pPr>
             <a:r>
-              <a:rPr sz="1050">
+              <a:rPr sz="1200">
                 <a:solidFill>
                   <a:srgbClr val="42526B"/>
                 </a:solidFill>
               </a:rPr>
-              <a:t>Lead with cost-per-wear, outfit bundles, starter sets, quality proof, and durability before price cuts.</a:t>
+              <a:t>Use Facebook + search for reach, Amazon/retail for proof, TikTok for selective top-funnel testing.</a:t>
             </a:r>
           </a:p>
         </p:txBody>
@@ -8899,7 +10826,7 @@
                   <a:srgbClr val="FFFFFF"/>
                 </a:solidFill>
               </a:rPr>
-              <a:t>Scale scorecard</a:t>
+              <a:t>Measurement plan</a:t>
             </a:r>
           </a:p>
         </p:txBody>
@@ -8921,7 +10848,7 @@
         <p:spPr>
           <a:xfrm xmlns:a="http://schemas.openxmlformats.org/drawingml/2006/main">
             <a:off x="3162300" y="5257800"/>
-            <a:ext cx="7048500" cy="476250"/>
+            <a:ext cx="7048500" cy="438150"/>
           </a:xfrm>
           <a:prstGeom xmlns:a="http://schemas.openxmlformats.org/drawingml/2006/main" prst="rect">
             <a:avLst/>
@@ -8945,12 +10872,12 @@
               </a:defRPr>
             </a:pPr>
             <a:r>
-              <a:rPr sz="1200">
+              <a:rPr sz="1350">
                 <a:solidFill>
                   <a:srgbClr val="FFFFFF"/>
                 </a:solidFill>
               </a:rPr>
-              <a:t>Track unaided + aided lift, branded search, Amazon/retail PDP conversion, Q18 moving-beyond share, Q19 hook recall, first choice, and purchase intent.</a:t>
+              <a:t>Track aided + unaided lift, Q18 'Shapermint is moving beyond' share, Q19 hook recall, purchase intent, and Q17-Q19 by age once raw data is available.</a:t>
             </a:r>
           </a:p>
         </p:txBody>
@@ -9001,7 +10928,7 @@
                   <a:srgbClr val="6B7280"/>
                 </a:solidFill>
               </a:rPr>
-              <a:t>Source: Q2 2026 Brand Tracker Q17-Q19, Q13-Q14, Q22-Q23; tactics synthesized from tracker evidence and campaign recommendations.</a:t>
+              <a:t>Source: Q2 2026 Brand Tracker Q17-Q19, Q13-Q14, Q22-Q23; campaign recommendation synthesized from tracker evidence.</a:t>
             </a:r>
           </a:p>
         </p:txBody>
@@ -9050,6 +10977,1884 @@
               <a:rPr sz="825" b="1">
                 <a:solidFill>
                   <a:srgbClr val="42526B"/>
+                </a:solidFill>
+              </a:rPr>
+              <a:t>US Brand Tracker | Shapermint</a:t>
+            </a:r>
+          </a:p>
+        </p:txBody>
+      </p:sp>
+      <p:sp>
+        <p:nvSpPr>
+          <p:cNvPr id="29" name="revision-background">
+            <a:extLst xmlns:a="http://schemas.openxmlformats.org/drawingml/2006/main">
+              <a:ext uri="{FF2B5EF4-FFF2-40B4-BE49-F238E27FC236}">
+                <a16:creationId xmlns:a16="http://schemas.microsoft.com/office/drawing/2014/main" id="{9448BD96-1579-4B7A-B134-20A37D01DD63}"/>
+              </a:ext>
+            </a:extLst>
+          </p:cNvPr>
+          <p:cNvSpPr>
+            <a:spLocks xmlns:a="http://schemas.openxmlformats.org/drawingml/2006/main" noGrp="1"/>
+          </p:cNvSpPr>
+          <p:nvPr/>
+        </p:nvSpPr>
+        <p:spPr>
+          <a:xfrm xmlns:a="http://schemas.openxmlformats.org/drawingml/2006/main">
+            <a:off x="0" y="0"/>
+            <a:ext cx="12192000" cy="6858000"/>
+          </a:xfrm>
+          <a:prstGeom xmlns:a="http://schemas.openxmlformats.org/drawingml/2006/main" prst="rect">
+            <a:avLst/>
+          </a:prstGeom>
+          <a:solidFill xmlns:a="http://schemas.openxmlformats.org/drawingml/2006/main">
+            <a:srgbClr val="F8F4EE"/>
+          </a:solidFill>
+          <a:ln xmlns:a="http://schemas.openxmlformats.org/drawingml/2006/main" w="0">
+            <a:noFill/>
+            <a:prstDash val="solid"/>
+          </a:ln>
+        </p:spPr>
+      </p:sp>
+      <p:sp>
+        <p:nvSpPr>
+          <p:cNvPr id="30" name="">
+            <a:extLst xmlns:a="http://schemas.openxmlformats.org/drawingml/2006/main">
+              <a:ext uri="{FF2B5EF4-FFF2-40B4-BE49-F238E27FC236}">
+                <a16:creationId xmlns:a16="http://schemas.microsoft.com/office/drawing/2014/main" id="{EAD588EB-58AF-4789-A3CA-534B07DE31D6}"/>
+              </a:ext>
+            </a:extLst>
+          </p:cNvPr>
+          <p:cNvSpPr>
+            <a:spLocks xmlns:a="http://schemas.openxmlformats.org/drawingml/2006/main" noGrp="1"/>
+          </p:cNvSpPr>
+          <p:nvPr/>
+        </p:nvSpPr>
+        <p:spPr>
+          <a:xfrm xmlns:a="http://schemas.openxmlformats.org/drawingml/2006/main">
+            <a:off x="609600" y="457200"/>
+            <a:ext cx="3429000" cy="209550"/>
+          </a:xfrm>
+          <a:prstGeom xmlns:a="http://schemas.openxmlformats.org/drawingml/2006/main" prst="rect">
+            <a:avLst/>
+          </a:prstGeom>
+          <a:noFill xmlns:a="http://schemas.openxmlformats.org/drawingml/2006/main"/>
+          <a:ln xmlns:a="http://schemas.openxmlformats.org/drawingml/2006/main" w="0">
+            <a:noFill/>
+            <a:prstDash val="solid"/>
+          </a:ln>
+        </p:spPr>
+        <p:txBody>
+          <a:bodyPr xmlns:a="http://schemas.openxmlformats.org/drawingml/2006/main" lIns="0" tIns="0" rIns="0" bIns="0" anchor="t"/>
+          <a:lstStyle xmlns:a="http://schemas.openxmlformats.org/drawingml/2006/main"/>
+          <a:p xmlns:a="http://schemas.openxmlformats.org/drawingml/2006/main">
+            <a:pPr algn="l">
+              <a:lnSpc>
+                <a:spcPct val="105000"/>
+              </a:lnSpc>
+              <a:buNone/>
+              <a:defRPr sz="900" b="1">
+                <a:solidFill>
+                  <a:srgbClr val="7C3AED"/>
+                </a:solidFill>
+              </a:defRPr>
+            </a:pPr>
+            <a:r>
+              <a:rPr sz="900" b="1">
+                <a:solidFill>
+                  <a:srgbClr val="7C3AED"/>
+                </a:solidFill>
+              </a:rPr>
+              <a:t>CAMPAIGN SCALE TACTICS</a:t>
+            </a:r>
+          </a:p>
+        </p:txBody>
+      </p:sp>
+      <p:sp>
+        <p:nvSpPr>
+          <p:cNvPr id="31" name="">
+            <a:extLst xmlns:a="http://schemas.openxmlformats.org/drawingml/2006/main">
+              <a:ext uri="{FF2B5EF4-FFF2-40B4-BE49-F238E27FC236}">
+                <a16:creationId xmlns:a16="http://schemas.microsoft.com/office/drawing/2014/main" id="{9E63B699-BB85-4B3C-BF21-499E288ECA20}"/>
+              </a:ext>
+            </a:extLst>
+          </p:cNvPr>
+          <p:cNvSpPr>
+            <a:spLocks xmlns:a="http://schemas.openxmlformats.org/drawingml/2006/main" noGrp="1"/>
+          </p:cNvSpPr>
+          <p:nvPr/>
+        </p:nvSpPr>
+        <p:spPr>
+          <a:xfrm xmlns:a="http://schemas.openxmlformats.org/drawingml/2006/main">
+            <a:off x="609600" y="819150"/>
+            <a:ext cx="10668000" cy="876300"/>
+          </a:xfrm>
+          <a:prstGeom xmlns:a="http://schemas.openxmlformats.org/drawingml/2006/main" prst="rect">
+            <a:avLst/>
+          </a:prstGeom>
+          <a:noFill xmlns:a="http://schemas.openxmlformats.org/drawingml/2006/main"/>
+          <a:ln xmlns:a="http://schemas.openxmlformats.org/drawingml/2006/main" w="0">
+            <a:noFill/>
+            <a:prstDash val="solid"/>
+          </a:ln>
+        </p:spPr>
+        <p:txBody>
+          <a:bodyPr xmlns:a="http://schemas.openxmlformats.org/drawingml/2006/main" lIns="0" tIns="0" rIns="0" bIns="0" anchor="t"/>
+          <a:lstStyle xmlns:a="http://schemas.openxmlformats.org/drawingml/2006/main"/>
+          <a:p xmlns:a="http://schemas.openxmlformats.org/drawingml/2006/main">
+            <a:pPr algn="l">
+              <a:lnSpc>
+                <a:spcPct val="100000"/>
+              </a:lnSpc>
+              <a:buNone/>
+              <a:defRPr sz="2813" b="1">
+                <a:solidFill>
+                  <a:srgbClr val="071425"/>
+                </a:solidFill>
+              </a:defRPr>
+            </a:pPr>
+            <a:r>
+              <a:rPr sz="2813" b="1">
+                <a:solidFill>
+                  <a:srgbClr val="071425"/>
+                </a:solidFill>
+              </a:rPr>
+              <a:t>Make Reshaping the Rules impossible to miss across retail, Amazon, and paid.</a:t>
+            </a:r>
+          </a:p>
+        </p:txBody>
+      </p:sp>
+      <p:sp>
+        <p:nvSpPr>
+          <p:cNvPr id="32" name="">
+            <a:extLst xmlns:a="http://schemas.openxmlformats.org/drawingml/2006/main">
+              <a:ext uri="{FF2B5EF4-FFF2-40B4-BE49-F238E27FC236}">
+                <a16:creationId xmlns:a16="http://schemas.microsoft.com/office/drawing/2014/main" id="{21B18FC9-BC7D-414D-9488-8E18200F88AC}"/>
+              </a:ext>
+            </a:extLst>
+          </p:cNvPr>
+          <p:cNvSpPr>
+            <a:spLocks xmlns:a="http://schemas.openxmlformats.org/drawingml/2006/main" noGrp="1"/>
+          </p:cNvSpPr>
+          <p:nvPr/>
+        </p:nvSpPr>
+        <p:spPr>
+          <a:xfrm xmlns:a="http://schemas.openxmlformats.org/drawingml/2006/main">
+            <a:off x="609600" y="1676400"/>
+            <a:ext cx="9620250" cy="419100"/>
+          </a:xfrm>
+          <a:prstGeom xmlns:a="http://schemas.openxmlformats.org/drawingml/2006/main" prst="rect">
+            <a:avLst/>
+          </a:prstGeom>
+          <a:noFill xmlns:a="http://schemas.openxmlformats.org/drawingml/2006/main"/>
+          <a:ln xmlns:a="http://schemas.openxmlformats.org/drawingml/2006/main" w="0">
+            <a:noFill/>
+            <a:prstDash val="solid"/>
+          </a:ln>
+        </p:spPr>
+        <p:txBody>
+          <a:bodyPr xmlns:a="http://schemas.openxmlformats.org/drawingml/2006/main" lIns="0" tIns="0" rIns="0" bIns="0" anchor="t"/>
+          <a:lstStyle xmlns:a="http://schemas.openxmlformats.org/drawingml/2006/main"/>
+          <a:p xmlns:a="http://schemas.openxmlformats.org/drawingml/2006/main">
+            <a:pPr algn="l">
+              <a:lnSpc>
+                <a:spcPct val="112000"/>
+              </a:lnSpc>
+              <a:buNone/>
+              <a:defRPr sz="1275" b="0">
+                <a:solidFill>
+                  <a:srgbClr val="41516B"/>
+                </a:solidFill>
+              </a:defRPr>
+            </a:pPr>
+            <a:r>
+              <a:rPr sz="1275" b="0">
+                <a:solidFill>
+                  <a:srgbClr val="41516B"/>
+                </a:solidFill>
+              </a:rPr>
+              <a:t>Spanx and Skims win by memory. Shapermint needs a repeatable asset system: same promise, same proof, same visual cue, adapted by age and channel.</a:t>
+            </a:r>
+          </a:p>
+        </p:txBody>
+      </p:sp>
+      <p:sp>
+        <p:nvSpPr>
+          <p:cNvPr id="33" name="">
+            <a:extLst xmlns:a="http://schemas.openxmlformats.org/drawingml/2006/main">
+              <a:ext uri="{FF2B5EF4-FFF2-40B4-BE49-F238E27FC236}">
+                <a16:creationId xmlns:a16="http://schemas.microsoft.com/office/drawing/2014/main" id="{32DF0B82-9DC5-4324-8A11-0F07194243CF}"/>
+              </a:ext>
+            </a:extLst>
+          </p:cNvPr>
+          <p:cNvSpPr>
+            <a:spLocks xmlns:a="http://schemas.openxmlformats.org/drawingml/2006/main" noGrp="1"/>
+          </p:cNvSpPr>
+          <p:nvPr/>
+        </p:nvSpPr>
+        <p:spPr>
+          <a:xfrm xmlns:a="http://schemas.openxmlformats.org/drawingml/2006/main">
+            <a:off x="609600" y="2286000"/>
+            <a:ext cx="3333750" cy="933450"/>
+          </a:xfrm>
+          <a:prstGeom xmlns:a="http://schemas.openxmlformats.org/drawingml/2006/main" prst="roundRect">
+            <a:avLst>
+              <a:gd name="adj" fmla="val 8163"/>
+            </a:avLst>
+          </a:prstGeom>
+          <a:solidFill xmlns:a="http://schemas.openxmlformats.org/drawingml/2006/main">
+            <a:srgbClr val="FFFDF9"/>
+          </a:solidFill>
+          <a:ln xmlns:a="http://schemas.openxmlformats.org/drawingml/2006/main" w="9525">
+            <a:solidFill>
+              <a:srgbClr val="E5DCD1"/>
+            </a:solidFill>
+            <a:prstDash val="solid"/>
+          </a:ln>
+        </p:spPr>
+      </p:sp>
+      <p:sp>
+        <p:nvSpPr>
+          <p:cNvPr id="34" name="">
+            <a:extLst xmlns:a="http://schemas.openxmlformats.org/drawingml/2006/main">
+              <a:ext uri="{FF2B5EF4-FFF2-40B4-BE49-F238E27FC236}">
+                <a16:creationId xmlns:a16="http://schemas.microsoft.com/office/drawing/2014/main" id="{DB58A86E-393A-4E9E-BEC8-66717FA1803A}"/>
+              </a:ext>
+            </a:extLst>
+          </p:cNvPr>
+          <p:cNvSpPr>
+            <a:spLocks xmlns:a="http://schemas.openxmlformats.org/drawingml/2006/main" noGrp="1"/>
+          </p:cNvSpPr>
+          <p:nvPr/>
+        </p:nvSpPr>
+        <p:spPr>
+          <a:xfrm xmlns:a="http://schemas.openxmlformats.org/drawingml/2006/main">
+            <a:off x="800100" y="2457450"/>
+            <a:ext cx="895350" cy="381000"/>
+          </a:xfrm>
+          <a:prstGeom xmlns:a="http://schemas.openxmlformats.org/drawingml/2006/main" prst="rect">
+            <a:avLst/>
+          </a:prstGeom>
+          <a:noFill xmlns:a="http://schemas.openxmlformats.org/drawingml/2006/main"/>
+          <a:ln xmlns:a="http://schemas.openxmlformats.org/drawingml/2006/main" w="0">
+            <a:noFill/>
+            <a:prstDash val="solid"/>
+          </a:ln>
+        </p:spPr>
+        <p:txBody>
+          <a:bodyPr xmlns:a="http://schemas.openxmlformats.org/drawingml/2006/main" lIns="0" tIns="0" rIns="0" bIns="0" anchor="t"/>
+          <a:lstStyle xmlns:a="http://schemas.openxmlformats.org/drawingml/2006/main"/>
+          <a:p xmlns:a="http://schemas.openxmlformats.org/drawingml/2006/main">
+            <a:pPr algn="l">
+              <a:lnSpc>
+                <a:spcPct val="105000"/>
+              </a:lnSpc>
+              <a:buNone/>
+              <a:defRPr sz="2100" b="1">
+                <a:solidFill>
+                  <a:srgbClr val="EC4899"/>
+                </a:solidFill>
+              </a:defRPr>
+            </a:pPr>
+            <a:r>
+              <a:rPr sz="2100" b="1">
+                <a:solidFill>
+                  <a:srgbClr val="EC4899"/>
+                </a:solidFill>
+              </a:rPr>
+              <a:t>33.9%</a:t>
+            </a:r>
+          </a:p>
+        </p:txBody>
+      </p:sp>
+      <p:sp>
+        <p:nvSpPr>
+          <p:cNvPr id="35" name="">
+            <a:extLst xmlns:a="http://schemas.openxmlformats.org/drawingml/2006/main">
+              <a:ext uri="{FF2B5EF4-FFF2-40B4-BE49-F238E27FC236}">
+                <a16:creationId xmlns:a16="http://schemas.microsoft.com/office/drawing/2014/main" id="{368A70E6-399F-4073-9C65-D86D62D6058F}"/>
+              </a:ext>
+            </a:extLst>
+          </p:cNvPr>
+          <p:cNvSpPr>
+            <a:spLocks xmlns:a="http://schemas.openxmlformats.org/drawingml/2006/main" noGrp="1"/>
+          </p:cNvSpPr>
+          <p:nvPr/>
+        </p:nvSpPr>
+        <p:spPr>
+          <a:xfrm xmlns:a="http://schemas.openxmlformats.org/drawingml/2006/main">
+            <a:off x="1733550" y="2466975"/>
+            <a:ext cx="2019300" cy="514350"/>
+          </a:xfrm>
+          <a:prstGeom xmlns:a="http://schemas.openxmlformats.org/drawingml/2006/main" prst="rect">
+            <a:avLst/>
+          </a:prstGeom>
+          <a:noFill xmlns:a="http://schemas.openxmlformats.org/drawingml/2006/main"/>
+          <a:ln xmlns:a="http://schemas.openxmlformats.org/drawingml/2006/main" w="0">
+            <a:noFill/>
+            <a:prstDash val="solid"/>
+          </a:ln>
+        </p:spPr>
+        <p:txBody>
+          <a:bodyPr xmlns:a="http://schemas.openxmlformats.org/drawingml/2006/main" lIns="0" tIns="0" rIns="0" bIns="0" anchor="t"/>
+          <a:lstStyle xmlns:a="http://schemas.openxmlformats.org/drawingml/2006/main"/>
+          <a:p xmlns:a="http://schemas.openxmlformats.org/drawingml/2006/main">
+            <a:pPr algn="l">
+              <a:lnSpc>
+                <a:spcPct val="110000"/>
+              </a:lnSpc>
+              <a:buNone/>
+              <a:defRPr sz="1065" b="1">
+                <a:solidFill>
+                  <a:srgbClr val="41516B"/>
+                </a:solidFill>
+              </a:defRPr>
+            </a:pPr>
+            <a:r>
+              <a:rPr sz="1065" b="1">
+                <a:solidFill>
+                  <a:srgbClr val="41516B"/>
+                </a:solidFill>
+              </a:rPr>
+              <a:t>say brands focus on looking slimmer; 20.2% say younger women, 19.2% miss life stage.</a:t>
+            </a:r>
+          </a:p>
+        </p:txBody>
+      </p:sp>
+      <p:sp>
+        <p:nvSpPr>
+          <p:cNvPr id="36" name="">
+            <a:extLst xmlns:a="http://schemas.openxmlformats.org/drawingml/2006/main">
+              <a:ext uri="{FF2B5EF4-FFF2-40B4-BE49-F238E27FC236}">
+                <a16:creationId xmlns:a16="http://schemas.microsoft.com/office/drawing/2014/main" id="{1ECA3053-5738-4A8A-860E-96A7D21A36FF}"/>
+              </a:ext>
+            </a:extLst>
+          </p:cNvPr>
+          <p:cNvSpPr>
+            <a:spLocks xmlns:a="http://schemas.openxmlformats.org/drawingml/2006/main" noGrp="1"/>
+          </p:cNvSpPr>
+          <p:nvPr/>
+        </p:nvSpPr>
+        <p:spPr>
+          <a:xfrm xmlns:a="http://schemas.openxmlformats.org/drawingml/2006/main">
+            <a:off x="4210050" y="2286000"/>
+            <a:ext cx="3333750" cy="933450"/>
+          </a:xfrm>
+          <a:prstGeom xmlns:a="http://schemas.openxmlformats.org/drawingml/2006/main" prst="roundRect">
+            <a:avLst>
+              <a:gd name="adj" fmla="val 8163"/>
+            </a:avLst>
+          </a:prstGeom>
+          <a:solidFill xmlns:a="http://schemas.openxmlformats.org/drawingml/2006/main">
+            <a:srgbClr val="FFFDF9"/>
+          </a:solidFill>
+          <a:ln xmlns:a="http://schemas.openxmlformats.org/drawingml/2006/main" w="9525">
+            <a:solidFill>
+              <a:srgbClr val="E5DCD1"/>
+            </a:solidFill>
+            <a:prstDash val="solid"/>
+          </a:ln>
+        </p:spPr>
+      </p:sp>
+      <p:sp>
+        <p:nvSpPr>
+          <p:cNvPr id="37" name="">
+            <a:extLst xmlns:a="http://schemas.openxmlformats.org/drawingml/2006/main">
+              <a:ext uri="{FF2B5EF4-FFF2-40B4-BE49-F238E27FC236}">
+                <a16:creationId xmlns:a16="http://schemas.microsoft.com/office/drawing/2014/main" id="{25A4D2E5-BF18-4617-9477-6F555C231279}"/>
+              </a:ext>
+            </a:extLst>
+          </p:cNvPr>
+          <p:cNvSpPr>
+            <a:spLocks xmlns:a="http://schemas.openxmlformats.org/drawingml/2006/main" noGrp="1"/>
+          </p:cNvSpPr>
+          <p:nvPr/>
+        </p:nvSpPr>
+        <p:spPr>
+          <a:xfrm xmlns:a="http://schemas.openxmlformats.org/drawingml/2006/main">
+            <a:off x="4400550" y="2457450"/>
+            <a:ext cx="895350" cy="381000"/>
+          </a:xfrm>
+          <a:prstGeom xmlns:a="http://schemas.openxmlformats.org/drawingml/2006/main" prst="rect">
+            <a:avLst/>
+          </a:prstGeom>
+          <a:noFill xmlns:a="http://schemas.openxmlformats.org/drawingml/2006/main"/>
+          <a:ln xmlns:a="http://schemas.openxmlformats.org/drawingml/2006/main" w="0">
+            <a:noFill/>
+            <a:prstDash val="solid"/>
+          </a:ln>
+        </p:spPr>
+        <p:txBody>
+          <a:bodyPr xmlns:a="http://schemas.openxmlformats.org/drawingml/2006/main" lIns="0" tIns="0" rIns="0" bIns="0" anchor="t"/>
+          <a:lstStyle xmlns:a="http://schemas.openxmlformats.org/drawingml/2006/main"/>
+          <a:p xmlns:a="http://schemas.openxmlformats.org/drawingml/2006/main">
+            <a:pPr algn="l">
+              <a:lnSpc>
+                <a:spcPct val="105000"/>
+              </a:lnSpc>
+              <a:buNone/>
+              <a:defRPr sz="2100" b="1">
+                <a:solidFill>
+                  <a:srgbClr val="7C3AED"/>
+                </a:solidFill>
+              </a:defRPr>
+            </a:pPr>
+            <a:r>
+              <a:rPr sz="2100" b="1">
+                <a:solidFill>
+                  <a:srgbClr val="7C3AED"/>
+                </a:solidFill>
+              </a:rPr>
+              <a:t>55.6%</a:t>
+            </a:r>
+          </a:p>
+        </p:txBody>
+      </p:sp>
+      <p:sp>
+        <p:nvSpPr>
+          <p:cNvPr id="38" name="">
+            <a:extLst xmlns:a="http://schemas.openxmlformats.org/drawingml/2006/main">
+              <a:ext uri="{FF2B5EF4-FFF2-40B4-BE49-F238E27FC236}">
+                <a16:creationId xmlns:a16="http://schemas.microsoft.com/office/drawing/2014/main" id="{4F81931E-B014-4F2F-BCEF-61982C6A87C1}"/>
+              </a:ext>
+            </a:extLst>
+          </p:cNvPr>
+          <p:cNvSpPr>
+            <a:spLocks xmlns:a="http://schemas.openxmlformats.org/drawingml/2006/main" noGrp="1"/>
+          </p:cNvSpPr>
+          <p:nvPr/>
+        </p:nvSpPr>
+        <p:spPr>
+          <a:xfrm xmlns:a="http://schemas.openxmlformats.org/drawingml/2006/main">
+            <a:off x="5334000" y="2466975"/>
+            <a:ext cx="2019300" cy="514350"/>
+          </a:xfrm>
+          <a:prstGeom xmlns:a="http://schemas.openxmlformats.org/drawingml/2006/main" prst="rect">
+            <a:avLst/>
+          </a:prstGeom>
+          <a:noFill xmlns:a="http://schemas.openxmlformats.org/drawingml/2006/main"/>
+          <a:ln xmlns:a="http://schemas.openxmlformats.org/drawingml/2006/main" w="0">
+            <a:noFill/>
+            <a:prstDash val="solid"/>
+          </a:ln>
+        </p:spPr>
+        <p:txBody>
+          <a:bodyPr xmlns:a="http://schemas.openxmlformats.org/drawingml/2006/main" lIns="0" tIns="0" rIns="0" bIns="0" anchor="t"/>
+          <a:lstStyle xmlns:a="http://schemas.openxmlformats.org/drawingml/2006/main"/>
+          <a:p xmlns:a="http://schemas.openxmlformats.org/drawingml/2006/main">
+            <a:pPr algn="l">
+              <a:lnSpc>
+                <a:spcPct val="110000"/>
+              </a:lnSpc>
+              <a:buNone/>
+              <a:defRPr sz="1065" b="1">
+                <a:solidFill>
+                  <a:srgbClr val="41516B"/>
+                </a:solidFill>
+              </a:defRPr>
+            </a:pPr>
+            <a:r>
+              <a:rPr sz="1065" b="1">
+                <a:solidFill>
+                  <a:srgbClr val="41516B"/>
+                </a:solidFill>
+              </a:rPr>
+              <a:t>respond to “adapts to my body”; 53.6% to life stage; 47.5% to comfort as power.</a:t>
+            </a:r>
+          </a:p>
+        </p:txBody>
+      </p:sp>
+      <p:sp>
+        <p:nvSpPr>
+          <p:cNvPr id="39" name="">
+            <a:extLst xmlns:a="http://schemas.openxmlformats.org/drawingml/2006/main">
+              <a:ext uri="{FF2B5EF4-FFF2-40B4-BE49-F238E27FC236}">
+                <a16:creationId xmlns:a16="http://schemas.microsoft.com/office/drawing/2014/main" id="{14462FE2-DA9B-4D5B-AF72-74DE23718B23}"/>
+              </a:ext>
+            </a:extLst>
+          </p:cNvPr>
+          <p:cNvSpPr>
+            <a:spLocks xmlns:a="http://schemas.openxmlformats.org/drawingml/2006/main" noGrp="1"/>
+          </p:cNvSpPr>
+          <p:nvPr/>
+        </p:nvSpPr>
+        <p:spPr>
+          <a:xfrm xmlns:a="http://schemas.openxmlformats.org/drawingml/2006/main">
+            <a:off x="7810500" y="2286000"/>
+            <a:ext cx="3333750" cy="933450"/>
+          </a:xfrm>
+          <a:prstGeom xmlns:a="http://schemas.openxmlformats.org/drawingml/2006/main" prst="roundRect">
+            <a:avLst>
+              <a:gd name="adj" fmla="val 8163"/>
+            </a:avLst>
+          </a:prstGeom>
+          <a:solidFill xmlns:a="http://schemas.openxmlformats.org/drawingml/2006/main">
+            <a:srgbClr val="FFFDF9"/>
+          </a:solidFill>
+          <a:ln xmlns:a="http://schemas.openxmlformats.org/drawingml/2006/main" w="9525">
+            <a:solidFill>
+              <a:srgbClr val="E5DCD1"/>
+            </a:solidFill>
+            <a:prstDash val="solid"/>
+          </a:ln>
+        </p:spPr>
+      </p:sp>
+      <p:sp>
+        <p:nvSpPr>
+          <p:cNvPr id="40" name="">
+            <a:extLst xmlns:a="http://schemas.openxmlformats.org/drawingml/2006/main">
+              <a:ext uri="{FF2B5EF4-FFF2-40B4-BE49-F238E27FC236}">
+                <a16:creationId xmlns:a16="http://schemas.microsoft.com/office/drawing/2014/main" id="{FB52258D-9983-47A2-887D-E38E44E77ABC}"/>
+              </a:ext>
+            </a:extLst>
+          </p:cNvPr>
+          <p:cNvSpPr>
+            <a:spLocks xmlns:a="http://schemas.openxmlformats.org/drawingml/2006/main" noGrp="1"/>
+          </p:cNvSpPr>
+          <p:nvPr/>
+        </p:nvSpPr>
+        <p:spPr>
+          <a:xfrm xmlns:a="http://schemas.openxmlformats.org/drawingml/2006/main">
+            <a:off x="8001000" y="2457450"/>
+            <a:ext cx="895350" cy="381000"/>
+          </a:xfrm>
+          <a:prstGeom xmlns:a="http://schemas.openxmlformats.org/drawingml/2006/main" prst="rect">
+            <a:avLst/>
+          </a:prstGeom>
+          <a:noFill xmlns:a="http://schemas.openxmlformats.org/drawingml/2006/main"/>
+          <a:ln xmlns:a="http://schemas.openxmlformats.org/drawingml/2006/main" w="0">
+            <a:noFill/>
+            <a:prstDash val="solid"/>
+          </a:ln>
+        </p:spPr>
+        <p:txBody>
+          <a:bodyPr xmlns:a="http://schemas.openxmlformats.org/drawingml/2006/main" lIns="0" tIns="0" rIns="0" bIns="0" anchor="t"/>
+          <a:lstStyle xmlns:a="http://schemas.openxmlformats.org/drawingml/2006/main"/>
+          <a:p xmlns:a="http://schemas.openxmlformats.org/drawingml/2006/main">
+            <a:pPr algn="l">
+              <a:lnSpc>
+                <a:spcPct val="105000"/>
+              </a:lnSpc>
+              <a:buNone/>
+              <a:defRPr sz="2100" b="1">
+                <a:solidFill>
+                  <a:srgbClr val="F59E0B"/>
+                </a:solidFill>
+              </a:defRPr>
+            </a:pPr>
+            <a:r>
+              <a:rPr sz="2100" b="1">
+                <a:solidFill>
+                  <a:srgbClr val="F59E0B"/>
+                </a:solidFill>
+              </a:rPr>
+              <a:t>26.4%</a:t>
+            </a:r>
+          </a:p>
+        </p:txBody>
+      </p:sp>
+      <p:sp>
+        <p:nvSpPr>
+          <p:cNvPr id="41" name="">
+            <a:extLst xmlns:a="http://schemas.openxmlformats.org/drawingml/2006/main">
+              <a:ext uri="{FF2B5EF4-FFF2-40B4-BE49-F238E27FC236}">
+                <a16:creationId xmlns:a16="http://schemas.microsoft.com/office/drawing/2014/main" id="{D737717E-0A3B-4E1B-9754-1F244A30783C}"/>
+              </a:ext>
+            </a:extLst>
+          </p:cNvPr>
+          <p:cNvSpPr>
+            <a:spLocks xmlns:a="http://schemas.openxmlformats.org/drawingml/2006/main" noGrp="1"/>
+          </p:cNvSpPr>
+          <p:nvPr/>
+        </p:nvSpPr>
+        <p:spPr>
+          <a:xfrm xmlns:a="http://schemas.openxmlformats.org/drawingml/2006/main">
+            <a:off x="8934450" y="2466975"/>
+            <a:ext cx="2019300" cy="514350"/>
+          </a:xfrm>
+          <a:prstGeom xmlns:a="http://schemas.openxmlformats.org/drawingml/2006/main" prst="rect">
+            <a:avLst/>
+          </a:prstGeom>
+          <a:noFill xmlns:a="http://schemas.openxmlformats.org/drawingml/2006/main"/>
+          <a:ln xmlns:a="http://schemas.openxmlformats.org/drawingml/2006/main" w="0">
+            <a:noFill/>
+            <a:prstDash val="solid"/>
+          </a:ln>
+        </p:spPr>
+        <p:txBody>
+          <a:bodyPr xmlns:a="http://schemas.openxmlformats.org/drawingml/2006/main" lIns="0" tIns="0" rIns="0" bIns="0" anchor="t"/>
+          <a:lstStyle xmlns:a="http://schemas.openxmlformats.org/drawingml/2006/main"/>
+          <a:p xmlns:a="http://schemas.openxmlformats.org/drawingml/2006/main">
+            <a:pPr algn="l">
+              <a:lnSpc>
+                <a:spcPct val="110000"/>
+              </a:lnSpc>
+              <a:buNone/>
+              <a:defRPr sz="1065" b="1">
+                <a:solidFill>
+                  <a:srgbClr val="41516B"/>
+                </a:solidFill>
+              </a:defRPr>
+            </a:pPr>
+            <a:r>
+              <a:rPr sz="1065" b="1">
+                <a:solidFill>
+                  <a:srgbClr val="41516B"/>
+                </a:solidFill>
+              </a:rPr>
+              <a:t>say no brand is moving beyond old rules; Shapermint is only 9.3%.</a:t>
+            </a:r>
+          </a:p>
+        </p:txBody>
+      </p:sp>
+      <p:sp>
+        <p:nvSpPr>
+          <p:cNvPr id="42" name="">
+            <a:extLst xmlns:a="http://schemas.openxmlformats.org/drawingml/2006/main">
+              <a:ext uri="{FF2B5EF4-FFF2-40B4-BE49-F238E27FC236}">
+                <a16:creationId xmlns:a16="http://schemas.microsoft.com/office/drawing/2014/main" id="{A6FA9B4E-F157-4D92-AEAC-19F00102DFD6}"/>
+              </a:ext>
+            </a:extLst>
+          </p:cNvPr>
+          <p:cNvSpPr>
+            <a:spLocks xmlns:a="http://schemas.openxmlformats.org/drawingml/2006/main" noGrp="1"/>
+          </p:cNvSpPr>
+          <p:nvPr/>
+        </p:nvSpPr>
+        <p:spPr>
+          <a:xfrm xmlns:a="http://schemas.openxmlformats.org/drawingml/2006/main">
+            <a:off x="609600" y="3486150"/>
+            <a:ext cx="3371850" cy="1695450"/>
+          </a:xfrm>
+          <a:prstGeom xmlns:a="http://schemas.openxmlformats.org/drawingml/2006/main" prst="roundRect">
+            <a:avLst>
+              <a:gd name="adj" fmla="val 4494"/>
+            </a:avLst>
+          </a:prstGeom>
+          <a:solidFill xmlns:a="http://schemas.openxmlformats.org/drawingml/2006/main">
+            <a:srgbClr val="071425"/>
+          </a:solidFill>
+          <a:ln xmlns:a="http://schemas.openxmlformats.org/drawingml/2006/main" w="0">
+            <a:noFill/>
+            <a:prstDash val="solid"/>
+          </a:ln>
+        </p:spPr>
+      </p:sp>
+      <p:sp>
+        <p:nvSpPr>
+          <p:cNvPr id="43" name="">
+            <a:extLst xmlns:a="http://schemas.openxmlformats.org/drawingml/2006/main">
+              <a:ext uri="{FF2B5EF4-FFF2-40B4-BE49-F238E27FC236}">
+                <a16:creationId xmlns:a16="http://schemas.microsoft.com/office/drawing/2014/main" id="{02A8315C-5807-4BC3-9AC2-2E7BAD2246AE}"/>
+              </a:ext>
+            </a:extLst>
+          </p:cNvPr>
+          <p:cNvSpPr>
+            <a:spLocks xmlns:a="http://schemas.openxmlformats.org/drawingml/2006/main" noGrp="1"/>
+          </p:cNvSpPr>
+          <p:nvPr/>
+        </p:nvSpPr>
+        <p:spPr>
+          <a:xfrm xmlns:a="http://schemas.openxmlformats.org/drawingml/2006/main">
+            <a:off x="781050" y="3657600"/>
+            <a:ext cx="323850" cy="247650"/>
+          </a:xfrm>
+          <a:prstGeom xmlns:a="http://schemas.openxmlformats.org/drawingml/2006/main" prst="roundRect">
+            <a:avLst>
+              <a:gd name="adj" fmla="val 50000"/>
+            </a:avLst>
+          </a:prstGeom>
+          <a:solidFill xmlns:a="http://schemas.openxmlformats.org/drawingml/2006/main">
+            <a:srgbClr val="7C3AED"/>
+          </a:solidFill>
+          <a:ln xmlns:a="http://schemas.openxmlformats.org/drawingml/2006/main" w="0">
+            <a:noFill/>
+            <a:prstDash val="solid"/>
+          </a:ln>
+        </p:spPr>
+      </p:sp>
+      <p:sp>
+        <p:nvSpPr>
+          <p:cNvPr id="44" name="">
+            <a:extLst xmlns:a="http://schemas.openxmlformats.org/drawingml/2006/main">
+              <a:ext uri="{FF2B5EF4-FFF2-40B4-BE49-F238E27FC236}">
+                <a16:creationId xmlns:a16="http://schemas.microsoft.com/office/drawing/2014/main" id="{5D31A71C-4405-4E24-BA21-3E0B46E1A6C0}"/>
+              </a:ext>
+            </a:extLst>
+          </p:cNvPr>
+          <p:cNvSpPr>
+            <a:spLocks xmlns:a="http://schemas.openxmlformats.org/drawingml/2006/main" noGrp="1"/>
+          </p:cNvSpPr>
+          <p:nvPr/>
+        </p:nvSpPr>
+        <p:spPr>
+          <a:xfrm xmlns:a="http://schemas.openxmlformats.org/drawingml/2006/main">
+            <a:off x="781050" y="3714750"/>
+            <a:ext cx="323850" cy="133350"/>
+          </a:xfrm>
+          <a:prstGeom xmlns:a="http://schemas.openxmlformats.org/drawingml/2006/main" prst="rect">
+            <a:avLst/>
+          </a:prstGeom>
+          <a:noFill xmlns:a="http://schemas.openxmlformats.org/drawingml/2006/main"/>
+          <a:ln xmlns:a="http://schemas.openxmlformats.org/drawingml/2006/main" w="0">
+            <a:noFill/>
+            <a:prstDash val="solid"/>
+          </a:ln>
+        </p:spPr>
+        <p:txBody>
+          <a:bodyPr xmlns:a="http://schemas.openxmlformats.org/drawingml/2006/main" lIns="0" tIns="0" rIns="0" bIns="0" anchor="t"/>
+          <a:lstStyle xmlns:a="http://schemas.openxmlformats.org/drawingml/2006/main"/>
+          <a:p xmlns:a="http://schemas.openxmlformats.org/drawingml/2006/main">
+            <a:pPr algn="ctr">
+              <a:lnSpc>
+                <a:spcPct val="105000"/>
+              </a:lnSpc>
+              <a:buNone/>
+              <a:defRPr sz="900" b="1">
+                <a:solidFill>
+                  <a:srgbClr val="FFFFFF"/>
+                </a:solidFill>
+              </a:defRPr>
+            </a:pPr>
+            <a:r>
+              <a:rPr sz="900" b="1">
+                <a:solidFill>
+                  <a:srgbClr val="FFFFFF"/>
+                </a:solidFill>
+              </a:rPr>
+              <a:t>1</a:t>
+            </a:r>
+          </a:p>
+        </p:txBody>
+      </p:sp>
+      <p:sp>
+        <p:nvSpPr>
+          <p:cNvPr id="45" name="">
+            <a:extLst xmlns:a="http://schemas.openxmlformats.org/drawingml/2006/main">
+              <a:ext uri="{FF2B5EF4-FFF2-40B4-BE49-F238E27FC236}">
+                <a16:creationId xmlns:a16="http://schemas.microsoft.com/office/drawing/2014/main" id="{2A29FECE-D94D-4D3F-AB40-28BD3DF6E642}"/>
+              </a:ext>
+            </a:extLst>
+          </p:cNvPr>
+          <p:cNvSpPr>
+            <a:spLocks xmlns:a="http://schemas.openxmlformats.org/drawingml/2006/main" noGrp="1"/>
+          </p:cNvSpPr>
+          <p:nvPr/>
+        </p:nvSpPr>
+        <p:spPr>
+          <a:xfrm xmlns:a="http://schemas.openxmlformats.org/drawingml/2006/main">
+            <a:off x="1238250" y="3648075"/>
+            <a:ext cx="2552700" cy="266700"/>
+          </a:xfrm>
+          <a:prstGeom xmlns:a="http://schemas.openxmlformats.org/drawingml/2006/main" prst="rect">
+            <a:avLst/>
+          </a:prstGeom>
+          <a:noFill xmlns:a="http://schemas.openxmlformats.org/drawingml/2006/main"/>
+          <a:ln xmlns:a="http://schemas.openxmlformats.org/drawingml/2006/main" w="0">
+            <a:noFill/>
+            <a:prstDash val="solid"/>
+          </a:ln>
+        </p:spPr>
+        <p:txBody>
+          <a:bodyPr xmlns:a="http://schemas.openxmlformats.org/drawingml/2006/main" lIns="0" tIns="0" rIns="0" bIns="0" anchor="t"/>
+          <a:lstStyle xmlns:a="http://schemas.openxmlformats.org/drawingml/2006/main"/>
+          <a:p xmlns:a="http://schemas.openxmlformats.org/drawingml/2006/main">
+            <a:pPr algn="l">
+              <a:lnSpc>
+                <a:spcPct val="105000"/>
+              </a:lnSpc>
+              <a:buNone/>
+              <a:defRPr sz="1388" b="1">
+                <a:solidFill>
+                  <a:srgbClr val="FFFFFF"/>
+                </a:solidFill>
+              </a:defRPr>
+            </a:pPr>
+            <a:r>
+              <a:rPr sz="1388" b="1">
+                <a:solidFill>
+                  <a:srgbClr val="FFFFFF"/>
+                </a:solidFill>
+              </a:rPr>
+              <a:t>Build one memory device</a:t>
+            </a:r>
+          </a:p>
+        </p:txBody>
+      </p:sp>
+      <p:sp>
+        <p:nvSpPr>
+          <p:cNvPr id="46" name="">
+            <a:extLst xmlns:a="http://schemas.openxmlformats.org/drawingml/2006/main">
+              <a:ext uri="{FF2B5EF4-FFF2-40B4-BE49-F238E27FC236}">
+                <a16:creationId xmlns:a16="http://schemas.microsoft.com/office/drawing/2014/main" id="{1F4662FC-5E09-48EE-BC4E-6C6303A6C32A}"/>
+              </a:ext>
+            </a:extLst>
+          </p:cNvPr>
+          <p:cNvSpPr>
+            <a:spLocks xmlns:a="http://schemas.openxmlformats.org/drawingml/2006/main" noGrp="1"/>
+          </p:cNvSpPr>
+          <p:nvPr/>
+        </p:nvSpPr>
+        <p:spPr>
+          <a:xfrm xmlns:a="http://schemas.openxmlformats.org/drawingml/2006/main">
+            <a:off x="1238250" y="3981450"/>
+            <a:ext cx="2552700" cy="1104900"/>
+          </a:xfrm>
+          <a:prstGeom xmlns:a="http://schemas.openxmlformats.org/drawingml/2006/main" prst="rect">
+            <a:avLst/>
+          </a:prstGeom>
+          <a:noFill xmlns:a="http://schemas.openxmlformats.org/drawingml/2006/main"/>
+          <a:ln xmlns:a="http://schemas.openxmlformats.org/drawingml/2006/main" w="0">
+            <a:noFill/>
+            <a:prstDash val="solid"/>
+          </a:ln>
+        </p:spPr>
+        <p:txBody>
+          <a:bodyPr xmlns:a="http://schemas.openxmlformats.org/drawingml/2006/main" lIns="0" tIns="0" rIns="0" bIns="0" anchor="t"/>
+          <a:lstStyle xmlns:a="http://schemas.openxmlformats.org/drawingml/2006/main"/>
+          <a:p xmlns:a="http://schemas.openxmlformats.org/drawingml/2006/main">
+            <a:pPr algn="l">
+              <a:lnSpc>
+                <a:spcPct val="112000"/>
+              </a:lnSpc>
+              <a:buNone/>
+              <a:defRPr sz="1065" b="0">
+                <a:solidFill>
+                  <a:srgbClr val="E8EDF5"/>
+                </a:solidFill>
+              </a:defRPr>
+            </a:pPr>
+            <a:r>
+              <a:rPr sz="1065" b="0">
+                <a:solidFill>
+                  <a:srgbClr val="E8EDF5"/>
+                </a:solidFill>
+              </a:rPr>
+              <a:t>Create an ownable “Adapt Fit” cue: the garment visibly flexes around different bodies, outfits, and life moments. Repeat the same phrase, motion, and proof shot everywhere.</a:t>
+            </a:r>
+          </a:p>
+        </p:txBody>
+      </p:sp>
+      <p:sp>
+        <p:nvSpPr>
+          <p:cNvPr id="47" name="">
+            <a:extLst xmlns:a="http://schemas.openxmlformats.org/drawingml/2006/main">
+              <a:ext uri="{FF2B5EF4-FFF2-40B4-BE49-F238E27FC236}">
+                <a16:creationId xmlns:a16="http://schemas.microsoft.com/office/drawing/2014/main" id="{D6572ED2-C9C8-4ECB-981B-C451F709E2B6}"/>
+              </a:ext>
+            </a:extLst>
+          </p:cNvPr>
+          <p:cNvSpPr>
+            <a:spLocks xmlns:a="http://schemas.openxmlformats.org/drawingml/2006/main" noGrp="1"/>
+          </p:cNvSpPr>
+          <p:nvPr/>
+        </p:nvSpPr>
+        <p:spPr>
+          <a:xfrm xmlns:a="http://schemas.openxmlformats.org/drawingml/2006/main">
+            <a:off x="4267200" y="3486150"/>
+            <a:ext cx="3371850" cy="1695450"/>
+          </a:xfrm>
+          <a:prstGeom xmlns:a="http://schemas.openxmlformats.org/drawingml/2006/main" prst="roundRect">
+            <a:avLst>
+              <a:gd name="adj" fmla="val 4494"/>
+            </a:avLst>
+          </a:prstGeom>
+          <a:solidFill xmlns:a="http://schemas.openxmlformats.org/drawingml/2006/main">
+            <a:srgbClr val="FFFDF9"/>
+          </a:solidFill>
+          <a:ln xmlns:a="http://schemas.openxmlformats.org/drawingml/2006/main" w="9525">
+            <a:solidFill>
+              <a:srgbClr val="E5DCD1"/>
+            </a:solidFill>
+            <a:prstDash val="solid"/>
+          </a:ln>
+        </p:spPr>
+      </p:sp>
+      <p:sp>
+        <p:nvSpPr>
+          <p:cNvPr id="48" name="">
+            <a:extLst xmlns:a="http://schemas.openxmlformats.org/drawingml/2006/main">
+              <a:ext uri="{FF2B5EF4-FFF2-40B4-BE49-F238E27FC236}">
+                <a16:creationId xmlns:a16="http://schemas.microsoft.com/office/drawing/2014/main" id="{57EFBD9A-F856-489C-BCC5-CB6EF3E442A9}"/>
+              </a:ext>
+            </a:extLst>
+          </p:cNvPr>
+          <p:cNvSpPr>
+            <a:spLocks xmlns:a="http://schemas.openxmlformats.org/drawingml/2006/main" noGrp="1"/>
+          </p:cNvSpPr>
+          <p:nvPr/>
+        </p:nvSpPr>
+        <p:spPr>
+          <a:xfrm xmlns:a="http://schemas.openxmlformats.org/drawingml/2006/main">
+            <a:off x="4438650" y="3657600"/>
+            <a:ext cx="323850" cy="247650"/>
+          </a:xfrm>
+          <a:prstGeom xmlns:a="http://schemas.openxmlformats.org/drawingml/2006/main" prst="roundRect">
+            <a:avLst>
+              <a:gd name="adj" fmla="val 50000"/>
+            </a:avLst>
+          </a:prstGeom>
+          <a:solidFill xmlns:a="http://schemas.openxmlformats.org/drawingml/2006/main">
+            <a:srgbClr val="EDE1FF"/>
+          </a:solidFill>
+          <a:ln xmlns:a="http://schemas.openxmlformats.org/drawingml/2006/main" w="0">
+            <a:noFill/>
+            <a:prstDash val="solid"/>
+          </a:ln>
+        </p:spPr>
+      </p:sp>
+      <p:sp>
+        <p:nvSpPr>
+          <p:cNvPr id="49" name="">
+            <a:extLst xmlns:a="http://schemas.openxmlformats.org/drawingml/2006/main">
+              <a:ext uri="{FF2B5EF4-FFF2-40B4-BE49-F238E27FC236}">
+                <a16:creationId xmlns:a16="http://schemas.microsoft.com/office/drawing/2014/main" id="{3EB65051-E535-448C-B7DD-40E6810EF479}"/>
+              </a:ext>
+            </a:extLst>
+          </p:cNvPr>
+          <p:cNvSpPr>
+            <a:spLocks xmlns:a="http://schemas.openxmlformats.org/drawingml/2006/main" noGrp="1"/>
+          </p:cNvSpPr>
+          <p:nvPr/>
+        </p:nvSpPr>
+        <p:spPr>
+          <a:xfrm xmlns:a="http://schemas.openxmlformats.org/drawingml/2006/main">
+            <a:off x="4438650" y="3714750"/>
+            <a:ext cx="323850" cy="133350"/>
+          </a:xfrm>
+          <a:prstGeom xmlns:a="http://schemas.openxmlformats.org/drawingml/2006/main" prst="rect">
+            <a:avLst/>
+          </a:prstGeom>
+          <a:noFill xmlns:a="http://schemas.openxmlformats.org/drawingml/2006/main"/>
+          <a:ln xmlns:a="http://schemas.openxmlformats.org/drawingml/2006/main" w="0">
+            <a:noFill/>
+            <a:prstDash val="solid"/>
+          </a:ln>
+        </p:spPr>
+        <p:txBody>
+          <a:bodyPr xmlns:a="http://schemas.openxmlformats.org/drawingml/2006/main" lIns="0" tIns="0" rIns="0" bIns="0" anchor="t"/>
+          <a:lstStyle xmlns:a="http://schemas.openxmlformats.org/drawingml/2006/main"/>
+          <a:p xmlns:a="http://schemas.openxmlformats.org/drawingml/2006/main">
+            <a:pPr algn="ctr">
+              <a:lnSpc>
+                <a:spcPct val="105000"/>
+              </a:lnSpc>
+              <a:buNone/>
+              <a:defRPr sz="900" b="1">
+                <a:solidFill>
+                  <a:srgbClr val="7C3AED"/>
+                </a:solidFill>
+              </a:defRPr>
+            </a:pPr>
+            <a:r>
+              <a:rPr sz="900" b="1">
+                <a:solidFill>
+                  <a:srgbClr val="7C3AED"/>
+                </a:solidFill>
+              </a:rPr>
+              <a:t>2</a:t>
+            </a:r>
+          </a:p>
+        </p:txBody>
+      </p:sp>
+      <p:sp>
+        <p:nvSpPr>
+          <p:cNvPr id="50" name="">
+            <a:extLst xmlns:a="http://schemas.openxmlformats.org/drawingml/2006/main">
+              <a:ext uri="{FF2B5EF4-FFF2-40B4-BE49-F238E27FC236}">
+                <a16:creationId xmlns:a16="http://schemas.microsoft.com/office/drawing/2014/main" id="{4246F0E8-AC76-49A3-BBBD-869C85D1C6AB}"/>
+              </a:ext>
+            </a:extLst>
+          </p:cNvPr>
+          <p:cNvSpPr>
+            <a:spLocks xmlns:a="http://schemas.openxmlformats.org/drawingml/2006/main" noGrp="1"/>
+          </p:cNvSpPr>
+          <p:nvPr/>
+        </p:nvSpPr>
+        <p:spPr>
+          <a:xfrm xmlns:a="http://schemas.openxmlformats.org/drawingml/2006/main">
+            <a:off x="4895850" y="3648075"/>
+            <a:ext cx="2552700" cy="266700"/>
+          </a:xfrm>
+          <a:prstGeom xmlns:a="http://schemas.openxmlformats.org/drawingml/2006/main" prst="rect">
+            <a:avLst/>
+          </a:prstGeom>
+          <a:noFill xmlns:a="http://schemas.openxmlformats.org/drawingml/2006/main"/>
+          <a:ln xmlns:a="http://schemas.openxmlformats.org/drawingml/2006/main" w="0">
+            <a:noFill/>
+            <a:prstDash val="solid"/>
+          </a:ln>
+        </p:spPr>
+        <p:txBody>
+          <a:bodyPr xmlns:a="http://schemas.openxmlformats.org/drawingml/2006/main" lIns="0" tIns="0" rIns="0" bIns="0" anchor="t"/>
+          <a:lstStyle xmlns:a="http://schemas.openxmlformats.org/drawingml/2006/main"/>
+          <a:p xmlns:a="http://schemas.openxmlformats.org/drawingml/2006/main">
+            <a:pPr algn="l">
+              <a:lnSpc>
+                <a:spcPct val="105000"/>
+              </a:lnSpc>
+              <a:buNone/>
+              <a:defRPr sz="1388" b="1">
+                <a:solidFill>
+                  <a:srgbClr val="071425"/>
+                </a:solidFill>
+              </a:defRPr>
+            </a:pPr>
+            <a:r>
+              <a:rPr sz="1388" b="1">
+                <a:solidFill>
+                  <a:srgbClr val="071425"/>
+                </a:solidFill>
+              </a:rPr>
+              <a:t>Turn Amazon into proof</a:t>
+            </a:r>
+          </a:p>
+        </p:txBody>
+      </p:sp>
+      <p:sp>
+        <p:nvSpPr>
+          <p:cNvPr id="51" name="">
+            <a:extLst xmlns:a="http://schemas.openxmlformats.org/drawingml/2006/main">
+              <a:ext uri="{FF2B5EF4-FFF2-40B4-BE49-F238E27FC236}">
+                <a16:creationId xmlns:a16="http://schemas.microsoft.com/office/drawing/2014/main" id="{875B3412-E1D9-4E49-AB7F-BE7F6BE8C0AE}"/>
+              </a:ext>
+            </a:extLst>
+          </p:cNvPr>
+          <p:cNvSpPr>
+            <a:spLocks xmlns:a="http://schemas.openxmlformats.org/drawingml/2006/main" noGrp="1"/>
+          </p:cNvSpPr>
+          <p:nvPr/>
+        </p:nvSpPr>
+        <p:spPr>
+          <a:xfrm xmlns:a="http://schemas.openxmlformats.org/drawingml/2006/main">
+            <a:off x="4895850" y="3981450"/>
+            <a:ext cx="2552700" cy="1104900"/>
+          </a:xfrm>
+          <a:prstGeom xmlns:a="http://schemas.openxmlformats.org/drawingml/2006/main" prst="rect">
+            <a:avLst/>
+          </a:prstGeom>
+          <a:noFill xmlns:a="http://schemas.openxmlformats.org/drawingml/2006/main"/>
+          <a:ln xmlns:a="http://schemas.openxmlformats.org/drawingml/2006/main" w="0">
+            <a:noFill/>
+            <a:prstDash val="solid"/>
+          </a:ln>
+        </p:spPr>
+        <p:txBody>
+          <a:bodyPr xmlns:a="http://schemas.openxmlformats.org/drawingml/2006/main" lIns="0" tIns="0" rIns="0" bIns="0" anchor="t"/>
+          <a:lstStyle xmlns:a="http://schemas.openxmlformats.org/drawingml/2006/main"/>
+          <a:p xmlns:a="http://schemas.openxmlformats.org/drawingml/2006/main">
+            <a:pPr algn="l">
+              <a:lnSpc>
+                <a:spcPct val="112000"/>
+              </a:lnSpc>
+              <a:buNone/>
+              <a:defRPr sz="1065" b="0">
+                <a:solidFill>
+                  <a:srgbClr val="41516B"/>
+                </a:solidFill>
+              </a:defRPr>
+            </a:pPr>
+            <a:r>
+              <a:rPr sz="1065" b="0">
+                <a:solidFill>
+                  <a:srgbClr val="41516B"/>
+                </a:solidFill>
+              </a:rPr>
+              <a:t>Above the fold: comfort-first headline, 15-sec fit demo, compression scale, review badge, size/fit reassurance, starter bundle, and cost-per-wear tile.</a:t>
+            </a:r>
+          </a:p>
+        </p:txBody>
+      </p:sp>
+      <p:sp>
+        <p:nvSpPr>
+          <p:cNvPr id="52" name="">
+            <a:extLst xmlns:a="http://schemas.openxmlformats.org/drawingml/2006/main">
+              <a:ext uri="{FF2B5EF4-FFF2-40B4-BE49-F238E27FC236}">
+                <a16:creationId xmlns:a16="http://schemas.microsoft.com/office/drawing/2014/main" id="{154FC9BB-B92F-439D-A570-C650C9692478}"/>
+              </a:ext>
+            </a:extLst>
+          </p:cNvPr>
+          <p:cNvSpPr>
+            <a:spLocks xmlns:a="http://schemas.openxmlformats.org/drawingml/2006/main" noGrp="1"/>
+          </p:cNvSpPr>
+          <p:nvPr/>
+        </p:nvSpPr>
+        <p:spPr>
+          <a:xfrm xmlns:a="http://schemas.openxmlformats.org/drawingml/2006/main">
+            <a:off x="7924800" y="3486150"/>
+            <a:ext cx="3371850" cy="1695450"/>
+          </a:xfrm>
+          <a:prstGeom xmlns:a="http://schemas.openxmlformats.org/drawingml/2006/main" prst="roundRect">
+            <a:avLst>
+              <a:gd name="adj" fmla="val 4494"/>
+            </a:avLst>
+          </a:prstGeom>
+          <a:solidFill xmlns:a="http://schemas.openxmlformats.org/drawingml/2006/main">
+            <a:srgbClr val="FFFDF9"/>
+          </a:solidFill>
+          <a:ln xmlns:a="http://schemas.openxmlformats.org/drawingml/2006/main" w="9525">
+            <a:solidFill>
+              <a:srgbClr val="E5DCD1"/>
+            </a:solidFill>
+            <a:prstDash val="solid"/>
+          </a:ln>
+        </p:spPr>
+      </p:sp>
+      <p:sp>
+        <p:nvSpPr>
+          <p:cNvPr id="53" name="">
+            <a:extLst xmlns:a="http://schemas.openxmlformats.org/drawingml/2006/main">
+              <a:ext uri="{FF2B5EF4-FFF2-40B4-BE49-F238E27FC236}">
+                <a16:creationId xmlns:a16="http://schemas.microsoft.com/office/drawing/2014/main" id="{E08BBFD5-86BE-4F0B-84D7-80C6BD306BA5}"/>
+              </a:ext>
+            </a:extLst>
+          </p:cNvPr>
+          <p:cNvSpPr>
+            <a:spLocks xmlns:a="http://schemas.openxmlformats.org/drawingml/2006/main" noGrp="1"/>
+          </p:cNvSpPr>
+          <p:nvPr/>
+        </p:nvSpPr>
+        <p:spPr>
+          <a:xfrm xmlns:a="http://schemas.openxmlformats.org/drawingml/2006/main">
+            <a:off x="8096250" y="3657600"/>
+            <a:ext cx="323850" cy="247650"/>
+          </a:xfrm>
+          <a:prstGeom xmlns:a="http://schemas.openxmlformats.org/drawingml/2006/main" prst="roundRect">
+            <a:avLst>
+              <a:gd name="adj" fmla="val 50000"/>
+            </a:avLst>
+          </a:prstGeom>
+          <a:solidFill xmlns:a="http://schemas.openxmlformats.org/drawingml/2006/main">
+            <a:srgbClr val="EDE1FF"/>
+          </a:solidFill>
+          <a:ln xmlns:a="http://schemas.openxmlformats.org/drawingml/2006/main" w="0">
+            <a:noFill/>
+            <a:prstDash val="solid"/>
+          </a:ln>
+        </p:spPr>
+      </p:sp>
+      <p:sp>
+        <p:nvSpPr>
+          <p:cNvPr id="54" name="">
+            <a:extLst xmlns:a="http://schemas.openxmlformats.org/drawingml/2006/main">
+              <a:ext uri="{FF2B5EF4-FFF2-40B4-BE49-F238E27FC236}">
+                <a16:creationId xmlns:a16="http://schemas.microsoft.com/office/drawing/2014/main" id="{DCE273A7-DF46-4218-B67D-14853E09C523}"/>
+              </a:ext>
+            </a:extLst>
+          </p:cNvPr>
+          <p:cNvSpPr>
+            <a:spLocks xmlns:a="http://schemas.openxmlformats.org/drawingml/2006/main" noGrp="1"/>
+          </p:cNvSpPr>
+          <p:nvPr/>
+        </p:nvSpPr>
+        <p:spPr>
+          <a:xfrm xmlns:a="http://schemas.openxmlformats.org/drawingml/2006/main">
+            <a:off x="8096250" y="3714750"/>
+            <a:ext cx="323850" cy="133350"/>
+          </a:xfrm>
+          <a:prstGeom xmlns:a="http://schemas.openxmlformats.org/drawingml/2006/main" prst="rect">
+            <a:avLst/>
+          </a:prstGeom>
+          <a:noFill xmlns:a="http://schemas.openxmlformats.org/drawingml/2006/main"/>
+          <a:ln xmlns:a="http://schemas.openxmlformats.org/drawingml/2006/main" w="0">
+            <a:noFill/>
+            <a:prstDash val="solid"/>
+          </a:ln>
+        </p:spPr>
+        <p:txBody>
+          <a:bodyPr xmlns:a="http://schemas.openxmlformats.org/drawingml/2006/main" lIns="0" tIns="0" rIns="0" bIns="0" anchor="t"/>
+          <a:lstStyle xmlns:a="http://schemas.openxmlformats.org/drawingml/2006/main"/>
+          <a:p xmlns:a="http://schemas.openxmlformats.org/drawingml/2006/main">
+            <a:pPr algn="ctr">
+              <a:lnSpc>
+                <a:spcPct val="105000"/>
+              </a:lnSpc>
+              <a:buNone/>
+              <a:defRPr sz="900" b="1">
+                <a:solidFill>
+                  <a:srgbClr val="7C3AED"/>
+                </a:solidFill>
+              </a:defRPr>
+            </a:pPr>
+            <a:r>
+              <a:rPr sz="900" b="1">
+                <a:solidFill>
+                  <a:srgbClr val="7C3AED"/>
+                </a:solidFill>
+              </a:rPr>
+              <a:t>3</a:t>
+            </a:r>
+          </a:p>
+        </p:txBody>
+      </p:sp>
+      <p:sp>
+        <p:nvSpPr>
+          <p:cNvPr id="55" name="">
+            <a:extLst xmlns:a="http://schemas.openxmlformats.org/drawingml/2006/main">
+              <a:ext uri="{FF2B5EF4-FFF2-40B4-BE49-F238E27FC236}">
+                <a16:creationId xmlns:a16="http://schemas.microsoft.com/office/drawing/2014/main" id="{8FEED53F-2D44-4616-A578-384DD4DF72CF}"/>
+              </a:ext>
+            </a:extLst>
+          </p:cNvPr>
+          <p:cNvSpPr>
+            <a:spLocks xmlns:a="http://schemas.openxmlformats.org/drawingml/2006/main" noGrp="1"/>
+          </p:cNvSpPr>
+          <p:nvPr/>
+        </p:nvSpPr>
+        <p:spPr>
+          <a:xfrm xmlns:a="http://schemas.openxmlformats.org/drawingml/2006/main">
+            <a:off x="8553450" y="3648075"/>
+            <a:ext cx="2552700" cy="266700"/>
+          </a:xfrm>
+          <a:prstGeom xmlns:a="http://schemas.openxmlformats.org/drawingml/2006/main" prst="rect">
+            <a:avLst/>
+          </a:prstGeom>
+          <a:noFill xmlns:a="http://schemas.openxmlformats.org/drawingml/2006/main"/>
+          <a:ln xmlns:a="http://schemas.openxmlformats.org/drawingml/2006/main" w="0">
+            <a:noFill/>
+            <a:prstDash val="solid"/>
+          </a:ln>
+        </p:spPr>
+        <p:txBody>
+          <a:bodyPr xmlns:a="http://schemas.openxmlformats.org/drawingml/2006/main" lIns="0" tIns="0" rIns="0" bIns="0" anchor="t"/>
+          <a:lstStyle xmlns:a="http://schemas.openxmlformats.org/drawingml/2006/main"/>
+          <a:p xmlns:a="http://schemas.openxmlformats.org/drawingml/2006/main">
+            <a:pPr algn="l">
+              <a:lnSpc>
+                <a:spcPct val="105000"/>
+              </a:lnSpc>
+              <a:buNone/>
+              <a:defRPr sz="1388" b="1">
+                <a:solidFill>
+                  <a:srgbClr val="071425"/>
+                </a:solidFill>
+              </a:defRPr>
+            </a:pPr>
+            <a:r>
+              <a:rPr sz="1388" b="1">
+                <a:solidFill>
+                  <a:srgbClr val="071425"/>
+                </a:solidFill>
+              </a:rPr>
+              <a:t>Make retail do brand work</a:t>
+            </a:r>
+          </a:p>
+        </p:txBody>
+      </p:sp>
+      <p:sp>
+        <p:nvSpPr>
+          <p:cNvPr id="56" name="">
+            <a:extLst xmlns:a="http://schemas.openxmlformats.org/drawingml/2006/main">
+              <a:ext uri="{FF2B5EF4-FFF2-40B4-BE49-F238E27FC236}">
+                <a16:creationId xmlns:a16="http://schemas.microsoft.com/office/drawing/2014/main" id="{C2CC0ABD-03D0-4BAD-956B-E828E3E21E1D}"/>
+              </a:ext>
+            </a:extLst>
+          </p:cNvPr>
+          <p:cNvSpPr>
+            <a:spLocks xmlns:a="http://schemas.openxmlformats.org/drawingml/2006/main" noGrp="1"/>
+          </p:cNvSpPr>
+          <p:nvPr/>
+        </p:nvSpPr>
+        <p:spPr>
+          <a:xfrm xmlns:a="http://schemas.openxmlformats.org/drawingml/2006/main">
+            <a:off x="8553450" y="3981450"/>
+            <a:ext cx="2552700" cy="1104900"/>
+          </a:xfrm>
+          <a:prstGeom xmlns:a="http://schemas.openxmlformats.org/drawingml/2006/main" prst="rect">
+            <a:avLst/>
+          </a:prstGeom>
+          <a:noFill xmlns:a="http://schemas.openxmlformats.org/drawingml/2006/main"/>
+          <a:ln xmlns:a="http://schemas.openxmlformats.org/drawingml/2006/main" w="0">
+            <a:noFill/>
+            <a:prstDash val="solid"/>
+          </a:ln>
+        </p:spPr>
+        <p:txBody>
+          <a:bodyPr xmlns:a="http://schemas.openxmlformats.org/drawingml/2006/main" lIns="0" tIns="0" rIns="0" bIns="0" anchor="t"/>
+          <a:lstStyle xmlns:a="http://schemas.openxmlformats.org/drawingml/2006/main"/>
+          <a:p xmlns:a="http://schemas.openxmlformats.org/drawingml/2006/main">
+            <a:pPr algn="l">
+              <a:lnSpc>
+                <a:spcPct val="112000"/>
+              </a:lnSpc>
+              <a:buNone/>
+              <a:defRPr sz="1065" b="0">
+                <a:solidFill>
+                  <a:srgbClr val="41516B"/>
+                </a:solidFill>
+              </a:defRPr>
+            </a:pPr>
+            <a:r>
+              <a:rPr sz="1065" b="0">
+                <a:solidFill>
+                  <a:srgbClr val="41516B"/>
+                </a:solidFill>
+              </a:rPr>
+              <a:t>Use the same cue on packaging, hangtags, displays, QR fit quiz, and “old rules vs new rules” shelf copy so retail becomes a credibility bridge.</a:t>
+            </a:r>
+          </a:p>
+        </p:txBody>
+      </p:sp>
+      <p:sp>
+        <p:nvSpPr>
+          <p:cNvPr id="57" name="">
+            <a:extLst xmlns:a="http://schemas.openxmlformats.org/drawingml/2006/main">
+              <a:ext uri="{FF2B5EF4-FFF2-40B4-BE49-F238E27FC236}">
+                <a16:creationId xmlns:a16="http://schemas.microsoft.com/office/drawing/2014/main" id="{7396F87F-83D4-4CA2-A863-09DA2BA4BD7A}"/>
+              </a:ext>
+            </a:extLst>
+          </p:cNvPr>
+          <p:cNvSpPr>
+            <a:spLocks xmlns:a="http://schemas.openxmlformats.org/drawingml/2006/main" noGrp="1"/>
+          </p:cNvSpPr>
+          <p:nvPr/>
+        </p:nvSpPr>
+        <p:spPr>
+          <a:xfrm xmlns:a="http://schemas.openxmlformats.org/drawingml/2006/main">
+            <a:off x="609600" y="5391150"/>
+            <a:ext cx="5200650" cy="876300"/>
+          </a:xfrm>
+          <a:prstGeom xmlns:a="http://schemas.openxmlformats.org/drawingml/2006/main" prst="roundRect">
+            <a:avLst>
+              <a:gd name="adj" fmla="val 8696"/>
+            </a:avLst>
+          </a:prstGeom>
+          <a:solidFill xmlns:a="http://schemas.openxmlformats.org/drawingml/2006/main">
+            <a:srgbClr val="FFFDF9"/>
+          </a:solidFill>
+          <a:ln xmlns:a="http://schemas.openxmlformats.org/drawingml/2006/main" w="9525">
+            <a:solidFill>
+              <a:srgbClr val="E5DCD1"/>
+            </a:solidFill>
+            <a:prstDash val="solid"/>
+          </a:ln>
+        </p:spPr>
+      </p:sp>
+      <p:sp>
+        <p:nvSpPr>
+          <p:cNvPr id="58" name="">
+            <a:extLst xmlns:a="http://schemas.openxmlformats.org/drawingml/2006/main">
+              <a:ext uri="{FF2B5EF4-FFF2-40B4-BE49-F238E27FC236}">
+                <a16:creationId xmlns:a16="http://schemas.microsoft.com/office/drawing/2014/main" id="{93D3C061-6BA9-4C1A-AD9A-B5AA3DA84C1A}"/>
+              </a:ext>
+            </a:extLst>
+          </p:cNvPr>
+          <p:cNvSpPr>
+            <a:spLocks xmlns:a="http://schemas.openxmlformats.org/drawingml/2006/main" noGrp="1"/>
+          </p:cNvSpPr>
+          <p:nvPr/>
+        </p:nvSpPr>
+        <p:spPr>
+          <a:xfrm xmlns:a="http://schemas.openxmlformats.org/drawingml/2006/main">
+            <a:off x="781050" y="5562600"/>
+            <a:ext cx="323850" cy="247650"/>
+          </a:xfrm>
+          <a:prstGeom xmlns:a="http://schemas.openxmlformats.org/drawingml/2006/main" prst="roundRect">
+            <a:avLst>
+              <a:gd name="adj" fmla="val 50000"/>
+            </a:avLst>
+          </a:prstGeom>
+          <a:solidFill xmlns:a="http://schemas.openxmlformats.org/drawingml/2006/main">
+            <a:srgbClr val="EDE1FF"/>
+          </a:solidFill>
+          <a:ln xmlns:a="http://schemas.openxmlformats.org/drawingml/2006/main" w="0">
+            <a:noFill/>
+            <a:prstDash val="solid"/>
+          </a:ln>
+        </p:spPr>
+      </p:sp>
+      <p:sp>
+        <p:nvSpPr>
+          <p:cNvPr id="59" name="">
+            <a:extLst xmlns:a="http://schemas.openxmlformats.org/drawingml/2006/main">
+              <a:ext uri="{FF2B5EF4-FFF2-40B4-BE49-F238E27FC236}">
+                <a16:creationId xmlns:a16="http://schemas.microsoft.com/office/drawing/2014/main" id="{640A5A05-4CF9-498A-B8CB-610DCB0F8802}"/>
+              </a:ext>
+            </a:extLst>
+          </p:cNvPr>
+          <p:cNvSpPr>
+            <a:spLocks xmlns:a="http://schemas.openxmlformats.org/drawingml/2006/main" noGrp="1"/>
+          </p:cNvSpPr>
+          <p:nvPr/>
+        </p:nvSpPr>
+        <p:spPr>
+          <a:xfrm xmlns:a="http://schemas.openxmlformats.org/drawingml/2006/main">
+            <a:off x="781050" y="5619750"/>
+            <a:ext cx="323850" cy="133350"/>
+          </a:xfrm>
+          <a:prstGeom xmlns:a="http://schemas.openxmlformats.org/drawingml/2006/main" prst="rect">
+            <a:avLst/>
+          </a:prstGeom>
+          <a:noFill xmlns:a="http://schemas.openxmlformats.org/drawingml/2006/main"/>
+          <a:ln xmlns:a="http://schemas.openxmlformats.org/drawingml/2006/main" w="0">
+            <a:noFill/>
+            <a:prstDash val="solid"/>
+          </a:ln>
+        </p:spPr>
+        <p:txBody>
+          <a:bodyPr xmlns:a="http://schemas.openxmlformats.org/drawingml/2006/main" lIns="0" tIns="0" rIns="0" bIns="0" anchor="t"/>
+          <a:lstStyle xmlns:a="http://schemas.openxmlformats.org/drawingml/2006/main"/>
+          <a:p xmlns:a="http://schemas.openxmlformats.org/drawingml/2006/main">
+            <a:pPr algn="ctr">
+              <a:lnSpc>
+                <a:spcPct val="105000"/>
+              </a:lnSpc>
+              <a:buNone/>
+              <a:defRPr sz="900" b="1">
+                <a:solidFill>
+                  <a:srgbClr val="7C3AED"/>
+                </a:solidFill>
+              </a:defRPr>
+            </a:pPr>
+            <a:r>
+              <a:rPr sz="900" b="1">
+                <a:solidFill>
+                  <a:srgbClr val="7C3AED"/>
+                </a:solidFill>
+              </a:rPr>
+              <a:t>4</a:t>
+            </a:r>
+          </a:p>
+        </p:txBody>
+      </p:sp>
+      <p:sp>
+        <p:nvSpPr>
+          <p:cNvPr id="60" name="">
+            <a:extLst xmlns:a="http://schemas.openxmlformats.org/drawingml/2006/main">
+              <a:ext uri="{FF2B5EF4-FFF2-40B4-BE49-F238E27FC236}">
+                <a16:creationId xmlns:a16="http://schemas.microsoft.com/office/drawing/2014/main" id="{371B78A5-748B-4E2C-8FD4-CB19A1C6D897}"/>
+              </a:ext>
+            </a:extLst>
+          </p:cNvPr>
+          <p:cNvSpPr>
+            <a:spLocks xmlns:a="http://schemas.openxmlformats.org/drawingml/2006/main" noGrp="1"/>
+          </p:cNvSpPr>
+          <p:nvPr/>
+        </p:nvSpPr>
+        <p:spPr>
+          <a:xfrm xmlns:a="http://schemas.openxmlformats.org/drawingml/2006/main">
+            <a:off x="1238250" y="5553075"/>
+            <a:ext cx="4381500" cy="266700"/>
+          </a:xfrm>
+          <a:prstGeom xmlns:a="http://schemas.openxmlformats.org/drawingml/2006/main" prst="rect">
+            <a:avLst/>
+          </a:prstGeom>
+          <a:noFill xmlns:a="http://schemas.openxmlformats.org/drawingml/2006/main"/>
+          <a:ln xmlns:a="http://schemas.openxmlformats.org/drawingml/2006/main" w="0">
+            <a:noFill/>
+            <a:prstDash val="solid"/>
+          </a:ln>
+        </p:spPr>
+        <p:txBody>
+          <a:bodyPr xmlns:a="http://schemas.openxmlformats.org/drawingml/2006/main" lIns="0" tIns="0" rIns="0" bIns="0" anchor="t"/>
+          <a:lstStyle xmlns:a="http://schemas.openxmlformats.org/drawingml/2006/main"/>
+          <a:p xmlns:a="http://schemas.openxmlformats.org/drawingml/2006/main">
+            <a:pPr algn="l">
+              <a:lnSpc>
+                <a:spcPct val="105000"/>
+              </a:lnSpc>
+              <a:buNone/>
+              <a:defRPr sz="1388" b="1">
+                <a:solidFill>
+                  <a:srgbClr val="071425"/>
+                </a:solidFill>
+              </a:defRPr>
+            </a:pPr>
+            <a:r>
+              <a:rPr sz="1388" b="1">
+                <a:solidFill>
+                  <a:srgbClr val="071425"/>
+                </a:solidFill>
+              </a:rPr>
+              <a:t>Rebuild value without anchoring on price</a:t>
+            </a:r>
+          </a:p>
+        </p:txBody>
+      </p:sp>
+      <p:sp>
+        <p:nvSpPr>
+          <p:cNvPr id="61" name="">
+            <a:extLst xmlns:a="http://schemas.openxmlformats.org/drawingml/2006/main">
+              <a:ext uri="{FF2B5EF4-FFF2-40B4-BE49-F238E27FC236}">
+                <a16:creationId xmlns:a16="http://schemas.microsoft.com/office/drawing/2014/main" id="{D8A64694-F520-43E5-B3CA-F051BB256C65}"/>
+              </a:ext>
+            </a:extLst>
+          </p:cNvPr>
+          <p:cNvSpPr>
+            <a:spLocks xmlns:a="http://schemas.openxmlformats.org/drawingml/2006/main" noGrp="1"/>
+          </p:cNvSpPr>
+          <p:nvPr/>
+        </p:nvSpPr>
+        <p:spPr>
+          <a:xfrm xmlns:a="http://schemas.openxmlformats.org/drawingml/2006/main">
+            <a:off x="1238250" y="5886450"/>
+            <a:ext cx="4381500" cy="285750"/>
+          </a:xfrm>
+          <a:prstGeom xmlns:a="http://schemas.openxmlformats.org/drawingml/2006/main" prst="rect">
+            <a:avLst/>
+          </a:prstGeom>
+          <a:noFill xmlns:a="http://schemas.openxmlformats.org/drawingml/2006/main"/>
+          <a:ln xmlns:a="http://schemas.openxmlformats.org/drawingml/2006/main" w="0">
+            <a:noFill/>
+            <a:prstDash val="solid"/>
+          </a:ln>
+        </p:spPr>
+        <p:txBody>
+          <a:bodyPr xmlns:a="http://schemas.openxmlformats.org/drawingml/2006/main" lIns="0" tIns="0" rIns="0" bIns="0" anchor="t"/>
+          <a:lstStyle xmlns:a="http://schemas.openxmlformats.org/drawingml/2006/main"/>
+          <a:p xmlns:a="http://schemas.openxmlformats.org/drawingml/2006/main">
+            <a:pPr algn="l">
+              <a:lnSpc>
+                <a:spcPct val="112000"/>
+              </a:lnSpc>
+              <a:buNone/>
+              <a:defRPr sz="1065" b="0">
+                <a:solidFill>
+                  <a:srgbClr val="41516B"/>
+                </a:solidFill>
+              </a:defRPr>
+            </a:pPr>
+            <a:r>
+              <a:rPr sz="1065" b="0">
+                <a:solidFill>
+                  <a:srgbClr val="41516B"/>
+                </a:solidFill>
+              </a:rPr>
+              <a:t>Lead with outfit bundles, cost-per-wear, quality proof, durability, easy care, and fit guarantees. Discounts can close, but should not lead the story.</a:t>
+            </a:r>
+          </a:p>
+        </p:txBody>
+      </p:sp>
+      <p:sp>
+        <p:nvSpPr>
+          <p:cNvPr id="62" name="">
+            <a:extLst xmlns:a="http://schemas.openxmlformats.org/drawingml/2006/main">
+              <a:ext uri="{FF2B5EF4-FFF2-40B4-BE49-F238E27FC236}">
+                <a16:creationId xmlns:a16="http://schemas.microsoft.com/office/drawing/2014/main" id="{7976C254-1D6C-4D12-B07C-B4891E359C86}"/>
+              </a:ext>
+            </a:extLst>
+          </p:cNvPr>
+          <p:cNvSpPr>
+            <a:spLocks xmlns:a="http://schemas.openxmlformats.org/drawingml/2006/main" noGrp="1"/>
+          </p:cNvSpPr>
+          <p:nvPr/>
+        </p:nvSpPr>
+        <p:spPr>
+          <a:xfrm xmlns:a="http://schemas.openxmlformats.org/drawingml/2006/main">
+            <a:off x="6096000" y="5391150"/>
+            <a:ext cx="5200650" cy="876300"/>
+          </a:xfrm>
+          <a:prstGeom xmlns:a="http://schemas.openxmlformats.org/drawingml/2006/main" prst="roundRect">
+            <a:avLst>
+              <a:gd name="adj" fmla="val 8696"/>
+            </a:avLst>
+          </a:prstGeom>
+          <a:solidFill xmlns:a="http://schemas.openxmlformats.org/drawingml/2006/main">
+            <a:srgbClr val="FFFDF9"/>
+          </a:solidFill>
+          <a:ln xmlns:a="http://schemas.openxmlformats.org/drawingml/2006/main" w="9525">
+            <a:solidFill>
+              <a:srgbClr val="E5DCD1"/>
+            </a:solidFill>
+            <a:prstDash val="solid"/>
+          </a:ln>
+        </p:spPr>
+      </p:sp>
+      <p:sp>
+        <p:nvSpPr>
+          <p:cNvPr id="63" name="">
+            <a:extLst xmlns:a="http://schemas.openxmlformats.org/drawingml/2006/main">
+              <a:ext uri="{FF2B5EF4-FFF2-40B4-BE49-F238E27FC236}">
+                <a16:creationId xmlns:a16="http://schemas.microsoft.com/office/drawing/2014/main" id="{99E80935-59F4-4C9F-9E0E-1C5267E25533}"/>
+              </a:ext>
+            </a:extLst>
+          </p:cNvPr>
+          <p:cNvSpPr>
+            <a:spLocks xmlns:a="http://schemas.openxmlformats.org/drawingml/2006/main" noGrp="1"/>
+          </p:cNvSpPr>
+          <p:nvPr/>
+        </p:nvSpPr>
+        <p:spPr>
+          <a:xfrm xmlns:a="http://schemas.openxmlformats.org/drawingml/2006/main">
+            <a:off x="6267450" y="5562600"/>
+            <a:ext cx="323850" cy="247650"/>
+          </a:xfrm>
+          <a:prstGeom xmlns:a="http://schemas.openxmlformats.org/drawingml/2006/main" prst="roundRect">
+            <a:avLst>
+              <a:gd name="adj" fmla="val 50000"/>
+            </a:avLst>
+          </a:prstGeom>
+          <a:solidFill xmlns:a="http://schemas.openxmlformats.org/drawingml/2006/main">
+            <a:srgbClr val="EDE1FF"/>
+          </a:solidFill>
+          <a:ln xmlns:a="http://schemas.openxmlformats.org/drawingml/2006/main" w="0">
+            <a:noFill/>
+            <a:prstDash val="solid"/>
+          </a:ln>
+        </p:spPr>
+      </p:sp>
+      <p:sp>
+        <p:nvSpPr>
+          <p:cNvPr id="64" name="">
+            <a:extLst xmlns:a="http://schemas.openxmlformats.org/drawingml/2006/main">
+              <a:ext uri="{FF2B5EF4-FFF2-40B4-BE49-F238E27FC236}">
+                <a16:creationId xmlns:a16="http://schemas.microsoft.com/office/drawing/2014/main" id="{FA91F9DB-6F2E-4C32-BFD4-AED7B4CE9D78}"/>
+              </a:ext>
+            </a:extLst>
+          </p:cNvPr>
+          <p:cNvSpPr>
+            <a:spLocks xmlns:a="http://schemas.openxmlformats.org/drawingml/2006/main" noGrp="1"/>
+          </p:cNvSpPr>
+          <p:nvPr/>
+        </p:nvSpPr>
+        <p:spPr>
+          <a:xfrm xmlns:a="http://schemas.openxmlformats.org/drawingml/2006/main">
+            <a:off x="6267450" y="5619750"/>
+            <a:ext cx="323850" cy="133350"/>
+          </a:xfrm>
+          <a:prstGeom xmlns:a="http://schemas.openxmlformats.org/drawingml/2006/main" prst="rect">
+            <a:avLst/>
+          </a:prstGeom>
+          <a:noFill xmlns:a="http://schemas.openxmlformats.org/drawingml/2006/main"/>
+          <a:ln xmlns:a="http://schemas.openxmlformats.org/drawingml/2006/main" w="0">
+            <a:noFill/>
+            <a:prstDash val="solid"/>
+          </a:ln>
+        </p:spPr>
+        <p:txBody>
+          <a:bodyPr xmlns:a="http://schemas.openxmlformats.org/drawingml/2006/main" lIns="0" tIns="0" rIns="0" bIns="0" anchor="t"/>
+          <a:lstStyle xmlns:a="http://schemas.openxmlformats.org/drawingml/2006/main"/>
+          <a:p xmlns:a="http://schemas.openxmlformats.org/drawingml/2006/main">
+            <a:pPr algn="ctr">
+              <a:lnSpc>
+                <a:spcPct val="105000"/>
+              </a:lnSpc>
+              <a:buNone/>
+              <a:defRPr sz="900" b="1">
+                <a:solidFill>
+                  <a:srgbClr val="7C3AED"/>
+                </a:solidFill>
+              </a:defRPr>
+            </a:pPr>
+            <a:r>
+              <a:rPr sz="900" b="1">
+                <a:solidFill>
+                  <a:srgbClr val="7C3AED"/>
+                </a:solidFill>
+              </a:rPr>
+              <a:t>5</a:t>
+            </a:r>
+          </a:p>
+        </p:txBody>
+      </p:sp>
+      <p:sp>
+        <p:nvSpPr>
+          <p:cNvPr id="65" name="">
+            <a:extLst xmlns:a="http://schemas.openxmlformats.org/drawingml/2006/main">
+              <a:ext uri="{FF2B5EF4-FFF2-40B4-BE49-F238E27FC236}">
+                <a16:creationId xmlns:a16="http://schemas.microsoft.com/office/drawing/2014/main" id="{3A5C00B6-4B76-4778-8389-B93945525292}"/>
+              </a:ext>
+            </a:extLst>
+          </p:cNvPr>
+          <p:cNvSpPr>
+            <a:spLocks xmlns:a="http://schemas.openxmlformats.org/drawingml/2006/main" noGrp="1"/>
+          </p:cNvSpPr>
+          <p:nvPr/>
+        </p:nvSpPr>
+        <p:spPr>
+          <a:xfrm xmlns:a="http://schemas.openxmlformats.org/drawingml/2006/main">
+            <a:off x="6724650" y="5553075"/>
+            <a:ext cx="4381500" cy="266700"/>
+          </a:xfrm>
+          <a:prstGeom xmlns:a="http://schemas.openxmlformats.org/drawingml/2006/main" prst="rect">
+            <a:avLst/>
+          </a:prstGeom>
+          <a:noFill xmlns:a="http://schemas.openxmlformats.org/drawingml/2006/main"/>
+          <a:ln xmlns:a="http://schemas.openxmlformats.org/drawingml/2006/main" w="0">
+            <a:noFill/>
+            <a:prstDash val="solid"/>
+          </a:ln>
+        </p:spPr>
+        <p:txBody>
+          <a:bodyPr xmlns:a="http://schemas.openxmlformats.org/drawingml/2006/main" lIns="0" tIns="0" rIns="0" bIns="0" anchor="t"/>
+          <a:lstStyle xmlns:a="http://schemas.openxmlformats.org/drawingml/2006/main"/>
+          <a:p xmlns:a="http://schemas.openxmlformats.org/drawingml/2006/main">
+            <a:pPr algn="l">
+              <a:lnSpc>
+                <a:spcPct val="105000"/>
+              </a:lnSpc>
+              <a:buNone/>
+              <a:defRPr sz="1388" b="1">
+                <a:solidFill>
+                  <a:srgbClr val="071425"/>
+                </a:solidFill>
+              </a:defRPr>
+            </a:pPr>
+            <a:r>
+              <a:rPr sz="1388" b="1">
+                <a:solidFill>
+                  <a:srgbClr val="071425"/>
+                </a:solidFill>
+              </a:rPr>
+              <a:t>Run one idea with two entry points</a:t>
+            </a:r>
+          </a:p>
+        </p:txBody>
+      </p:sp>
+      <p:sp>
+        <p:nvSpPr>
+          <p:cNvPr id="66" name="">
+            <a:extLst xmlns:a="http://schemas.openxmlformats.org/drawingml/2006/main">
+              <a:ext uri="{FF2B5EF4-FFF2-40B4-BE49-F238E27FC236}">
+                <a16:creationId xmlns:a16="http://schemas.microsoft.com/office/drawing/2014/main" id="{84C07693-345A-46AE-9615-6867D21D28E0}"/>
+              </a:ext>
+            </a:extLst>
+          </p:cNvPr>
+          <p:cNvSpPr>
+            <a:spLocks xmlns:a="http://schemas.openxmlformats.org/drawingml/2006/main" noGrp="1"/>
+          </p:cNvSpPr>
+          <p:nvPr/>
+        </p:nvSpPr>
+        <p:spPr>
+          <a:xfrm xmlns:a="http://schemas.openxmlformats.org/drawingml/2006/main">
+            <a:off x="6724650" y="5886450"/>
+            <a:ext cx="4381500" cy="285750"/>
+          </a:xfrm>
+          <a:prstGeom xmlns:a="http://schemas.openxmlformats.org/drawingml/2006/main" prst="rect">
+            <a:avLst/>
+          </a:prstGeom>
+          <a:noFill xmlns:a="http://schemas.openxmlformats.org/drawingml/2006/main"/>
+          <a:ln xmlns:a="http://schemas.openxmlformats.org/drawingml/2006/main" w="0">
+            <a:noFill/>
+            <a:prstDash val="solid"/>
+          </a:ln>
+        </p:spPr>
+        <p:txBody>
+          <a:bodyPr xmlns:a="http://schemas.openxmlformats.org/drawingml/2006/main" lIns="0" tIns="0" rIns="0" bIns="0" anchor="t"/>
+          <a:lstStyle xmlns:a="http://schemas.openxmlformats.org/drawingml/2006/main"/>
+          <a:p xmlns:a="http://schemas.openxmlformats.org/drawingml/2006/main">
+            <a:pPr algn="l">
+              <a:lnSpc>
+                <a:spcPct val="112000"/>
+              </a:lnSpc>
+              <a:buNone/>
+              <a:defRPr sz="1065" b="0">
+                <a:solidFill>
+                  <a:srgbClr val="41516B"/>
+                </a:solidFill>
+              </a:defRPr>
+            </a:pPr>
+            <a:r>
+              <a:rPr sz="1065" b="0">
+                <a:solidFill>
+                  <a:srgbClr val="41516B"/>
+                </a:solidFill>
+              </a:rPr>
+              <a:t>Under 40: comfort that feels powerful and lets clothes disappear. 40+: adapts to the body and life stage she is in now. Same cue, different proof.</a:t>
+            </a:r>
+          </a:p>
+        </p:txBody>
+      </p:sp>
+      <p:sp>
+        <p:nvSpPr>
+          <p:cNvPr id="67" name="">
+            <a:extLst xmlns:a="http://schemas.openxmlformats.org/drawingml/2006/main">
+              <a:ext uri="{FF2B5EF4-FFF2-40B4-BE49-F238E27FC236}">
+                <a16:creationId xmlns:a16="http://schemas.microsoft.com/office/drawing/2014/main" id="{924ACDBB-87DB-4A75-A75E-8F99DDEB3850}"/>
+              </a:ext>
+            </a:extLst>
+          </p:cNvPr>
+          <p:cNvSpPr>
+            <a:spLocks xmlns:a="http://schemas.openxmlformats.org/drawingml/2006/main" noGrp="1"/>
+          </p:cNvSpPr>
+          <p:nvPr/>
+        </p:nvSpPr>
+        <p:spPr>
+          <a:xfrm xmlns:a="http://schemas.openxmlformats.org/drawingml/2006/main">
+            <a:off x="609600" y="6496050"/>
+            <a:ext cx="7239000" cy="190500"/>
+          </a:xfrm>
+          <a:prstGeom xmlns:a="http://schemas.openxmlformats.org/drawingml/2006/main" prst="rect">
+            <a:avLst/>
+          </a:prstGeom>
+          <a:noFill xmlns:a="http://schemas.openxmlformats.org/drawingml/2006/main"/>
+          <a:ln xmlns:a="http://schemas.openxmlformats.org/drawingml/2006/main" w="0">
+            <a:noFill/>
+            <a:prstDash val="solid"/>
+          </a:ln>
+        </p:spPr>
+        <p:txBody>
+          <a:bodyPr xmlns:a="http://schemas.openxmlformats.org/drawingml/2006/main" lIns="0" tIns="0" rIns="0" bIns="0" anchor="t"/>
+          <a:lstStyle xmlns:a="http://schemas.openxmlformats.org/drawingml/2006/main"/>
+          <a:p xmlns:a="http://schemas.openxmlformats.org/drawingml/2006/main">
+            <a:pPr algn="l">
+              <a:lnSpc>
+                <a:spcPct val="105000"/>
+              </a:lnSpc>
+              <a:buNone/>
+              <a:defRPr sz="788" b="0">
+                <a:solidFill>
+                  <a:srgbClr val="667085"/>
+                </a:solidFill>
+              </a:defRPr>
+            </a:pPr>
+            <a:r>
+              <a:rPr sz="788" b="0">
+                <a:solidFill>
+                  <a:srgbClr val="667085"/>
+                </a:solidFill>
+              </a:rPr>
+              <a:t>Source: Q2 2026 Brand Tracker Q17-Q19; top stat strip matches corrected campaign-stat export n=1,060. Tactics synthesized from tracker evidence and channel recommendations.</a:t>
+            </a:r>
+          </a:p>
+        </p:txBody>
+      </p:sp>
+      <p:sp>
+        <p:nvSpPr>
+          <p:cNvPr id="68" name="">
+            <a:extLst xmlns:a="http://schemas.openxmlformats.org/drawingml/2006/main">
+              <a:ext uri="{FF2B5EF4-FFF2-40B4-BE49-F238E27FC236}">
+                <a16:creationId xmlns:a16="http://schemas.microsoft.com/office/drawing/2014/main" id="{F5F9905A-24BA-4208-89BC-204D70860145}"/>
+              </a:ext>
+            </a:extLst>
+          </p:cNvPr>
+          <p:cNvSpPr>
+            <a:spLocks xmlns:a="http://schemas.openxmlformats.org/drawingml/2006/main" noGrp="1"/>
+          </p:cNvSpPr>
+          <p:nvPr/>
+        </p:nvSpPr>
+        <p:spPr>
+          <a:xfrm xmlns:a="http://schemas.openxmlformats.org/drawingml/2006/main">
+            <a:off x="10001250" y="6496050"/>
+            <a:ext cx="1619250" cy="190500"/>
+          </a:xfrm>
+          <a:prstGeom xmlns:a="http://schemas.openxmlformats.org/drawingml/2006/main" prst="rect">
+            <a:avLst/>
+          </a:prstGeom>
+          <a:noFill xmlns:a="http://schemas.openxmlformats.org/drawingml/2006/main"/>
+          <a:ln xmlns:a="http://schemas.openxmlformats.org/drawingml/2006/main" w="0">
+            <a:noFill/>
+            <a:prstDash val="solid"/>
+          </a:ln>
+        </p:spPr>
+        <p:txBody>
+          <a:bodyPr xmlns:a="http://schemas.openxmlformats.org/drawingml/2006/main" lIns="0" tIns="0" rIns="0" bIns="0" anchor="t"/>
+          <a:lstStyle xmlns:a="http://schemas.openxmlformats.org/drawingml/2006/main"/>
+          <a:p xmlns:a="http://schemas.openxmlformats.org/drawingml/2006/main">
+            <a:pPr algn="r">
+              <a:lnSpc>
+                <a:spcPct val="105000"/>
+              </a:lnSpc>
+              <a:buNone/>
+              <a:defRPr sz="788" b="1">
+                <a:solidFill>
+                  <a:srgbClr val="41516B"/>
+                </a:solidFill>
+              </a:defRPr>
+            </a:pPr>
+            <a:r>
+              <a:rPr sz="788" b="1">
+                <a:solidFill>
+                  <a:srgbClr val="41516B"/>
                 </a:solidFill>
               </a:rPr>
               <a:t>US Brand Tracker | Shapermint</a:t>

</xml_diff>